<commit_message>
docs: deck rebuilt with the 66/66 eval run and the Sunrise screenshots
</commit_message>
<xml_diff>
--- a/docs/submission/BreederNear-AI-deck.pptx
+++ b/docs/submission/BreederNear-AI-deck.pptx
@@ -7294,7 +7294,7 @@
         </p:nvGraphicFramePr>
         <p:xfrm>
           <a:off x="320040" y="1115568"/>
-          <a:ext cx="8503920" cy="1463040"/>
+          <a:ext cx="8503920" cy="1700784"/>
         </p:xfrm>
         <a:graphic>
           <a:graphicData uri="http://schemas.openxmlformats.org/drawingml/2006/table">
@@ -7307,14 +7307,14 @@
                 <a:gridCol w="2743200"/>
                 <a:gridCol w="2194560"/>
               </a:tblGrid>
-              <a:tr h="292608">
+              <a:tr h="283464">
                 <a:tc>
                   <a:txBody>
                     <a:bodyPr wrap="square"/>
                     <a:lstStyle/>
                     <a:p>
                       <a:r>
-                        <a:rPr sz="900">
+                        <a:rPr sz="860">
                           <a:solidFill>
                             <a:srgbClr val="FFFFFF"/>
                           </a:solidFill>
@@ -7336,13 +7336,13 @@
                     <a:lstStyle/>
                     <a:p>
                       <a:r>
-                        <a:rPr sz="900">
+                        <a:rPr sz="860">
                           <a:solidFill>
                             <a:srgbClr val="FFFFFF"/>
                           </a:solidFill>
                           <a:latin typeface="Google Sans Flex SemiBold"/>
                         </a:rPr>
-                        <a:t>Gemini tokens</a:t>
+                        <a:t>Gemini tokens (in · out incl. thinking)</a:t>
                       </a:r>
                     </a:p>
                   </a:txBody>
@@ -7358,7 +7358,7 @@
                     <a:lstStyle/>
                     <a:p>
                       <a:r>
-                        <a:rPr sz="900">
+                        <a:rPr sz="860">
                           <a:solidFill>
                             <a:srgbClr val="FFFFFF"/>
                           </a:solidFill>
@@ -7375,14 +7375,14 @@
                   </a:tcPr>
                 </a:tc>
               </a:tr>
-              <a:tr h="292608">
+              <a:tr h="283464">
                 <a:tc>
                   <a:txBody>
                     <a:bodyPr wrap="square"/>
                     <a:lstStyle/>
                     <a:p>
                       <a:r>
-                        <a:rPr sz="900">
+                        <a:rPr sz="860">
                           <a:solidFill>
                             <a:srgbClr val="1D1D1F"/>
                           </a:solidFill>
@@ -7404,13 +7404,13 @@
                     <a:lstStyle/>
                     <a:p>
                       <a:r>
-                        <a:rPr sz="900">
+                        <a:rPr sz="860">
                           <a:solidFill>
                             <a:srgbClr val="1D1D1F"/>
                           </a:solidFill>
                           <a:latin typeface="Google Sans Flex"/>
                         </a:rPr>
-                        <a:t>≈ 4,560 in · ≤ 1,075 out</a:t>
+                        <a:t>≈ 4,560 · ≤ 1,075</a:t>
                       </a:r>
                     </a:p>
                   </a:txBody>
@@ -7426,7 +7426,7 @@
                     <a:lstStyle/>
                     <a:p>
                       <a:r>
-                        <a:rPr sz="900">
+                        <a:rPr sz="860">
                           <a:solidFill>
                             <a:srgbClr val="1D1D1F"/>
                           </a:solidFill>
@@ -7443,14 +7443,14 @@
                   </a:tcPr>
                 </a:tc>
               </a:tr>
-              <a:tr h="292608">
+              <a:tr h="283464">
                 <a:tc>
                   <a:txBody>
                     <a:bodyPr wrap="square"/>
                     <a:lstStyle/>
                     <a:p>
                       <a:r>
-                        <a:rPr sz="900">
+                        <a:rPr sz="860">
                           <a:solidFill>
                             <a:srgbClr val="1D1D1F"/>
                           </a:solidFill>
@@ -7472,13 +7472,13 @@
                     <a:lstStyle/>
                     <a:p>
                       <a:r>
-                        <a:rPr sz="900">
+                        <a:rPr sz="860">
                           <a:solidFill>
                             <a:srgbClr val="1D1D1F"/>
                           </a:solidFill>
                           <a:latin typeface="Google Sans Flex"/>
                         </a:rPr>
-                        <a:t>≈ 1,620 in · ≤ 445 out</a:t>
+                        <a:t>≈ 1,620 · ≤ 445</a:t>
                       </a:r>
                     </a:p>
                   </a:txBody>
@@ -7494,7 +7494,7 @@
                     <a:lstStyle/>
                     <a:p>
                       <a:r>
-                        <a:rPr sz="900">
+                        <a:rPr sz="860">
                           <a:solidFill>
                             <a:srgbClr val="1D1D1F"/>
                           </a:solidFill>
@@ -7511,20 +7511,20 @@
                   </a:tcPr>
                 </a:tc>
               </a:tr>
-              <a:tr h="292608">
+              <a:tr h="283464">
                 <a:tc>
                   <a:txBody>
                     <a:bodyPr wrap="square"/>
                     <a:lstStyle/>
                     <a:p>
                       <a:r>
-                        <a:rPr sz="900">
+                        <a:rPr sz="860">
                           <a:solidFill>
                             <a:srgbClr val="1D1D1F"/>
                           </a:solidFill>
                           <a:latin typeface="Google Sans Flex"/>
                         </a:rPr>
-                        <a:t>14-day care plan (cached per species and age)</a:t>
+                        <a:t>Verification: read a certificate · review 2 facility photos</a:t>
                       </a:r>
                     </a:p>
                   </a:txBody>
@@ -7540,13 +7540,13 @@
                     <a:lstStyle/>
                     <a:p>
                       <a:r>
-                        <a:rPr sz="900">
+                        <a:rPr sz="860">
                           <a:solidFill>
                             <a:srgbClr val="1D1D1F"/>
                           </a:solidFill>
                           <a:latin typeface="Google Sans Flex"/>
                         </a:rPr>
-                        <a:t>≈ 560 in · ≤ 1,680 out</a:t>
+                        <a:t>≈ 1,640 · 400  ·  ≈ 2,630 · 645</a:t>
                       </a:r>
                     </a:p>
                   </a:txBody>
@@ -7562,13 +7562,13 @@
                     <a:lstStyle/>
                     <a:p>
                       <a:r>
-                        <a:rPr sz="900">
+                        <a:rPr sz="860">
                           <a:solidFill>
                             <a:srgbClr val="1D1D1F"/>
                           </a:solidFill>
                           <a:latin typeface="Google Sans Flex"/>
                         </a:rPr>
-                        <a:t>≈ ₹1.2, once per species</a:t>
+                        <a:t>≈ ₹0.5 · ≈ ₹0.8</a:t>
                       </a:r>
                     </a:p>
                   </a:txBody>
@@ -7579,20 +7579,20 @@
                   </a:tcPr>
                 </a:tc>
               </a:tr>
-              <a:tr h="292608">
+              <a:tr h="283464">
                 <a:tc>
                   <a:txBody>
                     <a:bodyPr wrap="square"/>
                     <a:lstStyle/>
                     <a:p>
                       <a:r>
-                        <a:rPr sz="900">
+                        <a:rPr sz="860">
                           <a:solidFill>
                             <a:srgbClr val="1D1D1F"/>
                           </a:solidFill>
                           <a:latin typeface="Google Sans Flex"/>
                         </a:rPr>
-                        <a:t>Reply draft for an enquiry</a:t>
+                        <a:t>Buyer profile from their words · scan a message</a:t>
                       </a:r>
                     </a:p>
                   </a:txBody>
@@ -7608,13 +7608,13 @@
                     <a:lstStyle/>
                     <a:p>
                       <a:r>
-                        <a:rPr sz="900">
+                        <a:rPr sz="860">
                           <a:solidFill>
                             <a:srgbClr val="1D1D1F"/>
                           </a:solidFill>
                           <a:latin typeface="Google Sans Flex"/>
                         </a:rPr>
-                        <a:t>≈ 500 in · ≤ 790 out</a:t>
+                        <a:t>≈ 700 · 550  ·  ≈ 300 · 120</a:t>
                       </a:r>
                     </a:p>
                   </a:txBody>
@@ -7630,19 +7630,87 @@
                     <a:lstStyle/>
                     <a:p>
                       <a:r>
-                        <a:rPr sz="900">
+                        <a:rPr sz="860">
                           <a:solidFill>
                             <a:srgbClr val="1D1D1F"/>
                           </a:solidFill>
                           <a:latin typeface="Google Sans Flex"/>
                         </a:rPr>
-                        <a:t>≈ ₹0.6</a:t>
+                        <a:t>≈ ₹0.5 · ≈ ₹0.1</a:t>
                       </a:r>
                     </a:p>
                   </a:txBody>
                   <a:tcPr marL="54864" marR="54864" marT="22860" marB="22860" anchor="ctr">
                     <a:solidFill>
                       <a:srgbClr val="F3F3F0"/>
+                    </a:solidFill>
+                  </a:tcPr>
+                </a:tc>
+              </a:tr>
+              <a:tr h="283464">
+                <a:tc>
+                  <a:txBody>
+                    <a:bodyPr wrap="square"/>
+                    <a:lstStyle/>
+                    <a:p>
+                      <a:r>
+                        <a:rPr sz="860">
+                          <a:solidFill>
+                            <a:srgbClr val="1D1D1F"/>
+                          </a:solidFill>
+                          <a:latin typeface="Google Sans Flex"/>
+                        </a:rPr>
+                        <a:t>14-day care plan (cached per species and age) · reply draft</a:t>
+                      </a:r>
+                    </a:p>
+                  </a:txBody>
+                  <a:tcPr marL="54864" marR="54864" marT="22860" marB="22860" anchor="ctr">
+                    <a:solidFill>
+                      <a:srgbClr val="FFFFFF"/>
+                    </a:solidFill>
+                  </a:tcPr>
+                </a:tc>
+                <a:tc>
+                  <a:txBody>
+                    <a:bodyPr wrap="square"/>
+                    <a:lstStyle/>
+                    <a:p>
+                      <a:r>
+                        <a:rPr sz="860">
+                          <a:solidFill>
+                            <a:srgbClr val="1D1D1F"/>
+                          </a:solidFill>
+                          <a:latin typeface="Google Sans Flex"/>
+                        </a:rPr>
+                        <a:t>≈ 560 · ≤ 1,680  ·  ≈ 500 · ≤ 790</a:t>
+                      </a:r>
+                    </a:p>
+                  </a:txBody>
+                  <a:tcPr marL="54864" marR="54864" marT="22860" marB="22860" anchor="ctr">
+                    <a:solidFill>
+                      <a:srgbClr val="FFFFFF"/>
+                    </a:solidFill>
+                  </a:tcPr>
+                </a:tc>
+                <a:tc>
+                  <a:txBody>
+                    <a:bodyPr wrap="square"/>
+                    <a:lstStyle/>
+                    <a:p>
+                      <a:r>
+                        <a:rPr sz="860">
+                          <a:solidFill>
+                            <a:srgbClr val="1D1D1F"/>
+                          </a:solidFill>
+                          <a:latin typeface="Google Sans Flex"/>
+                        </a:rPr>
+                        <a:t>≈ ₹1.2 · ≈ ₹0.6</a:t>
+                      </a:r>
+                    </a:p>
+                  </a:txBody>
+                  <a:tcPr marL="54864" marR="54864" marT="22860" marB="22860" anchor="ctr">
+                    <a:solidFill>
+                      <a:srgbClr val="FFFFFF"/>
                     </a:solidFill>
                   </a:tcPr>
                 </a:tc>
@@ -7660,8 +7728,8 @@
           <p:nvPr/>
         </p:nvGraphicFramePr>
         <p:xfrm>
-          <a:off x="320040" y="2779776"/>
-          <a:ext cx="8503920" cy="1170432"/>
+          <a:off x="320040" y="2990087"/>
+          <a:ext cx="8503920" cy="1097280"/>
         </p:xfrm>
         <a:graphic>
           <a:graphicData uri="http://schemas.openxmlformats.org/drawingml/2006/table">
@@ -7674,14 +7742,14 @@
                 <a:gridCol w="2743200"/>
                 <a:gridCol w="2194560"/>
               </a:tblGrid>
-              <a:tr h="292608">
+              <a:tr h="274320">
                 <a:tc>
                   <a:txBody>
                     <a:bodyPr wrap="square"/>
                     <a:lstStyle/>
                     <a:p>
                       <a:r>
-                        <a:rPr sz="900">
+                        <a:rPr sz="860">
                           <a:solidFill>
                             <a:srgbClr val="FFFFFF"/>
                           </a:solidFill>
@@ -7703,7 +7771,7 @@
                     <a:lstStyle/>
                     <a:p>
                       <a:r>
-                        <a:rPr sz="900">
+                        <a:rPr sz="860">
                           <a:solidFill>
                             <a:srgbClr val="FFFFFF"/>
                           </a:solidFill>
@@ -7725,7 +7793,7 @@
                     <a:lstStyle/>
                     <a:p>
                       <a:r>
-                        <a:rPr sz="900">
+                        <a:rPr sz="860">
                           <a:solidFill>
                             <a:srgbClr val="FFFFFF"/>
                           </a:solidFill>
@@ -7742,14 +7810,14 @@
                   </a:tcPr>
                 </a:tc>
               </a:tr>
-              <a:tr h="292608">
+              <a:tr h="274320">
                 <a:tc>
                   <a:txBody>
                     <a:bodyPr wrap="square"/>
                     <a:lstStyle/>
                     <a:p>
                       <a:r>
-                        <a:rPr sz="900">
+                        <a:rPr sz="860">
                           <a:solidFill>
                             <a:srgbClr val="1D1D1F"/>
                           </a:solidFill>
@@ -7771,7 +7839,7 @@
                     <a:lstStyle/>
                     <a:p>
                       <a:r>
-                        <a:rPr sz="900">
+                        <a:rPr sz="860">
                           <a:solidFill>
                             <a:srgbClr val="1D1D1F"/>
                           </a:solidFill>
@@ -7793,7 +7861,7 @@
                     <a:lstStyle/>
                     <a:p>
                       <a:r>
-                        <a:rPr sz="900">
+                        <a:rPr sz="860">
                           <a:solidFill>
                             <a:srgbClr val="1D1D1F"/>
                           </a:solidFill>
@@ -7810,20 +7878,20 @@
                   </a:tcPr>
                 </a:tc>
               </a:tr>
-              <a:tr h="292608">
+              <a:tr h="274320">
                 <a:tc>
                   <a:txBody>
                     <a:bodyPr wrap="square"/>
                     <a:lstStyle/>
                     <a:p>
                       <a:r>
-                        <a:rPr sz="900">
+                        <a:rPr sz="860">
                           <a:solidFill>
                             <a:srgbClr val="1D1D1F"/>
                           </a:solidFill>
                           <a:latin typeface="Google Sans Flex"/>
                         </a:rPr>
-                        <a:t>Firestore, Cloud Storage, Firebase Hosting</a:t>
+                        <a:t>Firestore, Cloud Storage, Firebase Hosting + Auth</a:t>
                       </a:r>
                     </a:p>
                   </a:txBody>
@@ -7839,7 +7907,7 @@
                     <a:lstStyle/>
                     <a:p>
                       <a:r>
-                        <a:rPr sz="900">
+                        <a:rPr sz="860">
                           <a:solidFill>
                             <a:srgbClr val="1D1D1F"/>
                           </a:solidFill>
@@ -7861,7 +7929,7 @@
                     <a:lstStyle/>
                     <a:p>
                       <a:r>
-                        <a:rPr sz="900">
+                        <a:rPr sz="860">
                           <a:solidFill>
                             <a:srgbClr val="1D1D1F"/>
                           </a:solidFill>
@@ -7878,14 +7946,14 @@
                   </a:tcPr>
                 </a:tc>
               </a:tr>
-              <a:tr h="292608">
+              <a:tr h="274320">
                 <a:tc>
                   <a:txBody>
                     <a:bodyPr wrap="square"/>
                     <a:lstStyle/>
                     <a:p>
                       <a:r>
-                        <a:rPr sz="900">
+                        <a:rPr sz="860">
                           <a:solidFill>
                             <a:srgbClr val="1D1D1F"/>
                           </a:solidFill>
@@ -7907,7 +7975,7 @@
                     <a:lstStyle/>
                     <a:p>
                       <a:r>
-                        <a:rPr sz="900">
+                        <a:rPr sz="860">
                           <a:solidFill>
                             <a:srgbClr val="1D1D1F"/>
                           </a:solidFill>
@@ -7929,7 +7997,7 @@
                     <a:lstStyle/>
                     <a:p>
                       <a:r>
-                        <a:rPr sz="900">
+                        <a:rPr sz="860">
                           <a:solidFill>
                             <a:srgbClr val="1D1D1F"/>
                           </a:solidFill>
@@ -7958,8 +8026,8 @@
         </p:nvSpPr>
         <p:spPr>
           <a:xfrm>
-            <a:off x="320040" y="4041648"/>
-            <a:ext cx="8503920" cy="548640"/>
+            <a:off x="320040" y="4133087"/>
+            <a:ext cx="8503920" cy="457200"/>
           </a:xfrm>
           <a:prstGeom prst="rect">
             <a:avLst/>
@@ -7984,7 +8052,7 @@
                 </a:solidFill>
                 <a:latin typeface="Google Sans Flex SemiBold"/>
               </a:rPr>
-              <a:t>Screening a listing costs about ₹1.3, against animals priced from ₹400 to ₹25,000 in our sample listings, so trust checks are affordable on every listing.</a:t>
+              <a:t>Screening a listing costs about ₹1.3 against animals priced ₹400–₹25,000 in our sample listings, so every listing can be checked.</a:t>
             </a:r>
           </a:p>
         </p:txBody>
@@ -8023,7 +8091,7 @@
                 </a:solidFill>
                 <a:latin typeface="Google Sans Flex"/>
               </a:rPr>
-              <a:t>*Measured tokens (10 Oct 2026); thinking tokens counted as output · Gemini 3.8 Flash at $1.50 in / $7.50 out per 1M tokens (list price from 1 Jan 2027, as reported by price trackers; introductory price until then is half) · ₹88 = $1 (assumption) · Estimates are labelled</a:t>
+              <a:t>*Measured tokens (10–11 Oct 2026); thinking tokens counted as output · Gemini 3.8 Flash at $1.50 in / $7.50 out per 1M tokens (list price from 1 Jan 2027 as reported by price trackers; introductory price until then is half) · ₹88 = $1 (assumption) · Estimates are labelled</a:t>
             </a:r>
           </a:p>
         </p:txBody>
@@ -8220,7 +8288,7 @@
         <p:spPr>
           <a:xfrm>
             <a:off x="309975" y="1115568"/>
-            <a:ext cx="1499984" cy="3246120"/>
+            <a:ext cx="1501330" cy="3246120"/>
           </a:xfrm>
           <a:prstGeom prst="rect">
             <a:avLst/>
@@ -8241,7 +8309,7 @@
         <p:spPr>
           <a:xfrm>
             <a:off x="172815" y="4398264"/>
-            <a:ext cx="1774304" cy="274320"/>
+            <a:ext cx="1775650" cy="274320"/>
           </a:xfrm>
           <a:prstGeom prst="rect">
             <a:avLst/>
@@ -8266,7 +8334,7 @@
                 </a:solidFill>
                 <a:latin typeface="Google Sans Flex"/>
               </a:rPr>
-              <a:t>“Is this post safe?”</a:t>
+              <a:t>Seller analytics</a:t>
             </a:r>
           </a:p>
         </p:txBody>
@@ -8288,7 +8356,7 @@
         <p:spPr>
           <a:xfrm>
             <a:off x="2065991" y="1115568"/>
-            <a:ext cx="1499984" cy="3246120"/>
+            <a:ext cx="1501330" cy="3246120"/>
           </a:xfrm>
           <a:prstGeom prst="rect">
             <a:avLst/>
@@ -8309,7 +8377,7 @@
         <p:spPr>
           <a:xfrm>
             <a:off x="1928831" y="4398264"/>
-            <a:ext cx="1774304" cy="274320"/>
+            <a:ext cx="1775650" cy="274320"/>
           </a:xfrm>
           <a:prstGeom prst="rect">
             <a:avLst/>
@@ -8334,7 +8402,7 @@
                 </a:solidFill>
                 <a:latin typeface="Google Sans Flex"/>
               </a:rPr>
-              <a:t>Protected species: blocked</a:t>
+              <a:t>Verified breeder</a:t>
             </a:r>
           </a:p>
         </p:txBody>
@@ -8356,7 +8424,7 @@
         <p:spPr>
           <a:xfrm>
             <a:off x="3822007" y="1115568"/>
-            <a:ext cx="1499984" cy="3246120"/>
+            <a:ext cx="1501330" cy="3246120"/>
           </a:xfrm>
           <a:prstGeom prst="rect">
             <a:avLst/>
@@ -8377,7 +8445,7 @@
         <p:spPr>
           <a:xfrm>
             <a:off x="3684847" y="4398264"/>
-            <a:ext cx="1774304" cy="274320"/>
+            <a:ext cx="1775650" cy="274320"/>
           </a:xfrm>
           <a:prstGeom prst="rect">
             <a:avLst/>
@@ -8402,7 +8470,7 @@
                 </a:solidFill>
                 <a:latin typeface="Google Sans Flex"/>
               </a:rPr>
-              <a:t>Seller dashboard</a:t>
+              <a:t>Protected species: blocked</a:t>
             </a:r>
           </a:p>
         </p:txBody>
@@ -8424,7 +8492,7 @@
         <p:spPr>
           <a:xfrm>
             <a:off x="5578024" y="1115568"/>
-            <a:ext cx="1499984" cy="3246120"/>
+            <a:ext cx="1501330" cy="3246120"/>
           </a:xfrm>
           <a:prstGeom prst="rect">
             <a:avLst/>
@@ -8445,7 +8513,7 @@
         <p:spPr>
           <a:xfrm>
             <a:off x="5440864" y="4398264"/>
-            <a:ext cx="1774304" cy="274320"/>
+            <a:ext cx="1775650" cy="274320"/>
           </a:xfrm>
           <a:prstGeom prst="rect">
             <a:avLst/>
@@ -8470,7 +8538,7 @@
                 </a:solidFill>
                 <a:latin typeface="Google Sans Flex"/>
               </a:rPr>
-              <a:t>AI-drafted reply</a:t>
+              <a:t>“Is this post safe?”</a:t>
             </a:r>
           </a:p>
         </p:txBody>
@@ -8492,7 +8560,7 @@
         <p:spPr>
           <a:xfrm>
             <a:off x="7334040" y="1115568"/>
-            <a:ext cx="1499984" cy="3246120"/>
+            <a:ext cx="1501330" cy="3246120"/>
           </a:xfrm>
           <a:prstGeom prst="rect">
             <a:avLst/>
@@ -8513,7 +8581,7 @@
         <p:spPr>
           <a:xfrm>
             <a:off x="7196880" y="4398264"/>
-            <a:ext cx="1774304" cy="274320"/>
+            <a:ext cx="1775650" cy="274320"/>
           </a:xfrm>
           <a:prstGeom prst="rect">
             <a:avLst/>
@@ -8538,7 +8606,7 @@
                 </a:solidFill>
                 <a:latin typeface="Google Sans Flex"/>
               </a:rPr>
-              <a:t>14-day care plan</a:t>
+              <a:t>Symptom urgency, no doses</a:t>
             </a:r>
           </a:p>
         </p:txBody>
@@ -8747,13 +8815,13 @@
                     <a:lstStyle/>
                     <a:p>
                       <a:r>
-                        <a:rPr sz="830">
+                        <a:rPr sz="819">
                           <a:solidFill>
                             <a:srgbClr val="FFFFFF"/>
                           </a:solidFill>
                           <a:latin typeface="Google Sans Flex SemiBold"/>
                         </a:rPr>
-                        <a:t>Quality (real Gemini, 10 Oct 2026)</a:t>
+                        <a:t>Quality (real Gemini, 10–11 Oct 2026)</a:t>
                       </a:r>
                     </a:p>
                   </a:txBody>
@@ -8769,7 +8837,7 @@
                     <a:lstStyle/>
                     <a:p>
                       <a:r>
-                        <a:rPr sz="830">
+                        <a:rPr sz="819">
                           <a:solidFill>
                             <a:srgbClr val="FFFFFF"/>
                           </a:solidFill>
@@ -8793,13 +8861,13 @@
                     <a:lstStyle/>
                     <a:p>
                       <a:r>
-                        <a:rPr sz="830">
+                        <a:rPr sz="819">
                           <a:solidFill>
                             <a:srgbClr val="1D1D1F"/>
                           </a:solidFill>
                           <a:latin typeface="Google Sans Flex"/>
                         </a:rPr>
-                        <a:t>Agent evals: 18 cases × 3 runs (listing, Tamil, blocking, scams, reused photos, prompt injection, no medicine advice, roles, explanations, reply drafts)</a:t>
+                        <a:t>Agent evals: 22 cases × 3 runs (listing, Tamil, blocking, scams, reused photos, prompt injection, no medicine advice, roles, verification, visits, care companion)</a:t>
                       </a:r>
                     </a:p>
                   </a:txBody>
@@ -8815,13 +8883,13 @@
                     <a:lstStyle/>
                     <a:p>
                       <a:r>
-                        <a:rPr sz="830">
+                        <a:rPr sz="819">
                           <a:solidFill>
                             <a:srgbClr val="1F6E43"/>
                           </a:solidFill>
                           <a:latin typeface="Google Sans Flex SemiBold"/>
                         </a:rPr>
-                        <a:t>54/54 passed</a:t>
+                        <a:t>66/66 passed</a:t>
                       </a:r>
                     </a:p>
                   </a:txBody>
@@ -8839,7 +8907,7 @@
                     <a:lstStyle/>
                     <a:p>
                       <a:r>
-                        <a:rPr sz="830">
+                        <a:rPr sz="819">
                           <a:solidFill>
                             <a:srgbClr val="1D1D1F"/>
                           </a:solidFill>
@@ -8861,7 +8929,7 @@
                     <a:lstStyle/>
                     <a:p>
                       <a:r>
-                        <a:rPr sz="830">
+                        <a:rPr sz="819">
                           <a:solidFill>
                             <a:srgbClr val="1F6E43"/>
                           </a:solidFill>
@@ -8885,7 +8953,7 @@
                     <a:lstStyle/>
                     <a:p>
                       <a:r>
-                        <a:rPr sz="830">
+                        <a:rPr sz="819">
                           <a:solidFill>
                             <a:srgbClr val="1D1D1F"/>
                           </a:solidFill>
@@ -8907,7 +8975,7 @@
                     <a:lstStyle/>
                     <a:p>
                       <a:r>
-                        <a:rPr sz="830">
+                        <a:rPr sz="819">
                           <a:solidFill>
                             <a:srgbClr val="1F6E43"/>
                           </a:solidFill>
@@ -8931,7 +8999,7 @@
                     <a:lstStyle/>
                     <a:p>
                       <a:r>
-                        <a:rPr sz="830">
+                        <a:rPr sz="819">
                           <a:solidFill>
                             <a:srgbClr val="1D1D1F"/>
                           </a:solidFill>
@@ -8953,7 +9021,7 @@
                     <a:lstStyle/>
                     <a:p>
                       <a:r>
-                        <a:rPr sz="830">
+                        <a:rPr sz="819">
                           <a:solidFill>
                             <a:srgbClr val="1D1D1F"/>
                           </a:solidFill>
@@ -8977,13 +9045,13 @@
                     <a:lstStyle/>
                     <a:p>
                       <a:r>
-                        <a:rPr sz="830">
+                        <a:rPr sz="819">
                           <a:solidFill>
                             <a:srgbClr val="1D1D1F"/>
                           </a:solidFill>
                           <a:latin typeface="Google Sans Flex"/>
                         </a:rPr>
-                        <a:t>Accessibility: axe-core, WCAG 2.2 AA, light + dark, 320–1280 px</a:t>
+                        <a:t>Accessibility: axe-core, WCAG 2.2 AA, light + dark, 320–1280 px, all screens</a:t>
                       </a:r>
                     </a:p>
                   </a:txBody>
@@ -8999,7 +9067,7 @@
                     <a:lstStyle/>
                     <a:p>
                       <a:r>
-                        <a:rPr sz="830">
+                        <a:rPr sz="819">
                           <a:solidFill>
                             <a:srgbClr val="1F6E43"/>
                           </a:solidFill>
@@ -9023,7 +9091,7 @@
                     <a:lstStyle/>
                     <a:p>
                       <a:r>
-                        <a:rPr sz="830">
+                        <a:rPr sz="819">
                           <a:solidFill>
                             <a:srgbClr val="1D1D1F"/>
                           </a:solidFill>
@@ -9045,13 +9113,13 @@
                     <a:lstStyle/>
                     <a:p>
                       <a:r>
-                        <a:rPr sz="830">
+                        <a:rPr sz="819">
                           <a:solidFill>
                             <a:srgbClr val="1D1D1F"/>
                           </a:solidFill>
                           <a:latin typeface="Google Sans Flex SemiBold"/>
                         </a:rPr>
-                        <a:t>249 · 17/17</a:t>
+                        <a:t>317 · 17/17</a:t>
                       </a:r>
                     </a:p>
                   </a:txBody>
@@ -9095,7 +9163,7 @@
                     <a:lstStyle/>
                     <a:p>
                       <a:r>
-                        <a:rPr sz="830">
+                        <a:rPr sz="819">
                           <a:solidFill>
                             <a:srgbClr val="FFFFFF"/>
                           </a:solidFill>
@@ -9117,7 +9185,7 @@
                     <a:lstStyle/>
                     <a:p>
                       <a:r>
-                        <a:rPr sz="830">
+                        <a:rPr sz="819">
                           <a:solidFill>
                             <a:srgbClr val="FFFFFF"/>
                           </a:solidFill>
@@ -9141,7 +9209,7 @@
                     <a:lstStyle/>
                     <a:p>
                       <a:r>
-                        <a:rPr sz="830">
+                        <a:rPr sz="819">
                           <a:solidFill>
                             <a:srgbClr val="1D1D1F"/>
                           </a:solidFill>
@@ -9163,7 +9231,7 @@
                     <a:lstStyle/>
                     <a:p>
                       <a:r>
-                        <a:rPr sz="830">
+                        <a:rPr sz="819">
                           <a:solidFill>
                             <a:srgbClr val="1D1D1F"/>
                           </a:solidFill>
@@ -9187,7 +9255,7 @@
                     <a:lstStyle/>
                     <a:p>
                       <a:r>
-                        <a:rPr sz="830">
+                        <a:rPr sz="819">
                           <a:solidFill>
                             <a:srgbClr val="1D1D1F"/>
                           </a:solidFill>
@@ -9209,7 +9277,7 @@
                     <a:lstStyle/>
                     <a:p>
                       <a:r>
-                        <a:rPr sz="830">
+                        <a:rPr sz="819">
                           <a:solidFill>
                             <a:srgbClr val="1D1D1F"/>
                           </a:solidFill>
@@ -9233,7 +9301,7 @@
                     <a:lstStyle/>
                     <a:p>
                       <a:r>
-                        <a:rPr sz="830">
+                        <a:rPr sz="819">
                           <a:solidFill>
                             <a:srgbClr val="1D1D1F"/>
                           </a:solidFill>
@@ -9255,7 +9323,7 @@
                     <a:lstStyle/>
                     <a:p>
                       <a:r>
-                        <a:rPr sz="830">
+                        <a:rPr sz="819">
                           <a:solidFill>
                             <a:srgbClr val="1D1D1F"/>
                           </a:solidFill>
@@ -9279,13 +9347,13 @@
                     <a:lstStyle/>
                     <a:p>
                       <a:r>
-                        <a:rPr sz="830">
+                        <a:rPr sz="819">
                           <a:solidFill>
                             <a:srgbClr val="1D1D1F"/>
                           </a:solidFill>
                           <a:latin typeface="Google Sans Flex"/>
                         </a:rPr>
-                        <a:t>Gemini: extract a listing</a:t>
+                        <a:t>Gemini: read a certificate · scan a message</a:t>
                       </a:r>
                     </a:p>
                   </a:txBody>
@@ -9301,13 +9369,13 @@
                     <a:lstStyle/>
                     <a:p>
                       <a:r>
-                        <a:rPr sz="830">
+                        <a:rPr sz="819">
                           <a:solidFill>
                             <a:srgbClr val="1D1D1F"/>
                           </a:solidFill>
                           <a:latin typeface="Google Sans Flex"/>
                         </a:rPr>
-                        <a:t>3–7 s</a:t>
+                        <a:t>≈ 4.5 s · ≈ 2 s</a:t>
                       </a:r>
                     </a:p>
                   </a:txBody>
@@ -9325,13 +9393,13 @@
                     <a:lstStyle/>
                     <a:p>
                       <a:r>
-                        <a:rPr sz="830">
+                        <a:rPr sz="819">
                           <a:solidFill>
                             <a:srgbClr val="1D1D1F"/>
                           </a:solidFill>
                           <a:latin typeface="Google Sans Flex"/>
                         </a:rPr>
-                        <a:t>Gemini: screen a photo</a:t>
+                        <a:t>Gemini: symptom urgency · daily-log feedback</a:t>
                       </a:r>
                     </a:p>
                   </a:txBody>
@@ -9347,13 +9415,13 @@
                     <a:lstStyle/>
                     <a:p>
                       <a:r>
-                        <a:rPr sz="830">
+                        <a:rPr sz="819">
                           <a:solidFill>
                             <a:srgbClr val="1D1D1F"/>
                           </a:solidFill>
                           <a:latin typeface="Google Sans Flex"/>
                         </a:rPr>
-                        <a:t>4–5 s</a:t>
+                        <a:t>≈ 8 s</a:t>
                       </a:r>
                     </a:p>
                   </a:txBody>
@@ -9418,7 +9486,7 @@
                 </a:solidFill>
                 <a:latin typeface="Google Sans Flex"/>
               </a:rPr>
-              <a:t>Gemini isn’t deterministic, so each eval runs three times and we report the count. Trust decisions are made by tested code, so the model can’t be talked out of them.</a:t>
+              <a:t>Gemini isn’t deterministic, so each eval runs three times and we report the count. Decisions (trust, verification, match %, urgency floor) are made by tested code.</a:t>
             </a:r>
           </a:p>
         </p:txBody>
@@ -9726,7 +9794,7 @@
               <a:buChar char="•"/>
             </a:pPr>
             <a:r>
-              <a:rPr sz="1080" i="0">
+              <a:rPr sz="1040" i="0">
                 <a:solidFill>
                   <a:srgbClr val="1D1D1F"/>
                 </a:solidFill>
@@ -9743,12 +9811,29 @@
               <a:buChar char="•"/>
             </a:pPr>
             <a:r>
-              <a:rPr sz="1080" i="0">
+              <a:rPr sz="1040" i="0">
                 <a:solidFill>
                   <a:srgbClr val="1D1D1F"/>
                 </a:solidFill>
                 <a:latin typeface="Google Sans Flex"/>
               </a:rPr>
+              <a:t>Real SMS and email delivery for one-time codes</a:t>
+            </a:r>
+          </a:p>
+          <a:p>
+            <a:pPr algn="l" marL="146304" indent="-128016">
+              <a:spcAft>
+                <a:spcPts val="300"/>
+              </a:spcAft>
+              <a:buChar char="•"/>
+            </a:pPr>
+            <a:r>
+              <a:rPr sz="1040" i="0">
+                <a:solidFill>
+                  <a:srgbClr val="1D1D1F"/>
+                </a:solidFill>
+                <a:latin typeface="Google Sans Flex"/>
+              </a:rPr>
               <a:t>List by sending a WhatsApp message (WhatsApp Business Platform)</a:t>
             </a:r>
           </a:p>
@@ -9760,7 +9845,7 @@
               <a:buChar char="•"/>
             </a:pPr>
             <a:r>
-              <a:rPr sz="1080" i="0">
+              <a:rPr sz="1040" i="0">
                 <a:solidFill>
                   <a:srgbClr val="1D1D1F"/>
                 </a:solidFill>
@@ -9777,7 +9862,7 @@
               <a:buChar char="•"/>
             </a:pPr>
             <a:r>
-              <a:rPr sz="1080" i="0">
+              <a:rPr sz="1040" i="0">
                 <a:solidFill>
                   <a:srgbClr val="1D1D1F"/>
                 </a:solidFill>
@@ -9794,30 +9879,13 @@
               <a:buChar char="•"/>
             </a:pPr>
             <a:r>
-              <a:rPr sz="1080" i="0">
+              <a:rPr sz="1040" i="0">
                 <a:solidFill>
                   <a:srgbClr val="1D1D1F"/>
                 </a:solidFill>
                 <a:latin typeface="Google Sans Flex"/>
               </a:rPr>
-              <a:t>Breeder ratings from buyer feedback and the pet’s health after sale</a:t>
-            </a:r>
-          </a:p>
-          <a:p>
-            <a:pPr algn="l" marL="146304" indent="-128016">
-              <a:spcAft>
-                <a:spcPts val="300"/>
-              </a:spcAft>
-              <a:buChar char="•"/>
-            </a:pPr>
-            <a:r>
-              <a:rPr sz="1080" i="0">
-                <a:solidFill>
-                  <a:srgbClr val="1D1D1F"/>
-                </a:solidFill>
-                <a:latin typeface="Google Sans Flex"/>
-              </a:rPr>
-              <a:t>Hindi, Telugu, Kannada and more districts; vet and pet-pharmacy partners</a:t>
+              <a:t>Breeder ratings from buyers’ care-companion outcomes; vet and pet-pharmacy partners; more languages</a:t>
             </a:r>
           </a:p>
         </p:txBody>
@@ -9911,7 +9979,7 @@
               <a:buChar char="•"/>
             </a:pPr>
             <a:r>
-              <a:rPr sz="1080" i="0">
+              <a:rPr sz="1040" i="0">
                 <a:solidFill>
                   <a:srgbClr val="1D1D1F"/>
                 </a:solidFill>
@@ -9928,7 +9996,7 @@
               <a:buChar char="•"/>
             </a:pPr>
             <a:r>
-              <a:rPr sz="1080" i="0">
+              <a:rPr sz="1040" i="0">
                 <a:solidFill>
                   <a:srgbClr val="1D1D1F"/>
                 </a:solidFill>
@@ -9945,13 +10013,13 @@
               <a:buChar char="•"/>
             </a:pPr>
             <a:r>
-              <a:rPr sz="1080" i="0">
+              <a:rPr sz="1040" i="0">
                 <a:solidFill>
                   <a:srgbClr val="1D1D1F"/>
                 </a:solidFill>
                 <a:latin typeface="Google Sans Flex"/>
               </a:rPr>
-              <a:t>Health signs are “ask the seller”, never a diagnosis</a:t>
+              <a:t>Verification without ID documents or selfies; photos deleted once read</a:t>
             </a:r>
           </a:p>
           <a:p>
@@ -9962,13 +10030,13 @@
               <a:buChar char="•"/>
             </a:pPr>
             <a:r>
-              <a:rPr sz="1080" i="0">
+              <a:rPr sz="1040" i="0">
                 <a:solidFill>
                   <a:srgbClr val="1D1D1F"/>
                 </a:solidFill>
                 <a:latin typeface="Google Sans Flex"/>
               </a:rPr>
-              <a:t>No addresses, ID documents or payment details collected; sellers never see buyers’ logins</a:t>
+              <a:t>Codes shown on screen only open new or demo accounts, never someone else’s</a:t>
             </a:r>
           </a:p>
           <a:p>
@@ -9979,7 +10047,24 @@
               <a:buChar char="•"/>
             </a:pPr>
             <a:r>
-              <a:rPr sz="1080" i="0">
+              <a:rPr sz="1040" i="0">
+                <a:solidFill>
+                  <a:srgbClr val="1D1D1F"/>
+                </a:solidFill>
+                <a:latin typeface="Google Sans Flex"/>
+              </a:rPr>
+              <a:t>Symptom checker: red flags are always an emergency; never a diagnosis</a:t>
+            </a:r>
+          </a:p>
+          <a:p>
+            <a:pPr algn="l" marL="146304" indent="-128016">
+              <a:spcAft>
+                <a:spcPts val="300"/>
+              </a:spcAft>
+              <a:buChar char="•"/>
+            </a:pPr>
+            <a:r>
+              <a:rPr sz="1040" i="0">
                 <a:solidFill>
                   <a:srgbClr val="1D1D1F"/>
                 </a:solidFill>
@@ -11689,7 +11774,7 @@
                 </a:solidFill>
                 <a:latin typeface="Google Sans Flex"/>
               </a:rPr>
-              <a:t>A breeder-to-buyer pet marketplace where every listing is screened by Gemini and by rules in code before any buyer sees it.</a:t>
+              <a:t>A breeder-to-buyer pet marketplace where every listing is screened by Gemini and rules in code before any buyer sees it, and breeders can earn a Verified badge.</a:t>
             </a:r>
           </a:p>
           <a:p>
@@ -11723,7 +11808,7 @@
                 </a:solidFill>
                 <a:latin typeface="Google Sans Flex"/>
               </a:rPr>
-              <a:t>Buyers find trusted pets nearby at fair prices, then get a welfare-sized starter kit and a 14-day care plan.</a:t>
+              <a:t>Buyers see a match % for their home, book a visit, pay in person, then get a care companion for the pet at home.</a:t>
             </a:r>
           </a:p>
           <a:p>
@@ -12618,11 +12703,11 @@
         <p:spPr>
           <a:xfrm>
             <a:off x="320040" y="1115568"/>
-            <a:ext cx="4114800" cy="2514600"/>
+            <a:ext cx="4114800" cy="2697480"/>
           </a:xfrm>
           <a:prstGeom prst="roundRect">
             <a:avLst>
-              <a:gd name="adj" fmla="val 2909"/>
+              <a:gd name="adj" fmla="val 2711"/>
             </a:avLst>
           </a:prstGeom>
           <a:solidFill>
@@ -12662,7 +12747,7 @@
         <p:spPr>
           <a:xfrm>
             <a:off x="411479" y="1188720"/>
-            <a:ext cx="3931920" cy="2404872"/>
+            <a:ext cx="3931920" cy="2587752"/>
           </a:xfrm>
           <a:prstGeom prst="rect">
             <a:avLst/>
@@ -12698,13 +12783,13 @@
               <a:buChar char="•"/>
             </a:pPr>
             <a:r>
-              <a:rPr sz="1060" i="0">
+              <a:rPr sz="1019" i="0">
                 <a:solidFill>
                   <a:srgbClr val="1D1D1F"/>
                 </a:solidFill>
                 <a:latin typeface="Google Sans Flex"/>
               </a:rPr>
-              <a:t>Pets near me: trusted first, distance, fair-price bar</a:t>
+              <a:t>Pets near me with a match % for your home, trusted first, fair-price bar</a:t>
             </a:r>
           </a:p>
           <a:p>
@@ -12715,7 +12800,7 @@
               <a:buChar char="•"/>
             </a:pPr>
             <a:r>
-              <a:rPr sz="1060" i="0">
+              <a:rPr sz="1019" i="0">
                 <a:solidFill>
                   <a:srgbClr val="1D1D1F"/>
                 </a:solidFill>
@@ -12732,13 +12817,13 @@
               <a:buChar char="•"/>
             </a:pPr>
             <a:r>
-              <a:rPr sz="1060" i="0">
+              <a:rPr sz="1019" i="0">
                 <a:solidFill>
                   <a:srgbClr val="1D1D1F"/>
                 </a:solidFill>
                 <a:latin typeface="Google Sans Flex"/>
               </a:rPr>
-              <a:t>“Which pet suits me?” quiz: home, family, time, budget</a:t>
+              <a:t>AI-drafted first message; scam warnings on replies</a:t>
             </a:r>
           </a:p>
           <a:p>
@@ -12749,13 +12834,13 @@
               <a:buChar char="•"/>
             </a:pPr>
             <a:r>
-              <a:rPr sz="1060" i="0">
+              <a:rPr sz="1019" i="0">
                 <a:solidFill>
                   <a:srgbClr val="1D1D1F"/>
                 </a:solidFill>
                 <a:latin typeface="Google Sans Flex"/>
               </a:rPr>
-              <a:t>“Is this post safe?” for WhatsApp or Instagram posts</a:t>
+              <a:t>Book a visit; “I bought this pet” after it (paid in person)</a:t>
             </a:r>
           </a:p>
           <a:p>
@@ -12766,13 +12851,13 @@
               <a:buChar char="•"/>
             </a:pPr>
             <a:r>
-              <a:rPr sz="1060" i="0">
+              <a:rPr sz="1019" i="0">
                 <a:solidFill>
                   <a:srgbClr val="1D1D1F"/>
                 </a:solidFill>
                 <a:latin typeface="Google Sans Flex"/>
               </a:rPr>
-              <a:t>Contact the breeder; replies appear under Account</a:t>
+              <a:t>My pets: daily log with AI feedback, growth, health calendar</a:t>
             </a:r>
           </a:p>
           <a:p>
@@ -12783,13 +12868,13 @@
               <a:buChar char="•"/>
             </a:pPr>
             <a:r>
-              <a:rPr sz="1060" i="0">
+              <a:rPr sz="1019" i="0">
                 <a:solidFill>
                   <a:srgbClr val="1D1D1F"/>
                 </a:solidFill>
                 <a:latin typeface="Google Sans Flex"/>
               </a:rPr>
-              <a:t>Welfare-sized starter kit, 14-day care plan with vet warning signs</a:t>
+              <a:t>Symptom checker: how urgently to see a vet (never medicines)</a:t>
             </a:r>
           </a:p>
           <a:p>
@@ -12800,13 +12885,13 @@
               <a:buChar char="•"/>
             </a:pPr>
             <a:r>
-              <a:rPr sz="1060" i="0">
+              <a:rPr sz="1019" i="0">
                 <a:solidFill>
                   <a:srgbClr val="1D1D1F"/>
                 </a:solidFill>
                 <a:latin typeface="Google Sans Flex"/>
               </a:rPr>
-              <a:t>Local Breeders directory: buy direct at farm prices</a:t>
+              <a:t>“Is this post safe?”, starter kit, Local Breeders directory</a:t>
             </a:r>
           </a:p>
         </p:txBody>
@@ -12820,11 +12905,11 @@
         <p:spPr>
           <a:xfrm>
             <a:off x="4709159" y="1115568"/>
-            <a:ext cx="4114800" cy="2514600"/>
+            <a:ext cx="4114800" cy="2697480"/>
           </a:xfrm>
           <a:prstGeom prst="roundRect">
             <a:avLst>
-              <a:gd name="adj" fmla="val 2909"/>
+              <a:gd name="adj" fmla="val 2711"/>
             </a:avLst>
           </a:prstGeom>
           <a:solidFill>
@@ -12864,7 +12949,7 @@
         <p:spPr>
           <a:xfrm>
             <a:off x="4800599" y="1188720"/>
-            <a:ext cx="3931920" cy="2404872"/>
+            <a:ext cx="3931920" cy="2587752"/>
           </a:xfrm>
           <a:prstGeom prst="rect">
             <a:avLst/>
@@ -12900,7 +12985,7 @@
               <a:buChar char="•"/>
             </a:pPr>
             <a:r>
-              <a:rPr sz="1060" i="0">
+              <a:rPr sz="1019" i="0">
                 <a:solidFill>
                   <a:srgbClr val="1D1D1F"/>
                 </a:solidFill>
@@ -12917,7 +13002,7 @@
               <a:buChar char="•"/>
             </a:pPr>
             <a:r>
-              <a:rPr sz="1060" i="0">
+              <a:rPr sz="1019" i="0">
                 <a:solidFill>
                   <a:srgbClr val="1D1D1F"/>
                 </a:solidFill>
@@ -12934,13 +13019,13 @@
               <a:buChar char="•"/>
             </a:pPr>
             <a:r>
-              <a:rPr sz="1060" i="0">
+              <a:rPr sz="1019" i="0">
                 <a:solidFill>
                   <a:srgbClr val="1D1D1F"/>
                 </a:solidFill>
                 <a:latin typeface="Google Sans Flex"/>
               </a:rPr>
-              <a:t>Dashboard: live listings, views, enquiries, trust status</a:t>
+              <a:t>Dashboard charts: views, enquiries, visits, sales, funnel</a:t>
             </a:r>
           </a:p>
           <a:p>
@@ -12951,13 +13036,13 @@
               <a:buChar char="•"/>
             </a:pPr>
             <a:r>
-              <a:rPr sz="1060" i="0">
+              <a:rPr sz="1019" i="0">
                 <a:solidFill>
                   <a:srgbClr val="1D1D1F"/>
                 </a:solidFill>
                 <a:latin typeface="Google Sans Flex"/>
               </a:rPr>
-              <a:t>Manage listings: pause, resume, mark sold</a:t>
+              <a:t>Verified breeder badge: phone code, facility photos read by Gemini, dog-breeder certificate (no ID documents)</a:t>
             </a:r>
           </a:p>
           <a:p>
@@ -12968,13 +13053,13 @@
               <a:buChar char="•"/>
             </a:pPr>
             <a:r>
-              <a:rPr sz="1060" i="0">
+              <a:rPr sz="1019" i="0">
                 <a:solidFill>
                   <a:srgbClr val="1D1D1F"/>
                 </a:solidFill>
                 <a:latin typeface="Google Sans Flex"/>
               </a:rPr>
-              <a:t>Enquiries with AI-drafted replies from the listing’s facts</a:t>
+              <a:t>Visit requests to confirm; AI-drafted replies to enquiries</a:t>
             </a:r>
           </a:p>
           <a:p>
@@ -12985,13 +13070,13 @@
               <a:buChar char="•"/>
             </a:pPr>
             <a:r>
-              <a:rPr sz="1060" i="0">
+              <a:rPr sz="1019" i="0">
                 <a:solidFill>
                   <a:srgbClr val="1D1D1F"/>
                 </a:solidFill>
                 <a:latin typeface="Google Sans Flex"/>
               </a:rPr>
-              <a:t>Farm profile and dog-breeder registration (simulated registry)</a:t>
+              <a:t>Vaccination card read into the trust check</a:t>
             </a:r>
           </a:p>
         </p:txBody>
@@ -13004,12 +13089,12 @@
         </p:nvSpPr>
         <p:spPr>
           <a:xfrm>
-            <a:off x="320040" y="3767328"/>
-            <a:ext cx="8503920" cy="1051560"/>
+            <a:off x="320040" y="3904487"/>
+            <a:ext cx="8503920" cy="914400"/>
           </a:xfrm>
           <a:prstGeom prst="roundRect">
             <a:avLst>
-              <a:gd name="adj" fmla="val 6956"/>
+              <a:gd name="adj" fmla="val 8000"/>
             </a:avLst>
           </a:prstGeom>
           <a:solidFill>
@@ -13048,8 +13133,8 @@
         </p:nvSpPr>
         <p:spPr>
           <a:xfrm>
-            <a:off x="411479" y="3840480"/>
-            <a:ext cx="8321040" cy="941831"/>
+            <a:off x="411479" y="3977639"/>
+            <a:ext cx="8321040" cy="804672"/>
           </a:xfrm>
           <a:prstGeom prst="rect">
             <a:avLst/>
@@ -13068,7 +13153,7 @@
               </a:spcAft>
             </a:pPr>
             <a:r>
-              <a:rPr sz="1250" i="0">
+              <a:rPr sz="1200" i="0">
                 <a:solidFill>
                   <a:srgbClr val="1D1D1F"/>
                 </a:solidFill>
@@ -13084,43 +13169,61 @@
               </a:spcAft>
             </a:pPr>
             <a:r>
-              <a:rPr sz="1040" i="0">
+              <a:rPr sz="1000" i="0">
                 <a:solidFill>
                   <a:srgbClr val="1D1D1F"/>
                 </a:solidFill>
                 <a:latin typeface="Google Sans Flex SemiBold"/>
               </a:rPr>
-              <a:t>BreederNear AI chat</a:t>
-            </a:r>
-            <a:r>
-              <a:rPr sz="1040" i="0">
+              <a:t>Seven Gemini agents</a:t>
+            </a:r>
+            <a:r>
+              <a:rPr sz="1000" i="0">
                 <a:solidFill>
                   <a:srgbClr val="1D1D1F"/>
                 </a:solidFill>
                 <a:latin typeface="Google Sans Flex"/>
               </a:rPr>
-              <a:t> (5 Gemini agents, English or Tamil) uses the same tools as the screens.  </a:t>
-            </a:r>
-            <a:r>
-              <a:rPr sz="1040" i="0">
+              <a:t> in English or Tamil use the same tools as the screens.  </a:t>
+            </a:r>
+            <a:r>
+              <a:rPr sz="1000" i="0">
                 <a:solidFill>
                   <a:srgbClr val="1D1D1F"/>
                 </a:solidFill>
                 <a:latin typeface="Google Sans Flex SemiBold"/>
               </a:rPr>
+              <a:t>Sign-in:</a:t>
+            </a:r>
+            <a:r>
+              <a:rPr sz="1000" i="0">
+                <a:solidFill>
+                  <a:srgbClr val="1D1D1F"/>
+                </a:solidFill>
+                <a:latin typeface="Google Sans Flex"/>
+              </a:rPr>
+              <a:t> password, one-time code or Google (Firebase Authentication).  </a:t>
+            </a:r>
+            <a:r>
+              <a:rPr sz="1000" i="0">
+                <a:solidFill>
+                  <a:srgbClr val="1D1D1F"/>
+                </a:solidFill>
+                <a:latin typeface="Google Sans Flex SemiBold"/>
+              </a:rPr>
               <a:t>Safety:</a:t>
             </a:r>
             <a:r>
-              <a:rPr sz="960" i="0">
+              <a:rPr sz="1000" i="0">
                 <a:solidFill>
                   <a:srgbClr val="1D1D1F"/>
                 </a:solidFill>
                 <a:latin typeface="Google Sans Flex"/>
               </a:rPr>
-              <a:t> separate customer and seller accounts, roles checked in the API and inside the AI tools, rate limits, AI replies checked for medicine doses.  </a:t>
-            </a:r>
-            <a:r>
-              <a:rPr sz="1040" i="0">
+              <a:t> roles checked in the API and the AI tools, rate limits, every AI reply checked for medicine doses.  </a:t>
+            </a:r>
+            <a:r>
+              <a:rPr sz="1000" i="0">
                 <a:solidFill>
                   <a:srgbClr val="1D1D1F"/>
                 </a:solidFill>
@@ -13129,13 +13232,13 @@
               <a:t>Accessible:</a:t>
             </a:r>
             <a:r>
-              <a:rPr sz="1040" i="0">
+              <a:rPr sz="1000" i="0">
                 <a:solidFill>
                   <a:srgbClr val="1D1D1F"/>
                 </a:solidFill>
                 <a:latin typeface="Google Sans Flex"/>
               </a:rPr>
-              <a:t> WCAG 2.2 AA, light and dark, phone to desktop.</a:t>
+              <a:t> WCAG 2.2 AA, phone to desktop.</a:t>
             </a:r>
           </a:p>
         </p:txBody>
@@ -13718,7 +13821,7 @@
                 </a:solidFill>
                 <a:latin typeface="Google Sans Flex"/>
               </a:rPr>
-              <a:t>edit any field</a:t>
+              <a:t>+ optional vaccination card</a:t>
             </a:r>
           </a:p>
         </p:txBody>
@@ -14209,7 +14312,7 @@
                 </a:solidFill>
                 <a:latin typeface="Google Sans Flex SemiBold"/>
               </a:rPr>
-              <a:t>Browse or take the quiz</a:t>
+              <a:t>Pets with match %</a:t>
             </a:r>
           </a:p>
           <a:p>
@@ -14225,7 +14328,7 @@
                 </a:solidFill>
                 <a:latin typeface="Google Sans Flex"/>
               </a:rPr>
-              <a:t>pets near my district</a:t>
+              <a:t>rules score your home</a:t>
             </a:r>
           </a:p>
         </p:txBody>
@@ -14479,7 +14582,7 @@
                 </a:solidFill>
                 <a:latin typeface="Google Sans Flex SemiBold"/>
               </a:rPr>
-              <a:t>Contact breeder</a:t>
+              <a:t>Message the breeder</a:t>
             </a:r>
           </a:p>
           <a:p>
@@ -14495,7 +14598,7 @@
                 </a:solidFill>
                 <a:latin typeface="Google Sans Flex"/>
               </a:rPr>
-              <a:t>enquiry, no contact details</a:t>
+              <a:t>AI draft, scam shield</a:t>
             </a:r>
           </a:p>
         </p:txBody>
@@ -14614,7 +14717,7 @@
                 </a:solidFill>
                 <a:latin typeface="Google Sans Flex SemiBold"/>
               </a:rPr>
-              <a:t>Seller replies</a:t>
+              <a:t>Book a visit</a:t>
             </a:r>
           </a:p>
           <a:p>
@@ -14630,7 +14733,7 @@
                 </a:solidFill>
                 <a:latin typeface="Google Sans Flex"/>
               </a:rPr>
-              <a:t>AI draft, seller edits</a:t>
+              <a:t>seller confirms</a:t>
             </a:r>
           </a:p>
         </p:txBody>
@@ -14749,7 +14852,7 @@
                 </a:solidFill>
                 <a:latin typeface="Google Sans Flex SemiBold"/>
               </a:rPr>
-              <a:t>Visit and pay in person</a:t>
+              <a:t>See it, pay in person</a:t>
             </a:r>
           </a:p>
           <a:p>
@@ -14765,7 +14868,7 @@
                 </a:solidFill>
                 <a:latin typeface="Google Sans Flex"/>
               </a:rPr>
-              <a:t>see the parents first</a:t>
+              <a:t>“I bought this pet”</a:t>
             </a:r>
           </a:p>
         </p:txBody>
@@ -14923,7 +15026,7 @@
                 </a:solidFill>
                 <a:latin typeface="Google Sans Flex SemiBold"/>
               </a:rPr>
-              <a:t>Starter kit</a:t>
+              <a:t>My pets</a:t>
             </a:r>
           </a:p>
           <a:p>
@@ -14939,7 +15042,7 @@
                 </a:solidFill>
                 <a:latin typeface="Google Sans Flex"/>
               </a:rPr>
-              <a:t>cage sized for the animals</a:t>
+              <a:t>daily log, growth, calendar</a:t>
             </a:r>
           </a:p>
         </p:txBody>
@@ -15022,7 +15125,7 @@
                 </a:solidFill>
                 <a:latin typeface="Google Sans Flex SemiBold"/>
               </a:rPr>
-              <a:t>14-day care plan</a:t>
+              <a:t>Symptom checker</a:t>
             </a:r>
           </a:p>
           <a:p>
@@ -15038,7 +15141,7 @@
                 </a:solidFill>
                 <a:latin typeface="Google Sans Flex"/>
               </a:rPr>
-              <a:t>vet warning signs, no doses</a:t>
+              <a:t>urgency + vet, never doses</a:t>
             </a:r>
           </a:p>
         </p:txBody>
@@ -15502,7 +15605,7 @@
                 </a:solidFill>
                 <a:latin typeface="Google Sans Flex"/>
               </a:rPr>
-              <a:t>Every step works by tapping, or by asking BreederNear AI in chat: the same tools, the same checks.</a:t>
+              <a:t>Every step works by tapping, or by asking BreederNear AI in chat: the same tools, the same checks. Sellers also earn a Verified breeder badge.</a:t>
             </a:r>
           </a:p>
         </p:txBody>
@@ -15699,7 +15802,7 @@
         <p:spPr>
           <a:xfrm>
             <a:off x="309975" y="1115568"/>
-            <a:ext cx="1499984" cy="3246120"/>
+            <a:ext cx="1501330" cy="3246120"/>
           </a:xfrm>
           <a:prstGeom prst="rect">
             <a:avLst/>
@@ -15720,7 +15823,7 @@
         <p:spPr>
           <a:xfrm>
             <a:off x="172815" y="4398264"/>
-            <a:ext cx="1774304" cy="274320"/>
+            <a:ext cx="1775650" cy="274320"/>
           </a:xfrm>
           <a:prstGeom prst="rect">
             <a:avLst/>
@@ -15745,7 +15848,7 @@
                 </a:solidFill>
                 <a:latin typeface="Google Sans Flex"/>
               </a:rPr>
-              <a:t>Login: one-tap demo accounts</a:t>
+              <a:t>Sign in or one-tap demo</a:t>
             </a:r>
           </a:p>
         </p:txBody>
@@ -15767,7 +15870,7 @@
         <p:spPr>
           <a:xfrm>
             <a:off x="2065991" y="1115568"/>
-            <a:ext cx="1499984" cy="3246120"/>
+            <a:ext cx="1501330" cy="3246120"/>
           </a:xfrm>
           <a:prstGeom prst="rect">
             <a:avLst/>
@@ -15788,7 +15891,7 @@
         <p:spPr>
           <a:xfrm>
             <a:off x="1928831" y="4398264"/>
-            <a:ext cx="1774304" cy="274320"/>
+            <a:ext cx="1775650" cy="274320"/>
           </a:xfrm>
           <a:prstGeom prst="rect">
             <a:avLst/>
@@ -15813,7 +15916,7 @@
                 </a:solidFill>
                 <a:latin typeface="Google Sans Flex"/>
               </a:rPr>
-              <a:t>Pets near me</a:t>
+              <a:t>Pets with match %</a:t>
             </a:r>
           </a:p>
         </p:txBody>
@@ -15835,7 +15938,7 @@
         <p:spPr>
           <a:xfrm>
             <a:off x="3822007" y="1115568"/>
-            <a:ext cx="1499984" cy="3246120"/>
+            <a:ext cx="1501330" cy="3246120"/>
           </a:xfrm>
           <a:prstGeom prst="rect">
             <a:avLst/>
@@ -15856,7 +15959,7 @@
         <p:spPr>
           <a:xfrm>
             <a:off x="3684847" y="4398264"/>
-            <a:ext cx="1774304" cy="274320"/>
+            <a:ext cx="1775650" cy="274320"/>
           </a:xfrm>
           <a:prstGeom prst="rect">
             <a:avLst/>
@@ -15903,7 +16006,7 @@
         <p:spPr>
           <a:xfrm>
             <a:off x="5578024" y="1115568"/>
-            <a:ext cx="1499984" cy="3246120"/>
+            <a:ext cx="1501330" cy="3246120"/>
           </a:xfrm>
           <a:prstGeom prst="rect">
             <a:avLst/>
@@ -15924,7 +16027,7 @@
         <p:spPr>
           <a:xfrm>
             <a:off x="5440864" y="4398264"/>
-            <a:ext cx="1774304" cy="274320"/>
+            <a:ext cx="1775650" cy="274320"/>
           </a:xfrm>
           <a:prstGeom prst="rect">
             <a:avLst/>
@@ -15949,7 +16052,7 @@
                 </a:solidFill>
                 <a:latin typeface="Google Sans Flex"/>
               </a:rPr>
-              <a:t>Welfare-sized kit</a:t>
+              <a:t>Visits, then “I bought it”</a:t>
             </a:r>
           </a:p>
         </p:txBody>
@@ -15971,7 +16074,7 @@
         <p:spPr>
           <a:xfrm>
             <a:off x="7334040" y="1115568"/>
-            <a:ext cx="1499984" cy="3246120"/>
+            <a:ext cx="1501330" cy="3246120"/>
           </a:xfrm>
           <a:prstGeom prst="rect">
             <a:avLst/>
@@ -15992,7 +16095,7 @@
         <p:spPr>
           <a:xfrm>
             <a:off x="7196880" y="4398264"/>
-            <a:ext cx="1774304" cy="274320"/>
+            <a:ext cx="1775650" cy="274320"/>
           </a:xfrm>
           <a:prstGeom prst="rect">
             <a:avLst/>
@@ -16017,7 +16120,7 @@
                 </a:solidFill>
                 <a:latin typeface="Google Sans Flex"/>
               </a:rPr>
-              <a:t>AI buyer guide</a:t>
+              <a:t>My pets companion</a:t>
             </a:r>
           </a:p>
         </p:txBody>
@@ -16205,12 +16308,12 @@
         </p:nvSpPr>
         <p:spPr>
           <a:xfrm>
-            <a:off x="320040" y="1234440"/>
-            <a:ext cx="1234440" cy="566928"/>
+            <a:off x="320040" y="1188720"/>
+            <a:ext cx="1234440" cy="530352"/>
           </a:xfrm>
           <a:prstGeom prst="roundRect">
             <a:avLst>
-              <a:gd name="adj" fmla="val 11290"/>
+              <a:gd name="adj" fmla="val 12068"/>
             </a:avLst>
           </a:prstGeom>
           <a:solidFill>
@@ -16249,8 +16352,8 @@
         </p:nvSpPr>
         <p:spPr>
           <a:xfrm>
-            <a:off x="356615" y="1234440"/>
-            <a:ext cx="1161288" cy="566928"/>
+            <a:off x="356615" y="1188720"/>
+            <a:ext cx="1161288" cy="530352"/>
           </a:xfrm>
           <a:prstGeom prst="rect">
             <a:avLst/>
@@ -16304,12 +16407,12 @@
         </p:nvSpPr>
         <p:spPr>
           <a:xfrm>
-            <a:off x="320040" y="2148840"/>
-            <a:ext cx="1234440" cy="731520"/>
+            <a:off x="320040" y="1965960"/>
+            <a:ext cx="1234440" cy="658368"/>
           </a:xfrm>
           <a:prstGeom prst="roundRect">
             <a:avLst>
-              <a:gd name="adj" fmla="val 8750"/>
+              <a:gd name="adj" fmla="val 9722"/>
             </a:avLst>
           </a:prstGeom>
           <a:solidFill>
@@ -16348,8 +16451,8 @@
         </p:nvSpPr>
         <p:spPr>
           <a:xfrm>
-            <a:off x="356615" y="2148840"/>
-            <a:ext cx="1161288" cy="731520"/>
+            <a:off x="356615" y="1965960"/>
+            <a:ext cx="1161288" cy="658368"/>
           </a:xfrm>
           <a:prstGeom prst="rect">
             <a:avLst/>
@@ -16395,16 +16498,115 @@
           </a:p>
         </p:txBody>
       </p:sp>
+      <p:sp>
+        <p:nvSpPr>
+          <p:cNvPr id="116" name="Rounded Rectangle 115"/>
+          <p:cNvSpPr/>
+          <p:nvPr/>
+        </p:nvSpPr>
+        <p:spPr>
+          <a:xfrm>
+            <a:off x="320040" y="2834640"/>
+            <a:ext cx="1234440" cy="658368"/>
+          </a:xfrm>
+          <a:prstGeom prst="roundRect">
+            <a:avLst>
+              <a:gd name="adj" fmla="val 9722"/>
+            </a:avLst>
+          </a:prstGeom>
+          <a:solidFill>
+            <a:srgbClr val="FBEFD9"/>
+          </a:solidFill>
+          <a:ln>
+            <a:noFill/>
+          </a:ln>
+          <a:effectLst/>
+        </p:spPr>
+        <p:style>
+          <a:lnRef idx="1">
+            <a:schemeClr val="accent1"/>
+          </a:lnRef>
+          <a:fillRef idx="3">
+            <a:schemeClr val="accent1"/>
+          </a:fillRef>
+          <a:effectRef idx="2">
+            <a:schemeClr val="accent1"/>
+          </a:effectRef>
+          <a:fontRef idx="minor">
+            <a:schemeClr val="lt1"/>
+          </a:fontRef>
+        </p:style>
+        <p:txBody>
+          <a:bodyPr rtlCol="0" anchor="ctr"/>
+          <a:lstStyle/>
+          <a:p/>
+        </p:txBody>
+      </p:sp>
+      <p:sp>
+        <p:nvSpPr>
+          <p:cNvPr id="117" name="TextBox 116"/>
+          <p:cNvSpPr txBox="1"/>
+          <p:nvPr/>
+        </p:nvSpPr>
+        <p:spPr>
+          <a:xfrm>
+            <a:off x="356615" y="2834640"/>
+            <a:ext cx="1161288" cy="658368"/>
+          </a:xfrm>
+          <a:prstGeom prst="rect">
+            <a:avLst/>
+          </a:prstGeom>
+          <a:noFill/>
+        </p:spPr>
+        <p:txBody>
+          <a:bodyPr wrap="square" anchor="ctr" lIns="36576" rIns="36576" tIns="18288" bIns="18288">
+            <a:spAutoFit/>
+          </a:bodyPr>
+          <a:lstStyle/>
+          <a:p>
+            <a:pPr algn="ctr">
+              <a:spcAft>
+                <a:spcPts val="100"/>
+              </a:spcAft>
+            </a:pPr>
+            <a:r>
+              <a:rPr sz="950" i="0">
+                <a:solidFill>
+                  <a:srgbClr val="9A5700"/>
+                </a:solidFill>
+                <a:latin typeface="Google Sans Flex SemiBold"/>
+              </a:rPr>
+              <a:t>Firebase Auth</a:t>
+            </a:r>
+          </a:p>
+          <a:p>
+            <a:pPr algn="ctr">
+              <a:spcAft>
+                <a:spcPts val="0"/>
+              </a:spcAft>
+            </a:pPr>
+            <a:r>
+              <a:rPr sz="800" i="0">
+                <a:solidFill>
+                  <a:srgbClr val="5F5F64"/>
+                </a:solidFill>
+                <a:latin typeface="Google Sans Flex"/>
+              </a:rPr>
+              <a:t>Google sign-in (ID token)</a:t>
+            </a:r>
+          </a:p>
+        </p:txBody>
+      </p:sp>
       <p:cxnSp>
         <p:nvCxnSpPr>
-          <p:cNvPr id="116" name="Connector 115"/>
+          <p:cNvPr id="118" name="Connector 117"/>
           <p:cNvCxnSpPr/>
           <p:nvPr/>
         </p:nvCxnSpPr>
         <p:spPr>
           <a:xfrm>
-            <a:off x="932688" y="1801368"/>
-            <a:ext cx="0" cy="347472"/>
+            <a:off x="932688" y="1719072"/>
+            <a:ext cx="0" cy="246888"/>
           </a:xfrm>
           <a:prstGeom prst="line">
             <a:avLst/>
@@ -16433,18 +16635,18 @@
       </p:cxnSp>
       <p:sp>
         <p:nvSpPr>
-          <p:cNvPr id="117" name="Rounded Rectangle 116"/>
+          <p:cNvPr id="119" name="Rounded Rectangle 118"/>
           <p:cNvSpPr/>
           <p:nvPr/>
         </p:nvSpPr>
         <p:spPr>
           <a:xfrm>
             <a:off x="1920240" y="1143000"/>
-            <a:ext cx="4206240" cy="3429000"/>
+            <a:ext cx="4206240" cy="3474720"/>
           </a:xfrm>
           <a:prstGeom prst="roundRect">
             <a:avLst>
-              <a:gd name="adj" fmla="val 2666"/>
+              <a:gd name="adj" fmla="val 2631"/>
             </a:avLst>
           </a:prstGeom>
           <a:solidFill>
@@ -16479,7 +16681,7 @@
       </p:sp>
       <p:sp>
         <p:nvSpPr>
-          <p:cNvPr id="118" name="TextBox 117"/>
+          <p:cNvPr id="120" name="TextBox 119"/>
           <p:cNvSpPr txBox="1"/>
           <p:nvPr/>
         </p:nvSpPr>
@@ -16518,18 +16720,18 @@
       </p:sp>
       <p:sp>
         <p:nvSpPr>
-          <p:cNvPr id="119" name="Rounded Rectangle 118"/>
+          <p:cNvPr id="121" name="Rounded Rectangle 120"/>
           <p:cNvSpPr/>
           <p:nvPr/>
         </p:nvSpPr>
         <p:spPr>
           <a:xfrm>
-            <a:off x="2057400" y="1490472"/>
-            <a:ext cx="3931920" cy="384048"/>
+            <a:off x="2057400" y="1472184"/>
+            <a:ext cx="3931920" cy="365760"/>
           </a:xfrm>
           <a:prstGeom prst="roundRect">
             <a:avLst>
-              <a:gd name="adj" fmla="val 16666"/>
+              <a:gd name="adj" fmla="val 17500"/>
             </a:avLst>
           </a:prstGeom>
           <a:solidFill>
@@ -16562,14 +16764,14 @@
       </p:sp>
       <p:sp>
         <p:nvSpPr>
-          <p:cNvPr id="120" name="TextBox 119"/>
+          <p:cNvPr id="122" name="TextBox 121"/>
           <p:cNvSpPr txBox="1"/>
           <p:nvPr/>
         </p:nvSpPr>
         <p:spPr>
           <a:xfrm>
-            <a:off x="2093976" y="1490472"/>
-            <a:ext cx="3858768" cy="384048"/>
+            <a:off x="2093976" y="1472184"/>
+            <a:ext cx="3858768" cy="365760"/>
           </a:xfrm>
           <a:prstGeom prst="rect">
             <a:avLst/>
@@ -16594,7 +16796,7 @@
                 </a:solidFill>
                 <a:latin typeface="Google Sans Flex SemiBold"/>
               </a:rPr>
-              <a:t>Gatekeeper · login · rate limits</a:t>
+              <a:t>Gatekeeper · login · rate limits · Gemini retries</a:t>
             </a:r>
           </a:p>
           <a:p>
@@ -16617,18 +16819,18 @@
       </p:sp>
       <p:sp>
         <p:nvSpPr>
-          <p:cNvPr id="121" name="Rounded Rectangle 120"/>
+          <p:cNvPr id="123" name="Rounded Rectangle 122"/>
           <p:cNvSpPr/>
           <p:nvPr/>
         </p:nvSpPr>
         <p:spPr>
           <a:xfrm>
-            <a:off x="2057400" y="1984248"/>
-            <a:ext cx="1371600" cy="658368"/>
+            <a:off x="2057400" y="1947672"/>
+            <a:ext cx="1188720" cy="731520"/>
           </a:xfrm>
           <a:prstGeom prst="roundRect">
             <a:avLst>
-              <a:gd name="adj" fmla="val 9722"/>
+              <a:gd name="adj" fmla="val 8750"/>
             </a:avLst>
           </a:prstGeom>
           <a:solidFill>
@@ -16661,14 +16863,14 @@
       </p:sp>
       <p:sp>
         <p:nvSpPr>
-          <p:cNvPr id="122" name="TextBox 121"/>
+          <p:cNvPr id="124" name="TextBox 123"/>
           <p:cNvSpPr txBox="1"/>
           <p:nvPr/>
         </p:nvSpPr>
         <p:spPr>
           <a:xfrm>
-            <a:off x="2093976" y="1984248"/>
-            <a:ext cx="1298448" cy="658368"/>
+            <a:off x="2093976" y="1947672"/>
+            <a:ext cx="1115568" cy="731520"/>
           </a:xfrm>
           <a:prstGeom prst="rect">
             <a:avLst/>
@@ -16716,18 +16918,18 @@
       </p:sp>
       <p:sp>
         <p:nvSpPr>
-          <p:cNvPr id="123" name="Rounded Rectangle 122"/>
+          <p:cNvPr id="125" name="Rounded Rectangle 124"/>
           <p:cNvSpPr/>
           <p:nvPr/>
         </p:nvSpPr>
         <p:spPr>
           <a:xfrm>
-            <a:off x="3566160" y="1984248"/>
-            <a:ext cx="2423159" cy="1417320"/>
+            <a:off x="3383280" y="1947672"/>
+            <a:ext cx="2606039" cy="1481328"/>
           </a:xfrm>
           <a:prstGeom prst="roundRect">
             <a:avLst>
-              <a:gd name="adj" fmla="val 4516"/>
+              <a:gd name="adj" fmla="val 4320"/>
             </a:avLst>
           </a:prstGeom>
           <a:solidFill>
@@ -16760,14 +16962,14 @@
       </p:sp>
       <p:sp>
         <p:nvSpPr>
-          <p:cNvPr id="124" name="TextBox 123"/>
+          <p:cNvPr id="126" name="TextBox 125"/>
           <p:cNvSpPr txBox="1"/>
           <p:nvPr/>
         </p:nvSpPr>
         <p:spPr>
           <a:xfrm>
-            <a:off x="3611880" y="2011680"/>
-            <a:ext cx="2331720" cy="201168"/>
+            <a:off x="3429000" y="1965960"/>
+            <a:ext cx="2514599" cy="201168"/>
           </a:xfrm>
           <a:prstGeom prst="rect">
             <a:avLst/>
@@ -16792,25 +16994,25 @@
                 </a:solidFill>
                 <a:latin typeface="Google Sans Flex SemiBold"/>
               </a:rPr>
-              <a:t>Google ADK agents</a:t>
-            </a:r>
-          </a:p>
-        </p:txBody>
-      </p:sp>
-      <p:sp>
-        <p:nvSpPr>
-          <p:cNvPr id="125" name="Rounded Rectangle 124"/>
+              <a:t>Google ADK: 7 agents</a:t>
+            </a:r>
+          </a:p>
+        </p:txBody>
+      </p:sp>
+      <p:sp>
+        <p:nvSpPr>
+          <p:cNvPr id="127" name="Rounded Rectangle 126"/>
           <p:cNvSpPr/>
           <p:nvPr/>
         </p:nvSpPr>
         <p:spPr>
           <a:xfrm>
-            <a:off x="4178807" y="2240280"/>
-            <a:ext cx="1280160" cy="274320"/>
+            <a:off x="4142232" y="2185415"/>
+            <a:ext cx="1188720" cy="256032"/>
           </a:xfrm>
           <a:prstGeom prst="roundRect">
             <a:avLst>
-              <a:gd name="adj" fmla="val 23333"/>
+              <a:gd name="adj" fmla="val 25000"/>
             </a:avLst>
           </a:prstGeom>
           <a:solidFill>
@@ -16843,14 +17045,14 @@
       </p:sp>
       <p:sp>
         <p:nvSpPr>
-          <p:cNvPr id="126" name="TextBox 125"/>
+          <p:cNvPr id="128" name="TextBox 127"/>
           <p:cNvSpPr txBox="1"/>
           <p:nvPr/>
         </p:nvSpPr>
         <p:spPr>
           <a:xfrm>
-            <a:off x="4215383" y="2240280"/>
-            <a:ext cx="1207007" cy="274320"/>
+            <a:off x="4178808" y="2185415"/>
+            <a:ext cx="1115568" cy="256032"/>
           </a:xfrm>
           <a:prstGeom prst="rect">
             <a:avLst/>
@@ -16882,18 +17084,18 @@
       </p:sp>
       <p:sp>
         <p:nvSpPr>
-          <p:cNvPr id="127" name="Rounded Rectangle 126"/>
+          <p:cNvPr id="129" name="Rounded Rectangle 128"/>
           <p:cNvSpPr/>
           <p:nvPr/>
         </p:nvSpPr>
         <p:spPr>
           <a:xfrm>
-            <a:off x="3675887" y="2697480"/>
-            <a:ext cx="512064" cy="274320"/>
+            <a:off x="3456432" y="2532888"/>
+            <a:ext cx="804672" cy="246888"/>
           </a:xfrm>
           <a:prstGeom prst="roundRect">
             <a:avLst>
-              <a:gd name="adj" fmla="val 23333"/>
+              <a:gd name="adj" fmla="val 25925"/>
             </a:avLst>
           </a:prstGeom>
           <a:solidFill>
@@ -16926,14 +17128,14 @@
       </p:sp>
       <p:sp>
         <p:nvSpPr>
-          <p:cNvPr id="128" name="TextBox 127"/>
+          <p:cNvPr id="130" name="TextBox 129"/>
           <p:cNvSpPr txBox="1"/>
           <p:nvPr/>
         </p:nvSpPr>
         <p:spPr>
           <a:xfrm>
-            <a:off x="3712463" y="2697480"/>
-            <a:ext cx="438912" cy="274320"/>
+            <a:off x="3493008" y="2532888"/>
+            <a:ext cx="731520" cy="246888"/>
           </a:xfrm>
           <a:prstGeom prst="rect">
             <a:avLst/>
@@ -16965,18 +17167,18 @@
       </p:sp>
       <p:sp>
         <p:nvSpPr>
-          <p:cNvPr id="129" name="Rounded Rectangle 128"/>
+          <p:cNvPr id="131" name="Rounded Rectangle 130"/>
           <p:cNvSpPr/>
           <p:nvPr/>
         </p:nvSpPr>
         <p:spPr>
           <a:xfrm>
-            <a:off x="4242816" y="2697480"/>
-            <a:ext cx="512064" cy="274320"/>
+            <a:off x="4325112" y="2532888"/>
+            <a:ext cx="804672" cy="246888"/>
           </a:xfrm>
           <a:prstGeom prst="roundRect">
             <a:avLst>
-              <a:gd name="adj" fmla="val 23333"/>
+              <a:gd name="adj" fmla="val 25925"/>
             </a:avLst>
           </a:prstGeom>
           <a:solidFill>
@@ -17009,14 +17211,14 @@
       </p:sp>
       <p:sp>
         <p:nvSpPr>
-          <p:cNvPr id="130" name="TextBox 129"/>
+          <p:cNvPr id="132" name="TextBox 131"/>
           <p:cNvSpPr txBox="1"/>
           <p:nvPr/>
         </p:nvSpPr>
         <p:spPr>
           <a:xfrm>
-            <a:off x="4279392" y="2697480"/>
-            <a:ext cx="438912" cy="274320"/>
+            <a:off x="4361688" y="2532888"/>
+            <a:ext cx="731520" cy="246888"/>
           </a:xfrm>
           <a:prstGeom prst="rect">
             <a:avLst/>
@@ -17048,18 +17250,18 @@
       </p:sp>
       <p:sp>
         <p:nvSpPr>
-          <p:cNvPr id="131" name="Rounded Rectangle 130"/>
+          <p:cNvPr id="133" name="Rounded Rectangle 132"/>
           <p:cNvSpPr/>
           <p:nvPr/>
         </p:nvSpPr>
         <p:spPr>
           <a:xfrm>
-            <a:off x="4809744" y="2697480"/>
-            <a:ext cx="512064" cy="274320"/>
+            <a:off x="5193792" y="2532888"/>
+            <a:ext cx="804672" cy="246888"/>
           </a:xfrm>
           <a:prstGeom prst="roundRect">
             <a:avLst>
-              <a:gd name="adj" fmla="val 23333"/>
+              <a:gd name="adj" fmla="val 25925"/>
             </a:avLst>
           </a:prstGeom>
           <a:solidFill>
@@ -17092,14 +17294,14 @@
       </p:sp>
       <p:sp>
         <p:nvSpPr>
-          <p:cNvPr id="132" name="TextBox 131"/>
+          <p:cNvPr id="134" name="TextBox 133"/>
           <p:cNvSpPr txBox="1"/>
           <p:nvPr/>
         </p:nvSpPr>
         <p:spPr>
           <a:xfrm>
-            <a:off x="4846320" y="2697480"/>
-            <a:ext cx="438912" cy="274320"/>
+            <a:off x="5230368" y="2532888"/>
+            <a:ext cx="731520" cy="246888"/>
           </a:xfrm>
           <a:prstGeom prst="rect">
             <a:avLst/>
@@ -17131,18 +17333,18 @@
       </p:sp>
       <p:sp>
         <p:nvSpPr>
-          <p:cNvPr id="133" name="Rounded Rectangle 132"/>
+          <p:cNvPr id="135" name="Rounded Rectangle 134"/>
           <p:cNvSpPr/>
           <p:nvPr/>
         </p:nvSpPr>
         <p:spPr>
           <a:xfrm>
-            <a:off x="5376671" y="2697480"/>
-            <a:ext cx="512064" cy="274320"/>
+            <a:off x="3456432" y="2834640"/>
+            <a:ext cx="804672" cy="246888"/>
           </a:xfrm>
           <a:prstGeom prst="roundRect">
             <a:avLst>
-              <a:gd name="adj" fmla="val 23333"/>
+              <a:gd name="adj" fmla="val 25925"/>
             </a:avLst>
           </a:prstGeom>
           <a:solidFill>
@@ -17175,14 +17377,14 @@
       </p:sp>
       <p:sp>
         <p:nvSpPr>
-          <p:cNvPr id="134" name="TextBox 133"/>
+          <p:cNvPr id="136" name="TextBox 135"/>
           <p:cNvSpPr txBox="1"/>
           <p:nvPr/>
         </p:nvSpPr>
         <p:spPr>
           <a:xfrm>
-            <a:off x="5413247" y="2697480"/>
-            <a:ext cx="438912" cy="274320"/>
+            <a:off x="3493008" y="2834640"/>
+            <a:ext cx="731520" cy="246888"/>
           </a:xfrm>
           <a:prstGeom prst="rect">
             <a:avLst/>
@@ -17214,14 +17416,180 @@
       </p:sp>
       <p:sp>
         <p:nvSpPr>
-          <p:cNvPr id="135" name="TextBox 134"/>
+          <p:cNvPr id="137" name="Rounded Rectangle 136"/>
+          <p:cNvSpPr/>
+          <p:nvPr/>
+        </p:nvSpPr>
+        <p:spPr>
+          <a:xfrm>
+            <a:off x="4325112" y="2834640"/>
+            <a:ext cx="804672" cy="246888"/>
+          </a:xfrm>
+          <a:prstGeom prst="roundRect">
+            <a:avLst>
+              <a:gd name="adj" fmla="val 25925"/>
+            </a:avLst>
+          </a:prstGeom>
+          <a:solidFill>
+            <a:srgbClr val="FFFFFF"/>
+          </a:solidFill>
+          <a:ln>
+            <a:noFill/>
+          </a:ln>
+          <a:effectLst/>
+        </p:spPr>
+        <p:style>
+          <a:lnRef idx="1">
+            <a:schemeClr val="accent1"/>
+          </a:lnRef>
+          <a:fillRef idx="3">
+            <a:schemeClr val="accent1"/>
+          </a:fillRef>
+          <a:effectRef idx="2">
+            <a:schemeClr val="accent1"/>
+          </a:effectRef>
+          <a:fontRef idx="minor">
+            <a:schemeClr val="lt1"/>
+          </a:fontRef>
+        </p:style>
+        <p:txBody>
+          <a:bodyPr rtlCol="0" anchor="ctr"/>
+          <a:lstStyle/>
+          <a:p/>
+        </p:txBody>
+      </p:sp>
+      <p:sp>
+        <p:nvSpPr>
+          <p:cNvPr id="138" name="TextBox 137"/>
           <p:cNvSpPr txBox="1"/>
           <p:nvPr/>
         </p:nvSpPr>
         <p:spPr>
           <a:xfrm>
-            <a:off x="3611880" y="3017520"/>
-            <a:ext cx="2331720" cy="365760"/>
+            <a:off x="4361688" y="2834640"/>
+            <a:ext cx="731520" cy="246888"/>
+          </a:xfrm>
+          <a:prstGeom prst="rect">
+            <a:avLst/>
+          </a:prstGeom>
+          <a:noFill/>
+        </p:spPr>
+        <p:txBody>
+          <a:bodyPr wrap="square" anchor="ctr" lIns="36576" rIns="36576" tIns="18288" bIns="18288">
+            <a:spAutoFit/>
+          </a:bodyPr>
+          <a:lstStyle/>
+          <a:p>
+            <a:pPr algn="ctr">
+              <a:spcAft>
+                <a:spcPts val="100"/>
+              </a:spcAft>
+            </a:pPr>
+            <a:r>
+              <a:rPr sz="750" i="0">
+                <a:solidFill>
+                  <a:srgbClr val="1D1D1F"/>
+                </a:solidFill>
+                <a:latin typeface="Google Sans Flex SemiBold"/>
+              </a:rPr>
+              <a:t>Verify</a:t>
+            </a:r>
+          </a:p>
+        </p:txBody>
+      </p:sp>
+      <p:sp>
+        <p:nvSpPr>
+          <p:cNvPr id="139" name="Rounded Rectangle 138"/>
+          <p:cNvSpPr/>
+          <p:nvPr/>
+        </p:nvSpPr>
+        <p:spPr>
+          <a:xfrm>
+            <a:off x="5193792" y="2834640"/>
+            <a:ext cx="804672" cy="246888"/>
+          </a:xfrm>
+          <a:prstGeom prst="roundRect">
+            <a:avLst>
+              <a:gd name="adj" fmla="val 25925"/>
+            </a:avLst>
+          </a:prstGeom>
+          <a:solidFill>
+            <a:srgbClr val="FFFFFF"/>
+          </a:solidFill>
+          <a:ln>
+            <a:noFill/>
+          </a:ln>
+          <a:effectLst/>
+        </p:spPr>
+        <p:style>
+          <a:lnRef idx="1">
+            <a:schemeClr val="accent1"/>
+          </a:lnRef>
+          <a:fillRef idx="3">
+            <a:schemeClr val="accent1"/>
+          </a:fillRef>
+          <a:effectRef idx="2">
+            <a:schemeClr val="accent1"/>
+          </a:effectRef>
+          <a:fontRef idx="minor">
+            <a:schemeClr val="lt1"/>
+          </a:fontRef>
+        </p:style>
+        <p:txBody>
+          <a:bodyPr rtlCol="0" anchor="ctr"/>
+          <a:lstStyle/>
+          <a:p/>
+        </p:txBody>
+      </p:sp>
+      <p:sp>
+        <p:nvSpPr>
+          <p:cNvPr id="140" name="TextBox 139"/>
+          <p:cNvSpPr txBox="1"/>
+          <p:nvPr/>
+        </p:nvSpPr>
+        <p:spPr>
+          <a:xfrm>
+            <a:off x="5230368" y="2834640"/>
+            <a:ext cx="731520" cy="246888"/>
+          </a:xfrm>
+          <a:prstGeom prst="rect">
+            <a:avLst/>
+          </a:prstGeom>
+          <a:noFill/>
+        </p:spPr>
+        <p:txBody>
+          <a:bodyPr wrap="square" anchor="ctr" lIns="36576" rIns="36576" tIns="18288" bIns="18288">
+            <a:spAutoFit/>
+          </a:bodyPr>
+          <a:lstStyle/>
+          <a:p>
+            <a:pPr algn="ctr">
+              <a:spcAft>
+                <a:spcPts val="100"/>
+              </a:spcAft>
+            </a:pPr>
+            <a:r>
+              <a:rPr sz="750" i="0">
+                <a:solidFill>
+                  <a:srgbClr val="1D1D1F"/>
+                </a:solidFill>
+                <a:latin typeface="Google Sans Flex SemiBold"/>
+              </a:rPr>
+              <a:t>Companion</a:t>
+            </a:r>
+          </a:p>
+        </p:txBody>
+      </p:sp>
+      <p:sp>
+        <p:nvSpPr>
+          <p:cNvPr id="141" name="TextBox 140"/>
+          <p:cNvSpPr txBox="1"/>
+          <p:nvPr/>
+        </p:nvSpPr>
+        <p:spPr>
+          <a:xfrm>
+            <a:off x="3429000" y="3127248"/>
+            <a:ext cx="2514599" cy="274320"/>
           </a:xfrm>
           <a:prstGeom prst="rect">
             <a:avLst/>
@@ -17253,18 +17621,18 @@
       </p:sp>
       <p:sp>
         <p:nvSpPr>
-          <p:cNvPr id="136" name="Rounded Rectangle 135"/>
+          <p:cNvPr id="142" name="Rounded Rectangle 141"/>
           <p:cNvSpPr/>
           <p:nvPr/>
         </p:nvSpPr>
         <p:spPr>
           <a:xfrm>
             <a:off x="2057400" y="3538728"/>
-            <a:ext cx="3931920" cy="868680"/>
+            <a:ext cx="3931920" cy="960120"/>
           </a:xfrm>
           <a:prstGeom prst="roundRect">
             <a:avLst>
-              <a:gd name="adj" fmla="val 7368"/>
+              <a:gd name="adj" fmla="val 6666"/>
             </a:avLst>
           </a:prstGeom>
           <a:solidFill>
@@ -17297,14 +17665,14 @@
       </p:sp>
       <p:sp>
         <p:nvSpPr>
-          <p:cNvPr id="137" name="TextBox 136"/>
+          <p:cNvPr id="143" name="TextBox 142"/>
           <p:cNvSpPr txBox="1"/>
           <p:nvPr/>
         </p:nvSpPr>
         <p:spPr>
           <a:xfrm>
             <a:off x="2093976" y="3538728"/>
-            <a:ext cx="3858768" cy="868680"/>
+            <a:ext cx="3858768" cy="960120"/>
           </a:xfrm>
           <a:prstGeom prst="rect">
             <a:avLst/>
@@ -17329,7 +17697,7 @@
                 </a:solidFill>
                 <a:latin typeface="Google Sans Flex SemiBold"/>
               </a:rPr>
-              <a:t>breedernear_core</a:t>
+              <a:t>breedernear_core: one tool layer</a:t>
             </a:r>
           </a:p>
           <a:p>
@@ -17345,22 +17713,22 @@
                 </a:solidFill>
                 <a:latin typeface="Google Sans Flex"/>
               </a:rPr>
-              <a:t>one tool layer: listings · matching · care · accounts
-safety rules · deterministic trust score · reused-photo hashing · distance</a:t>
+              <a:t>listings · trust score · verification · match % · visits · care companion
+analytics · accounts · safety rules in code · reused-photo hashing</a:t>
             </a:r>
           </a:p>
         </p:txBody>
       </p:sp>
       <p:cxnSp>
         <p:nvCxnSpPr>
-          <p:cNvPr id="138" name="Connector 137"/>
+          <p:cNvPr id="144" name="Connector 143"/>
           <p:cNvCxnSpPr/>
           <p:nvPr/>
         </p:nvCxnSpPr>
         <p:spPr>
           <a:xfrm>
-            <a:off x="2743200" y="2642615"/>
-            <a:ext cx="0" cy="896113"/>
+            <a:off x="2651760" y="2679191"/>
+            <a:ext cx="0" cy="859537"/>
           </a:xfrm>
           <a:prstGeom prst="line">
             <a:avLst/>
@@ -17389,14 +17757,14 @@
       </p:cxnSp>
       <p:cxnSp>
         <p:nvCxnSpPr>
-          <p:cNvPr id="139" name="Connector 138"/>
+          <p:cNvPr id="145" name="Connector 144"/>
           <p:cNvCxnSpPr/>
           <p:nvPr/>
         </p:nvCxnSpPr>
         <p:spPr>
           <a:xfrm>
-            <a:off x="4754880" y="3401568"/>
-            <a:ext cx="0" cy="137160"/>
+            <a:off x="4754880" y="3429000"/>
+            <a:ext cx="0" cy="109728"/>
           </a:xfrm>
           <a:prstGeom prst="line">
             <a:avLst/>
@@ -17425,13 +17793,13 @@
       </p:cxnSp>
       <p:cxnSp>
         <p:nvCxnSpPr>
-          <p:cNvPr id="140" name="Connector 139"/>
+          <p:cNvPr id="146" name="Connector 145"/>
           <p:cNvCxnSpPr/>
           <p:nvPr/>
         </p:nvCxnSpPr>
         <p:spPr>
           <a:xfrm>
-            <a:off x="1554480" y="2514600"/>
+            <a:off x="1554480" y="2286000"/>
             <a:ext cx="365760" cy="0"/>
           </a:xfrm>
           <a:prstGeom prst="line">
@@ -17459,48 +17827,45 @@
           </a:fontRef>
         </p:style>
       </p:cxnSp>
-      <p:sp>
-        <p:nvSpPr>
-          <p:cNvPr id="141" name="TextBox 140"/>
-          <p:cNvSpPr txBox="1"/>
-          <p:nvPr/>
-        </p:nvSpPr>
-        <p:spPr>
-          <a:xfrm>
-            <a:off x="365759" y="2926080"/>
-            <a:ext cx="1188720" cy="365760"/>
-          </a:xfrm>
-          <a:prstGeom prst="rect">
-            <a:avLst/>
-          </a:prstGeom>
-          <a:noFill/>
-        </p:spPr>
-        <p:txBody>
-          <a:bodyPr wrap="square" anchor="t" lIns="36576" rIns="36576" tIns="18288" bIns="18288">
-            <a:spAutoFit/>
-          </a:bodyPr>
-          <a:lstStyle/>
-          <a:p>
-            <a:pPr algn="ctr">
-              <a:spcAft>
-                <a:spcPts val="300"/>
-              </a:spcAft>
-            </a:pPr>
-            <a:r>
-              <a:rPr sz="700" i="0">
-                <a:solidFill>
-                  <a:srgbClr val="5F5F64"/>
-                </a:solidFill>
-                <a:latin typeface="Google Sans Flex"/>
-              </a:rPr>
-              <a:t>calls Cloud Run directly: API + streamed AI</a:t>
-            </a:r>
-          </a:p>
-        </p:txBody>
-      </p:sp>
-      <p:sp>
-        <p:nvSpPr>
-          <p:cNvPr id="142" name="Rounded Rectangle 141"/>
+      <p:cxnSp>
+        <p:nvCxnSpPr>
+          <p:cNvPr id="147" name="Connector 146"/>
+          <p:cNvCxnSpPr/>
+          <p:nvPr/>
+        </p:nvCxnSpPr>
+        <p:spPr>
+          <a:xfrm>
+            <a:off x="1554480" y="3154680"/>
+            <a:ext cx="365760" cy="0"/>
+          </a:xfrm>
+          <a:prstGeom prst="line">
+            <a:avLst/>
+          </a:prstGeom>
+          <a:ln w="15875">
+            <a:solidFill>
+              <a:srgbClr val="5F5F64"/>
+            </a:solidFill>
+            <a:tailEnd type="triangle" w="med" len="med"/>
+          </a:ln>
+        </p:spPr>
+        <p:style>
+          <a:lnRef idx="2">
+            <a:schemeClr val="accent1"/>
+          </a:lnRef>
+          <a:fillRef idx="0">
+            <a:schemeClr val="accent1"/>
+          </a:fillRef>
+          <a:effectRef idx="1">
+            <a:schemeClr val="accent1"/>
+          </a:effectRef>
+          <a:fontRef idx="minor">
+            <a:schemeClr val="tx1"/>
+          </a:fontRef>
+        </p:style>
+      </p:cxnSp>
+      <p:sp>
+        <p:nvSpPr>
+          <p:cNvPr id="148" name="Rounded Rectangle 147"/>
           <p:cNvSpPr/>
           <p:nvPr/>
         </p:nvSpPr>
@@ -17544,7 +17909,7 @@
       </p:sp>
       <p:sp>
         <p:nvSpPr>
-          <p:cNvPr id="143" name="TextBox 142"/>
+          <p:cNvPr id="149" name="TextBox 148"/>
           <p:cNvSpPr txBox="1"/>
           <p:nvPr/>
         </p:nvSpPr>
@@ -17592,15 +17957,15 @@
                 </a:solidFill>
                 <a:latin typeface="Google Sans Flex"/>
               </a:rPr>
-              <a:t>Vertex AI: agents, photo screening,
-extraction, care plans, replies</a:t>
+              <a:t>Vertex AI: agents, photos, certificates,
+listings, care, scam scan</a:t>
             </a:r>
           </a:p>
         </p:txBody>
       </p:sp>
       <p:cxnSp>
         <p:nvCxnSpPr>
-          <p:cNvPr id="144" name="Connector 143"/>
+          <p:cNvPr id="150" name="Connector 149"/>
           <p:cNvCxnSpPr/>
           <p:nvPr/>
         </p:nvCxnSpPr>
@@ -17636,7 +18001,7 @@
       </p:cxnSp>
       <p:sp>
         <p:nvSpPr>
-          <p:cNvPr id="145" name="Rounded Rectangle 144"/>
+          <p:cNvPr id="151" name="Rounded Rectangle 150"/>
           <p:cNvSpPr/>
           <p:nvPr/>
         </p:nvSpPr>
@@ -17680,7 +18045,7 @@
       </p:sp>
       <p:sp>
         <p:nvSpPr>
-          <p:cNvPr id="146" name="TextBox 145"/>
+          <p:cNvPr id="152" name="TextBox 151"/>
           <p:cNvSpPr txBox="1"/>
           <p:nvPr/>
         </p:nvSpPr>
@@ -17728,14 +18093,15 @@
                 </a:solidFill>
                 <a:latin typeface="Google Sans Flex"/>
               </a:rPr>
-              <a:t>accounts, listings, enquiries, carts</a:t>
+              <a:t>accounts, listings, visits, pets,
+verification, analytics events</a:t>
             </a:r>
           </a:p>
         </p:txBody>
       </p:sp>
       <p:cxnSp>
         <p:nvCxnSpPr>
-          <p:cNvPr id="147" name="Connector 146"/>
+          <p:cNvPr id="153" name="Connector 152"/>
           <p:cNvCxnSpPr/>
           <p:nvPr/>
         </p:nvCxnSpPr>
@@ -17771,7 +18137,7 @@
       </p:cxnSp>
       <p:sp>
         <p:nvSpPr>
-          <p:cNvPr id="148" name="Rounded Rectangle 147"/>
+          <p:cNvPr id="154" name="Rounded Rectangle 153"/>
           <p:cNvSpPr/>
           <p:nvPr/>
         </p:nvSpPr>
@@ -17815,7 +18181,7 @@
       </p:sp>
       <p:sp>
         <p:nvSpPr>
-          <p:cNvPr id="149" name="TextBox 148"/>
+          <p:cNvPr id="155" name="TextBox 154"/>
           <p:cNvSpPr txBox="1"/>
           <p:nvPr/>
         </p:nvSpPr>
@@ -17863,14 +18229,14 @@
                 </a:solidFill>
                 <a:latin typeface="Google Sans Flex"/>
               </a:rPr>
-              <a:t>private uploads, deleted after 30 days</a:t>
+              <a:t>private uploads, deleted once read</a:t>
             </a:r>
           </a:p>
         </p:txBody>
       </p:sp>
       <p:cxnSp>
         <p:nvCxnSpPr>
-          <p:cNvPr id="150" name="Connector 149"/>
+          <p:cNvPr id="156" name="Connector 155"/>
           <p:cNvCxnSpPr/>
           <p:nvPr/>
         </p:nvCxnSpPr>
@@ -17906,7 +18272,7 @@
       </p:cxnSp>
       <p:sp>
         <p:nvSpPr>
-          <p:cNvPr id="151" name="Rounded Rectangle 150"/>
+          <p:cNvPr id="157" name="Rounded Rectangle 156"/>
           <p:cNvSpPr/>
           <p:nvPr/>
         </p:nvSpPr>
@@ -17950,7 +18316,7 @@
       </p:sp>
       <p:sp>
         <p:nvSpPr>
-          <p:cNvPr id="152" name="TextBox 151"/>
+          <p:cNvPr id="158" name="TextBox 157"/>
           <p:cNvSpPr txBox="1"/>
           <p:nvPr/>
         </p:nvSpPr>
@@ -18005,7 +18371,7 @@
       </p:sp>
       <p:cxnSp>
         <p:nvCxnSpPr>
-          <p:cNvPr id="153" name="Connector 152"/>
+          <p:cNvPr id="159" name="Connector 158"/>
           <p:cNvCxnSpPr/>
           <p:nvPr/>
         </p:nvCxnSpPr>
@@ -18041,7 +18407,7 @@
       </p:cxnSp>
       <p:sp>
         <p:nvSpPr>
-          <p:cNvPr id="154" name="Rounded Rectangle 153"/>
+          <p:cNvPr id="160" name="Rounded Rectangle 159"/>
           <p:cNvSpPr/>
           <p:nvPr/>
         </p:nvSpPr>
@@ -18085,7 +18451,7 @@
       </p:sp>
       <p:sp>
         <p:nvSpPr>
-          <p:cNvPr id="155" name="TextBox 154"/>
+          <p:cNvPr id="161" name="TextBox 160"/>
           <p:cNvSpPr txBox="1"/>
           <p:nvPr/>
         </p:nvSpPr>
@@ -18140,7 +18506,7 @@
       </p:sp>
       <p:cxnSp>
         <p:nvCxnSpPr>
-          <p:cNvPr id="156" name="Connector 155"/>
+          <p:cNvPr id="162" name="Connector 161"/>
           <p:cNvCxnSpPr/>
           <p:nvPr/>
         </p:nvCxnSpPr>
@@ -18359,7 +18725,7 @@
         </p:nvGraphicFramePr>
         <p:xfrm>
           <a:off x="320040" y="1115568"/>
-          <a:ext cx="5577840" cy="2962656"/>
+          <a:ext cx="5715000" cy="2880360"/>
         </p:xfrm>
         <a:graphic>
           <a:graphicData uri="http://schemas.openxmlformats.org/drawingml/2006/table">
@@ -18368,17 +18734,17 @@
                 <a:tableStyleId>{5C22544A-7EE6-4342-B048-85BDC9FD1C3A}</a:tableStyleId>
               </a:tblPr>
               <a:tblGrid>
-                <a:gridCol w="1737360"/>
-                <a:gridCol w="3840480"/>
+                <a:gridCol w="1783080"/>
+                <a:gridCol w="3931920"/>
               </a:tblGrid>
-              <a:tr h="329184">
+              <a:tr h="320040">
                 <a:tc>
                   <a:txBody>
                     <a:bodyPr wrap="square"/>
                     <a:lstStyle/>
                     <a:p>
                       <a:r>
-                        <a:rPr sz="830">
+                        <a:rPr sz="800">
                           <a:solidFill>
                             <a:srgbClr val="FFFFFF"/>
                           </a:solidFill>
@@ -18400,7 +18766,7 @@
                     <a:lstStyle/>
                     <a:p>
                       <a:r>
-                        <a:rPr sz="830">
+                        <a:rPr sz="800">
                           <a:solidFill>
                             <a:srgbClr val="FFFFFF"/>
                           </a:solidFill>
@@ -18417,14 +18783,14 @@
                   </a:tcPr>
                 </a:tc>
               </a:tr>
-              <a:tr h="329184">
+              <a:tr h="320040">
                 <a:tc>
                   <a:txBody>
                     <a:bodyPr wrap="square"/>
                     <a:lstStyle/>
                     <a:p>
                       <a:r>
-                        <a:rPr sz="830">
+                        <a:rPr sz="800">
                           <a:solidFill>
                             <a:srgbClr val="1D1D1F"/>
                           </a:solidFill>
@@ -18446,13 +18812,13 @@
                     <a:lstStyle/>
                     <a:p>
                       <a:r>
-                        <a:rPr sz="830">
+                        <a:rPr sz="800">
                           <a:solidFill>
                             <a:srgbClr val="1D1D1F"/>
                           </a:solidFill>
                           <a:latin typeface="Google Sans Flex"/>
                         </a:rPr>
-                        <a:t>Five ADK agents; multimodal listing extraction from photos + Tamil/English text; photo screening (species, dye, stock photos); care plans; reply drafts. JSON-schema outputs.</a:t>
+                        <a:t>Seven ADK agents; listing extraction from photos + Tamil/English; photo, facility and certificate reading; care plans, daily-log feedback, symptom urgency; message drafts and scam scan. JSON schemas.</a:t>
                       </a:r>
                     </a:p>
                   </a:txBody>
@@ -18463,14 +18829,14 @@
                   </a:tcPr>
                 </a:tc>
               </a:tr>
-              <a:tr h="329184">
+              <a:tr h="320040">
                 <a:tc>
                   <a:txBody>
                     <a:bodyPr wrap="square"/>
                     <a:lstStyle/>
                     <a:p>
                       <a:r>
-                        <a:rPr sz="830">
+                        <a:rPr sz="800">
                           <a:solidFill>
                             <a:srgbClr val="1D1D1F"/>
                           </a:solidFill>
@@ -18492,13 +18858,13 @@
                     <a:lstStyle/>
                     <a:p>
                       <a:r>
-                        <a:rPr sz="830">
+                        <a:rPr sz="800">
                           <a:solidFill>
                             <a:srgbClr val="1D1D1F"/>
                           </a:solidFill>
                           <a:latin typeface="Google Sans Flex"/>
                         </a:rPr>
-                        <a:t>Concierge + listing, trust, match and care agents; tools; callbacks on every agent; sessions; streamed replies</a:t>
+                        <a:t>Concierge + listing, trust, match, care, verification and companion agents; tools; callbacks on every agent; streamed replies</a:t>
                       </a:r>
                     </a:p>
                   </a:txBody>
@@ -18509,14 +18875,14 @@
                   </a:tcPr>
                 </a:tc>
               </a:tr>
-              <a:tr h="329184">
+              <a:tr h="320040">
                 <a:tc>
                   <a:txBody>
                     <a:bodyPr wrap="square"/>
                     <a:lstStyle/>
                     <a:p>
                       <a:r>
-                        <a:rPr sz="830">
+                        <a:rPr sz="800">
                           <a:solidFill>
                             <a:srgbClr val="1D1D1F"/>
                           </a:solidFill>
@@ -18538,13 +18904,13 @@
                     <a:lstStyle/>
                     <a:p>
                       <a:r>
-                        <a:rPr sz="830">
+                        <a:rPr sz="800">
                           <a:solidFill>
                             <a:srgbClr val="1D1D1F"/>
                           </a:solidFill>
                           <a:latin typeface="Google Sans Flex"/>
                         </a:rPr>
-                        <a:t>API and agents in one container; login gatekeeper; rate limits; asia-south1</a:t>
+                        <a:t>API and agents; login gatekeeper; rate limits; Gemini retries with backoff</a:t>
                       </a:r>
                     </a:p>
                   </a:txBody>
@@ -18555,14 +18921,14 @@
                   </a:tcPr>
                 </a:tc>
               </a:tr>
-              <a:tr h="329184">
+              <a:tr h="320040">
                 <a:tc>
                   <a:txBody>
                     <a:bodyPr wrap="square"/>
                     <a:lstStyle/>
                     <a:p>
                       <a:r>
-                        <a:rPr sz="830">
+                        <a:rPr sz="800">
                           <a:solidFill>
                             <a:srgbClr val="1D1D1F"/>
                           </a:solidFill>
@@ -18584,7 +18950,7 @@
                     <a:lstStyle/>
                     <a:p>
                       <a:r>
-                        <a:rPr sz="830">
+                        <a:rPr sz="800">
                           <a:solidFill>
                             <a:srgbClr val="1D1D1F"/>
                           </a:solidFill>
@@ -18601,20 +18967,20 @@
                   </a:tcPr>
                 </a:tc>
               </a:tr>
-              <a:tr h="329184">
+              <a:tr h="320040">
                 <a:tc>
                   <a:txBody>
                     <a:bodyPr wrap="square"/>
                     <a:lstStyle/>
                     <a:p>
                       <a:r>
-                        <a:rPr sz="830">
+                        <a:rPr sz="800">
                           <a:solidFill>
                             <a:srgbClr val="1D1D1F"/>
                           </a:solidFill>
                           <a:latin typeface="Google Sans Flex"/>
                         </a:rPr>
-                        <a:t>Firestore</a:t>
+                        <a:t>Firebase Authentication</a:t>
                       </a:r>
                     </a:p>
                   </a:txBody>
@@ -18630,13 +18996,13 @@
                     <a:lstStyle/>
                     <a:p>
                       <a:r>
-                        <a:rPr sz="830">
+                        <a:rPr sz="800">
                           <a:solidFill>
                             <a:srgbClr val="1D1D1F"/>
                           </a:solidFill>
                           <a:latin typeface="Google Sans Flex"/>
                         </a:rPr>
-                        <a:t>Accounts (scrypt-hashed passwords), listings, drafts, enquiries, carts</a:t>
+                        <a:t>Continue with Google; the server verifies the Firebase ID token</a:t>
                       </a:r>
                     </a:p>
                   </a:txBody>
@@ -18647,20 +19013,20 @@
                   </a:tcPr>
                 </a:tc>
               </a:tr>
-              <a:tr h="329184">
+              <a:tr h="320040">
                 <a:tc>
                   <a:txBody>
                     <a:bodyPr wrap="square"/>
                     <a:lstStyle/>
                     <a:p>
                       <a:r>
-                        <a:rPr sz="830">
+                        <a:rPr sz="800">
                           <a:solidFill>
                             <a:srgbClr val="1D1D1F"/>
                           </a:solidFill>
                           <a:latin typeface="Google Sans Flex"/>
                         </a:rPr>
-                        <a:t>Cloud Storage</a:t>
+                        <a:t>Firestore</a:t>
                       </a:r>
                     </a:p>
                   </a:txBody>
@@ -18676,13 +19042,13 @@
                     <a:lstStyle/>
                     <a:p>
                       <a:r>
-                        <a:rPr sz="830">
+                        <a:rPr sz="800">
                           <a:solidFill>
                             <a:srgbClr val="1D1D1F"/>
                           </a:solidFill>
                           <a:latin typeface="Google Sans Flex"/>
                         </a:rPr>
-                        <a:t>Private upload bucket, 30-day deletion</a:t>
+                        <a:t>Accounts, listings, enquiries, visits, sales, pets and logs, verification, analytics</a:t>
                       </a:r>
                     </a:p>
                   </a:txBody>
@@ -18693,20 +19059,20 @@
                   </a:tcPr>
                 </a:tc>
               </a:tr>
-              <a:tr h="329184">
+              <a:tr h="320040">
                 <a:tc>
                   <a:txBody>
                     <a:bodyPr wrap="square"/>
                     <a:lstStyle/>
                     <a:p>
                       <a:r>
-                        <a:rPr sz="830">
+                        <a:rPr sz="800">
                           <a:solidFill>
                             <a:srgbClr val="1D1D1F"/>
                           </a:solidFill>
                           <a:latin typeface="Google Sans Flex"/>
                         </a:rPr>
-                        <a:t>Cloud Build, Artifact Registry, Cloud Logging</a:t>
+                        <a:t>Cloud Storage, Cloud Build, Artifact Registry, Cloud Logging</a:t>
                       </a:r>
                     </a:p>
                   </a:txBody>
@@ -18722,13 +19088,13 @@
                     <a:lstStyle/>
                     <a:p>
                       <a:r>
-                        <a:rPr sz="830">
+                        <a:rPr sz="800">
                           <a:solidFill>
                             <a:srgbClr val="1D1D1F"/>
                           </a:solidFill>
                           <a:latin typeface="Google Sans Flex"/>
                         </a:rPr>
-                        <a:t>Deploy from source; structured tool-call logs</a:t>
+                        <a:t>Private uploads; deploy from source; tool-call logs</a:t>
                       </a:r>
                     </a:p>
                   </a:txBody>
@@ -18739,14 +19105,14 @@
                   </a:tcPr>
                 </a:tc>
               </a:tr>
-              <a:tr h="329184">
+              <a:tr h="320040">
                 <a:tc>
                   <a:txBody>
                     <a:bodyPr wrap="square"/>
                     <a:lstStyle/>
                     <a:p>
                       <a:r>
-                        <a:rPr sz="830">
+                        <a:rPr sz="800">
                           <a:solidFill>
                             <a:srgbClr val="1D1D1F"/>
                           </a:solidFill>
@@ -18768,7 +19134,7 @@
                     <a:lstStyle/>
                     <a:p>
                       <a:r>
-                        <a:rPr sz="830">
+                        <a:rPr sz="800">
                           <a:solidFill>
                             <a:srgbClr val="1D1D1F"/>
                           </a:solidFill>
@@ -18797,12 +19163,12 @@
         </p:nvSpPr>
         <p:spPr>
           <a:xfrm>
-            <a:off x="6080759" y="1115568"/>
-            <a:ext cx="2743200" cy="2962656"/>
+            <a:off x="6217920" y="1115568"/>
+            <a:ext cx="2606040" cy="2880360"/>
           </a:xfrm>
           <a:prstGeom prst="roundRect">
             <a:avLst>
-              <a:gd name="adj" fmla="val 2666"/>
+              <a:gd name="adj" fmla="val 2807"/>
             </a:avLst>
           </a:prstGeom>
           <a:solidFill>
@@ -18841,8 +19207,8 @@
         </p:nvSpPr>
         <p:spPr>
           <a:xfrm>
-            <a:off x="6172199" y="1188720"/>
-            <a:ext cx="2560320" cy="2852928"/>
+            <a:off x="6309359" y="1188720"/>
+            <a:ext cx="2423160" cy="2770632"/>
           </a:xfrm>
           <a:prstGeom prst="rect">
             <a:avLst/>
@@ -18878,7 +19244,7 @@
               <a:buChar char="•"/>
             </a:pPr>
             <a:r>
-              <a:rPr sz="930" i="0">
+              <a:rPr sz="919" i="0">
                 <a:solidFill>
                   <a:srgbClr val="1D1D1F"/>
                 </a:solidFill>
@@ -18895,13 +19261,13 @@
               <a:buChar char="•"/>
             </a:pPr>
             <a:r>
-              <a:rPr sz="930" i="0">
+              <a:rPr sz="919" i="0">
                 <a:solidFill>
                   <a:srgbClr val="1D1D1F"/>
                 </a:solidFill>
                 <a:latin typeface="Google Sans Flex"/>
               </a:rPr>
-              <a:t>imagehash: perceptual hashing for reused photos</a:t>
+              <a:t>imagehash: reused-photo detection</a:t>
             </a:r>
           </a:p>
           <a:p>
@@ -18912,13 +19278,13 @@
               <a:buChar char="•"/>
             </a:pPr>
             <a:r>
-              <a:rPr sz="930" i="0">
+              <a:rPr sz="919" i="0">
                 <a:solidFill>
                   <a:srgbClr val="1D1D1F"/>
                 </a:solidFill>
                 <a:latin typeface="Google Sans Flex"/>
               </a:rPr>
-              <a:t>Plain HTML, CSS and JavaScript: no build step</a:t>
+              <a:t>Plain HTML, CSS, JavaScript and SVG charts: no build step</a:t>
             </a:r>
           </a:p>
           <a:p>
@@ -18929,7 +19295,7 @@
               <a:buChar char="•"/>
             </a:pPr>
             <a:r>
-              <a:rPr sz="930" i="0">
+              <a:rPr sz="919" i="0">
                 <a:solidFill>
                   <a:srgbClr val="1D1D1F"/>
                 </a:solidFill>
@@ -18946,7 +19312,7 @@
               <a:buChar char="•"/>
             </a:pPr>
             <a:r>
-              <a:rPr sz="930" i="0">
+              <a:rPr sz="919" i="0">
                 <a:solidFill>
                   <a:srgbClr val="1D1D1F"/>
                 </a:solidFill>

</xml_diff>

<commit_message>
docs: deck tells the real problem: founder's story, pains for buyers, breeders and animals, a pain-to-product journey slide, scale and growth loop
- Problem slide with cited 2023 and 2026 cases and why it is still unsolved
- New slide maps each step (find, list, trust, check, talk, buy, after, grow) to what is built and measured
- Opportunities maps each pain to its fix; business slide adds market size, unit cost and rollout phases
- New sources recorded in 05-deck-sources.md
</commit_message>
<xml_diff>
--- a/docs/submission/BreederNear-AI-deck.pptx
+++ b/docs/submission/BreederNear-AI-deck.pptx
@@ -10,6 +10,7 @@
   <p:sldIdLst>
     <p:sldId id="256" r:id="rId6"/>
     <p:sldId id="258" r:id="rId8"/>
+    <p:sldId id="272" r:id="rId22"/>
     <p:sldId id="259" r:id="rId9"/>
     <p:sldId id="260" r:id="rId10"/>
     <p:sldId id="261" r:id="rId11"/>
@@ -10734,7 +10735,7 @@
                 <a:cs typeface="Google Sans Flex Medium"/>
                 <a:sym typeface="Google Sans Flex Medium"/>
               </a:rPr>
-              <a:t>Business case and go-to-market</a:t>
+              <a:t>Business case, scale and go-to-market</a:t>
             </a:r>
             <a:endParaRPr sz="1600">
               <a:latin typeface="Google Sans Flex Medium"/>
@@ -10753,12 +10754,12 @@
         </p:nvSpPr>
         <p:spPr>
           <a:xfrm>
-            <a:off x="320040" y="1115568"/>
-            <a:ext cx="2712720" cy="2377440"/>
+            <a:off x="320040" y="1097280"/>
+            <a:ext cx="8503920" cy="384048"/>
           </a:xfrm>
           <a:prstGeom prst="roundRect">
             <a:avLst>
-              <a:gd name="adj" fmla="val 3076"/>
+              <a:gd name="adj" fmla="val 19047"/>
             </a:avLst>
           </a:prstGeom>
           <a:solidFill>
@@ -10797,8 +10798,8 @@
         </p:nvSpPr>
         <p:spPr>
           <a:xfrm>
-            <a:off x="411479" y="1188720"/>
-            <a:ext cx="2529840" cy="2267712"/>
+            <a:off x="429768" y="1097280"/>
+            <a:ext cx="8284464" cy="384048"/>
           </a:xfrm>
           <a:prstGeom prst="rect">
             <a:avLst/>
@@ -10806,92 +10807,33 @@
           <a:noFill/>
         </p:spPr>
         <p:txBody>
-          <a:bodyPr wrap="square" anchor="t" lIns="36576" rIns="36576" tIns="18288" bIns="18288">
+          <a:bodyPr wrap="square" anchor="ctr" lIns="36576" rIns="36576" tIns="18288" bIns="18288">
             <a:spAutoFit/>
           </a:bodyPr>
           <a:lstStyle/>
           <a:p>
             <a:pPr algn="l">
               <a:spcAft>
-                <a:spcPts val="400"/>
-              </a:spcAft>
-            </a:pPr>
-            <a:r>
-              <a:rPr sz="1250" i="0">
+                <a:spcPts val="300"/>
+              </a:spcAft>
+            </a:pPr>
+            <a:r>
+              <a:rPr sz="1050" i="0">
                 <a:solidFill>
                   <a:srgbClr val="1F6E43"/>
                 </a:solidFill>
                 <a:latin typeface="Google Sans Flex SemiBold"/>
               </a:rPr>
-              <a:t>Revenue (planned)</a:t>
-            </a:r>
-          </a:p>
-          <a:p>
-            <a:pPr algn="l" marL="146304" indent="-128016">
-              <a:spcAft>
-                <a:spcPts val="300"/>
-              </a:spcAft>
-              <a:buChar char="•"/>
-            </a:pPr>
-            <a:r>
-              <a:rPr sz="1060" i="0">
+              <a:t>Market: </a:t>
+            </a:r>
+            <a:r>
+              <a:rPr sz="1050" i="0">
                 <a:solidFill>
                   <a:srgbClr val="1D1D1F"/>
                 </a:solidFill>
                 <a:latin typeface="Google Sans Flex"/>
               </a:rPr>
-              <a:t>Verified-breeder subscription: badge, dashboard insights, more listings</a:t>
-            </a:r>
-          </a:p>
-          <a:p>
-            <a:pPr algn="l" marL="146304" indent="-128016">
-              <a:spcAft>
-                <a:spcPts val="300"/>
-              </a:spcAft>
-              <a:buChar char="•"/>
-            </a:pPr>
-            <a:r>
-              <a:rPr sz="1060" i="0">
-                <a:solidFill>
-                  <a:srgbClr val="1D1D1F"/>
-                </a:solidFill>
-                <a:latin typeface="Google Sans Flex"/>
-              </a:rPr>
-              <a:t>Featured listings in a district</a:t>
-            </a:r>
-          </a:p>
-          <a:p>
-            <a:pPr algn="l" marL="146304" indent="-128016">
-              <a:spcAft>
-                <a:spcPts val="300"/>
-              </a:spcAft>
-              <a:buChar char="•"/>
-            </a:pPr>
-            <a:r>
-              <a:rPr sz="1060" i="0">
-                <a:solidFill>
-                  <a:srgbClr val="1D1D1F"/>
-                </a:solidFill>
-                <a:latin typeface="Google Sans Flex"/>
-              </a:rPr>
-              <a:t>Commission on starter kits and accessories from partner brands</a:t>
-            </a:r>
-          </a:p>
-          <a:p>
-            <a:pPr algn="l" marL="146304" indent="-128016">
-              <a:spcAft>
-                <a:spcPts val="300"/>
-              </a:spcAft>
-              <a:buChar char="•"/>
-            </a:pPr>
-            <a:r>
-              <a:rPr sz="1060" i="0">
-                <a:solidFill>
-                  <a:srgbClr val="1D1D1F"/>
-                </a:solidFill>
-                <a:latin typeface="Google Sans Flex"/>
-              </a:rPr>
-              <a:t>B2B: trust-screening API for classifieds and pet shops</a:t>
+              <a:t>India’s pet care products market is USD 9.2 B in 2026, heading to USD 13.9 B by 2034⁷, with about 39 million pets¹. The animals themselves are still sold with no checks: that is our wedge.</a:t>
             </a:r>
           </a:p>
         </p:txBody>
@@ -10904,16 +10846,16 @@
         </p:nvSpPr>
         <p:spPr>
           <a:xfrm>
-            <a:off x="3215640" y="1115568"/>
-            <a:ext cx="2712720" cy="2377440"/>
+            <a:off x="320040" y="1591056"/>
+            <a:ext cx="2712720" cy="2212848"/>
           </a:xfrm>
           <a:prstGeom prst="roundRect">
             <a:avLst>
-              <a:gd name="adj" fmla="val 3076"/>
+              <a:gd name="adj" fmla="val 3305"/>
             </a:avLst>
           </a:prstGeom>
           <a:solidFill>
-            <a:srgbClr val="E4EDF8"/>
+            <a:srgbClr val="E5F0E8"/>
           </a:solidFill>
           <a:ln>
             <a:noFill/>
@@ -10948,8 +10890,8 @@
         </p:nvSpPr>
         <p:spPr>
           <a:xfrm>
-            <a:off x="3307080" y="1188720"/>
-            <a:ext cx="2529840" cy="2267712"/>
+            <a:off x="411479" y="1664208"/>
+            <a:ext cx="2529840" cy="2103120"/>
           </a:xfrm>
           <a:prstGeom prst="rect">
             <a:avLst/>
@@ -10968,13 +10910,13 @@
               </a:spcAft>
             </a:pPr>
             <a:r>
-              <a:rPr sz="1250" i="0">
-                <a:solidFill>
-                  <a:srgbClr val="1F5FA8"/>
+              <a:rPr sz="1150" i="0">
+                <a:solidFill>
+                  <a:srgbClr val="1F6E43"/>
                 </a:solidFill>
                 <a:latin typeface="Google Sans Flex SemiBold"/>
               </a:rPr>
-              <a:t>Why it works</a:t>
+              <a:t>Revenue (planned)</a:t>
             </a:r>
           </a:p>
           <a:p>
@@ -10985,13 +10927,13 @@
               <a:buChar char="•"/>
             </a:pPr>
             <a:r>
-              <a:rPr sz="1060" i="0">
+              <a:rPr sz="980" i="0">
                 <a:solidFill>
                   <a:srgbClr val="1D1D1F"/>
                 </a:solidFill>
                 <a:latin typeface="Google Sans Flex"/>
               </a:rPr>
-              <a:t>Screening costs about ₹1.3 per listing (measured tokens)</a:t>
+              <a:t>Verified-breeder subscription: badge, dashboard insights, more listings</a:t>
             </a:r>
           </a:p>
           <a:p>
@@ -11002,13 +10944,13 @@
               <a:buChar char="•"/>
             </a:pPr>
             <a:r>
-              <a:rPr sz="1060" i="0">
+              <a:rPr sz="980" i="0">
                 <a:solidFill>
                   <a:srgbClr val="1D1D1F"/>
                 </a:solidFill>
                 <a:latin typeface="Google Sans Flex"/>
               </a:rPr>
-              <a:t>Serverless: Cloud Run and Firestore cost little when idle and scale per district</a:t>
+              <a:t>Featured listings per district</a:t>
             </a:r>
           </a:p>
           <a:p>
@@ -11019,13 +10961,30 @@
               <a:buChar char="•"/>
             </a:pPr>
             <a:r>
-              <a:rPr sz="1060" i="0">
+              <a:rPr sz="980" i="0">
                 <a:solidFill>
                   <a:srgbClr val="1D1D1F"/>
                 </a:solidFill>
                 <a:latin typeface="Google Sans Flex"/>
               </a:rPr>
-              <a:t>Trust is the product: OLX left this market because it couldn’t police sellers</a:t>
+              <a:t>Starter-kit and accessory commerce after every sale (cart already built)</a:t>
+            </a:r>
+          </a:p>
+          <a:p>
+            <a:pPr algn="l" marL="146304" indent="-128016">
+              <a:spcAft>
+                <a:spcPts val="300"/>
+              </a:spcAft>
+              <a:buChar char="•"/>
+            </a:pPr>
+            <a:r>
+              <a:rPr sz="980" i="0">
+                <a:solidFill>
+                  <a:srgbClr val="1D1D1F"/>
+                </a:solidFill>
+                <a:latin typeface="Google Sans Flex"/>
+              </a:rPr>
+              <a:t>B2B trust-screening API for classifieds and pet shops</a:t>
             </a:r>
           </a:p>
         </p:txBody>
@@ -11038,16 +10997,16 @@
         </p:nvSpPr>
         <p:spPr>
           <a:xfrm>
-            <a:off x="6111240" y="1115568"/>
-            <a:ext cx="2712720" cy="2377440"/>
+            <a:off x="3215640" y="1591056"/>
+            <a:ext cx="2712720" cy="2212848"/>
           </a:xfrm>
           <a:prstGeom prst="roundRect">
             <a:avLst>
-              <a:gd name="adj" fmla="val 3076"/>
+              <a:gd name="adj" fmla="val 3305"/>
             </a:avLst>
           </a:prstGeom>
           <a:solidFill>
-            <a:srgbClr val="FBEFD9"/>
+            <a:srgbClr val="E4EDF8"/>
           </a:solidFill>
           <a:ln>
             <a:noFill/>
@@ -11082,8 +11041,8 @@
         </p:nvSpPr>
         <p:spPr>
           <a:xfrm>
-            <a:off x="6202680" y="1188720"/>
-            <a:ext cx="2529840" cy="2267712"/>
+            <a:off x="3307080" y="1664208"/>
+            <a:ext cx="2529840" cy="2103120"/>
           </a:xfrm>
           <a:prstGeom prst="rect">
             <a:avLst/>
@@ -11102,13 +11061,13 @@
               </a:spcAft>
             </a:pPr>
             <a:r>
-              <a:rPr sz="1250" i="0">
-                <a:solidFill>
-                  <a:srgbClr val="9A5700"/>
+              <a:rPr sz="1150" i="0">
+                <a:solidFill>
+                  <a:srgbClr val="1F5FA8"/>
                 </a:solidFill>
                 <a:latin typeface="Google Sans Flex SemiBold"/>
               </a:rPr>
-              <a:t>Go-to-market</a:t>
+              <a:t>Built to scale</a:t>
             </a:r>
           </a:p>
           <a:p>
@@ -11119,13 +11078,13 @@
               <a:buChar char="•"/>
             </a:pPr>
             <a:r>
-              <a:rPr sz="1060" i="0">
+              <a:rPr sz="980" i="0">
                 <a:solidFill>
                   <a:srgbClr val="1D1D1F"/>
                 </a:solidFill>
                 <a:latin typeface="Google Sans Flex"/>
               </a:rPr>
-              <a:t>Start where the founder trades: Coimbatore and Tiruppur breeder groups</a:t>
+              <a:t>Trust costs ≈ ₹1.3 per listing (measured) against pets priced ₹400–₹25,000</a:t>
             </a:r>
           </a:p>
           <a:p>
@@ -11136,13 +11095,13 @@
               <a:buChar char="•"/>
             </a:pPr>
             <a:r>
-              <a:rPr sz="1060" i="0">
+              <a:rPr sz="980" i="0">
                 <a:solidFill>
                   <a:srgbClr val="1D1D1F"/>
                 </a:solidFill>
                 <a:latin typeface="Google Sans Flex"/>
               </a:rPr>
-              <a:t>Breeders onboard with one message and their phone photos</a:t>
+              <a:t>Serverless Cloud Run + Firestore: near zero when idle, scales out per request</a:t>
             </a:r>
           </a:p>
           <a:p>
@@ -11153,13 +11112,13 @@
               <a:buChar char="•"/>
             </a:pPr>
             <a:r>
-              <a:rPr sz="1060" i="0">
+              <a:rPr sz="980" i="0">
                 <a:solidFill>
                   <a:srgbClr val="1D1D1F"/>
                 </a:solidFill>
                 <a:latin typeface="Google Sans Flex"/>
               </a:rPr>
-              <a:t>Buyers arrive via “Is this post safe?” links shared in the same groups</a:t>
+              <a:t>Districts, species, fair prices and protected lists are data, not code: a new district is a data file</a:t>
             </a:r>
           </a:p>
           <a:p>
@@ -11170,27 +11129,71 @@
               <a:buChar char="•"/>
             </a:pPr>
             <a:r>
-              <a:rPr sz="1060" i="0">
+              <a:rPr sz="980" i="0">
                 <a:solidFill>
                   <a:srgbClr val="1D1D1F"/>
                 </a:solidFill>
                 <a:latin typeface="Google Sans Flex"/>
               </a:rPr>
-              <a:t>Then district by district across Tamil Nadu</a:t>
+              <a:t>Gemini already reads Tamil, English and mixed messages</a:t>
             </a:r>
           </a:p>
         </p:txBody>
       </p:sp>
       <p:sp>
         <p:nvSpPr>
-          <p:cNvPr id="173" name="TextBox 172"/>
+          <p:cNvPr id="173" name="Rounded Rectangle 172"/>
+          <p:cNvSpPr/>
+          <p:nvPr/>
+        </p:nvSpPr>
+        <p:spPr>
+          <a:xfrm>
+            <a:off x="6111240" y="1591056"/>
+            <a:ext cx="2712720" cy="2212848"/>
+          </a:xfrm>
+          <a:prstGeom prst="roundRect">
+            <a:avLst>
+              <a:gd name="adj" fmla="val 3305"/>
+            </a:avLst>
+          </a:prstGeom>
+          <a:solidFill>
+            <a:srgbClr val="FBEFD9"/>
+          </a:solidFill>
+          <a:ln>
+            <a:noFill/>
+          </a:ln>
+          <a:effectLst/>
+        </p:spPr>
+        <p:style>
+          <a:lnRef idx="1">
+            <a:schemeClr val="accent1"/>
+          </a:lnRef>
+          <a:fillRef idx="3">
+            <a:schemeClr val="accent1"/>
+          </a:fillRef>
+          <a:effectRef idx="2">
+            <a:schemeClr val="accent1"/>
+          </a:effectRef>
+          <a:fontRef idx="minor">
+            <a:schemeClr val="lt1"/>
+          </a:fontRef>
+        </p:style>
+        <p:txBody>
+          <a:bodyPr rtlCol="0" anchor="ctr"/>
+          <a:lstStyle/>
+          <a:p/>
+        </p:txBody>
+      </p:sp>
+      <p:sp>
+        <p:nvSpPr>
+          <p:cNvPr id="174" name="TextBox 173"/>
           <p:cNvSpPr txBox="1"/>
           <p:nvPr/>
         </p:nvSpPr>
         <p:spPr>
           <a:xfrm>
-            <a:off x="320040" y="3630168"/>
-            <a:ext cx="8503920" cy="914400"/>
+            <a:off x="6202680" y="1664208"/>
+            <a:ext cx="2529840" cy="2103120"/>
           </a:xfrm>
           <a:prstGeom prst="rect">
             <a:avLst/>
@@ -11205,19 +11208,227 @@
           <a:p>
             <a:pPr algn="l">
               <a:spcAft>
-                <a:spcPts val="200"/>
+                <a:spcPts val="400"/>
+              </a:spcAft>
+            </a:pPr>
+            <a:r>
+              <a:rPr sz="1150" i="0">
+                <a:solidFill>
+                  <a:srgbClr val="9A5700"/>
+                </a:solidFill>
+                <a:latin typeface="Google Sans Flex SemiBold"/>
+              </a:rPr>
+              <a:t>Go-to-market</a:t>
+            </a:r>
+          </a:p>
+          <a:p>
+            <a:pPr algn="l" marL="146304" indent="-128016">
+              <a:spcAft>
+                <a:spcPts val="300"/>
+              </a:spcAft>
+              <a:buChar char="•"/>
+            </a:pPr>
+            <a:r>
+              <a:rPr sz="980" i="0">
+                <a:solidFill>
+                  <a:srgbClr val="1D1D1F"/>
+                </a:solidFill>
+                <a:latin typeface="Google Sans Flex"/>
+              </a:rPr>
+              <a:t>1 · Pilot in Coimbatore and Tiruppur with the founder’s breeder network</a:t>
+            </a:r>
+          </a:p>
+          <a:p>
+            <a:pPr algn="l" marL="146304" indent="-128016">
+              <a:spcAft>
+                <a:spcPts val="300"/>
+              </a:spcAft>
+              <a:buChar char="•"/>
+            </a:pPr>
+            <a:r>
+              <a:rPr sz="980" i="0">
+                <a:solidFill>
+                  <a:srgbClr val="1D1D1F"/>
+                </a:solidFill>
+                <a:latin typeface="Google Sans Flex"/>
+              </a:rPr>
+              <a:t>2 · Tamil Nadu, district by district; list by sending a WhatsApp message</a:t>
+            </a:r>
+          </a:p>
+          <a:p>
+            <a:pPr algn="l" marL="146304" indent="-128016">
+              <a:spcAft>
+                <a:spcPts val="300"/>
+              </a:spcAft>
+              <a:buChar char="•"/>
+            </a:pPr>
+            <a:r>
+              <a:rPr sz="980" i="0">
+                <a:solidFill>
+                  <a:srgbClr val="1D1D1F"/>
+                </a:solidFill>
+                <a:latin typeface="Google Sans Flex"/>
+              </a:rPr>
+              <a:t>3 · Other states and languages; the trust API for other marketplaces</a:t>
+            </a:r>
+          </a:p>
+          <a:p>
+            <a:pPr algn="l" marL="146304" indent="-128016">
+              <a:spcAft>
+                <a:spcPts val="300"/>
+              </a:spcAft>
+              <a:buChar char="•"/>
+            </a:pPr>
+            <a:r>
+              <a:rPr sz="980" i="0">
+                <a:solidFill>
+                  <a:srgbClr val="1D1D1F"/>
+                </a:solidFill>
+                <a:latin typeface="Google Sans Flex"/>
+              </a:rPr>
+              <a:t>Buyers arrive through “Is this post safe?” links shared in the same groups</a:t>
+            </a:r>
+          </a:p>
+        </p:txBody>
+      </p:sp>
+      <p:sp>
+        <p:nvSpPr>
+          <p:cNvPr id="175" name="Rounded Rectangle 174"/>
+          <p:cNvSpPr/>
+          <p:nvPr/>
+        </p:nvSpPr>
+        <p:spPr>
+          <a:xfrm>
+            <a:off x="320040" y="3895344"/>
+            <a:ext cx="8503920" cy="566928"/>
+          </a:xfrm>
+          <a:prstGeom prst="roundRect">
+            <a:avLst>
+              <a:gd name="adj" fmla="val 12903"/>
+            </a:avLst>
+          </a:prstGeom>
+          <a:solidFill>
+            <a:srgbClr val="F3F3F0"/>
+          </a:solidFill>
+          <a:ln>
+            <a:noFill/>
+          </a:ln>
+          <a:effectLst/>
+        </p:spPr>
+        <p:style>
+          <a:lnRef idx="1">
+            <a:schemeClr val="accent1"/>
+          </a:lnRef>
+          <a:fillRef idx="3">
+            <a:schemeClr val="accent1"/>
+          </a:fillRef>
+          <a:effectRef idx="2">
+            <a:schemeClr val="accent1"/>
+          </a:effectRef>
+          <a:fontRef idx="minor">
+            <a:schemeClr val="lt1"/>
+          </a:fontRef>
+        </p:style>
+        <p:txBody>
+          <a:bodyPr rtlCol="0" anchor="ctr"/>
+          <a:lstStyle/>
+          <a:p/>
+        </p:txBody>
+      </p:sp>
+      <p:sp>
+        <p:nvSpPr>
+          <p:cNvPr id="176" name="TextBox 175"/>
+          <p:cNvSpPr txBox="1"/>
+          <p:nvPr/>
+        </p:nvSpPr>
+        <p:spPr>
+          <a:xfrm>
+            <a:off x="429768" y="3913632"/>
+            <a:ext cx="8284464" cy="548640"/>
+          </a:xfrm>
+          <a:prstGeom prst="rect">
+            <a:avLst/>
+          </a:prstGeom>
+          <a:noFill/>
+        </p:spPr>
+        <p:txBody>
+          <a:bodyPr wrap="square" anchor="t" lIns="36576" rIns="36576" tIns="18288" bIns="18288">
+            <a:spAutoFit/>
+          </a:bodyPr>
+          <a:lstStyle/>
+          <a:p>
+            <a:pPr algn="l">
+              <a:spcAft>
+                <a:spcPts val="300"/>
               </a:spcAft>
             </a:pPr>
             <a:r>
               <a:rPr sz="1000" i="0">
                 <a:solidFill>
+                  <a:srgbClr val="1F6E43"/>
+                </a:solidFill>
+                <a:latin typeface="Google Sans Flex SemiBold"/>
+              </a:rPr>
+              <a:t>Growth loop: </a:t>
+            </a:r>
+            <a:r>
+              <a:rPr sz="1000" i="0">
+                <a:solidFill>
                   <a:srgbClr val="1D1D1F"/>
                 </a:solidFill>
+                <a:latin typeface="Google Sans Flex"/>
+              </a:rPr>
+              <a:t>verified breeders → trusted listings → more buyers → more sales and care data → sharper fair prices and trust scores → more breeders join.</a:t>
+            </a:r>
+          </a:p>
+          <a:p>
+            <a:pPr algn="l">
+              <a:spcAft>
+                <a:spcPts val="300"/>
+              </a:spcAft>
+            </a:pPr>
+            <a:r>
+              <a:rPr sz="1000" i="0">
+                <a:solidFill>
+                  <a:srgbClr val="1F6E43"/>
+                </a:solidFill>
                 <a:latin typeface="Google Sans Flex SemiBold"/>
               </a:rPr>
-              <a:t>Who benefits</a:t>
-            </a:r>
-          </a:p>
+              <a:t>Who benefits: </a:t>
+            </a:r>
+            <a:r>
+              <a:rPr sz="1000" i="0">
+                <a:solidFill>
+                  <a:srgbClr val="1D1D1F"/>
+                </a:solidFill>
+                <a:latin typeface="Google Sans Flex"/>
+              </a:rPr>
+              <a:t>buyers pay fair prices for healthy, legal pets; breeders win hours and reach; protected birds never get listed.</a:t>
+            </a:r>
+          </a:p>
+        </p:txBody>
+      </p:sp>
+      <p:sp>
+        <p:nvSpPr>
+          <p:cNvPr id="177" name="TextBox 176"/>
+          <p:cNvSpPr txBox="1"/>
+          <p:nvPr/>
+        </p:nvSpPr>
+        <p:spPr>
+          <a:xfrm>
+            <a:off x="320040" y="4681728"/>
+            <a:ext cx="8503920" cy="274320"/>
+          </a:xfrm>
+          <a:prstGeom prst="rect">
+            <a:avLst/>
+          </a:prstGeom>
+          <a:noFill/>
+        </p:spPr>
+        <p:txBody>
+          <a:bodyPr wrap="square" anchor="t" lIns="36576" rIns="36576" tIns="18288" bIns="18288">
+            <a:spAutoFit/>
+          </a:bodyPr>
+          <a:lstStyle/>
           <a:p>
             <a:pPr algn="l">
               <a:spcAft>
@@ -11225,29 +11436,13 @@
               </a:spcAft>
             </a:pPr>
             <a:r>
-              <a:rPr sz="1050" i="0">
-                <a:solidFill>
-                  <a:srgbClr val="1D1D1F"/>
+              <a:rPr sz="650" i="0">
+                <a:solidFill>
+                  <a:srgbClr val="5F5F64"/>
                 </a:solidFill>
                 <a:latin typeface="Google Sans Flex"/>
               </a:rPr>
-              <a:t>Buyers: fair prices and healthier, legal pets.  Breeders: hours saved and buyers beyond their own contacts.  Wildlife: fewer protected birds traded, because illegal listings never go live.</a:t>
-            </a:r>
-          </a:p>
-          <a:p>
-            <a:pPr algn="l">
-              <a:spcAft>
-                <a:spcPts val="300"/>
-              </a:spcAft>
-            </a:pPr>
-            <a:r>
-              <a:rPr sz="800" i="0">
-                <a:solidFill>
-                  <a:srgbClr val="5F5F64"/>
-                </a:solidFill>
-                <a:latin typeface="Google Sans Flex"/>
-              </a:rPr>
-              <a:t>Revenue lines and the rollout are plans and assumptions, not results.</a:t>
+              <a:t>Revenue lines and rollout are plans, not results · ¹ Euromonitor 2025 · ⁷ IMARC Group, India Pet Care Products Market (2026) · Cost: docs/submission/05-deck-sources.md</a:t>
             </a:r>
           </a:p>
         </p:txBody>
@@ -11340,6 +11535,1060 @@
 </p:sld>
 </file>
 
+<file path=ppt/slides/slide17.xml><?xml version="1.0" encoding="utf-8"?>
+<p:sld xmlns:a="http://schemas.openxmlformats.org/drawingml/2006/main" xmlns:p="http://schemas.openxmlformats.org/presentationml/2006/main" xmlns:r="http://schemas.openxmlformats.org/officeDocument/2006/relationships">
+  <p:cSld>
+    <p:spTree>
+      <p:nvGrpSpPr>
+        <p:cNvPr id="1" name=""/>
+        <p:cNvGrpSpPr/>
+        <p:nvPr/>
+      </p:nvGrpSpPr>
+      <p:grpSpPr/>
+      <p:pic>
+        <p:nvPicPr>
+          <p:cNvPr id="164" name="Google Shape;164;p27" title="Frame 144.png"/>
+          <p:cNvPicPr preferRelativeResize="0"/>
+          <p:nvPr/>
+        </p:nvPicPr>
+        <p:blipFill rotWithShape="1">
+          <a:blip r:embed="rId2">
+            <a:alphaModFix/>
+          </a:blip>
+          <a:srcRect b="98001" l="0" r="0" t="0"/>
+          <a:stretch/>
+        </p:blipFill>
+        <p:spPr>
+          <a:xfrm>
+            <a:off x="0" y="5093562"/>
+            <a:ext cx="9144000" cy="54275"/>
+          </a:xfrm>
+          <a:prstGeom prst="rect">
+            <a:avLst/>
+          </a:prstGeom>
+          <a:noFill/>
+          <a:ln>
+            <a:noFill/>
+          </a:ln>
+        </p:spPr>
+      </p:pic>
+      <p:pic>
+        <p:nvPicPr>
+          <p:cNvPr id="165" name="Google Shape;165;p27" title="Group 427319979.png"/>
+          <p:cNvPicPr preferRelativeResize="0"/>
+          <p:nvPr/>
+        </p:nvPicPr>
+        <p:blipFill>
+          <a:blip r:embed="rId3">
+            <a:alphaModFix/>
+          </a:blip>
+          <a:stretch>
+            <a:fillRect/>
+          </a:stretch>
+        </p:blipFill>
+        <p:spPr>
+          <a:xfrm>
+            <a:off x="0" y="1"/>
+            <a:ext cx="9144000" cy="507359"/>
+          </a:xfrm>
+          <a:prstGeom prst="rect">
+            <a:avLst/>
+          </a:prstGeom>
+          <a:noFill/>
+          <a:ln>
+            <a:noFill/>
+          </a:ln>
+        </p:spPr>
+      </p:pic>
+      <p:sp>
+        <p:nvSpPr>
+          <p:cNvPr id="166" name="Google Shape;166;p27"/>
+          <p:cNvSpPr/>
+          <p:nvPr/>
+        </p:nvSpPr>
+        <p:spPr>
+          <a:xfrm>
+            <a:off x="-29250" y="5071875"/>
+            <a:ext cx="9173400" cy="97800"/>
+          </a:xfrm>
+          <a:prstGeom prst="rect">
+            <a:avLst/>
+          </a:prstGeom>
+          <a:solidFill>
+            <a:schemeClr val="dk1"/>
+          </a:solidFill>
+          <a:ln>
+            <a:noFill/>
+          </a:ln>
+        </p:spPr>
+        <p:txBody>
+          <a:bodyPr anchorCtr="0" anchor="ctr" bIns="91425" lIns="91425" spcFirstLastPara="1" rIns="91425" wrap="square" tIns="91425">
+            <a:noAutofit/>
+          </a:bodyPr>
+          <a:lstStyle/>
+          <a:p>
+            <a:pPr indent="0" lvl="0" marL="0" rtl="0" algn="ctr">
+              <a:spcBef>
+                <a:spcPts val="0"/>
+              </a:spcBef>
+              <a:spcAft>
+                <a:spcPts val="0"/>
+              </a:spcAft>
+              <a:buNone/>
+            </a:pPr>
+            <a:r>
+              <a:t/>
+            </a:r>
+            <a:endParaRPr/>
+          </a:p>
+        </p:txBody>
+      </p:sp>
+      <p:sp>
+        <p:nvSpPr>
+          <p:cNvPr id="135" name="Google Shape;135;p23"/>
+          <p:cNvSpPr txBox="1"/>
+          <p:nvPr/>
+        </p:nvSpPr>
+        <p:spPr>
+          <a:xfrm>
+            <a:off x="265350" y="663825"/>
+            <a:ext cx="8943000" cy="561900"/>
+          </a:xfrm>
+          <a:prstGeom prst="rect">
+            <a:avLst/>
+          </a:prstGeom>
+          <a:noFill/>
+          <a:ln>
+            <a:noFill/>
+          </a:ln>
+        </p:spPr>
+        <p:txBody>
+          <a:bodyPr anchorCtr="0" anchor="t" bIns="91425" lIns="91425" spcFirstLastPara="1" rIns="91425" wrap="square" tIns="91425">
+            <a:noAutofit/>
+          </a:bodyPr>
+          <a:lstStyle/>
+          <a:p>
+            <a:pPr indent="0" lvl="0" marL="0" rtl="0" algn="l">
+              <a:spcBef>
+                <a:spcPts val="0"/>
+              </a:spcBef>
+              <a:spcAft>
+                <a:spcPts val="0"/>
+              </a:spcAft>
+              <a:buNone/>
+            </a:pPr>
+            <a:r>
+              <a:rPr lang="en-GB" sz="1600">
+                <a:latin typeface="Google Sans Flex Medium"/>
+                <a:ea typeface="Google Sans Flex Medium"/>
+                <a:cs typeface="Google Sans Flex Medium"/>
+                <a:sym typeface="Google Sans Flex Medium"/>
+              </a:rPr>
+              <a:t>From pain to product: the whole journey, end to end</a:t>
+            </a:r>
+            <a:endParaRPr sz="1600">
+              <a:latin typeface="Google Sans Flex Medium"/>
+              <a:ea typeface="Google Sans Flex Medium"/>
+              <a:cs typeface="Google Sans Flex Medium"/>
+              <a:sym typeface="Google Sans Flex Medium"/>
+            </a:endParaRPr>
+          </a:p>
+        </p:txBody>
+      </p:sp>
+      <p:graphicFrame>
+        <p:nvGraphicFramePr>
+          <p:cNvPr id="167" name="Table 166"/>
+          <p:cNvGraphicFramePr>
+            <a:graphicFrameLocks noGrp="1"/>
+          </p:cNvGraphicFramePr>
+          <p:nvPr/>
+        </p:nvGraphicFramePr>
+        <p:xfrm>
+          <a:off x="320040" y="1097280"/>
+          <a:ext cx="8503920" cy="3209544"/>
+        </p:xfrm>
+        <a:graphic>
+          <a:graphicData uri="http://schemas.openxmlformats.org/drawingml/2006/table">
+            <a:tbl>
+              <a:tblPr firstRow="1" bandRow="1">
+                <a:tableStyleId>{5C22544A-7EE6-4342-B048-85BDC9FD1C3A}</a:tableStyleId>
+              </a:tblPr>
+              <a:tblGrid>
+                <a:gridCol w="685800"/>
+                <a:gridCol w="2331720"/>
+                <a:gridCol w="3154680"/>
+                <a:gridCol w="2331720"/>
+              </a:tblGrid>
+              <a:tr h="356616">
+                <a:tc>
+                  <a:txBody>
+                    <a:bodyPr wrap="square"/>
+                    <a:lstStyle/>
+                    <a:p>
+                      <a:r>
+                        <a:rPr sz="880">
+                          <a:solidFill>
+                            <a:srgbClr val="FFFFFF"/>
+                          </a:solidFill>
+                          <a:latin typeface="Google Sans Flex SemiBold"/>
+                        </a:rPr>
+                        <a:t>Step</a:t>
+                      </a:r>
+                    </a:p>
+                  </a:txBody>
+                  <a:tcPr marL="54864" marR="54864" marT="22860" marB="22860" anchor="ctr">
+                    <a:solidFill>
+                      <a:srgbClr val="1D1D1F"/>
+                    </a:solidFill>
+                  </a:tcPr>
+                </a:tc>
+                <a:tc>
+                  <a:txBody>
+                    <a:bodyPr wrap="square"/>
+                    <a:lstStyle/>
+                    <a:p>
+                      <a:r>
+                        <a:rPr sz="880">
+                          <a:solidFill>
+                            <a:srgbClr val="FFFFFF"/>
+                          </a:solidFill>
+                          <a:latin typeface="Google Sans Flex SemiBold"/>
+                        </a:rPr>
+                        <a:t>Today, in groups and shops</a:t>
+                      </a:r>
+                    </a:p>
+                  </a:txBody>
+                  <a:tcPr marL="54864" marR="54864" marT="22860" marB="22860" anchor="ctr">
+                    <a:solidFill>
+                      <a:srgbClr val="1D1D1F"/>
+                    </a:solidFill>
+                  </a:tcPr>
+                </a:tc>
+                <a:tc>
+                  <a:txBody>
+                    <a:bodyPr wrap="square"/>
+                    <a:lstStyle/>
+                    <a:p>
+                      <a:r>
+                        <a:rPr sz="880">
+                          <a:solidFill>
+                            <a:srgbClr val="FFFFFF"/>
+                          </a:solidFill>
+                          <a:latin typeface="Google Sans Flex SemiBold"/>
+                        </a:rPr>
+                        <a:t>With BreederNear AI</a:t>
+                      </a:r>
+                    </a:p>
+                  </a:txBody>
+                  <a:tcPr marL="54864" marR="54864" marT="22860" marB="22860" anchor="ctr">
+                    <a:solidFill>
+                      <a:srgbClr val="1D1D1F"/>
+                    </a:solidFill>
+                  </a:tcPr>
+                </a:tc>
+                <a:tc>
+                  <a:txBody>
+                    <a:bodyPr wrap="square"/>
+                    <a:lstStyle/>
+                    <a:p>
+                      <a:r>
+                        <a:rPr sz="880">
+                          <a:solidFill>
+                            <a:srgbClr val="FFFFFF"/>
+                          </a:solidFill>
+                          <a:latin typeface="Google Sans Flex SemiBold"/>
+                        </a:rPr>
+                        <a:t>Built and measured</a:t>
+                      </a:r>
+                    </a:p>
+                  </a:txBody>
+                  <a:tcPr marL="54864" marR="54864" marT="22860" marB="22860" anchor="ctr">
+                    <a:solidFill>
+                      <a:srgbClr val="1D1D1F"/>
+                    </a:solidFill>
+                  </a:tcPr>
+                </a:tc>
+              </a:tr>
+              <a:tr h="356616">
+                <a:tc>
+                  <a:txBody>
+                    <a:bodyPr wrap="square"/>
+                    <a:lstStyle/>
+                    <a:p>
+                      <a:r>
+                        <a:rPr sz="880">
+                          <a:solidFill>
+                            <a:srgbClr val="1D1D1F"/>
+                          </a:solidFill>
+                          <a:latin typeface="Google Sans Flex"/>
+                        </a:rPr>
+                        <a:t>Find</a:t>
+                      </a:r>
+                    </a:p>
+                  </a:txBody>
+                  <a:tcPr marL="54864" marR="54864" marT="22860" marB="22860" anchor="ctr">
+                    <a:solidFill>
+                      <a:srgbClr val="FFFFFF"/>
+                    </a:solidFill>
+                  </a:tcPr>
+                </a:tc>
+                <a:tc>
+                  <a:txBody>
+                    <a:bodyPr wrap="square"/>
+                    <a:lstStyle/>
+                    <a:p>
+                      <a:r>
+                        <a:rPr sz="880">
+                          <a:solidFill>
+                            <a:srgbClr val="1D1D1F"/>
+                          </a:solidFill>
+                          <a:latin typeface="Google Sans Flex"/>
+                        </a:rPr>
+                        <a:t>Walk into the nearest shop; the breeder next door is invisible</a:t>
+                      </a:r>
+                    </a:p>
+                  </a:txBody>
+                  <a:tcPr marL="54864" marR="54864" marT="22860" marB="22860" anchor="ctr">
+                    <a:solidFill>
+                      <a:srgbClr val="FFFFFF"/>
+                    </a:solidFill>
+                  </a:tcPr>
+                </a:tc>
+                <a:tc>
+                  <a:txBody>
+                    <a:bodyPr wrap="square"/>
+                    <a:lstStyle/>
+                    <a:p>
+                      <a:r>
+                        <a:rPr sz="880">
+                          <a:solidFill>
+                            <a:srgbClr val="1D1D1F"/>
+                          </a:solidFill>
+                          <a:latin typeface="Google Sans Flex"/>
+                        </a:rPr>
+                        <a:t>Pets near you, trusted first, a match % for your home, a fair-price bar</a:t>
+                      </a:r>
+                    </a:p>
+                  </a:txBody>
+                  <a:tcPr marL="54864" marR="54864" marT="22860" marB="22860" anchor="ctr">
+                    <a:solidFill>
+                      <a:srgbClr val="FFFFFF"/>
+                    </a:solidFill>
+                  </a:tcPr>
+                </a:tc>
+                <a:tc>
+                  <a:txBody>
+                    <a:bodyPr wrap="square"/>
+                    <a:lstStyle/>
+                    <a:p>
+                      <a:r>
+                        <a:rPr sz="880">
+                          <a:solidFill>
+                            <a:srgbClr val="1D1D1F"/>
+                          </a:solidFill>
+                          <a:latin typeface="Google Sans Flex"/>
+                        </a:rPr>
+                        <a:t>Match % calculated in code; 16 breeders, 36 pets</a:t>
+                      </a:r>
+                    </a:p>
+                  </a:txBody>
+                  <a:tcPr marL="54864" marR="54864" marT="22860" marB="22860" anchor="ctr">
+                    <a:solidFill>
+                      <a:srgbClr val="FFFFFF"/>
+                    </a:solidFill>
+                  </a:tcPr>
+                </a:tc>
+              </a:tr>
+              <a:tr h="356616">
+                <a:tc>
+                  <a:txBody>
+                    <a:bodyPr wrap="square"/>
+                    <a:lstStyle/>
+                    <a:p>
+                      <a:r>
+                        <a:rPr sz="880">
+                          <a:solidFill>
+                            <a:srgbClr val="1D1D1F"/>
+                          </a:solidFill>
+                          <a:latin typeface="Google Sans Flex"/>
+                        </a:rPr>
+                        <a:t>List</a:t>
+                      </a:r>
+                    </a:p>
+                  </a:txBody>
+                  <a:tcPr marL="54864" marR="54864" marT="22860" marB="22860" anchor="ctr">
+                    <a:solidFill>
+                      <a:srgbClr val="F3F3F0"/>
+                    </a:solidFill>
+                  </a:tcPr>
+                </a:tc>
+                <a:tc>
+                  <a:txBody>
+                    <a:bodyPr wrap="square"/>
+                    <a:lstStyle/>
+                    <a:p>
+                      <a:r>
+                        <a:rPr sz="880">
+                          <a:solidFill>
+                            <a:srgbClr val="1D1D1F"/>
+                          </a:solidFill>
+                          <a:latin typeface="Google Sans Flex"/>
+                        </a:rPr>
+                        <a:t>Breeder retypes the same post in every group</a:t>
+                      </a:r>
+                    </a:p>
+                  </a:txBody>
+                  <a:tcPr marL="54864" marR="54864" marT="22860" marB="22860" anchor="ctr">
+                    <a:solidFill>
+                      <a:srgbClr val="F3F3F0"/>
+                    </a:solidFill>
+                  </a:tcPr>
+                </a:tc>
+                <a:tc>
+                  <a:txBody>
+                    <a:bodyPr wrap="square"/>
+                    <a:lstStyle/>
+                    <a:p>
+                      <a:r>
+                        <a:rPr sz="880">
+                          <a:solidFill>
+                            <a:srgbClr val="1D1D1F"/>
+                          </a:solidFill>
+                          <a:latin typeface="Google Sans Flex"/>
+                        </a:rPr>
+                        <a:t>Photos + a Tamil or English message become a full listing</a:t>
+                      </a:r>
+                    </a:p>
+                  </a:txBody>
+                  <a:tcPr marL="54864" marR="54864" marT="22860" marB="22860" anchor="ctr">
+                    <a:solidFill>
+                      <a:srgbClr val="F3F3F0"/>
+                    </a:solidFill>
+                  </a:tcPr>
+                </a:tc>
+                <a:tc>
+                  <a:txBody>
+                    <a:bodyPr wrap="square"/>
+                    <a:lstStyle/>
+                    <a:p>
+                      <a:r>
+                        <a:rPr sz="880">
+                          <a:solidFill>
+                            <a:srgbClr val="1D1D1F"/>
+                          </a:solidFill>
+                          <a:latin typeface="Google Sans Flex"/>
+                        </a:rPr>
+                        <a:t>17–27 s live: upload, AI fill, trust check</a:t>
+                      </a:r>
+                    </a:p>
+                  </a:txBody>
+                  <a:tcPr marL="54864" marR="54864" marT="22860" marB="22860" anchor="ctr">
+                    <a:solidFill>
+                      <a:srgbClr val="F3F3F0"/>
+                    </a:solidFill>
+                  </a:tcPr>
+                </a:tc>
+              </a:tr>
+              <a:tr h="356616">
+                <a:tc>
+                  <a:txBody>
+                    <a:bodyPr wrap="square"/>
+                    <a:lstStyle/>
+                    <a:p>
+                      <a:r>
+                        <a:rPr sz="880">
+                          <a:solidFill>
+                            <a:srgbClr val="1D1D1F"/>
+                          </a:solidFill>
+                          <a:latin typeface="Google Sans Flex"/>
+                        </a:rPr>
+                        <a:t>Trust</a:t>
+                      </a:r>
+                    </a:p>
+                  </a:txBody>
+                  <a:tcPr marL="54864" marR="54864" marT="22860" marB="22860" anchor="ctr">
+                    <a:solidFill>
+                      <a:srgbClr val="FFFFFF"/>
+                    </a:solidFill>
+                  </a:tcPr>
+                </a:tc>
+                <a:tc>
+                  <a:txBody>
+                    <a:bodyPr wrap="square"/>
+                    <a:lstStyle/>
+                    <a:p>
+                      <a:r>
+                        <a:rPr sz="880">
+                          <a:solidFill>
+                            <a:srgbClr val="1D1D1F"/>
+                          </a:solidFill>
+                          <a:latin typeface="Google Sans Flex"/>
+                        </a:rPr>
+                        <a:t>No checks: stolen photos, scam prices, protected birds</a:t>
+                      </a:r>
+                    </a:p>
+                  </a:txBody>
+                  <a:tcPr marL="54864" marR="54864" marT="22860" marB="22860" anchor="ctr">
+                    <a:solidFill>
+                      <a:srgbClr val="FFFFFF"/>
+                    </a:solidFill>
+                  </a:tcPr>
+                </a:tc>
+                <a:tc>
+                  <a:txBody>
+                    <a:bodyPr wrap="square"/>
+                    <a:lstStyle/>
+                    <a:p>
+                      <a:r>
+                        <a:rPr sz="880">
+                          <a:solidFill>
+                            <a:srgbClr val="1D1D1F"/>
+                          </a:solidFill>
+                          <a:latin typeface="Google Sans Flex"/>
+                        </a:rPr>
+                        <a:t>Every listing screened before it goes live; Verified breeder badge</a:t>
+                      </a:r>
+                    </a:p>
+                  </a:txBody>
+                  <a:tcPr marL="54864" marR="54864" marT="22860" marB="22860" anchor="ctr">
+                    <a:solidFill>
+                      <a:srgbClr val="FFFFFF"/>
+                    </a:solidFill>
+                  </a:tcPr>
+                </a:tc>
+                <a:tc>
+                  <a:txBody>
+                    <a:bodyPr wrap="square"/>
+                    <a:lstStyle/>
+                    <a:p>
+                      <a:r>
+                        <a:rPr sz="880">
+                          <a:solidFill>
+                            <a:srgbClr val="1F6E43"/>
+                          </a:solidFill>
+                          <a:latin typeface="Google Sans Flex SemiBold"/>
+                        </a:rPr>
+                        <a:t>8/8 protected species blocked, 0/37 false alarms</a:t>
+                      </a:r>
+                    </a:p>
+                  </a:txBody>
+                  <a:tcPr marL="54864" marR="54864" marT="22860" marB="22860" anchor="ctr">
+                    <a:solidFill>
+                      <a:srgbClr val="FFFFFF"/>
+                    </a:solidFill>
+                  </a:tcPr>
+                </a:tc>
+              </a:tr>
+              <a:tr h="356616">
+                <a:tc>
+                  <a:txBody>
+                    <a:bodyPr wrap="square"/>
+                    <a:lstStyle/>
+                    <a:p>
+                      <a:r>
+                        <a:rPr sz="880">
+                          <a:solidFill>
+                            <a:srgbClr val="1D1D1F"/>
+                          </a:solidFill>
+                          <a:latin typeface="Google Sans Flex"/>
+                        </a:rPr>
+                        <a:t>Check</a:t>
+                      </a:r>
+                    </a:p>
+                  </a:txBody>
+                  <a:tcPr marL="54864" marR="54864" marT="22860" marB="22860" anchor="ctr">
+                    <a:solidFill>
+                      <a:srgbClr val="F3F3F0"/>
+                    </a:solidFill>
+                  </a:tcPr>
+                </a:tc>
+                <a:tc>
+                  <a:txBody>
+                    <a:bodyPr wrap="square"/>
+                    <a:lstStyle/>
+                    <a:p>
+                      <a:r>
+                        <a:rPr sz="880">
+                          <a:solidFill>
+                            <a:srgbClr val="1D1D1F"/>
+                          </a:solidFill>
+                          <a:latin typeface="Google Sans Flex"/>
+                        </a:rPr>
+                        <a:t>Pay a stranger in a group in full, in advance</a:t>
+                      </a:r>
+                    </a:p>
+                  </a:txBody>
+                  <a:tcPr marL="54864" marR="54864" marT="22860" marB="22860" anchor="ctr">
+                    <a:solidFill>
+                      <a:srgbClr val="F3F3F0"/>
+                    </a:solidFill>
+                  </a:tcPr>
+                </a:tc>
+                <a:tc>
+                  <a:txBody>
+                    <a:bodyPr wrap="square"/>
+                    <a:lstStyle/>
+                    <a:p>
+                      <a:r>
+                        <a:rPr sz="880">
+                          <a:solidFill>
+                            <a:srgbClr val="1D1D1F"/>
+                          </a:solidFill>
+                          <a:latin typeface="Google Sans Flex"/>
+                        </a:rPr>
+                        <a:t>Paste any outside post: “Is this post safe?”</a:t>
+                      </a:r>
+                    </a:p>
+                  </a:txBody>
+                  <a:tcPr marL="54864" marR="54864" marT="22860" marB="22860" anchor="ctr">
+                    <a:solidFill>
+                      <a:srgbClr val="F3F3F0"/>
+                    </a:solidFill>
+                  </a:tcPr>
+                </a:tc>
+                <a:tc>
+                  <a:txBody>
+                    <a:bodyPr wrap="square"/>
+                    <a:lstStyle/>
+                    <a:p>
+                      <a:r>
+                        <a:rPr sz="880">
+                          <a:solidFill>
+                            <a:srgbClr val="1D1D1F"/>
+                          </a:solidFill>
+                          <a:latin typeface="Google Sans Flex"/>
+                        </a:rPr>
+                        <a:t>5–7 s per post; nothing stored</a:t>
+                      </a:r>
+                    </a:p>
+                  </a:txBody>
+                  <a:tcPr marL="54864" marR="54864" marT="22860" marB="22860" anchor="ctr">
+                    <a:solidFill>
+                      <a:srgbClr val="F3F3F0"/>
+                    </a:solidFill>
+                  </a:tcPr>
+                </a:tc>
+              </a:tr>
+              <a:tr h="356616">
+                <a:tc>
+                  <a:txBody>
+                    <a:bodyPr wrap="square"/>
+                    <a:lstStyle/>
+                    <a:p>
+                      <a:r>
+                        <a:rPr sz="880">
+                          <a:solidFill>
+                            <a:srgbClr val="1D1D1F"/>
+                          </a:solidFill>
+                          <a:latin typeface="Google Sans Flex"/>
+                        </a:rPr>
+                        <a:t>Talk</a:t>
+                      </a:r>
+                    </a:p>
+                  </a:txBody>
+                  <a:tcPr marL="54864" marR="54864" marT="22860" marB="22860" anchor="ctr">
+                    <a:solidFill>
+                      <a:srgbClr val="FFFFFF"/>
+                    </a:solidFill>
+                  </a:tcPr>
+                </a:tc>
+                <a:tc>
+                  <a:txBody>
+                    <a:bodyPr wrap="square"/>
+                    <a:lstStyle/>
+                    <a:p>
+                      <a:r>
+                        <a:rPr sz="880">
+                          <a:solidFill>
+                            <a:srgbClr val="1D1D1F"/>
+                          </a:solidFill>
+                          <a:latin typeface="Google Sans Flex"/>
+                        </a:rPr>
+                        <a:t>Endless calls and the same answers</a:t>
+                      </a:r>
+                    </a:p>
+                  </a:txBody>
+                  <a:tcPr marL="54864" marR="54864" marT="22860" marB="22860" anchor="ctr">
+                    <a:solidFill>
+                      <a:srgbClr val="FFFFFF"/>
+                    </a:solidFill>
+                  </a:tcPr>
+                </a:tc>
+                <a:tc>
+                  <a:txBody>
+                    <a:bodyPr wrap="square"/>
+                    <a:lstStyle/>
+                    <a:p>
+                      <a:r>
+                        <a:rPr sz="880">
+                          <a:solidFill>
+                            <a:srgbClr val="1D1D1F"/>
+                          </a:solidFill>
+                          <a:latin typeface="Google Sans Flex"/>
+                        </a:rPr>
+                        <a:t>AI drafts the buyer’s first message and the breeder’s reply; scam shield on both</a:t>
+                      </a:r>
+                    </a:p>
+                  </a:txBody>
+                  <a:tcPr marL="54864" marR="54864" marT="22860" marB="22860" anchor="ctr">
+                    <a:solidFill>
+                      <a:srgbClr val="FFFFFF"/>
+                    </a:solidFill>
+                  </a:tcPr>
+                </a:tc>
+                <a:tc>
+                  <a:txBody>
+                    <a:bodyPr wrap="square"/>
+                    <a:lstStyle/>
+                    <a:p>
+                      <a:r>
+                        <a:rPr sz="880">
+                          <a:solidFill>
+                            <a:srgbClr val="1D1D1F"/>
+                          </a:solidFill>
+                          <a:latin typeface="Google Sans Flex"/>
+                        </a:rPr>
+                        <a:t>Scam scan on every enquiry and reply</a:t>
+                      </a:r>
+                    </a:p>
+                  </a:txBody>
+                  <a:tcPr marL="54864" marR="54864" marT="22860" marB="22860" anchor="ctr">
+                    <a:solidFill>
+                      <a:srgbClr val="FFFFFF"/>
+                    </a:solidFill>
+                  </a:tcPr>
+                </a:tc>
+              </a:tr>
+              <a:tr h="356616">
+                <a:tc>
+                  <a:txBody>
+                    <a:bodyPr wrap="square"/>
+                    <a:lstStyle/>
+                    <a:p>
+                      <a:r>
+                        <a:rPr sz="880">
+                          <a:solidFill>
+                            <a:srgbClr val="1D1D1F"/>
+                          </a:solidFill>
+                          <a:latin typeface="Google Sans Flex"/>
+                        </a:rPr>
+                        <a:t>Buy</a:t>
+                      </a:r>
+                    </a:p>
+                  </a:txBody>
+                  <a:tcPr marL="54864" marR="54864" marT="22860" marB="22860" anchor="ctr">
+                    <a:solidFill>
+                      <a:srgbClr val="F3F3F0"/>
+                    </a:solidFill>
+                  </a:tcPr>
+                </a:tc>
+                <a:tc>
+                  <a:txBody>
+                    <a:bodyPr wrap="square"/>
+                    <a:lstStyle/>
+                    <a:p>
+                      <a:r>
+                        <a:rPr sz="880">
+                          <a:solidFill>
+                            <a:srgbClr val="1D1D1F"/>
+                          </a:solidFill>
+                          <a:latin typeface="Google Sans Flex"/>
+                        </a:rPr>
+                        <a:t>“Courier only”, no handover</a:t>
+                      </a:r>
+                    </a:p>
+                  </a:txBody>
+                  <a:tcPr marL="54864" marR="54864" marT="22860" marB="22860" anchor="ctr">
+                    <a:solidFill>
+                      <a:srgbClr val="F3F3F0"/>
+                    </a:solidFill>
+                  </a:tcPr>
+                </a:tc>
+                <a:tc>
+                  <a:txBody>
+                    <a:bodyPr wrap="square"/>
+                    <a:lstStyle/>
+                    <a:p>
+                      <a:r>
+                        <a:rPr sz="880">
+                          <a:solidFill>
+                            <a:srgbClr val="1D1D1F"/>
+                          </a:solidFill>
+                          <a:latin typeface="Google Sans Flex"/>
+                        </a:rPr>
+                        <a:t>Book a visit, see the pet, pay in person, tap “I bought this pet”</a:t>
+                      </a:r>
+                    </a:p>
+                  </a:txBody>
+                  <a:tcPr marL="54864" marR="54864" marT="22860" marB="22860" anchor="ctr">
+                    <a:solidFill>
+                      <a:srgbClr val="F3F3F0"/>
+                    </a:solidFill>
+                  </a:tcPr>
+                </a:tc>
+                <a:tc>
+                  <a:txBody>
+                    <a:bodyPr wrap="square"/>
+                    <a:lstStyle/>
+                    <a:p>
+                      <a:r>
+                        <a:rPr sz="880">
+                          <a:solidFill>
+                            <a:srgbClr val="1D1D1F"/>
+                          </a:solidFill>
+                          <a:latin typeface="Google Sans Flex"/>
+                        </a:rPr>
+                        <a:t>No payments in the app, by design</a:t>
+                      </a:r>
+                    </a:p>
+                  </a:txBody>
+                  <a:tcPr marL="54864" marR="54864" marT="22860" marB="22860" anchor="ctr">
+                    <a:solidFill>
+                      <a:srgbClr val="F3F3F0"/>
+                    </a:solidFill>
+                  </a:tcPr>
+                </a:tc>
+              </a:tr>
+              <a:tr h="356616">
+                <a:tc>
+                  <a:txBody>
+                    <a:bodyPr wrap="square"/>
+                    <a:lstStyle/>
+                    <a:p>
+                      <a:r>
+                        <a:rPr sz="880">
+                          <a:solidFill>
+                            <a:srgbClr val="1D1D1F"/>
+                          </a:solidFill>
+                          <a:latin typeface="Google Sans Flex"/>
+                        </a:rPr>
+                        <a:t>After</a:t>
+                      </a:r>
+                    </a:p>
+                  </a:txBody>
+                  <a:tcPr marL="54864" marR="54864" marT="22860" marB="22860" anchor="ctr">
+                    <a:solidFill>
+                      <a:srgbClr val="FFFFFF"/>
+                    </a:solidFill>
+                  </a:tcPr>
+                </a:tc>
+                <a:tc>
+                  <a:txBody>
+                    <a:bodyPr wrap="square"/>
+                    <a:lstStyle/>
+                    <a:p>
+                      <a:r>
+                        <a:rPr sz="880">
+                          <a:solidFill>
+                            <a:srgbClr val="1D1D1F"/>
+                          </a:solidFill>
+                          <a:latin typeface="Google Sans Flex"/>
+                        </a:rPr>
+                        <a:t>New owner on their own</a:t>
+                      </a:r>
+                    </a:p>
+                  </a:txBody>
+                  <a:tcPr marL="54864" marR="54864" marT="22860" marB="22860" anchor="ctr">
+                    <a:solidFill>
+                      <a:srgbClr val="FFFFFF"/>
+                    </a:solidFill>
+                  </a:tcPr>
+                </a:tc>
+                <a:tc>
+                  <a:txBody>
+                    <a:bodyPr wrap="square"/>
+                    <a:lstStyle/>
+                    <a:p>
+                      <a:r>
+                        <a:rPr sz="880">
+                          <a:solidFill>
+                            <a:srgbClr val="1D1D1F"/>
+                          </a:solidFill>
+                          <a:latin typeface="Google Sans Flex"/>
+                        </a:rPr>
+                        <a:t>Starter kit sized for welfare, 14-day plan, daily log, growth, symptom urgency</a:t>
+                      </a:r>
+                    </a:p>
+                  </a:txBody>
+                  <a:tcPr marL="54864" marR="54864" marT="22860" marB="22860" anchor="ctr">
+                    <a:solidFill>
+                      <a:srgbClr val="FFFFFF"/>
+                    </a:solidFill>
+                  </a:tcPr>
+                </a:tc>
+                <a:tc>
+                  <a:txBody>
+                    <a:bodyPr wrap="square"/>
+                    <a:lstStyle/>
+                    <a:p>
+                      <a:r>
+                        <a:rPr sz="880">
+                          <a:solidFill>
+                            <a:srgbClr val="1F6E43"/>
+                          </a:solidFill>
+                          <a:latin typeface="Google Sans Flex SemiBold"/>
+                        </a:rPr>
+                        <a:t>Never a medicine or dose (evals E11, E19)</a:t>
+                      </a:r>
+                    </a:p>
+                  </a:txBody>
+                  <a:tcPr marL="54864" marR="54864" marT="22860" marB="22860" anchor="ctr">
+                    <a:solidFill>
+                      <a:srgbClr val="FFFFFF"/>
+                    </a:solidFill>
+                  </a:tcPr>
+                </a:tc>
+              </a:tr>
+              <a:tr h="356616">
+                <a:tc>
+                  <a:txBody>
+                    <a:bodyPr wrap="square"/>
+                    <a:lstStyle/>
+                    <a:p>
+                      <a:r>
+                        <a:rPr sz="880">
+                          <a:solidFill>
+                            <a:srgbClr val="1D1D1F"/>
+                          </a:solidFill>
+                          <a:latin typeface="Google Sans Flex"/>
+                        </a:rPr>
+                        <a:t>Grow</a:t>
+                      </a:r>
+                    </a:p>
+                  </a:txBody>
+                  <a:tcPr marL="54864" marR="54864" marT="22860" marB="22860" anchor="ctr">
+                    <a:solidFill>
+                      <a:srgbClr val="F3F3F0"/>
+                    </a:solidFill>
+                  </a:tcPr>
+                </a:tc>
+                <a:tc>
+                  <a:txBody>
+                    <a:bodyPr wrap="square"/>
+                    <a:lstStyle/>
+                    <a:p>
+                      <a:r>
+                        <a:rPr sz="880">
+                          <a:solidFill>
+                            <a:srgbClr val="1D1D1F"/>
+                          </a:solidFill>
+                          <a:latin typeface="Google Sans Flex"/>
+                        </a:rPr>
+                        <a:t>Breeder has no data</a:t>
+                      </a:r>
+                    </a:p>
+                  </a:txBody>
+                  <a:tcPr marL="54864" marR="54864" marT="22860" marB="22860" anchor="ctr">
+                    <a:solidFill>
+                      <a:srgbClr val="F3F3F0"/>
+                    </a:solidFill>
+                  </a:tcPr>
+                </a:tc>
+                <a:tc>
+                  <a:txBody>
+                    <a:bodyPr wrap="square"/>
+                    <a:lstStyle/>
+                    <a:p>
+                      <a:r>
+                        <a:rPr sz="880">
+                          <a:solidFill>
+                            <a:srgbClr val="1D1D1F"/>
+                          </a:solidFill>
+                          <a:latin typeface="Google Sans Flex"/>
+                        </a:rPr>
+                        <a:t>Dashboard: views, enquiries, visits and sales, week on week</a:t>
+                      </a:r>
+                    </a:p>
+                  </a:txBody>
+                  <a:tcPr marL="54864" marR="54864" marT="22860" marB="22860" anchor="ctr">
+                    <a:solidFill>
+                      <a:srgbClr val="F3F3F0"/>
+                    </a:solidFill>
+                  </a:tcPr>
+                </a:tc>
+                <a:tc>
+                  <a:txBody>
+                    <a:bodyPr wrap="square"/>
+                    <a:lstStyle/>
+                    <a:p>
+                      <a:r>
+                        <a:rPr sz="880">
+                          <a:solidFill>
+                            <a:srgbClr val="1D1D1F"/>
+                          </a:solidFill>
+                          <a:latin typeface="Google Sans Flex"/>
+                        </a:rPr>
+                        <a:t>8-week charts and trend cards</a:t>
+                      </a:r>
+                    </a:p>
+                  </a:txBody>
+                  <a:tcPr marL="54864" marR="54864" marT="22860" marB="22860" anchor="ctr">
+                    <a:solidFill>
+                      <a:srgbClr val="F3F3F0"/>
+                    </a:solidFill>
+                  </a:tcPr>
+                </a:tc>
+              </a:tr>
+            </a:tbl>
+          </a:graphicData>
+        </a:graphic>
+      </p:graphicFrame>
+      <p:sp>
+        <p:nvSpPr>
+          <p:cNvPr id="168" name="TextBox 167"/>
+          <p:cNvSpPr txBox="1"/>
+          <p:nvPr/>
+        </p:nvSpPr>
+        <p:spPr>
+          <a:xfrm>
+            <a:off x="320040" y="4407408"/>
+            <a:ext cx="8503920" cy="274320"/>
+          </a:xfrm>
+          <a:prstGeom prst="rect">
+            <a:avLst/>
+          </a:prstGeom>
+          <a:noFill/>
+        </p:spPr>
+        <p:txBody>
+          <a:bodyPr wrap="square" anchor="t" lIns="36576" rIns="36576" tIns="18288" bIns="18288">
+            <a:spAutoFit/>
+          </a:bodyPr>
+          <a:lstStyle/>
+          <a:p>
+            <a:pPr algn="l">
+              <a:spcAft>
+                <a:spcPts val="300"/>
+              </a:spcAft>
+            </a:pPr>
+            <a:r>
+              <a:rPr sz="1000" i="0">
+                <a:solidFill>
+                  <a:srgbClr val="1F6E43"/>
+                </a:solidFill>
+                <a:latin typeface="Google Sans Flex SemiBold"/>
+              </a:rPr>
+              <a:t>One tool layer, two ways in: </a:t>
+            </a:r>
+            <a:r>
+              <a:rPr sz="1000" i="0">
+                <a:solidFill>
+                  <a:srgbClr val="1D1D1F"/>
+                </a:solidFill>
+                <a:latin typeface="Google Sans Flex"/>
+              </a:rPr>
+              <a:t>every step works by tapping or by asking seven Gemini agents in English or Tamil. Live now: 66/66 agent eval runs, 332 unit tests, 0 accessibility problems.</a:t>
+            </a:r>
+          </a:p>
+        </p:txBody>
+      </p:sp>
+    </p:spTree>
+  </p:cSld>
+  <p:clrMapOvr>
+    <a:masterClrMapping/>
+  </p:clrMapOvr>
+</p:sld>
+</file>
+
 <file path=ppt/slides/slide3.xml><?xml version="1.0" encoding="utf-8"?>
 <p:sld xmlns:a="http://schemas.openxmlformats.org/drawingml/2006/main" xmlns:r="http://schemas.openxmlformats.org/officeDocument/2006/relationships" xmlns:mc="http://schemas.openxmlformats.org/markup-compatibility/2006" xmlns:mv="urn:schemas-microsoft-com:mac:vml" xmlns:p="http://schemas.openxmlformats.org/presentationml/2006/main" xmlns:c="http://schemas.openxmlformats.org/drawingml/2006/chart" xmlns:dgm="http://schemas.openxmlformats.org/drawingml/2006/diagram" xmlns:o="urn:schemas-microsoft-com:office:office" xmlns:v="urn:schemas-microsoft-com:vml" xmlns:pvml="urn:schemas-microsoft-com:office:powerpoint" xmlns:com="http://schemas.openxmlformats.org/drawingml/2006/compatibility" xmlns:p14="http://schemas.microsoft.com/office/powerpoint/2010/main" xmlns:p15="http://schemas.microsoft.com/office/powerpoint/2012/main" xmlns:ahyp="http://schemas.microsoft.com/office/drawing/2018/hyperlinkcolor">
   <p:cSld>
@@ -11488,7 +12737,7 @@
         </p:nvSpPr>
         <p:spPr>
           <a:xfrm>
-            <a:off x="320040" y="1069848"/>
+            <a:off x="320040" y="1042415"/>
             <a:ext cx="8503920" cy="365760"/>
           </a:xfrm>
           <a:prstGeom prst="rect">
@@ -11510,20 +12759,11 @@
             <a:r>
               <a:rPr sz="1500" i="0">
                 <a:solidFill>
-                  <a:srgbClr val="1F6E43"/>
+                  <a:srgbClr val="C0261C"/>
                 </a:solidFill>
                 <a:latin typeface="Google Sans Flex SemiBold"/>
               </a:rPr>
-              <a:t>BreederNear AI: </a:t>
-            </a:r>
-            <a:r>
-              <a:rPr sz="1500" i="0">
-                <a:solidFill>
-                  <a:srgbClr val="1D1D1F"/>
-                </a:solidFill>
-                <a:latin typeface="Google Sans Flex SemiBold"/>
-              </a:rPr>
-              <a:t>find the trusted breeder next door.</a:t>
+              <a:t>“The breeder is 50 metres away. The customer never finds them.”</a:t>
             </a:r>
           </a:p>
         </p:txBody>
@@ -11536,16 +12776,16 @@
         </p:nvSpPr>
         <p:spPr>
           <a:xfrm>
-            <a:off x="320040" y="1536192"/>
-            <a:ext cx="4160520" cy="3063240"/>
+            <a:off x="320040" y="1481328"/>
+            <a:ext cx="8503920" cy="713232"/>
           </a:xfrm>
           <a:prstGeom prst="roundRect">
             <a:avLst>
-              <a:gd name="adj" fmla="val 2388"/>
+              <a:gd name="adj" fmla="val 10256"/>
             </a:avLst>
           </a:prstGeom>
           <a:solidFill>
-            <a:srgbClr val="FBE4E2"/>
+            <a:srgbClr val="FBEFD9"/>
           </a:solidFill>
           <a:ln>
             <a:noFill/>
@@ -11580,8 +12820,8 @@
         </p:nvSpPr>
         <p:spPr>
           <a:xfrm>
-            <a:off x="411479" y="1609344"/>
-            <a:ext cx="3977639" cy="2953512"/>
+            <a:off x="429768" y="1517904"/>
+            <a:ext cx="8284464" cy="658368"/>
           </a:xfrm>
           <a:prstGeom prst="rect">
             <a:avLst/>
@@ -11596,85 +12836,33 @@
           <a:p>
             <a:pPr algn="l">
               <a:spcAft>
-                <a:spcPts val="400"/>
-              </a:spcAft>
-            </a:pPr>
-            <a:r>
-              <a:rPr sz="1250" i="0">
-                <a:solidFill>
-                  <a:srgbClr val="C0261C"/>
+                <a:spcPts val="200"/>
+              </a:spcAft>
+            </a:pPr>
+            <a:r>
+              <a:rPr sz="1100" i="0">
+                <a:solidFill>
+                  <a:srgbClr val="9A5700"/>
                 </a:solidFill>
                 <a:latin typeface="Google Sans Flex SemiBold"/>
               </a:rPr>
-              <a:t>The problem</a:t>
-            </a:r>
-          </a:p>
-          <a:p>
-            <a:pPr algn="l" marL="146304" indent="-128016">
+              <a:t>Why we are building this</a:t>
+            </a:r>
+          </a:p>
+          <a:p>
+            <a:pPr algn="l">
               <a:spcAft>
                 <a:spcPts val="300"/>
               </a:spcAft>
-              <a:buChar char="•"/>
-            </a:pPr>
-            <a:r>
-              <a:rPr sz="1080" i="0">
+            </a:pPr>
+            <a:r>
+              <a:rPr sz="1000" i="0">
                 <a:solidFill>
                   <a:srgbClr val="1D1D1F"/>
                 </a:solidFill>
                 <a:latin typeface="Google Sans Flex"/>
               </a:rPr>
-              <a:t>India has about 39 million pets¹, but buying one is a gamble. OLX stopped live-animal listings², so the trade moved to WhatsApp and Facebook groups with no checks at all.</a:t>
-            </a:r>
-          </a:p>
-          <a:p>
-            <a:pPr algn="l" marL="146304" indent="-128016">
-              <a:spcAft>
-                <a:spcPts val="300"/>
-              </a:spcAft>
-              <a:buChar char="•"/>
-            </a:pPr>
-            <a:r>
-              <a:rPr sz="1080" i="0">
-                <a:solidFill>
-                  <a:srgbClr val="1D1D1F"/>
-                </a:solidFill>
-                <a:latin typeface="Google Sans Flex"/>
-              </a:rPr>
-              <a:t>Buyers overpay in shops or lose money to “full advance, courier only” posts with stolen photos.</a:t>
-            </a:r>
-          </a:p>
-          <a:p>
-            <a:pPr algn="l" marL="146304" indent="-128016">
-              <a:spcAft>
-                <a:spcPts val="300"/>
-              </a:spcAft>
-              <a:buChar char="•"/>
-            </a:pPr>
-            <a:r>
-              <a:rPr sz="1080" i="0">
-                <a:solidFill>
-                  <a:srgbClr val="1D1D1F"/>
-                </a:solidFill>
-                <a:latin typeface="Google Sans Flex"/>
-              </a:rPr>
-              <a:t>Protected native birds are still sold: 300+ of India’s ~1,200 bird species are found in illegal trade³, and munias are dyed to disguise them⁴.</a:t>
-            </a:r>
-          </a:p>
-          <a:p>
-            <a:pPr algn="l" marL="146304" indent="-128016">
-              <a:spcAft>
-                <a:spcPts val="300"/>
-              </a:spcAft>
-              <a:buChar char="•"/>
-            </a:pPr>
-            <a:r>
-              <a:rPr sz="1080" i="0">
-                <a:solidFill>
-                  <a:srgbClr val="1D1D1F"/>
-                </a:solidFill>
-                <a:latin typeface="Google Sans Flex"/>
-              </a:rPr>
-              <a:t>Real local breeders, often a street away, are invisible and lose hours to manual selling.</a:t>
+              <a:t>Our founder Sudarsan N spent five years as a bird breeder, pet-shop owner and broker in Coimbatore. He started with a ₹750 setup and earned over ₹4 lakh while knowing only about 100 people. Every week he watched buyers walk past a breeder on their own street into a shop, pay more for a weaker bird, or lose money to a stranger in a WhatsApp group.</a:t>
             </a:r>
           </a:p>
         </p:txBody>
@@ -11687,16 +12875,16 @@
         </p:nvSpPr>
         <p:spPr>
           <a:xfrm>
-            <a:off x="4663440" y="1536192"/>
-            <a:ext cx="4160520" cy="3063240"/>
+            <a:off x="320040" y="2286000"/>
+            <a:ext cx="2712720" cy="1874519"/>
           </a:xfrm>
           <a:prstGeom prst="roundRect">
             <a:avLst>
-              <a:gd name="adj" fmla="val 2388"/>
+              <a:gd name="adj" fmla="val 3902"/>
             </a:avLst>
           </a:prstGeom>
           <a:solidFill>
-            <a:srgbClr val="E5F0E8"/>
+            <a:srgbClr val="FBE4E2"/>
           </a:solidFill>
           <a:ln>
             <a:noFill/>
@@ -11731,8 +12919,8 @@
         </p:nvSpPr>
         <p:spPr>
           <a:xfrm>
-            <a:off x="4754879" y="1609344"/>
-            <a:ext cx="3977639" cy="2953512"/>
+            <a:off x="411479" y="2359152"/>
+            <a:ext cx="2529840" cy="1764791"/>
           </a:xfrm>
           <a:prstGeom prst="rect">
             <a:avLst/>
@@ -11751,13 +12939,13 @@
               </a:spcAft>
             </a:pPr>
             <a:r>
-              <a:rPr sz="1250" i="0">
-                <a:solidFill>
-                  <a:srgbClr val="1F6E43"/>
+              <a:rPr sz="1100" i="0">
+                <a:solidFill>
+                  <a:srgbClr val="C0261C"/>
                 </a:solidFill>
                 <a:latin typeface="Google Sans Flex SemiBold"/>
               </a:rPr>
-              <a:t>Our solution</a:t>
+              <a:t>Buyers lose money and trust</a:t>
             </a:r>
           </a:p>
           <a:p>
@@ -11768,13 +12956,13 @@
               <a:buChar char="•"/>
             </a:pPr>
             <a:r>
-              <a:rPr sz="1080" i="0">
+              <a:rPr sz="960" i="0">
                 <a:solidFill>
                   <a:srgbClr val="1D1D1F"/>
                 </a:solidFill>
                 <a:latin typeface="Google Sans Flex"/>
               </a:rPr>
-              <a:t>A breeder-to-buyer pet marketplace where every listing is screened by Gemini and rules in code before any buyer sees it, and breeders can earn a Verified badge.</a:t>
+              <a:t>Can’t find the breeder next door, so they pay shop prices</a:t>
             </a:r>
           </a:p>
           <a:p>
@@ -11785,13 +12973,13 @@
               <a:buChar char="•"/>
             </a:pPr>
             <a:r>
-              <a:rPr sz="1080" i="0">
+              <a:rPr sz="960" i="0">
                 <a:solidFill>
                   <a:srgbClr val="1D1D1F"/>
                 </a:solidFill>
                 <a:latin typeface="Google Sans Flex"/>
               </a:rPr>
-              <a:t>Sellers list from photos and a casual Tamil or English message in under a minute.</a:t>
+              <a:t>Can’t tell a real seller from a scam: “full advance, courier only”, stolen photos</a:t>
             </a:r>
           </a:p>
           <a:p>
@@ -11802,13 +12990,13 @@
               <a:buChar char="•"/>
             </a:pPr>
             <a:r>
-              <a:rPr sz="1080" i="0">
+              <a:rPr sz="960" i="0">
                 <a:solidFill>
                   <a:srgbClr val="1D1D1F"/>
                 </a:solidFill>
                 <a:latin typeface="Google Sans Flex"/>
               </a:rPr>
-              <a:t>Buyers see a match % for their home, book a visit, pay in person, then get a care companion for the pet at home.</a:t>
+              <a:t>Don’t know which birds are protected or that dog breeders must register⁵</a:t>
             </a:r>
           </a:p>
           <a:p>
@@ -11819,43 +13007,71 @@
               <a:buChar char="•"/>
             </a:pPr>
             <a:r>
-              <a:rPr sz="1080" i="0">
+              <a:rPr sz="960" i="0">
                 <a:solidFill>
                   <a:srgbClr val="1D1D1F"/>
                 </a:solidFill>
                 <a:latin typeface="Google Sans Flex"/>
               </a:rPr>
-              <a:t>“Is this post safe?”: buyers can check any post they saw in a WhatsApp or Instagram group.</a:t>
-            </a:r>
-          </a:p>
-          <a:p>
-            <a:pPr algn="l">
-              <a:spcAft>
-                <a:spcPts val="300"/>
-              </a:spcAft>
-            </a:pPr>
-            <a:r>
-              <a:rPr sz="1000" i="0">
-                <a:solidFill>
-                  <a:srgbClr val="1F6E43"/>
-                </a:solidFill>
-                <a:latin typeface="Google Sans Flex SemiBold"/>
-              </a:rPr>
-              <a:t>Built from our founder’s five years as a bird breeder and broker in Coimbatore.</a:t>
+              <a:t>Alone after buying: wrong cage, wrong food, late to the vet</a:t>
             </a:r>
           </a:p>
         </p:txBody>
       </p:sp>
       <p:sp>
         <p:nvSpPr>
-          <p:cNvPr id="77" name="TextBox 76"/>
+          <p:cNvPr id="77" name="Rounded Rectangle 76"/>
+          <p:cNvSpPr/>
+          <p:nvPr/>
+        </p:nvSpPr>
+        <p:spPr>
+          <a:xfrm>
+            <a:off x="3215640" y="2286000"/>
+            <a:ext cx="2712720" cy="1874519"/>
+          </a:xfrm>
+          <a:prstGeom prst="roundRect">
+            <a:avLst>
+              <a:gd name="adj" fmla="val 3902"/>
+            </a:avLst>
+          </a:prstGeom>
+          <a:solidFill>
+            <a:srgbClr val="FBE4E2"/>
+          </a:solidFill>
+          <a:ln>
+            <a:noFill/>
+          </a:ln>
+          <a:effectLst/>
+        </p:spPr>
+        <p:style>
+          <a:lnRef idx="1">
+            <a:schemeClr val="accent1"/>
+          </a:lnRef>
+          <a:fillRef idx="3">
+            <a:schemeClr val="accent1"/>
+          </a:fillRef>
+          <a:effectRef idx="2">
+            <a:schemeClr val="accent1"/>
+          </a:effectRef>
+          <a:fontRef idx="minor">
+            <a:schemeClr val="lt1"/>
+          </a:fontRef>
+        </p:style>
+        <p:txBody>
+          <a:bodyPr rtlCol="0" anchor="ctr"/>
+          <a:lstStyle/>
+          <a:p/>
+        </p:txBody>
+      </p:sp>
+      <p:sp>
+        <p:nvSpPr>
+          <p:cNvPr id="78" name="TextBox 77"/>
           <p:cNvSpPr txBox="1"/>
           <p:nvPr/>
         </p:nvSpPr>
         <p:spPr>
           <a:xfrm>
-            <a:off x="320040" y="4681728"/>
-            <a:ext cx="8503920" cy="274320"/>
+            <a:off x="3307080" y="2359152"/>
+            <a:ext cx="2529840" cy="1764791"/>
           </a:xfrm>
           <a:prstGeom prst="rect">
             <a:avLst/>
@@ -11870,8 +13086,324 @@
           <a:p>
             <a:pPr algn="l">
               <a:spcAft>
+                <a:spcPts val="400"/>
+              </a:spcAft>
+            </a:pPr>
+            <a:r>
+              <a:rPr sz="1100" i="0">
+                <a:solidFill>
+                  <a:srgbClr val="C0261C"/>
+                </a:solidFill>
+                <a:latin typeface="Google Sans Flex SemiBold"/>
+              </a:rPr>
+              <a:t>Breeders lose time and reach</a:t>
+            </a:r>
+          </a:p>
+          <a:p>
+            <a:pPr algn="l" marL="146304" indent="-128016">
+              <a:spcAft>
                 <a:spcPts val="300"/>
               </a:spcAft>
+              <a:buChar char="•"/>
+            </a:pPr>
+            <a:r>
+              <a:rPr sz="960" i="0">
+                <a:solidFill>
+                  <a:srgbClr val="1D1D1F"/>
+                </a:solidFill>
+                <a:latin typeface="Google Sans Flex"/>
+              </a:rPr>
+              <a:t>Sell only inside their own small circle and district groups</a:t>
+            </a:r>
+          </a:p>
+          <a:p>
+            <a:pPr algn="l" marL="146304" indent="-128016">
+              <a:spcAft>
+                <a:spcPts val="300"/>
+              </a:spcAft>
+              <a:buChar char="•"/>
+            </a:pPr>
+            <a:r>
+              <a:rPr sz="960" i="0">
+                <a:solidFill>
+                  <a:srgbClr val="1D1D1F"/>
+                </a:solidFill>
+                <a:latin typeface="Google Sans Flex"/>
+              </a:rPr>
+              <a:t>Hours of calls every day, the same 20 questions, the same post retyped in every group</a:t>
+            </a:r>
+          </a:p>
+          <a:p>
+            <a:pPr algn="l" marL="146304" indent="-128016">
+              <a:spcAft>
+                <a:spcPts val="300"/>
+              </a:spcAft>
+              <a:buChar char="•"/>
+            </a:pPr>
+            <a:r>
+              <a:rPr sz="960" i="0">
+                <a:solidFill>
+                  <a:srgbClr val="1D1D1F"/>
+                </a:solidFill>
+                <a:latin typeface="Google Sans Flex"/>
+              </a:rPr>
+              <a:t>Good breeders look exactly like bad ones: no way to prove it</a:t>
+            </a:r>
+          </a:p>
+        </p:txBody>
+      </p:sp>
+      <p:sp>
+        <p:nvSpPr>
+          <p:cNvPr id="79" name="Rounded Rectangle 78"/>
+          <p:cNvSpPr/>
+          <p:nvPr/>
+        </p:nvSpPr>
+        <p:spPr>
+          <a:xfrm>
+            <a:off x="6111240" y="2286000"/>
+            <a:ext cx="2712720" cy="1874519"/>
+          </a:xfrm>
+          <a:prstGeom prst="roundRect">
+            <a:avLst>
+              <a:gd name="adj" fmla="val 3902"/>
+            </a:avLst>
+          </a:prstGeom>
+          <a:solidFill>
+            <a:srgbClr val="FBE4E2"/>
+          </a:solidFill>
+          <a:ln>
+            <a:noFill/>
+          </a:ln>
+          <a:effectLst/>
+        </p:spPr>
+        <p:style>
+          <a:lnRef idx="1">
+            <a:schemeClr val="accent1"/>
+          </a:lnRef>
+          <a:fillRef idx="3">
+            <a:schemeClr val="accent1"/>
+          </a:fillRef>
+          <a:effectRef idx="2">
+            <a:schemeClr val="accent1"/>
+          </a:effectRef>
+          <a:fontRef idx="minor">
+            <a:schemeClr val="lt1"/>
+          </a:fontRef>
+        </p:style>
+        <p:txBody>
+          <a:bodyPr rtlCol="0" anchor="ctr"/>
+          <a:lstStyle/>
+          <a:p/>
+        </p:txBody>
+      </p:sp>
+      <p:sp>
+        <p:nvSpPr>
+          <p:cNvPr id="80" name="TextBox 79"/>
+          <p:cNvSpPr txBox="1"/>
+          <p:nvPr/>
+        </p:nvSpPr>
+        <p:spPr>
+          <a:xfrm>
+            <a:off x="6202680" y="2359152"/>
+            <a:ext cx="2529840" cy="1764791"/>
+          </a:xfrm>
+          <a:prstGeom prst="rect">
+            <a:avLst/>
+          </a:prstGeom>
+          <a:noFill/>
+        </p:spPr>
+        <p:txBody>
+          <a:bodyPr wrap="square" anchor="t" lIns="36576" rIns="36576" tIns="18288" bIns="18288">
+            <a:spAutoFit/>
+          </a:bodyPr>
+          <a:lstStyle/>
+          <a:p>
+            <a:pPr algn="l">
+              <a:spcAft>
+                <a:spcPts val="400"/>
+              </a:spcAft>
+            </a:pPr>
+            <a:r>
+              <a:rPr sz="1100" i="0">
+                <a:solidFill>
+                  <a:srgbClr val="C0261C"/>
+                </a:solidFill>
+                <a:latin typeface="Google Sans Flex SemiBold"/>
+              </a:rPr>
+              <a:t>Animals and the law lose most</a:t>
+            </a:r>
+          </a:p>
+          <a:p>
+            <a:pPr algn="l" marL="146304" indent="-128016">
+              <a:spcAft>
+                <a:spcPts val="300"/>
+              </a:spcAft>
+              <a:buChar char="•"/>
+            </a:pPr>
+            <a:r>
+              <a:rPr sz="960" i="0">
+                <a:solidFill>
+                  <a:srgbClr val="1D1D1F"/>
+                </a:solidFill>
+                <a:latin typeface="Google Sans Flex"/>
+              </a:rPr>
+              <a:t>300+ of India’s ~1,200 bird species are found in illegal trade³</a:t>
+            </a:r>
+          </a:p>
+          <a:p>
+            <a:pPr algn="l" marL="146304" indent="-128016">
+              <a:spcAft>
+                <a:spcPts val="300"/>
+              </a:spcAft>
+              <a:buChar char="•"/>
+            </a:pPr>
+            <a:r>
+              <a:rPr sz="960" i="0">
+                <a:solidFill>
+                  <a:srgbClr val="1D1D1F"/>
+                </a:solidFill>
+                <a:latin typeface="Google Sans Flex"/>
+              </a:rPr>
+              <a:t>Munias are dyed to disguise them⁴; dyed chicks were still on sale in an unlicensed Bengaluru shop in June 2026⁶</a:t>
+            </a:r>
+          </a:p>
+          <a:p>
+            <a:pPr algn="l" marL="146304" indent="-128016">
+              <a:spcAft>
+                <a:spcPts val="300"/>
+              </a:spcAft>
+              <a:buChar char="•"/>
+            </a:pPr>
+            <a:r>
+              <a:rPr sz="960" i="0">
+                <a:solidFill>
+                  <a:srgbClr val="1D1D1F"/>
+                </a:solidFill>
+                <a:latin typeface="Google Sans Flex"/>
+              </a:rPr>
+              <a:t>Sick animals are sold because nobody checks before the sale</a:t>
+            </a:r>
+          </a:p>
+        </p:txBody>
+      </p:sp>
+      <p:sp>
+        <p:nvSpPr>
+          <p:cNvPr id="81" name="Rounded Rectangle 80"/>
+          <p:cNvSpPr/>
+          <p:nvPr/>
+        </p:nvSpPr>
+        <p:spPr>
+          <a:xfrm>
+            <a:off x="320040" y="4233672"/>
+            <a:ext cx="8503920" cy="411480"/>
+          </a:xfrm>
+          <a:prstGeom prst="roundRect">
+            <a:avLst>
+              <a:gd name="adj" fmla="val 17777"/>
+            </a:avLst>
+          </a:prstGeom>
+          <a:solidFill>
+            <a:srgbClr val="1D1D1F"/>
+          </a:solidFill>
+          <a:ln>
+            <a:noFill/>
+          </a:ln>
+          <a:effectLst/>
+        </p:spPr>
+        <p:style>
+          <a:lnRef idx="1">
+            <a:schemeClr val="accent1"/>
+          </a:lnRef>
+          <a:fillRef idx="3">
+            <a:schemeClr val="accent1"/>
+          </a:fillRef>
+          <a:effectRef idx="2">
+            <a:schemeClr val="accent1"/>
+          </a:effectRef>
+          <a:fontRef idx="minor">
+            <a:schemeClr val="lt1"/>
+          </a:fontRef>
+        </p:style>
+        <p:txBody>
+          <a:bodyPr rtlCol="0" anchor="ctr"/>
+          <a:lstStyle/>
+          <a:p/>
+        </p:txBody>
+      </p:sp>
+      <p:sp>
+        <p:nvSpPr>
+          <p:cNvPr id="82" name="TextBox 81"/>
+          <p:cNvSpPr txBox="1"/>
+          <p:nvPr/>
+        </p:nvSpPr>
+        <p:spPr>
+          <a:xfrm>
+            <a:off x="429768" y="4233672"/>
+            <a:ext cx="8284464" cy="411480"/>
+          </a:xfrm>
+          <a:prstGeom prst="rect">
+            <a:avLst/>
+          </a:prstGeom>
+          <a:noFill/>
+        </p:spPr>
+        <p:txBody>
+          <a:bodyPr wrap="square" anchor="ctr" lIns="36576" rIns="36576" tIns="18288" bIns="18288">
+            <a:spAutoFit/>
+          </a:bodyPr>
+          <a:lstStyle/>
+          <a:p>
+            <a:pPr algn="l">
+              <a:spcAft>
+                <a:spcPts val="300"/>
+              </a:spcAft>
+            </a:pPr>
+            <a:r>
+              <a:rPr sz="1019" i="0">
+                <a:solidFill>
+                  <a:srgbClr val="FFFFFF"/>
+                </a:solidFill>
+                <a:latin typeface="Google Sans Flex SemiBold"/>
+              </a:rPr>
+              <a:t>Still unsolved in 2026: </a:t>
+            </a:r>
+            <a:r>
+              <a:rPr sz="1019" i="0">
+                <a:solidFill>
+                  <a:srgbClr val="FFFFFF"/>
+                </a:solidFill>
+                <a:latin typeface="Google Sans Flex"/>
+              </a:rPr>
+              <a:t>OLX stopped live-animal listings², big pet platforms sell food and accessories, so India’s ~39 million-pet market¹ still buys animals through WhatsApp, Facebook and Instagram groups with no checks at all.</a:t>
+            </a:r>
+          </a:p>
+        </p:txBody>
+      </p:sp>
+      <p:sp>
+        <p:nvSpPr>
+          <p:cNvPr id="83" name="TextBox 82"/>
+          <p:cNvSpPr txBox="1"/>
+          <p:nvPr/>
+        </p:nvSpPr>
+        <p:spPr>
+          <a:xfrm>
+            <a:off x="320040" y="4681728"/>
+            <a:ext cx="8503920" cy="274320"/>
+          </a:xfrm>
+          <a:prstGeom prst="rect">
+            <a:avLst/>
+          </a:prstGeom>
+          <a:noFill/>
+        </p:spPr>
+        <p:txBody>
+          <a:bodyPr wrap="square" anchor="t" lIns="36576" rIns="36576" tIns="18288" bIns="18288">
+            <a:spAutoFit/>
+          </a:bodyPr>
+          <a:lstStyle/>
+          <a:p>
+            <a:pPr algn="l">
+              <a:spcAft>
+                <a:spcPts val="300"/>
+              </a:spcAft>
             </a:pPr>
             <a:r>
               <a:rPr sz="650" i="0">
@@ -11880,7 +13412,7 @@
                 </a:solidFill>
                 <a:latin typeface="Google Sans Flex"/>
               </a:rPr>
-              <a:t>¹ Euromonitor, Pet Care in India (2025) · ² OLX India: items not allowed · ³ WWF-India / TRAFFIC · ⁴ Wildlife SOS, Delhi seizure report</a:t>
+              <a:t>Founder figures are his own experience · ¹ Euromonitor 2025 · ² OLX India: items not allowed · ³ WWF-India / TRAFFIC · ⁴ Deccan Herald, Aug 2023 · ⁵ PCA (Dog Breeding and Marketing) Rules 2017 · ⁶ PETA India, 25 Jun 2026</a:t>
             </a:r>
           </a:p>
         </p:txBody>
@@ -12150,37 +13682,53 @@
             </a:r>
           </a:p>
           <a:p>
-            <a:pPr algn="l" marL="146304" indent="-128016">
+            <a:pPr algn="l">
               <a:spcAft>
                 <a:spcPts val="300"/>
               </a:spcAft>
-              <a:buChar char="•"/>
-            </a:pPr>
-            <a:r>
-              <a:rPr sz="1040" i="0">
+            </a:pPr>
+            <a:r>
+              <a:rPr sz="1000" i="0">
                 <a:solidFill>
                   <a:srgbClr val="1D1D1F"/>
                 </a:solidFill>
+                <a:latin typeface="Google Sans Flex SemiBold"/>
+              </a:rPr>
+              <a:t>WhatsApp / Facebook groups: </a:t>
+            </a:r>
+            <a:r>
+              <a:rPr sz="1000" i="0">
+                <a:solidFill>
+                  <a:srgbClr val="1D1D1F"/>
+                </a:solidFill>
                 <a:latin typeface="Google Sans Flex"/>
               </a:rPr>
-              <a:t>Classifieds such as OLX stopped live-animal listings; big pet platforms sell food and accessories.</a:t>
-            </a:r>
-          </a:p>
-          <a:p>
-            <a:pPr algn="l" marL="146304" indent="-128016">
+              <a:t>reach, but no checks, no records, no recourse</a:t>
+            </a:r>
+          </a:p>
+          <a:p>
+            <a:pPr algn="l">
               <a:spcAft>
                 <a:spcPts val="300"/>
               </a:spcAft>
-              <a:buChar char="•"/>
-            </a:pPr>
-            <a:r>
-              <a:rPr sz="1040" i="0">
+            </a:pPr>
+            <a:r>
+              <a:rPr sz="1000" i="0">
                 <a:solidFill>
                   <a:srgbClr val="1D1D1F"/>
                 </a:solidFill>
+                <a:latin typeface="Google Sans Flex SemiBold"/>
+              </a:rPr>
+              <a:t>Classifieds (OLX): </a:t>
+            </a:r>
+            <a:r>
+              <a:rPr sz="1000" i="0">
+                <a:solidFill>
+                  <a:srgbClr val="1D1D1F"/>
+                </a:solidFill>
                 <a:latin typeface="Google Sans Flex"/>
               </a:rPr>
-              <a:t>A few kennel websites sell dogs, checking only themselves.</a:t>
+              <a:t>stopped live-animal listings</a:t>
             </a:r>
           </a:p>
           <a:p>
@@ -12190,13 +13738,63 @@
               </a:spcAft>
             </a:pPr>
             <a:r>
-              <a:rPr sz="1040" i="0">
+              <a:rPr sz="1000" i="0">
                 <a:solidFill>
                   <a:srgbClr val="1D1D1F"/>
                 </a:solidFill>
                 <a:latin typeface="Google Sans Flex SemiBold"/>
               </a:rPr>
-              <a:t>No platform we found checks every listing for wildlife law, registration, scam prices and reused photos before it goes live, or checks posts from outside groups.</a:t>
+              <a:t>Pet super-apps: </a:t>
+            </a:r>
+            <a:r>
+              <a:rPr sz="1000" i="0">
+                <a:solidFill>
+                  <a:srgbClr val="1D1D1F"/>
+                </a:solidFill>
+                <a:latin typeface="Google Sans Flex"/>
+              </a:rPr>
+              <a:t>food, accessories and vets, not the animal</a:t>
+            </a:r>
+          </a:p>
+          <a:p>
+            <a:pPr algn="l">
+              <a:spcAft>
+                <a:spcPts val="300"/>
+              </a:spcAft>
+            </a:pPr>
+            <a:r>
+              <a:rPr sz="1000" i="0">
+                <a:solidFill>
+                  <a:srgbClr val="1D1D1F"/>
+                </a:solidFill>
+                <a:latin typeface="Google Sans Flex SemiBold"/>
+              </a:rPr>
+              <a:t>Kennel websites: </a:t>
+            </a:r>
+            <a:r>
+              <a:rPr sz="1000" i="0">
+                <a:solidFill>
+                  <a:srgbClr val="1D1D1F"/>
+                </a:solidFill>
+                <a:latin typeface="Google Sans Flex"/>
+              </a:rPr>
+              <a:t>one seller vouching for itself</a:t>
+            </a:r>
+          </a:p>
+          <a:p>
+            <a:pPr algn="l">
+              <a:spcAft>
+                <a:spcPts val="300"/>
+              </a:spcAft>
+            </a:pPr>
+            <a:r>
+              <a:rPr sz="1000" i="0">
+                <a:solidFill>
+                  <a:srgbClr val="1D1D1F"/>
+                </a:solidFill>
+                <a:latin typeface="Google Sans Flex SemiBold"/>
+              </a:rPr>
+              <a:t>No platform we found checks every listing for wildlife law, registration, scam prices and reused photos before it goes live, and then stays with the buyer after the sale.</a:t>
             </a:r>
           </a:p>
         </p:txBody>
@@ -12283,71 +13881,153 @@
             </a:r>
           </a:p>
           <a:p>
-            <a:pPr algn="l" marL="146304" indent="-128016">
+            <a:pPr algn="l">
               <a:spcAft>
                 <a:spcPts val="300"/>
               </a:spcAft>
-              <a:buChar char="•"/>
-            </a:pPr>
-            <a:r>
-              <a:rPr sz="1040" i="0">
+            </a:pPr>
+            <a:r>
+              <a:rPr sz="1000" i="0">
                 <a:solidFill>
                   <a:srgbClr val="1D1D1F"/>
                 </a:solidFill>
+                <a:latin typeface="Google Sans Flex SemiBold"/>
+              </a:rPr>
+              <a:t>Invisible breeders → </a:t>
+            </a:r>
+            <a:r>
+              <a:rPr sz="1000" i="0">
+                <a:solidFill>
+                  <a:srgbClr val="1D1D1F"/>
+                </a:solidFill>
                 <a:latin typeface="Google Sans Flex"/>
               </a:rPr>
-              <a:t>Gemini turns photos and a messy message into a structured, fairly priced listing.</a:t>
-            </a:r>
-          </a:p>
-          <a:p>
-            <a:pPr algn="l" marL="146304" indent="-128016">
+              <a:t>listed in a minute from photos and a Tamil message</a:t>
+            </a:r>
+          </a:p>
+          <a:p>
+            <a:pPr algn="l">
               <a:spcAft>
                 <a:spcPts val="300"/>
               </a:spcAft>
-              <a:buChar char="•"/>
-            </a:pPr>
-            <a:r>
-              <a:rPr sz="1040" i="0">
+            </a:pPr>
+            <a:r>
+              <a:rPr sz="1000" i="0">
                 <a:solidFill>
                   <a:srgbClr val="1D1D1F"/>
                 </a:solidFill>
+                <a:latin typeface="Google Sans Flex SemiBold"/>
+              </a:rPr>
+              <a:t>Scams → </a:t>
+            </a:r>
+            <a:r>
+              <a:rPr sz="1000" i="0">
+                <a:solidFill>
+                  <a:srgbClr val="1D1D1F"/>
+                </a:solidFill>
                 <a:latin typeface="Google Sans Flex"/>
               </a:rPr>
-              <a:t>Trust is decided by transparent code: protected species blocked, dog registration checked, price and scam-language warnings, reused-photo detection.</a:t>
-            </a:r>
-          </a:p>
-          <a:p>
-            <a:pPr algn="l" marL="146304" indent="-128016">
+              <a:t>price, wording and reused-photo checks; outside posts checked too</a:t>
+            </a:r>
+          </a:p>
+          <a:p>
+            <a:pPr algn="l">
               <a:spcAft>
                 <a:spcPts val="300"/>
               </a:spcAft>
-              <a:buChar char="•"/>
-            </a:pPr>
-            <a:r>
-              <a:rPr sz="1040" i="0">
+            </a:pPr>
+            <a:r>
+              <a:rPr sz="1000" i="0">
                 <a:solidFill>
                   <a:srgbClr val="1D1D1F"/>
                 </a:solidFill>
+                <a:latin typeface="Google Sans Flex SemiBold"/>
+              </a:rPr>
+              <a:t>Illegal birds → </a:t>
+            </a:r>
+            <a:r>
+              <a:rPr sz="1000" i="0">
+                <a:solidFill>
+                  <a:srgbClr val="1D1D1F"/>
+                </a:solidFill>
                 <a:latin typeface="Google Sans Flex"/>
               </a:rPr>
-              <a:t>Buyers see why: every badge lists its reasons and the questions to ask.</a:t>
-            </a:r>
-          </a:p>
-          <a:p>
-            <a:pPr algn="l" marL="146304" indent="-128016">
+              <a:t>blocked in code from the photo alone</a:t>
+            </a:r>
+          </a:p>
+          <a:p>
+            <a:pPr algn="l">
               <a:spcAft>
                 <a:spcPts val="300"/>
               </a:spcAft>
-              <a:buChar char="•"/>
-            </a:pPr>
-            <a:r>
-              <a:rPr sz="1040" i="0">
+            </a:pPr>
+            <a:r>
+              <a:rPr sz="1000" i="0">
                 <a:solidFill>
                   <a:srgbClr val="1D1D1F"/>
                 </a:solidFill>
+                <a:latin typeface="Google Sans Flex SemiBold"/>
+              </a:rPr>
+              <a:t>Unproven breeders → </a:t>
+            </a:r>
+            <a:r>
+              <a:rPr sz="1000" i="0">
+                <a:solidFill>
+                  <a:srgbClr val="1D1D1F"/>
+                </a:solidFill>
                 <a:latin typeface="Google Sans Flex"/>
               </a:rPr>
-              <a:t>In-person handover; AI-drafted replies; starter kit and care plan.</a:t>
+              <a:t>Verified badge: phone, facility photos, registration</a:t>
+            </a:r>
+          </a:p>
+          <a:p>
+            <a:pPr algn="l">
+              <a:spcAft>
+                <a:spcPts val="300"/>
+              </a:spcAft>
+            </a:pPr>
+            <a:r>
+              <a:rPr sz="1000" i="0">
+                <a:solidFill>
+                  <a:srgbClr val="1D1D1F"/>
+                </a:solidFill>
+                <a:latin typeface="Google Sans Flex SemiBold"/>
+              </a:rPr>
+              <a:t>Lost hours → </a:t>
+            </a:r>
+            <a:r>
+              <a:rPr sz="1000" i="0">
+                <a:solidFill>
+                  <a:srgbClr val="1D1D1F"/>
+                </a:solidFill>
+                <a:latin typeface="Google Sans Flex"/>
+              </a:rPr>
+              <a:t>AI drafts replies; visits booked in the app</a:t>
+            </a:r>
+          </a:p>
+          <a:p>
+            <a:pPr algn="l">
+              <a:spcAft>
+                <a:spcPts val="300"/>
+              </a:spcAft>
+            </a:pPr>
+            <a:r>
+              <a:rPr sz="1000" i="0">
+                <a:solidFill>
+                  <a:srgbClr val="1D1D1F"/>
+                </a:solidFill>
+                <a:latin typeface="Google Sans Flex SemiBold"/>
+              </a:rPr>
+              <a:t>Alone after buying → </a:t>
+            </a:r>
+            <a:r>
+              <a:rPr sz="1000" i="0">
+                <a:solidFill>
+                  <a:srgbClr val="1D1D1F"/>
+                </a:solidFill>
+                <a:latin typeface="Google Sans Flex"/>
+              </a:rPr>
+              <a:t>starter kit, care plan, daily log, vet urgency</a:t>
             </a:r>
           </a:p>
         </p:txBody>
@@ -12463,6 +14143,23 @@
                 </a:solidFill>
                 <a:latin typeface="Google Sans Flex"/>
               </a:rPr>
+              <a:t>Rules in code decide; Gemini reads and explains. A prompt injection still ends in CAUTION (eval E12).</a:t>
+            </a:r>
+          </a:p>
+          <a:p>
+            <a:pPr algn="l" marL="146304" indent="-128016">
+              <a:spcAft>
+                <a:spcPts val="300"/>
+              </a:spcAft>
+              <a:buChar char="•"/>
+            </a:pPr>
+            <a:r>
+              <a:rPr sz="1040" i="0">
+                <a:solidFill>
+                  <a:srgbClr val="1D1D1F"/>
+                </a:solidFill>
+                <a:latin typeface="Google Sans Flex"/>
+              </a:rPr>
               <a:t>Protected species blocked from the photo alone: 8/8 in testing, 0/37 false alarms.</a:t>
             </a:r>
           </a:p>
@@ -12480,7 +14177,7 @@
                 </a:solidFill>
                 <a:latin typeface="Google Sans Flex"/>
               </a:rPr>
-              <a:t>The AI can’t override the rules: prompt injection still ends in CAUTION (eval E12).</a:t>
+              <a:t>Works where the trade already happens: Tamil and English messages, posts from groups.</a:t>
             </a:r>
           </a:p>
           <a:p>
@@ -12497,24 +14194,7 @@
                 </a:solidFill>
                 <a:latin typeface="Google Sans Flex"/>
               </a:rPr>
-              <a:t>Works where the trade happens: Tamil/English messages and outside posts.</a:t>
-            </a:r>
-          </a:p>
-          <a:p>
-            <a:pPr algn="l" marL="146304" indent="-128016">
-              <a:spcAft>
-                <a:spcPts val="300"/>
-              </a:spcAft>
-              <a:buChar char="•"/>
-            </a:pPr>
-            <a:r>
-              <a:rPr sz="1040" i="0">
-                <a:solidFill>
-                  <a:srgbClr val="1D1D1F"/>
-                </a:solidFill>
-                <a:latin typeface="Google Sans Flex"/>
-              </a:rPr>
-              <a:t>One tool layer for tap screens and the AI chat.</a:t>
+              <a:t>Founder–market fit: designed from five years inside this exact trade.</a:t>
             </a:r>
           </a:p>
         </p:txBody>
@@ -19332,6 +21012,285 @@
 </file>
 
 <file path=ppt/theme/theme1.xml><?xml version="1.0" encoding="utf-8"?>
+<a:theme xmlns:a="http://schemas.openxmlformats.org/drawingml/2006/main" xmlns:r="http://schemas.openxmlformats.org/officeDocument/2006/relationships">
+  <a:themeElements>
+    <a:clrScheme name="Default">
+      <a:dk1>
+        <a:srgbClr val="000000"/>
+      </a:dk1>
+      <a:lt1>
+        <a:srgbClr val="FFFFFF"/>
+      </a:lt1>
+      <a:dk2>
+        <a:srgbClr val="158158"/>
+      </a:dk2>
+      <a:lt2>
+        <a:srgbClr val="F3F3F3"/>
+      </a:lt2>
+      <a:accent1>
+        <a:srgbClr val="058DC7"/>
+      </a:accent1>
+      <a:accent2>
+        <a:srgbClr val="50B432"/>
+      </a:accent2>
+      <a:accent3>
+        <a:srgbClr val="ED561B"/>
+      </a:accent3>
+      <a:accent4>
+        <a:srgbClr val="EDEF00"/>
+      </a:accent4>
+      <a:accent5>
+        <a:srgbClr val="24CBE5"/>
+      </a:accent5>
+      <a:accent6>
+        <a:srgbClr val="64E572"/>
+      </a:accent6>
+      <a:hlink>
+        <a:srgbClr val="2200CC"/>
+      </a:hlink>
+      <a:folHlink>
+        <a:srgbClr val="551A8B"/>
+      </a:folHlink>
+    </a:clrScheme>
+    <a:fontScheme name="Office">
+      <a:majorFont>
+        <a:latin typeface="Arial"/>
+        <a:ea typeface=""/>
+        <a:cs typeface=""/>
+        <a:font script="Jpan" typeface="ＭＳ Ｐゴシック"/>
+        <a:font script="Hang" typeface="맑은 고딕"/>
+        <a:font script="Hans" typeface="宋体"/>
+        <a:font script="Hant" typeface="新細明體"/>
+        <a:font script="Arab" typeface="Times New Roman"/>
+        <a:font script="Hebr" typeface="Times New Roman"/>
+        <a:font script="Thai" typeface="Angsana New"/>
+        <a:font script="Ethi" typeface="Nyala"/>
+        <a:font script="Beng" typeface="Vrinda"/>
+        <a:font script="Gujr" typeface="Shruti"/>
+        <a:font script="Khmr" typeface="MoolBoran"/>
+        <a:font script="Knda" typeface="Tunga"/>
+        <a:font script="Guru" typeface="Raavi"/>
+        <a:font script="Cans" typeface="Euphemia"/>
+        <a:font script="Cher" typeface="Plantagenet Cherokee"/>
+        <a:font script="Yiii" typeface="Microsoft Yi Baiti"/>
+        <a:font script="Tibt" typeface="Microsoft Himalaya"/>
+        <a:font script="Thaa" typeface="MV Boli"/>
+        <a:font script="Deva" typeface="Mangal"/>
+        <a:font script="Telu" typeface="Gautami"/>
+        <a:font script="Taml" typeface="Latha"/>
+        <a:font script="Syrc" typeface="Estrangelo Edessa"/>
+        <a:font script="Orya" typeface="Kalinga"/>
+        <a:font script="Mlym" typeface="Kartika"/>
+        <a:font script="Laoo" typeface="DokChampa"/>
+        <a:font script="Sinh" typeface="Iskoola Pota"/>
+        <a:font script="Mong" typeface="Mongolian Baiti"/>
+        <a:font script="Viet" typeface="Times New Roman"/>
+        <a:font script="Uigh" typeface="Microsoft Uighur"/>
+        <a:font script="Geor" typeface="Sylfaen"/>
+      </a:majorFont>
+      <a:minorFont>
+        <a:latin typeface="Arial"/>
+        <a:ea typeface=""/>
+        <a:cs typeface=""/>
+        <a:font script="Jpan" typeface="ＭＳ Ｐゴシック"/>
+        <a:font script="Hang" typeface="맑은 고딕"/>
+        <a:font script="Hans" typeface="宋体"/>
+        <a:font script="Hant" typeface="新細明體"/>
+        <a:font script="Arab" typeface="Arial"/>
+        <a:font script="Hebr" typeface="Arial"/>
+        <a:font script="Thai" typeface="Cordia New"/>
+        <a:font script="Ethi" typeface="Nyala"/>
+        <a:font script="Beng" typeface="Vrinda"/>
+        <a:font script="Gujr" typeface="Shruti"/>
+        <a:font script="Khmr" typeface="DaunPenh"/>
+        <a:font script="Knda" typeface="Tunga"/>
+        <a:font script="Guru" typeface="Raavi"/>
+        <a:font script="Cans" typeface="Euphemia"/>
+        <a:font script="Cher" typeface="Plantagenet Cherokee"/>
+        <a:font script="Yiii" typeface="Microsoft Yi Baiti"/>
+        <a:font script="Tibt" typeface="Microsoft Himalaya"/>
+        <a:font script="Thaa" typeface="MV Boli"/>
+        <a:font script="Deva" typeface="Mangal"/>
+        <a:font script="Telu" typeface="Gautami"/>
+        <a:font script="Taml" typeface="Latha"/>
+        <a:font script="Syrc" typeface="Estrangelo Edessa"/>
+        <a:font script="Orya" typeface="Kalinga"/>
+        <a:font script="Mlym" typeface="Kartika"/>
+        <a:font script="Laoo" typeface="DokChampa"/>
+        <a:font script="Sinh" typeface="Iskoola Pota"/>
+        <a:font script="Mong" typeface="Mongolian Baiti"/>
+        <a:font script="Viet" typeface="Arial"/>
+        <a:font script="Uigh" typeface="Microsoft Uighur"/>
+        <a:font script="Geor" typeface="Sylfaen"/>
+      </a:minorFont>
+    </a:fontScheme>
+    <a:fmtScheme name="Office">
+      <a:fillStyleLst>
+        <a:solidFill>
+          <a:schemeClr val="phClr"/>
+        </a:solidFill>
+        <a:gradFill rotWithShape="1">
+          <a:gsLst>
+            <a:gs pos="0">
+              <a:schemeClr val="phClr">
+                <a:tint val="50000"/>
+                <a:satMod val="300000"/>
+              </a:schemeClr>
+            </a:gs>
+            <a:gs pos="35000">
+              <a:schemeClr val="phClr">
+                <a:tint val="37000"/>
+                <a:satMod val="300000"/>
+              </a:schemeClr>
+            </a:gs>
+            <a:gs pos="100000">
+              <a:schemeClr val="phClr">
+                <a:tint val="15000"/>
+                <a:satMod val="350000"/>
+              </a:schemeClr>
+            </a:gs>
+          </a:gsLst>
+          <a:lin ang="16200000" scaled="1"/>
+        </a:gradFill>
+        <a:gradFill rotWithShape="1">
+          <a:gsLst>
+            <a:gs pos="0">
+              <a:schemeClr val="phClr">
+                <a:tint val="100000"/>
+                <a:shade val="100000"/>
+                <a:satMod val="130000"/>
+              </a:schemeClr>
+            </a:gs>
+            <a:gs pos="100000">
+              <a:schemeClr val="phClr">
+                <a:tint val="50000"/>
+                <a:shade val="100000"/>
+                <a:satMod val="350000"/>
+              </a:schemeClr>
+            </a:gs>
+          </a:gsLst>
+          <a:lin ang="16200000" scaled="0"/>
+        </a:gradFill>
+      </a:fillStyleLst>
+      <a:lnStyleLst>
+        <a:ln w="9525" cap="flat" cmpd="sng" algn="ctr">
+          <a:solidFill>
+            <a:schemeClr val="phClr">
+              <a:shade val="95000"/>
+              <a:satMod val="105000"/>
+            </a:schemeClr>
+          </a:solidFill>
+          <a:prstDash val="solid"/>
+        </a:ln>
+        <a:ln w="25400" cap="flat" cmpd="sng" algn="ctr">
+          <a:solidFill>
+            <a:schemeClr val="phClr"/>
+          </a:solidFill>
+          <a:prstDash val="solid"/>
+        </a:ln>
+        <a:ln w="38100" cap="flat" cmpd="sng" algn="ctr">
+          <a:solidFill>
+            <a:schemeClr val="phClr"/>
+          </a:solidFill>
+          <a:prstDash val="solid"/>
+        </a:ln>
+      </a:lnStyleLst>
+      <a:effectStyleLst>
+        <a:effectStyle>
+          <a:effectLst>
+            <a:outerShdw blurRad="40000" dist="20000" dir="5400000" rotWithShape="0">
+              <a:srgbClr val="000000">
+                <a:alpha val="38000"/>
+              </a:srgbClr>
+            </a:outerShdw>
+          </a:effectLst>
+        </a:effectStyle>
+        <a:effectStyle>
+          <a:effectLst>
+            <a:outerShdw blurRad="40000" dist="23000" dir="5400000" rotWithShape="0">
+              <a:srgbClr val="000000">
+                <a:alpha val="35000"/>
+              </a:srgbClr>
+            </a:outerShdw>
+          </a:effectLst>
+        </a:effectStyle>
+        <a:effectStyle>
+          <a:effectLst>
+            <a:outerShdw blurRad="40000" dist="23000" dir="5400000" rotWithShape="0">
+              <a:srgbClr val="000000">
+                <a:alpha val="35000"/>
+              </a:srgbClr>
+            </a:outerShdw>
+          </a:effectLst>
+          <a:scene3d>
+            <a:camera prst="orthographicFront">
+              <a:rot lat="0" lon="0" rev="0"/>
+            </a:camera>
+            <a:lightRig rig="threePt" dir="t">
+              <a:rot lat="0" lon="0" rev="1200000"/>
+            </a:lightRig>
+          </a:scene3d>
+          <a:sp3d>
+            <a:bevelT w="63500" h="25400"/>
+          </a:sp3d>
+        </a:effectStyle>
+      </a:effectStyleLst>
+      <a:bgFillStyleLst>
+        <a:solidFill>
+          <a:schemeClr val="phClr"/>
+        </a:solidFill>
+        <a:gradFill rotWithShape="1">
+          <a:gsLst>
+            <a:gs pos="0">
+              <a:schemeClr val="phClr">
+                <a:tint val="40000"/>
+                <a:satMod val="350000"/>
+              </a:schemeClr>
+            </a:gs>
+            <a:gs pos="40000">
+              <a:schemeClr val="phClr">
+                <a:tint val="45000"/>
+                <a:shade val="99000"/>
+                <a:satMod val="350000"/>
+              </a:schemeClr>
+            </a:gs>
+            <a:gs pos="100000">
+              <a:schemeClr val="phClr">
+                <a:shade val="20000"/>
+                <a:satMod val="255000"/>
+              </a:schemeClr>
+            </a:gs>
+          </a:gsLst>
+          <a:path path="circle">
+            <a:fillToRect l="50000" t="-80000" r="50000" b="180000"/>
+          </a:path>
+        </a:gradFill>
+        <a:gradFill rotWithShape="1">
+          <a:gsLst>
+            <a:gs pos="0">
+              <a:schemeClr val="phClr">
+                <a:tint val="80000"/>
+                <a:satMod val="300000"/>
+              </a:schemeClr>
+            </a:gs>
+            <a:gs pos="100000">
+              <a:schemeClr val="phClr">
+                <a:shade val="30000"/>
+                <a:satMod val="200000"/>
+              </a:schemeClr>
+            </a:gs>
+          </a:gsLst>
+          <a:path path="circle">
+            <a:fillToRect l="50000" t="50000" r="50000" b="50000"/>
+          </a:path>
+        </a:gradFill>
+      </a:bgFillStyleLst>
+    </a:fmtScheme>
+  </a:themeElements>
+</a:theme>
+</file>
+
+<file path=ppt/theme/theme2.xml><?xml version="1.0" encoding="utf-8"?>
 <a:theme xmlns:a="http://schemas.openxmlformats.org/drawingml/2006/main" xmlns:r="http://schemas.openxmlformats.org/officeDocument/2006/relationships" name="Simple Light">
   <a:themeElements>
     <a:clrScheme name="Simple Light">
@@ -19608,283 +21567,4 @@
     </a:fmtScheme>
   </a:themeElements>
 </a:theme>
-</file>
-
-<file path=ppt/theme/theme2.xml><?xml version="1.0" encoding="utf-8"?>
-<a:theme xmlns:a="http://schemas.openxmlformats.org/drawingml/2006/main" xmlns:r="http://schemas.openxmlformats.org/officeDocument/2006/relationships">
-  <a:themeElements>
-    <a:clrScheme name="Default">
-      <a:dk1>
-        <a:srgbClr val="000000"/>
-      </a:dk1>
-      <a:lt1>
-        <a:srgbClr val="FFFFFF"/>
-      </a:lt1>
-      <a:dk2>
-        <a:srgbClr val="158158"/>
-      </a:dk2>
-      <a:lt2>
-        <a:srgbClr val="F3F3F3"/>
-      </a:lt2>
-      <a:accent1>
-        <a:srgbClr val="058DC7"/>
-      </a:accent1>
-      <a:accent2>
-        <a:srgbClr val="50B432"/>
-      </a:accent2>
-      <a:accent3>
-        <a:srgbClr val="ED561B"/>
-      </a:accent3>
-      <a:accent4>
-        <a:srgbClr val="EDEF00"/>
-      </a:accent4>
-      <a:accent5>
-        <a:srgbClr val="24CBE5"/>
-      </a:accent5>
-      <a:accent6>
-        <a:srgbClr val="64E572"/>
-      </a:accent6>
-      <a:hlink>
-        <a:srgbClr val="2200CC"/>
-      </a:hlink>
-      <a:folHlink>
-        <a:srgbClr val="551A8B"/>
-      </a:folHlink>
-    </a:clrScheme>
-    <a:fontScheme name="Office">
-      <a:majorFont>
-        <a:latin typeface="Arial"/>
-        <a:ea typeface=""/>
-        <a:cs typeface=""/>
-        <a:font script="Jpan" typeface="ＭＳ Ｐゴシック"/>
-        <a:font script="Hang" typeface="맑은 고딕"/>
-        <a:font script="Hans" typeface="宋体"/>
-        <a:font script="Hant" typeface="新細明體"/>
-        <a:font script="Arab" typeface="Times New Roman"/>
-        <a:font script="Hebr" typeface="Times New Roman"/>
-        <a:font script="Thai" typeface="Angsana New"/>
-        <a:font script="Ethi" typeface="Nyala"/>
-        <a:font script="Beng" typeface="Vrinda"/>
-        <a:font script="Gujr" typeface="Shruti"/>
-        <a:font script="Khmr" typeface="MoolBoran"/>
-        <a:font script="Knda" typeface="Tunga"/>
-        <a:font script="Guru" typeface="Raavi"/>
-        <a:font script="Cans" typeface="Euphemia"/>
-        <a:font script="Cher" typeface="Plantagenet Cherokee"/>
-        <a:font script="Yiii" typeface="Microsoft Yi Baiti"/>
-        <a:font script="Tibt" typeface="Microsoft Himalaya"/>
-        <a:font script="Thaa" typeface="MV Boli"/>
-        <a:font script="Deva" typeface="Mangal"/>
-        <a:font script="Telu" typeface="Gautami"/>
-        <a:font script="Taml" typeface="Latha"/>
-        <a:font script="Syrc" typeface="Estrangelo Edessa"/>
-        <a:font script="Orya" typeface="Kalinga"/>
-        <a:font script="Mlym" typeface="Kartika"/>
-        <a:font script="Laoo" typeface="DokChampa"/>
-        <a:font script="Sinh" typeface="Iskoola Pota"/>
-        <a:font script="Mong" typeface="Mongolian Baiti"/>
-        <a:font script="Viet" typeface="Times New Roman"/>
-        <a:font script="Uigh" typeface="Microsoft Uighur"/>
-        <a:font script="Geor" typeface="Sylfaen"/>
-      </a:majorFont>
-      <a:minorFont>
-        <a:latin typeface="Arial"/>
-        <a:ea typeface=""/>
-        <a:cs typeface=""/>
-        <a:font script="Jpan" typeface="ＭＳ Ｐゴシック"/>
-        <a:font script="Hang" typeface="맑은 고딕"/>
-        <a:font script="Hans" typeface="宋体"/>
-        <a:font script="Hant" typeface="新細明體"/>
-        <a:font script="Arab" typeface="Arial"/>
-        <a:font script="Hebr" typeface="Arial"/>
-        <a:font script="Thai" typeface="Cordia New"/>
-        <a:font script="Ethi" typeface="Nyala"/>
-        <a:font script="Beng" typeface="Vrinda"/>
-        <a:font script="Gujr" typeface="Shruti"/>
-        <a:font script="Khmr" typeface="DaunPenh"/>
-        <a:font script="Knda" typeface="Tunga"/>
-        <a:font script="Guru" typeface="Raavi"/>
-        <a:font script="Cans" typeface="Euphemia"/>
-        <a:font script="Cher" typeface="Plantagenet Cherokee"/>
-        <a:font script="Yiii" typeface="Microsoft Yi Baiti"/>
-        <a:font script="Tibt" typeface="Microsoft Himalaya"/>
-        <a:font script="Thaa" typeface="MV Boli"/>
-        <a:font script="Deva" typeface="Mangal"/>
-        <a:font script="Telu" typeface="Gautami"/>
-        <a:font script="Taml" typeface="Latha"/>
-        <a:font script="Syrc" typeface="Estrangelo Edessa"/>
-        <a:font script="Orya" typeface="Kalinga"/>
-        <a:font script="Mlym" typeface="Kartika"/>
-        <a:font script="Laoo" typeface="DokChampa"/>
-        <a:font script="Sinh" typeface="Iskoola Pota"/>
-        <a:font script="Mong" typeface="Mongolian Baiti"/>
-        <a:font script="Viet" typeface="Arial"/>
-        <a:font script="Uigh" typeface="Microsoft Uighur"/>
-        <a:font script="Geor" typeface="Sylfaen"/>
-      </a:minorFont>
-    </a:fontScheme>
-    <a:fmtScheme name="Office">
-      <a:fillStyleLst>
-        <a:solidFill>
-          <a:schemeClr val="phClr"/>
-        </a:solidFill>
-        <a:gradFill rotWithShape="1">
-          <a:gsLst>
-            <a:gs pos="0">
-              <a:schemeClr val="phClr">
-                <a:tint val="50000"/>
-                <a:satMod val="300000"/>
-              </a:schemeClr>
-            </a:gs>
-            <a:gs pos="35000">
-              <a:schemeClr val="phClr">
-                <a:tint val="37000"/>
-                <a:satMod val="300000"/>
-              </a:schemeClr>
-            </a:gs>
-            <a:gs pos="100000">
-              <a:schemeClr val="phClr">
-                <a:tint val="15000"/>
-                <a:satMod val="350000"/>
-              </a:schemeClr>
-            </a:gs>
-          </a:gsLst>
-          <a:lin ang="16200000" scaled="1"/>
-        </a:gradFill>
-        <a:gradFill rotWithShape="1">
-          <a:gsLst>
-            <a:gs pos="0">
-              <a:schemeClr val="phClr">
-                <a:tint val="100000"/>
-                <a:shade val="100000"/>
-                <a:satMod val="130000"/>
-              </a:schemeClr>
-            </a:gs>
-            <a:gs pos="100000">
-              <a:schemeClr val="phClr">
-                <a:tint val="50000"/>
-                <a:shade val="100000"/>
-                <a:satMod val="350000"/>
-              </a:schemeClr>
-            </a:gs>
-          </a:gsLst>
-          <a:lin ang="16200000" scaled="0"/>
-        </a:gradFill>
-      </a:fillStyleLst>
-      <a:lnStyleLst>
-        <a:ln w="9525" cap="flat" cmpd="sng" algn="ctr">
-          <a:solidFill>
-            <a:schemeClr val="phClr">
-              <a:shade val="95000"/>
-              <a:satMod val="105000"/>
-            </a:schemeClr>
-          </a:solidFill>
-          <a:prstDash val="solid"/>
-        </a:ln>
-        <a:ln w="25400" cap="flat" cmpd="sng" algn="ctr">
-          <a:solidFill>
-            <a:schemeClr val="phClr"/>
-          </a:solidFill>
-          <a:prstDash val="solid"/>
-        </a:ln>
-        <a:ln w="38100" cap="flat" cmpd="sng" algn="ctr">
-          <a:solidFill>
-            <a:schemeClr val="phClr"/>
-          </a:solidFill>
-          <a:prstDash val="solid"/>
-        </a:ln>
-      </a:lnStyleLst>
-      <a:effectStyleLst>
-        <a:effectStyle>
-          <a:effectLst>
-            <a:outerShdw blurRad="40000" dist="20000" dir="5400000" rotWithShape="0">
-              <a:srgbClr val="000000">
-                <a:alpha val="38000"/>
-              </a:srgbClr>
-            </a:outerShdw>
-          </a:effectLst>
-        </a:effectStyle>
-        <a:effectStyle>
-          <a:effectLst>
-            <a:outerShdw blurRad="40000" dist="23000" dir="5400000" rotWithShape="0">
-              <a:srgbClr val="000000">
-                <a:alpha val="35000"/>
-              </a:srgbClr>
-            </a:outerShdw>
-          </a:effectLst>
-        </a:effectStyle>
-        <a:effectStyle>
-          <a:effectLst>
-            <a:outerShdw blurRad="40000" dist="23000" dir="5400000" rotWithShape="0">
-              <a:srgbClr val="000000">
-                <a:alpha val="35000"/>
-              </a:srgbClr>
-            </a:outerShdw>
-          </a:effectLst>
-          <a:scene3d>
-            <a:camera prst="orthographicFront">
-              <a:rot lat="0" lon="0" rev="0"/>
-            </a:camera>
-            <a:lightRig rig="threePt" dir="t">
-              <a:rot lat="0" lon="0" rev="1200000"/>
-            </a:lightRig>
-          </a:scene3d>
-          <a:sp3d>
-            <a:bevelT w="63500" h="25400"/>
-          </a:sp3d>
-        </a:effectStyle>
-      </a:effectStyleLst>
-      <a:bgFillStyleLst>
-        <a:solidFill>
-          <a:schemeClr val="phClr"/>
-        </a:solidFill>
-        <a:gradFill rotWithShape="1">
-          <a:gsLst>
-            <a:gs pos="0">
-              <a:schemeClr val="phClr">
-                <a:tint val="40000"/>
-                <a:satMod val="350000"/>
-              </a:schemeClr>
-            </a:gs>
-            <a:gs pos="40000">
-              <a:schemeClr val="phClr">
-                <a:tint val="45000"/>
-                <a:shade val="99000"/>
-                <a:satMod val="350000"/>
-              </a:schemeClr>
-            </a:gs>
-            <a:gs pos="100000">
-              <a:schemeClr val="phClr">
-                <a:shade val="20000"/>
-                <a:satMod val="255000"/>
-              </a:schemeClr>
-            </a:gs>
-          </a:gsLst>
-          <a:path path="circle">
-            <a:fillToRect l="50000" t="-80000" r="50000" b="180000"/>
-          </a:path>
-        </a:gradFill>
-        <a:gradFill rotWithShape="1">
-          <a:gsLst>
-            <a:gs pos="0">
-              <a:schemeClr val="phClr">
-                <a:tint val="80000"/>
-                <a:satMod val="300000"/>
-              </a:schemeClr>
-            </a:gs>
-            <a:gs pos="100000">
-              <a:schemeClr val="phClr">
-                <a:shade val="30000"/>
-                <a:satMod val="200000"/>
-              </a:schemeClr>
-            </a:gs>
-          </a:gsLst>
-          <a:path path="circle">
-            <a:fillToRect l="50000" t="50000" r="50000" b="50000"/>
-          </a:path>
-        </a:gradFill>
-      </a:bgFillStyleLst>
-    </a:fmtScheme>
-  </a:themeElements>
-</a:theme>
 </file>
</xml_diff>

<commit_message>
docs: leave the optional implementation-cost slide blank
</commit_message>
<xml_diff>
--- a/docs/submission/BreederNear-AI-deck.pptx
+++ b/docs/submission/BreederNear-AI-deck.pptx
@@ -7282,818 +7282,6 @@
               <a:cs typeface="Google Sans Flex Medium"/>
               <a:sym typeface="Google Sans Flex Medium"/>
             </a:endParaRPr>
-          </a:p>
-        </p:txBody>
-      </p:sp>
-      <p:graphicFrame>
-        <p:nvGraphicFramePr>
-          <p:cNvPr id="128" name="Table 127"/>
-          <p:cNvGraphicFramePr>
-            <a:graphicFrameLocks noGrp="1"/>
-          </p:cNvGraphicFramePr>
-          <p:nvPr/>
-        </p:nvGraphicFramePr>
-        <p:xfrm>
-          <a:off x="320040" y="1115568"/>
-          <a:ext cx="8503920" cy="1700784"/>
-        </p:xfrm>
-        <a:graphic>
-          <a:graphicData uri="http://schemas.openxmlformats.org/drawingml/2006/table">
-            <a:tbl>
-              <a:tblPr firstRow="1" bandRow="1">
-                <a:tableStyleId>{5C22544A-7EE6-4342-B048-85BDC9FD1C3A}</a:tableStyleId>
-              </a:tblPr>
-              <a:tblGrid>
-                <a:gridCol w="3566160"/>
-                <a:gridCol w="2743200"/>
-                <a:gridCol w="2194560"/>
-              </a:tblGrid>
-              <a:tr h="283464">
-                <a:tc>
-                  <a:txBody>
-                    <a:bodyPr wrap="square"/>
-                    <a:lstStyle/>
-                    <a:p>
-                      <a:r>
-                        <a:rPr sz="860">
-                          <a:solidFill>
-                            <a:srgbClr val="FFFFFF"/>
-                          </a:solidFill>
-                          <a:latin typeface="Google Sans Flex SemiBold"/>
-                        </a:rPr>
-                        <a:t>AI action (measured, real calls)</a:t>
-                      </a:r>
-                    </a:p>
-                  </a:txBody>
-                  <a:tcPr marL="54864" marR="54864" marT="22860" marB="22860" anchor="ctr">
-                    <a:solidFill>
-                      <a:srgbClr val="1D1D1F"/>
-                    </a:solidFill>
-                  </a:tcPr>
-                </a:tc>
-                <a:tc>
-                  <a:txBody>
-                    <a:bodyPr wrap="square"/>
-                    <a:lstStyle/>
-                    <a:p>
-                      <a:r>
-                        <a:rPr sz="860">
-                          <a:solidFill>
-                            <a:srgbClr val="FFFFFF"/>
-                          </a:solidFill>
-                          <a:latin typeface="Google Sans Flex SemiBold"/>
-                        </a:rPr>
-                        <a:t>Gemini tokens (in · out incl. thinking)</a:t>
-                      </a:r>
-                    </a:p>
-                  </a:txBody>
-                  <a:tcPr marL="54864" marR="54864" marT="22860" marB="22860" anchor="ctr">
-                    <a:solidFill>
-                      <a:srgbClr val="1D1D1F"/>
-                    </a:solidFill>
-                  </a:tcPr>
-                </a:tc>
-                <a:tc>
-                  <a:txBody>
-                    <a:bodyPr wrap="square"/>
-                    <a:lstStyle/>
-                    <a:p>
-                      <a:r>
-                        <a:rPr sz="860">
-                          <a:solidFill>
-                            <a:srgbClr val="FFFFFF"/>
-                          </a:solidFill>
-                          <a:latin typeface="Google Sans Flex SemiBold"/>
-                        </a:rPr>
-                        <a:t>Cost per action*</a:t>
-                      </a:r>
-                    </a:p>
-                  </a:txBody>
-                  <a:tcPr marL="54864" marR="54864" marT="22860" marB="22860" anchor="ctr">
-                    <a:solidFill>
-                      <a:srgbClr val="1D1D1F"/>
-                    </a:solidFill>
-                  </a:tcPr>
-                </a:tc>
-              </a:tr>
-              <a:tr h="283464">
-                <a:tc>
-                  <a:txBody>
-                    <a:bodyPr wrap="square"/>
-                    <a:lstStyle/>
-                    <a:p>
-                      <a:r>
-                        <a:rPr sz="860">
-                          <a:solidFill>
-                            <a:srgbClr val="1D1D1F"/>
-                          </a:solidFill>
-                          <a:latin typeface="Google Sans Flex"/>
-                        </a:rPr>
-                        <a:t>List a pet: extract listing + screen photo</a:t>
-                      </a:r>
-                    </a:p>
-                  </a:txBody>
-                  <a:tcPr marL="54864" marR="54864" marT="22860" marB="22860" anchor="ctr">
-                    <a:solidFill>
-                      <a:srgbClr val="FFFFFF"/>
-                    </a:solidFill>
-                  </a:tcPr>
-                </a:tc>
-                <a:tc>
-                  <a:txBody>
-                    <a:bodyPr wrap="square"/>
-                    <a:lstStyle/>
-                    <a:p>
-                      <a:r>
-                        <a:rPr sz="860">
-                          <a:solidFill>
-                            <a:srgbClr val="1D1D1F"/>
-                          </a:solidFill>
-                          <a:latin typeface="Google Sans Flex"/>
-                        </a:rPr>
-                        <a:t>≈ 4,560 · ≤ 1,075</a:t>
-                      </a:r>
-                    </a:p>
-                  </a:txBody>
-                  <a:tcPr marL="54864" marR="54864" marT="22860" marB="22860" anchor="ctr">
-                    <a:solidFill>
-                      <a:srgbClr val="FFFFFF"/>
-                    </a:solidFill>
-                  </a:tcPr>
-                </a:tc>
-                <a:tc>
-                  <a:txBody>
-                    <a:bodyPr wrap="square"/>
-                    <a:lstStyle/>
-                    <a:p>
-                      <a:r>
-                        <a:rPr sz="860">
-                          <a:solidFill>
-                            <a:srgbClr val="1D1D1F"/>
-                          </a:solidFill>
-                          <a:latin typeface="Google Sans Flex"/>
-                        </a:rPr>
-                        <a:t>≈ ₹1.3</a:t>
-                      </a:r>
-                    </a:p>
-                  </a:txBody>
-                  <a:tcPr marL="54864" marR="54864" marT="22860" marB="22860" anchor="ctr">
-                    <a:solidFill>
-                      <a:srgbClr val="FFFFFF"/>
-                    </a:solidFill>
-                  </a:tcPr>
-                </a:tc>
-              </a:tr>
-              <a:tr h="283464">
-                <a:tc>
-                  <a:txBody>
-                    <a:bodyPr wrap="square"/>
-                    <a:lstStyle/>
-                    <a:p>
-                      <a:r>
-                        <a:rPr sz="860">
-                          <a:solidFill>
-                            <a:srgbClr val="1D1D1F"/>
-                          </a:solidFill>
-                          <a:latin typeface="Google Sans Flex"/>
-                        </a:rPr>
-                        <a:t>Check an outside post (text only; a screenshot adds ≈ ₹0.5)</a:t>
-                      </a:r>
-                    </a:p>
-                  </a:txBody>
-                  <a:tcPr marL="54864" marR="54864" marT="22860" marB="22860" anchor="ctr">
-                    <a:solidFill>
-                      <a:srgbClr val="F3F3F0"/>
-                    </a:solidFill>
-                  </a:tcPr>
-                </a:tc>
-                <a:tc>
-                  <a:txBody>
-                    <a:bodyPr wrap="square"/>
-                    <a:lstStyle/>
-                    <a:p>
-                      <a:r>
-                        <a:rPr sz="860">
-                          <a:solidFill>
-                            <a:srgbClr val="1D1D1F"/>
-                          </a:solidFill>
-                          <a:latin typeface="Google Sans Flex"/>
-                        </a:rPr>
-                        <a:t>≈ 1,620 · ≤ 445</a:t>
-                      </a:r>
-                    </a:p>
-                  </a:txBody>
-                  <a:tcPr marL="54864" marR="54864" marT="22860" marB="22860" anchor="ctr">
-                    <a:solidFill>
-                      <a:srgbClr val="F3F3F0"/>
-                    </a:solidFill>
-                  </a:tcPr>
-                </a:tc>
-                <a:tc>
-                  <a:txBody>
-                    <a:bodyPr wrap="square"/>
-                    <a:lstStyle/>
-                    <a:p>
-                      <a:r>
-                        <a:rPr sz="860">
-                          <a:solidFill>
-                            <a:srgbClr val="1D1D1F"/>
-                          </a:solidFill>
-                          <a:latin typeface="Google Sans Flex"/>
-                        </a:rPr>
-                        <a:t>≈ ₹0.5</a:t>
-                      </a:r>
-                    </a:p>
-                  </a:txBody>
-                  <a:tcPr marL="54864" marR="54864" marT="22860" marB="22860" anchor="ctr">
-                    <a:solidFill>
-                      <a:srgbClr val="F3F3F0"/>
-                    </a:solidFill>
-                  </a:tcPr>
-                </a:tc>
-              </a:tr>
-              <a:tr h="283464">
-                <a:tc>
-                  <a:txBody>
-                    <a:bodyPr wrap="square"/>
-                    <a:lstStyle/>
-                    <a:p>
-                      <a:r>
-                        <a:rPr sz="860">
-                          <a:solidFill>
-                            <a:srgbClr val="1D1D1F"/>
-                          </a:solidFill>
-                          <a:latin typeface="Google Sans Flex"/>
-                        </a:rPr>
-                        <a:t>Verification: read a certificate · review 2 facility photos</a:t>
-                      </a:r>
-                    </a:p>
-                  </a:txBody>
-                  <a:tcPr marL="54864" marR="54864" marT="22860" marB="22860" anchor="ctr">
-                    <a:solidFill>
-                      <a:srgbClr val="FFFFFF"/>
-                    </a:solidFill>
-                  </a:tcPr>
-                </a:tc>
-                <a:tc>
-                  <a:txBody>
-                    <a:bodyPr wrap="square"/>
-                    <a:lstStyle/>
-                    <a:p>
-                      <a:r>
-                        <a:rPr sz="860">
-                          <a:solidFill>
-                            <a:srgbClr val="1D1D1F"/>
-                          </a:solidFill>
-                          <a:latin typeface="Google Sans Flex"/>
-                        </a:rPr>
-                        <a:t>≈ 1,640 · 400  ·  ≈ 2,630 · 645</a:t>
-                      </a:r>
-                    </a:p>
-                  </a:txBody>
-                  <a:tcPr marL="54864" marR="54864" marT="22860" marB="22860" anchor="ctr">
-                    <a:solidFill>
-                      <a:srgbClr val="FFFFFF"/>
-                    </a:solidFill>
-                  </a:tcPr>
-                </a:tc>
-                <a:tc>
-                  <a:txBody>
-                    <a:bodyPr wrap="square"/>
-                    <a:lstStyle/>
-                    <a:p>
-                      <a:r>
-                        <a:rPr sz="860">
-                          <a:solidFill>
-                            <a:srgbClr val="1D1D1F"/>
-                          </a:solidFill>
-                          <a:latin typeface="Google Sans Flex"/>
-                        </a:rPr>
-                        <a:t>≈ ₹0.5 · ≈ ₹0.8</a:t>
-                      </a:r>
-                    </a:p>
-                  </a:txBody>
-                  <a:tcPr marL="54864" marR="54864" marT="22860" marB="22860" anchor="ctr">
-                    <a:solidFill>
-                      <a:srgbClr val="FFFFFF"/>
-                    </a:solidFill>
-                  </a:tcPr>
-                </a:tc>
-              </a:tr>
-              <a:tr h="283464">
-                <a:tc>
-                  <a:txBody>
-                    <a:bodyPr wrap="square"/>
-                    <a:lstStyle/>
-                    <a:p>
-                      <a:r>
-                        <a:rPr sz="860">
-                          <a:solidFill>
-                            <a:srgbClr val="1D1D1F"/>
-                          </a:solidFill>
-                          <a:latin typeface="Google Sans Flex"/>
-                        </a:rPr>
-                        <a:t>Buyer profile from their words · scan a message</a:t>
-                      </a:r>
-                    </a:p>
-                  </a:txBody>
-                  <a:tcPr marL="54864" marR="54864" marT="22860" marB="22860" anchor="ctr">
-                    <a:solidFill>
-                      <a:srgbClr val="F3F3F0"/>
-                    </a:solidFill>
-                  </a:tcPr>
-                </a:tc>
-                <a:tc>
-                  <a:txBody>
-                    <a:bodyPr wrap="square"/>
-                    <a:lstStyle/>
-                    <a:p>
-                      <a:r>
-                        <a:rPr sz="860">
-                          <a:solidFill>
-                            <a:srgbClr val="1D1D1F"/>
-                          </a:solidFill>
-                          <a:latin typeface="Google Sans Flex"/>
-                        </a:rPr>
-                        <a:t>≈ 700 · 550  ·  ≈ 300 · 120</a:t>
-                      </a:r>
-                    </a:p>
-                  </a:txBody>
-                  <a:tcPr marL="54864" marR="54864" marT="22860" marB="22860" anchor="ctr">
-                    <a:solidFill>
-                      <a:srgbClr val="F3F3F0"/>
-                    </a:solidFill>
-                  </a:tcPr>
-                </a:tc>
-                <a:tc>
-                  <a:txBody>
-                    <a:bodyPr wrap="square"/>
-                    <a:lstStyle/>
-                    <a:p>
-                      <a:r>
-                        <a:rPr sz="860">
-                          <a:solidFill>
-                            <a:srgbClr val="1D1D1F"/>
-                          </a:solidFill>
-                          <a:latin typeface="Google Sans Flex"/>
-                        </a:rPr>
-                        <a:t>≈ ₹0.5 · ≈ ₹0.1</a:t>
-                      </a:r>
-                    </a:p>
-                  </a:txBody>
-                  <a:tcPr marL="54864" marR="54864" marT="22860" marB="22860" anchor="ctr">
-                    <a:solidFill>
-                      <a:srgbClr val="F3F3F0"/>
-                    </a:solidFill>
-                  </a:tcPr>
-                </a:tc>
-              </a:tr>
-              <a:tr h="283464">
-                <a:tc>
-                  <a:txBody>
-                    <a:bodyPr wrap="square"/>
-                    <a:lstStyle/>
-                    <a:p>
-                      <a:r>
-                        <a:rPr sz="860">
-                          <a:solidFill>
-                            <a:srgbClr val="1D1D1F"/>
-                          </a:solidFill>
-                          <a:latin typeface="Google Sans Flex"/>
-                        </a:rPr>
-                        <a:t>14-day care plan (cached per species and age) · reply draft</a:t>
-                      </a:r>
-                    </a:p>
-                  </a:txBody>
-                  <a:tcPr marL="54864" marR="54864" marT="22860" marB="22860" anchor="ctr">
-                    <a:solidFill>
-                      <a:srgbClr val="FFFFFF"/>
-                    </a:solidFill>
-                  </a:tcPr>
-                </a:tc>
-                <a:tc>
-                  <a:txBody>
-                    <a:bodyPr wrap="square"/>
-                    <a:lstStyle/>
-                    <a:p>
-                      <a:r>
-                        <a:rPr sz="860">
-                          <a:solidFill>
-                            <a:srgbClr val="1D1D1F"/>
-                          </a:solidFill>
-                          <a:latin typeface="Google Sans Flex"/>
-                        </a:rPr>
-                        <a:t>≈ 560 · ≤ 1,680  ·  ≈ 500 · ≤ 790</a:t>
-                      </a:r>
-                    </a:p>
-                  </a:txBody>
-                  <a:tcPr marL="54864" marR="54864" marT="22860" marB="22860" anchor="ctr">
-                    <a:solidFill>
-                      <a:srgbClr val="FFFFFF"/>
-                    </a:solidFill>
-                  </a:tcPr>
-                </a:tc>
-                <a:tc>
-                  <a:txBody>
-                    <a:bodyPr wrap="square"/>
-                    <a:lstStyle/>
-                    <a:p>
-                      <a:r>
-                        <a:rPr sz="860">
-                          <a:solidFill>
-                            <a:srgbClr val="1D1D1F"/>
-                          </a:solidFill>
-                          <a:latin typeface="Google Sans Flex"/>
-                        </a:rPr>
-                        <a:t>≈ ₹1.2 · ≈ ₹0.6</a:t>
-                      </a:r>
-                    </a:p>
-                  </a:txBody>
-                  <a:tcPr marL="54864" marR="54864" marT="22860" marB="22860" anchor="ctr">
-                    <a:solidFill>
-                      <a:srgbClr val="FFFFFF"/>
-                    </a:solidFill>
-                  </a:tcPr>
-                </a:tc>
-              </a:tr>
-            </a:tbl>
-          </a:graphicData>
-        </a:graphic>
-      </p:graphicFrame>
-      <p:graphicFrame>
-        <p:nvGraphicFramePr>
-          <p:cNvPr id="129" name="Table 128"/>
-          <p:cNvGraphicFramePr>
-            <a:graphicFrameLocks noGrp="1"/>
-          </p:cNvGraphicFramePr>
-          <p:nvPr/>
-        </p:nvGraphicFramePr>
-        <p:xfrm>
-          <a:off x="320040" y="2990087"/>
-          <a:ext cx="8503920" cy="1097280"/>
-        </p:xfrm>
-        <a:graphic>
-          <a:graphicData uri="http://schemas.openxmlformats.org/drawingml/2006/table">
-            <a:tbl>
-              <a:tblPr firstRow="1" bandRow="1">
-                <a:tableStyleId>{5C22544A-7EE6-4342-B048-85BDC9FD1C3A}</a:tableStyleId>
-              </a:tblPr>
-              <a:tblGrid>
-                <a:gridCol w="3566160"/>
-                <a:gridCol w="2743200"/>
-                <a:gridCol w="2194560"/>
-              </a:tblGrid>
-              <a:tr h="274320">
-                <a:tc>
-                  <a:txBody>
-                    <a:bodyPr wrap="square"/>
-                    <a:lstStyle/>
-                    <a:p>
-                      <a:r>
-                        <a:rPr sz="860">
-                          <a:solidFill>
-                            <a:srgbClr val="FFFFFF"/>
-                          </a:solidFill>
-                          <a:latin typeface="Google Sans Flex SemiBold"/>
-                        </a:rPr>
-                        <a:t>Running cost</a:t>
-                      </a:r>
-                    </a:p>
-                  </a:txBody>
-                  <a:tcPr marL="54864" marR="54864" marT="22860" marB="22860" anchor="ctr">
-                    <a:solidFill>
-                      <a:srgbClr val="1D1D1F"/>
-                    </a:solidFill>
-                  </a:tcPr>
-                </a:tc>
-                <a:tc>
-                  <a:txBody>
-                    <a:bodyPr wrap="square"/>
-                    <a:lstStyle/>
-                    <a:p>
-                      <a:r>
-                        <a:rPr sz="860">
-                          <a:solidFill>
-                            <a:srgbClr val="FFFFFF"/>
-                          </a:solidFill>
-                          <a:latin typeface="Google Sans Flex SemiBold"/>
-                        </a:rPr>
-                        <a:t>Prototype through judging</a:t>
-                      </a:r>
-                    </a:p>
-                  </a:txBody>
-                  <a:tcPr marL="54864" marR="54864" marT="22860" marB="22860" anchor="ctr">
-                    <a:solidFill>
-                      <a:srgbClr val="1D1D1F"/>
-                    </a:solidFill>
-                  </a:tcPr>
-                </a:tc>
-                <a:tc>
-                  <a:txBody>
-                    <a:bodyPr wrap="square"/>
-                    <a:lstStyle/>
-                    <a:p>
-                      <a:r>
-                        <a:rPr sz="860">
-                          <a:solidFill>
-                            <a:srgbClr val="FFFFFF"/>
-                          </a:solidFill>
-                          <a:latin typeface="Google Sans Flex SemiBold"/>
-                        </a:rPr>
-                        <a:t>Example: 10,000 listings a month</a:t>
-                      </a:r>
-                    </a:p>
-                  </a:txBody>
-                  <a:tcPr marL="54864" marR="54864" marT="22860" marB="22860" anchor="ctr">
-                    <a:solidFill>
-                      <a:srgbClr val="1D1D1F"/>
-                    </a:solidFill>
-                  </a:tcPr>
-                </a:tc>
-              </a:tr>
-              <a:tr h="274320">
-                <a:tc>
-                  <a:txBody>
-                    <a:bodyPr wrap="square"/>
-                    <a:lstStyle/>
-                    <a:p>
-                      <a:r>
-                        <a:rPr sz="860">
-                          <a:solidFill>
-                            <a:srgbClr val="1D1D1F"/>
-                          </a:solidFill>
-                          <a:latin typeface="Google Sans Flex"/>
-                        </a:rPr>
-                        <a:t>Cloud Run (1 always-on instance)</a:t>
-                      </a:r>
-                    </a:p>
-                  </a:txBody>
-                  <a:tcPr marL="54864" marR="54864" marT="22860" marB="22860" anchor="ctr">
-                    <a:solidFill>
-                      <a:srgbClr val="FFFFFF"/>
-                    </a:solidFill>
-                  </a:tcPr>
-                </a:tc>
-                <a:tc>
-                  <a:txBody>
-                    <a:bodyPr wrap="square"/>
-                    <a:lstStyle/>
-                    <a:p>
-                      <a:r>
-                        <a:rPr sz="860">
-                          <a:solidFill>
-                            <a:srgbClr val="1D1D1F"/>
-                          </a:solidFill>
-                          <a:latin typeface="Google Sans Flex"/>
-                        </a:rPr>
-                        <a:t>≈ ₹600–1,000 / month (estimate)</a:t>
-                      </a:r>
-                    </a:p>
-                  </a:txBody>
-                  <a:tcPr marL="54864" marR="54864" marT="22860" marB="22860" anchor="ctr">
-                    <a:solidFill>
-                      <a:srgbClr val="FFFFFF"/>
-                    </a:solidFill>
-                  </a:tcPr>
-                </a:tc>
-                <a:tc>
-                  <a:txBody>
-                    <a:bodyPr wrap="square"/>
-                    <a:lstStyle/>
-                    <a:p>
-                      <a:r>
-                        <a:rPr sz="860">
-                          <a:solidFill>
-                            <a:srgbClr val="1D1D1F"/>
-                          </a:solidFill>
-                          <a:latin typeface="Google Sans Flex"/>
-                        </a:rPr>
-                        <a:t>scales per request</a:t>
-                      </a:r>
-                    </a:p>
-                  </a:txBody>
-                  <a:tcPr marL="54864" marR="54864" marT="22860" marB="22860" anchor="ctr">
-                    <a:solidFill>
-                      <a:srgbClr val="FFFFFF"/>
-                    </a:solidFill>
-                  </a:tcPr>
-                </a:tc>
-              </a:tr>
-              <a:tr h="274320">
-                <a:tc>
-                  <a:txBody>
-                    <a:bodyPr wrap="square"/>
-                    <a:lstStyle/>
-                    <a:p>
-                      <a:r>
-                        <a:rPr sz="860">
-                          <a:solidFill>
-                            <a:srgbClr val="1D1D1F"/>
-                          </a:solidFill>
-                          <a:latin typeface="Google Sans Flex"/>
-                        </a:rPr>
-                        <a:t>Firestore, Cloud Storage, Firebase Hosting + Auth</a:t>
-                      </a:r>
-                    </a:p>
-                  </a:txBody>
-                  <a:tcPr marL="54864" marR="54864" marT="22860" marB="22860" anchor="ctr">
-                    <a:solidFill>
-                      <a:srgbClr val="F3F3F0"/>
-                    </a:solidFill>
-                  </a:tcPr>
-                </a:tc>
-                <a:tc>
-                  <a:txBody>
-                    <a:bodyPr wrap="square"/>
-                    <a:lstStyle/>
-                    <a:p>
-                      <a:r>
-                        <a:rPr sz="860">
-                          <a:solidFill>
-                            <a:srgbClr val="1D1D1F"/>
-                          </a:solidFill>
-                          <a:latin typeface="Google Sans Flex"/>
-                        </a:rPr>
-                        <a:t>within free usage at prototype scale</a:t>
-                      </a:r>
-                    </a:p>
-                  </a:txBody>
-                  <a:tcPr marL="54864" marR="54864" marT="22860" marB="22860" anchor="ctr">
-                    <a:solidFill>
-                      <a:srgbClr val="F3F3F0"/>
-                    </a:solidFill>
-                  </a:tcPr>
-                </a:tc>
-                <a:tc>
-                  <a:txBody>
-                    <a:bodyPr wrap="square"/>
-                    <a:lstStyle/>
-                    <a:p>
-                      <a:r>
-                        <a:rPr sz="860">
-                          <a:solidFill>
-                            <a:srgbClr val="1D1D1F"/>
-                          </a:solidFill>
-                          <a:latin typeface="Google Sans Flex"/>
-                        </a:rPr>
-                        <a:t>pay per use (not measured)</a:t>
-                      </a:r>
-                    </a:p>
-                  </a:txBody>
-                  <a:tcPr marL="54864" marR="54864" marT="22860" marB="22860" anchor="ctr">
-                    <a:solidFill>
-                      <a:srgbClr val="F3F3F0"/>
-                    </a:solidFill>
-                  </a:tcPr>
-                </a:tc>
-              </a:tr>
-              <a:tr h="274320">
-                <a:tc>
-                  <a:txBody>
-                    <a:bodyPr wrap="square"/>
-                    <a:lstStyle/>
-                    <a:p>
-                      <a:r>
-                        <a:rPr sz="860">
-                          <a:solidFill>
-                            <a:srgbClr val="1D1D1F"/>
-                          </a:solidFill>
-                          <a:latin typeface="Google Sans Flex"/>
-                        </a:rPr>
-                        <a:t>Gemini</a:t>
-                      </a:r>
-                    </a:p>
-                  </a:txBody>
-                  <a:tcPr marL="54864" marR="54864" marT="22860" marB="22860" anchor="ctr">
-                    <a:solidFill>
-                      <a:srgbClr val="FFFFFF"/>
-                    </a:solidFill>
-                  </a:tcPr>
-                </a:tc>
-                <a:tc>
-                  <a:txBody>
-                    <a:bodyPr wrap="square"/>
-                    <a:lstStyle/>
-                    <a:p>
-                      <a:r>
-                        <a:rPr sz="860">
-                          <a:solidFill>
-                            <a:srgbClr val="1D1D1F"/>
-                          </a:solidFill>
-                          <a:latin typeface="Google Sans Flex"/>
-                        </a:rPr>
-                        <a:t>a few hundred ₹ (tests + judges)</a:t>
-                      </a:r>
-                    </a:p>
-                  </a:txBody>
-                  <a:tcPr marL="54864" marR="54864" marT="22860" marB="22860" anchor="ctr">
-                    <a:solidFill>
-                      <a:srgbClr val="FFFFFF"/>
-                    </a:solidFill>
-                  </a:tcPr>
-                </a:tc>
-                <a:tc>
-                  <a:txBody>
-                    <a:bodyPr wrap="square"/>
-                    <a:lstStyle/>
-                    <a:p>
-                      <a:r>
-                        <a:rPr sz="860">
-                          <a:solidFill>
-                            <a:srgbClr val="1D1D1F"/>
-                          </a:solidFill>
-                          <a:latin typeface="Google Sans Flex"/>
-                        </a:rPr>
-                        <a:t>≈ ₹13,000 / month for screening</a:t>
-                      </a:r>
-                    </a:p>
-                  </a:txBody>
-                  <a:tcPr marL="54864" marR="54864" marT="22860" marB="22860" anchor="ctr">
-                    <a:solidFill>
-                      <a:srgbClr val="FFFFFF"/>
-                    </a:solidFill>
-                  </a:tcPr>
-                </a:tc>
-              </a:tr>
-            </a:tbl>
-          </a:graphicData>
-        </a:graphic>
-      </p:graphicFrame>
-      <p:sp>
-        <p:nvSpPr>
-          <p:cNvPr id="130" name="TextBox 129"/>
-          <p:cNvSpPr txBox="1"/>
-          <p:nvPr/>
-        </p:nvSpPr>
-        <p:spPr>
-          <a:xfrm>
-            <a:off x="320040" y="4133087"/>
-            <a:ext cx="8503920" cy="457200"/>
-          </a:xfrm>
-          <a:prstGeom prst="rect">
-            <a:avLst/>
-          </a:prstGeom>
-          <a:noFill/>
-        </p:spPr>
-        <p:txBody>
-          <a:bodyPr wrap="square" anchor="t" lIns="36576" rIns="36576" tIns="18288" bIns="18288">
-            <a:spAutoFit/>
-          </a:bodyPr>
-          <a:lstStyle/>
-          <a:p>
-            <a:pPr algn="l">
-              <a:spcAft>
-                <a:spcPts val="300"/>
-              </a:spcAft>
-            </a:pPr>
-            <a:r>
-              <a:rPr sz="950" i="0">
-                <a:solidFill>
-                  <a:srgbClr val="1F6E43"/>
-                </a:solidFill>
-                <a:latin typeface="Google Sans Flex SemiBold"/>
-              </a:rPr>
-              <a:t>Screening a listing costs about ₹1.3 against animals priced ₹400–₹25,000 in our sample listings, so every listing can be checked.</a:t>
-            </a:r>
-          </a:p>
-        </p:txBody>
-      </p:sp>
-      <p:sp>
-        <p:nvSpPr>
-          <p:cNvPr id="131" name="TextBox 130"/>
-          <p:cNvSpPr txBox="1"/>
-          <p:nvPr/>
-        </p:nvSpPr>
-        <p:spPr>
-          <a:xfrm>
-            <a:off x="320040" y="4681728"/>
-            <a:ext cx="8503920" cy="274320"/>
-          </a:xfrm>
-          <a:prstGeom prst="rect">
-            <a:avLst/>
-          </a:prstGeom>
-          <a:noFill/>
-        </p:spPr>
-        <p:txBody>
-          <a:bodyPr wrap="square" anchor="t" lIns="36576" rIns="36576" tIns="18288" bIns="18288">
-            <a:spAutoFit/>
-          </a:bodyPr>
-          <a:lstStyle/>
-          <a:p>
-            <a:pPr algn="l">
-              <a:spcAft>
-                <a:spcPts val="300"/>
-              </a:spcAft>
-            </a:pPr>
-            <a:r>
-              <a:rPr sz="650" i="0">
-                <a:solidFill>
-                  <a:srgbClr val="5F5F64"/>
-                </a:solidFill>
-                <a:latin typeface="Google Sans Flex"/>
-              </a:rPr>
-              <a:t>*Measured tokens (10–11 Oct 2026); thinking tokens counted as output · Gemini 3.8 Flash at $1.50 in / $7.50 out per 1M tokens (list price from 1 Jan 2027 as reported by price trackers; introductory price until then is half) · ₹88 = $1 (assumption) · Estimates are labelled</a:t>
-            </a:r>
           </a:p>
         </p:txBody>
       </p:sp>

</xml_diff>

<commit_message>
feat: Impact so far, share this warning and report it
- GET /api/impact counts listings screened, blocked and Caution, outside posts checked, flagged and with a
  protected species (counters only, posts never stored), scam-like messages and verified breeders
- Impact so far on the Pets tab and the seller dashboard
- After a post check: Share this warning back to the group; protected species link to Tamil Nadu's wildlife-crime
  complaint portal; risky posts show the 1930 cyber-fraud helpline and cybercrime.gov.in; same in the AI chat card
- Trust agent points to sharing and reporting; E04, E06, E07, E12 re-run and passing
- README impact section, feature F22, privacy notes, API doc, deck journey and business slides
</commit_message>
<xml_diff>
--- a/docs/submission/BreederNear-AI-deck.pptx
+++ b/docs/submission/BreederNear-AI-deck.pptx
@@ -8308,7 +8308,7 @@
                           </a:solidFill>
                           <a:latin typeface="Google Sans Flex SemiBold"/>
                         </a:rPr>
-                        <a:t>332 · 17/17</a:t>
+                        <a:t>335 · 17/17</a:t>
                       </a:r>
                     </a:p>
                   </a:txBody>
@@ -10487,12 +10487,12 @@
         </p:nvSpPr>
         <p:spPr>
           <a:xfrm>
-            <a:off x="320040" y="3895344"/>
-            <a:ext cx="8503920" cy="566928"/>
+            <a:off x="320040" y="3877056"/>
+            <a:ext cx="8503920" cy="749808"/>
           </a:xfrm>
           <a:prstGeom prst="roundRect">
             <a:avLst>
-              <a:gd name="adj" fmla="val 12903"/>
+              <a:gd name="adj" fmla="val 9756"/>
             </a:avLst>
           </a:prstGeom>
           <a:solidFill>
@@ -10531,8 +10531,8 @@
         </p:nvSpPr>
         <p:spPr>
           <a:xfrm>
-            <a:off x="429768" y="3913632"/>
-            <a:ext cx="8284464" cy="548640"/>
+            <a:off x="429768" y="3895344"/>
+            <a:ext cx="8284464" cy="731520"/>
           </a:xfrm>
           <a:prstGeom prst="rect">
             <a:avLst/>
@@ -10582,7 +10582,7 @@
                 </a:solidFill>
                 <a:latin typeface="Google Sans Flex SemiBold"/>
               </a:rPr>
-              <a:t>Who benefits: </a:t>
+              <a:t>Impact we measure, live in the app: </a:t>
             </a:r>
             <a:r>
               <a:rPr sz="1000" i="0">
@@ -10591,7 +10591,7 @@
                 </a:solidFill>
                 <a:latin typeface="Google Sans Flex"/>
               </a:rPr>
-              <a:t>buyers pay fair prices for healthy, legal pets; breeders win hours and reach; protected birds never get listed.</a:t>
+              <a:t>listings checked before going live · protected animals stopped · scam warnings raised · verified breeders. Every warning can be shared back to the group it came from, and protected species come with a way to report them.</a:t>
             </a:r>
           </a:p>
         </p:txBody>
@@ -11302,7 +11302,7 @@
                           </a:solidFill>
                           <a:latin typeface="Google Sans Flex"/>
                         </a:rPr>
-                        <a:t>Pay a stranger in a group in full, in advance</a:t>
+                        <a:t>Pay a stranger on social media in full, in advance</a:t>
                       </a:r>
                     </a:p>
                   </a:txBody>
@@ -11324,7 +11324,7 @@
                           </a:solidFill>
                           <a:latin typeface="Google Sans Flex"/>
                         </a:rPr>
-                        <a:t>Paste any outside post: “Is this post safe?”</a:t>
+                        <a:t>Paste any outside post: “Is this post safe?”; share the warning back to the group; report protected animals</a:t>
                       </a:r>
                     </a:p>
                   </a:txBody>
@@ -11764,7 +11764,7 @@
                 </a:solidFill>
                 <a:latin typeface="Google Sans Flex"/>
               </a:rPr>
-              <a:t>every step works by tapping or by asking seven Gemini agents in English or Tamil. Live now: 66/66 agent eval runs, 332 unit tests, 0 accessibility problems.</a:t>
+              <a:t>every step works by tapping or by asking seven Gemini agents in English or Tamil. Live now: 66/66 agent eval runs, 335 unit tests, 0 accessibility problems.</a:t>
             </a:r>
           </a:p>
         </p:txBody>
@@ -20200,6 +20200,285 @@
 </file>
 
 <file path=ppt/theme/theme1.xml><?xml version="1.0" encoding="utf-8"?>
+<a:theme xmlns:a="http://schemas.openxmlformats.org/drawingml/2006/main" xmlns:r="http://schemas.openxmlformats.org/officeDocument/2006/relationships" name="Simple Light">
+  <a:themeElements>
+    <a:clrScheme name="Simple Light">
+      <a:dk1>
+        <a:srgbClr val="000000"/>
+      </a:dk1>
+      <a:lt1>
+        <a:srgbClr val="FFFFFF"/>
+      </a:lt1>
+      <a:dk2>
+        <a:srgbClr val="595959"/>
+      </a:dk2>
+      <a:lt2>
+        <a:srgbClr val="EEEEEE"/>
+      </a:lt2>
+      <a:accent1>
+        <a:srgbClr val="4285F4"/>
+      </a:accent1>
+      <a:accent2>
+        <a:srgbClr val="212121"/>
+      </a:accent2>
+      <a:accent3>
+        <a:srgbClr val="78909C"/>
+      </a:accent3>
+      <a:accent4>
+        <a:srgbClr val="FFAB40"/>
+      </a:accent4>
+      <a:accent5>
+        <a:srgbClr val="0097A7"/>
+      </a:accent5>
+      <a:accent6>
+        <a:srgbClr val="EEFF41"/>
+      </a:accent6>
+      <a:hlink>
+        <a:srgbClr val="0097A7"/>
+      </a:hlink>
+      <a:folHlink>
+        <a:srgbClr val="0097A7"/>
+      </a:folHlink>
+    </a:clrScheme>
+    <a:fontScheme name="Office">
+      <a:majorFont>
+        <a:latin typeface="Arial"/>
+        <a:ea typeface=""/>
+        <a:cs typeface=""/>
+        <a:font script="Jpan" typeface="ＭＳ Ｐゴシック"/>
+        <a:font script="Hang" typeface="맑은 고딕"/>
+        <a:font script="Hans" typeface="宋体"/>
+        <a:font script="Hant" typeface="新細明體"/>
+        <a:font script="Arab" typeface="Times New Roman"/>
+        <a:font script="Hebr" typeface="Times New Roman"/>
+        <a:font script="Thai" typeface="Angsana New"/>
+        <a:font script="Ethi" typeface="Nyala"/>
+        <a:font script="Beng" typeface="Vrinda"/>
+        <a:font script="Gujr" typeface="Shruti"/>
+        <a:font script="Khmr" typeface="MoolBoran"/>
+        <a:font script="Knda" typeface="Tunga"/>
+        <a:font script="Guru" typeface="Raavi"/>
+        <a:font script="Cans" typeface="Euphemia"/>
+        <a:font script="Cher" typeface="Plantagenet Cherokee"/>
+        <a:font script="Yiii" typeface="Microsoft Yi Baiti"/>
+        <a:font script="Tibt" typeface="Microsoft Himalaya"/>
+        <a:font script="Thaa" typeface="MV Boli"/>
+        <a:font script="Deva" typeface="Mangal"/>
+        <a:font script="Telu" typeface="Gautami"/>
+        <a:font script="Taml" typeface="Latha"/>
+        <a:font script="Syrc" typeface="Estrangelo Edessa"/>
+        <a:font script="Orya" typeface="Kalinga"/>
+        <a:font script="Mlym" typeface="Kartika"/>
+        <a:font script="Laoo" typeface="DokChampa"/>
+        <a:font script="Sinh" typeface="Iskoola Pota"/>
+        <a:font script="Mong" typeface="Mongolian Baiti"/>
+        <a:font script="Viet" typeface="Times New Roman"/>
+        <a:font script="Uigh" typeface="Microsoft Uighur"/>
+        <a:font script="Geor" typeface="Sylfaen"/>
+      </a:majorFont>
+      <a:minorFont>
+        <a:latin typeface="Arial"/>
+        <a:ea typeface=""/>
+        <a:cs typeface=""/>
+        <a:font script="Jpan" typeface="ＭＳ Ｐゴシック"/>
+        <a:font script="Hang" typeface="맑은 고딕"/>
+        <a:font script="Hans" typeface="宋体"/>
+        <a:font script="Hant" typeface="新細明體"/>
+        <a:font script="Arab" typeface="Arial"/>
+        <a:font script="Hebr" typeface="Arial"/>
+        <a:font script="Thai" typeface="Cordia New"/>
+        <a:font script="Ethi" typeface="Nyala"/>
+        <a:font script="Beng" typeface="Vrinda"/>
+        <a:font script="Gujr" typeface="Shruti"/>
+        <a:font script="Khmr" typeface="DaunPenh"/>
+        <a:font script="Knda" typeface="Tunga"/>
+        <a:font script="Guru" typeface="Raavi"/>
+        <a:font script="Cans" typeface="Euphemia"/>
+        <a:font script="Cher" typeface="Plantagenet Cherokee"/>
+        <a:font script="Yiii" typeface="Microsoft Yi Baiti"/>
+        <a:font script="Tibt" typeface="Microsoft Himalaya"/>
+        <a:font script="Thaa" typeface="MV Boli"/>
+        <a:font script="Deva" typeface="Mangal"/>
+        <a:font script="Telu" typeface="Gautami"/>
+        <a:font script="Taml" typeface="Latha"/>
+        <a:font script="Syrc" typeface="Estrangelo Edessa"/>
+        <a:font script="Orya" typeface="Kalinga"/>
+        <a:font script="Mlym" typeface="Kartika"/>
+        <a:font script="Laoo" typeface="DokChampa"/>
+        <a:font script="Sinh" typeface="Iskoola Pota"/>
+        <a:font script="Mong" typeface="Mongolian Baiti"/>
+        <a:font script="Viet" typeface="Arial"/>
+        <a:font script="Uigh" typeface="Microsoft Uighur"/>
+        <a:font script="Geor" typeface="Sylfaen"/>
+      </a:minorFont>
+    </a:fontScheme>
+    <a:fmtScheme name="Office">
+      <a:fillStyleLst>
+        <a:solidFill>
+          <a:schemeClr val="phClr"/>
+        </a:solidFill>
+        <a:gradFill rotWithShape="1">
+          <a:gsLst>
+            <a:gs pos="0">
+              <a:schemeClr val="phClr">
+                <a:tint val="50000"/>
+                <a:satMod val="300000"/>
+              </a:schemeClr>
+            </a:gs>
+            <a:gs pos="35000">
+              <a:schemeClr val="phClr">
+                <a:tint val="37000"/>
+                <a:satMod val="300000"/>
+              </a:schemeClr>
+            </a:gs>
+            <a:gs pos="100000">
+              <a:schemeClr val="phClr">
+                <a:tint val="15000"/>
+                <a:satMod val="350000"/>
+              </a:schemeClr>
+            </a:gs>
+          </a:gsLst>
+          <a:lin ang="16200000" scaled="1"/>
+        </a:gradFill>
+        <a:gradFill rotWithShape="1">
+          <a:gsLst>
+            <a:gs pos="0">
+              <a:schemeClr val="phClr">
+                <a:tint val="100000"/>
+                <a:shade val="100000"/>
+                <a:satMod val="130000"/>
+              </a:schemeClr>
+            </a:gs>
+            <a:gs pos="100000">
+              <a:schemeClr val="phClr">
+                <a:tint val="50000"/>
+                <a:shade val="100000"/>
+                <a:satMod val="350000"/>
+              </a:schemeClr>
+            </a:gs>
+          </a:gsLst>
+          <a:lin ang="16200000" scaled="0"/>
+        </a:gradFill>
+      </a:fillStyleLst>
+      <a:lnStyleLst>
+        <a:ln w="9525" cap="flat" cmpd="sng" algn="ctr">
+          <a:solidFill>
+            <a:schemeClr val="phClr">
+              <a:shade val="95000"/>
+              <a:satMod val="105000"/>
+            </a:schemeClr>
+          </a:solidFill>
+          <a:prstDash val="solid"/>
+        </a:ln>
+        <a:ln w="25400" cap="flat" cmpd="sng" algn="ctr">
+          <a:solidFill>
+            <a:schemeClr val="phClr"/>
+          </a:solidFill>
+          <a:prstDash val="solid"/>
+        </a:ln>
+        <a:ln w="38100" cap="flat" cmpd="sng" algn="ctr">
+          <a:solidFill>
+            <a:schemeClr val="phClr"/>
+          </a:solidFill>
+          <a:prstDash val="solid"/>
+        </a:ln>
+      </a:lnStyleLst>
+      <a:effectStyleLst>
+        <a:effectStyle>
+          <a:effectLst>
+            <a:outerShdw blurRad="40000" dist="20000" dir="5400000" rotWithShape="0">
+              <a:srgbClr val="000000">
+                <a:alpha val="38000"/>
+              </a:srgbClr>
+            </a:outerShdw>
+          </a:effectLst>
+        </a:effectStyle>
+        <a:effectStyle>
+          <a:effectLst>
+            <a:outerShdw blurRad="40000" dist="23000" dir="5400000" rotWithShape="0">
+              <a:srgbClr val="000000">
+                <a:alpha val="35000"/>
+              </a:srgbClr>
+            </a:outerShdw>
+          </a:effectLst>
+        </a:effectStyle>
+        <a:effectStyle>
+          <a:effectLst>
+            <a:outerShdw blurRad="40000" dist="23000" dir="5400000" rotWithShape="0">
+              <a:srgbClr val="000000">
+                <a:alpha val="35000"/>
+              </a:srgbClr>
+            </a:outerShdw>
+          </a:effectLst>
+          <a:scene3d>
+            <a:camera prst="orthographicFront">
+              <a:rot lat="0" lon="0" rev="0"/>
+            </a:camera>
+            <a:lightRig rig="threePt" dir="t">
+              <a:rot lat="0" lon="0" rev="1200000"/>
+            </a:lightRig>
+          </a:scene3d>
+          <a:sp3d>
+            <a:bevelT w="63500" h="25400"/>
+          </a:sp3d>
+        </a:effectStyle>
+      </a:effectStyleLst>
+      <a:bgFillStyleLst>
+        <a:solidFill>
+          <a:schemeClr val="phClr"/>
+        </a:solidFill>
+        <a:gradFill rotWithShape="1">
+          <a:gsLst>
+            <a:gs pos="0">
+              <a:schemeClr val="phClr">
+                <a:tint val="40000"/>
+                <a:satMod val="350000"/>
+              </a:schemeClr>
+            </a:gs>
+            <a:gs pos="40000">
+              <a:schemeClr val="phClr">
+                <a:tint val="45000"/>
+                <a:shade val="99000"/>
+                <a:satMod val="350000"/>
+              </a:schemeClr>
+            </a:gs>
+            <a:gs pos="100000">
+              <a:schemeClr val="phClr">
+                <a:shade val="20000"/>
+                <a:satMod val="255000"/>
+              </a:schemeClr>
+            </a:gs>
+          </a:gsLst>
+          <a:path path="circle">
+            <a:fillToRect l="50000" t="-80000" r="50000" b="180000"/>
+          </a:path>
+        </a:gradFill>
+        <a:gradFill rotWithShape="1">
+          <a:gsLst>
+            <a:gs pos="0">
+              <a:schemeClr val="phClr">
+                <a:tint val="80000"/>
+                <a:satMod val="300000"/>
+              </a:schemeClr>
+            </a:gs>
+            <a:gs pos="100000">
+              <a:schemeClr val="phClr">
+                <a:shade val="30000"/>
+                <a:satMod val="200000"/>
+              </a:schemeClr>
+            </a:gs>
+          </a:gsLst>
+          <a:path path="circle">
+            <a:fillToRect l="50000" t="50000" r="50000" b="50000"/>
+          </a:path>
+        </a:gradFill>
+      </a:bgFillStyleLst>
+    </a:fmtScheme>
+  </a:themeElements>
+</a:theme>
+</file>
+
+<file path=ppt/theme/theme2.xml><?xml version="1.0" encoding="utf-8"?>
 <a:theme xmlns:a="http://schemas.openxmlformats.org/drawingml/2006/main" xmlns:r="http://schemas.openxmlformats.org/officeDocument/2006/relationships">
   <a:themeElements>
     <a:clrScheme name="Default">
@@ -20476,283 +20755,4 @@
     </a:fmtScheme>
   </a:themeElements>
 </a:theme>
-</file>
-
-<file path=ppt/theme/theme2.xml><?xml version="1.0" encoding="utf-8"?>
-<a:theme xmlns:a="http://schemas.openxmlformats.org/drawingml/2006/main" xmlns:r="http://schemas.openxmlformats.org/officeDocument/2006/relationships" name="Simple Light">
-  <a:themeElements>
-    <a:clrScheme name="Simple Light">
-      <a:dk1>
-        <a:srgbClr val="000000"/>
-      </a:dk1>
-      <a:lt1>
-        <a:srgbClr val="FFFFFF"/>
-      </a:lt1>
-      <a:dk2>
-        <a:srgbClr val="595959"/>
-      </a:dk2>
-      <a:lt2>
-        <a:srgbClr val="EEEEEE"/>
-      </a:lt2>
-      <a:accent1>
-        <a:srgbClr val="4285F4"/>
-      </a:accent1>
-      <a:accent2>
-        <a:srgbClr val="212121"/>
-      </a:accent2>
-      <a:accent3>
-        <a:srgbClr val="78909C"/>
-      </a:accent3>
-      <a:accent4>
-        <a:srgbClr val="FFAB40"/>
-      </a:accent4>
-      <a:accent5>
-        <a:srgbClr val="0097A7"/>
-      </a:accent5>
-      <a:accent6>
-        <a:srgbClr val="EEFF41"/>
-      </a:accent6>
-      <a:hlink>
-        <a:srgbClr val="0097A7"/>
-      </a:hlink>
-      <a:folHlink>
-        <a:srgbClr val="0097A7"/>
-      </a:folHlink>
-    </a:clrScheme>
-    <a:fontScheme name="Office">
-      <a:majorFont>
-        <a:latin typeface="Arial"/>
-        <a:ea typeface=""/>
-        <a:cs typeface=""/>
-        <a:font script="Jpan" typeface="ＭＳ Ｐゴシック"/>
-        <a:font script="Hang" typeface="맑은 고딕"/>
-        <a:font script="Hans" typeface="宋体"/>
-        <a:font script="Hant" typeface="新細明體"/>
-        <a:font script="Arab" typeface="Times New Roman"/>
-        <a:font script="Hebr" typeface="Times New Roman"/>
-        <a:font script="Thai" typeface="Angsana New"/>
-        <a:font script="Ethi" typeface="Nyala"/>
-        <a:font script="Beng" typeface="Vrinda"/>
-        <a:font script="Gujr" typeface="Shruti"/>
-        <a:font script="Khmr" typeface="MoolBoran"/>
-        <a:font script="Knda" typeface="Tunga"/>
-        <a:font script="Guru" typeface="Raavi"/>
-        <a:font script="Cans" typeface="Euphemia"/>
-        <a:font script="Cher" typeface="Plantagenet Cherokee"/>
-        <a:font script="Yiii" typeface="Microsoft Yi Baiti"/>
-        <a:font script="Tibt" typeface="Microsoft Himalaya"/>
-        <a:font script="Thaa" typeface="MV Boli"/>
-        <a:font script="Deva" typeface="Mangal"/>
-        <a:font script="Telu" typeface="Gautami"/>
-        <a:font script="Taml" typeface="Latha"/>
-        <a:font script="Syrc" typeface="Estrangelo Edessa"/>
-        <a:font script="Orya" typeface="Kalinga"/>
-        <a:font script="Mlym" typeface="Kartika"/>
-        <a:font script="Laoo" typeface="DokChampa"/>
-        <a:font script="Sinh" typeface="Iskoola Pota"/>
-        <a:font script="Mong" typeface="Mongolian Baiti"/>
-        <a:font script="Viet" typeface="Times New Roman"/>
-        <a:font script="Uigh" typeface="Microsoft Uighur"/>
-        <a:font script="Geor" typeface="Sylfaen"/>
-      </a:majorFont>
-      <a:minorFont>
-        <a:latin typeface="Arial"/>
-        <a:ea typeface=""/>
-        <a:cs typeface=""/>
-        <a:font script="Jpan" typeface="ＭＳ Ｐゴシック"/>
-        <a:font script="Hang" typeface="맑은 고딕"/>
-        <a:font script="Hans" typeface="宋体"/>
-        <a:font script="Hant" typeface="新細明體"/>
-        <a:font script="Arab" typeface="Arial"/>
-        <a:font script="Hebr" typeface="Arial"/>
-        <a:font script="Thai" typeface="Cordia New"/>
-        <a:font script="Ethi" typeface="Nyala"/>
-        <a:font script="Beng" typeface="Vrinda"/>
-        <a:font script="Gujr" typeface="Shruti"/>
-        <a:font script="Khmr" typeface="DaunPenh"/>
-        <a:font script="Knda" typeface="Tunga"/>
-        <a:font script="Guru" typeface="Raavi"/>
-        <a:font script="Cans" typeface="Euphemia"/>
-        <a:font script="Cher" typeface="Plantagenet Cherokee"/>
-        <a:font script="Yiii" typeface="Microsoft Yi Baiti"/>
-        <a:font script="Tibt" typeface="Microsoft Himalaya"/>
-        <a:font script="Thaa" typeface="MV Boli"/>
-        <a:font script="Deva" typeface="Mangal"/>
-        <a:font script="Telu" typeface="Gautami"/>
-        <a:font script="Taml" typeface="Latha"/>
-        <a:font script="Syrc" typeface="Estrangelo Edessa"/>
-        <a:font script="Orya" typeface="Kalinga"/>
-        <a:font script="Mlym" typeface="Kartika"/>
-        <a:font script="Laoo" typeface="DokChampa"/>
-        <a:font script="Sinh" typeface="Iskoola Pota"/>
-        <a:font script="Mong" typeface="Mongolian Baiti"/>
-        <a:font script="Viet" typeface="Arial"/>
-        <a:font script="Uigh" typeface="Microsoft Uighur"/>
-        <a:font script="Geor" typeface="Sylfaen"/>
-      </a:minorFont>
-    </a:fontScheme>
-    <a:fmtScheme name="Office">
-      <a:fillStyleLst>
-        <a:solidFill>
-          <a:schemeClr val="phClr"/>
-        </a:solidFill>
-        <a:gradFill rotWithShape="1">
-          <a:gsLst>
-            <a:gs pos="0">
-              <a:schemeClr val="phClr">
-                <a:tint val="50000"/>
-                <a:satMod val="300000"/>
-              </a:schemeClr>
-            </a:gs>
-            <a:gs pos="35000">
-              <a:schemeClr val="phClr">
-                <a:tint val="37000"/>
-                <a:satMod val="300000"/>
-              </a:schemeClr>
-            </a:gs>
-            <a:gs pos="100000">
-              <a:schemeClr val="phClr">
-                <a:tint val="15000"/>
-                <a:satMod val="350000"/>
-              </a:schemeClr>
-            </a:gs>
-          </a:gsLst>
-          <a:lin ang="16200000" scaled="1"/>
-        </a:gradFill>
-        <a:gradFill rotWithShape="1">
-          <a:gsLst>
-            <a:gs pos="0">
-              <a:schemeClr val="phClr">
-                <a:tint val="100000"/>
-                <a:shade val="100000"/>
-                <a:satMod val="130000"/>
-              </a:schemeClr>
-            </a:gs>
-            <a:gs pos="100000">
-              <a:schemeClr val="phClr">
-                <a:tint val="50000"/>
-                <a:shade val="100000"/>
-                <a:satMod val="350000"/>
-              </a:schemeClr>
-            </a:gs>
-          </a:gsLst>
-          <a:lin ang="16200000" scaled="0"/>
-        </a:gradFill>
-      </a:fillStyleLst>
-      <a:lnStyleLst>
-        <a:ln w="9525" cap="flat" cmpd="sng" algn="ctr">
-          <a:solidFill>
-            <a:schemeClr val="phClr">
-              <a:shade val="95000"/>
-              <a:satMod val="105000"/>
-            </a:schemeClr>
-          </a:solidFill>
-          <a:prstDash val="solid"/>
-        </a:ln>
-        <a:ln w="25400" cap="flat" cmpd="sng" algn="ctr">
-          <a:solidFill>
-            <a:schemeClr val="phClr"/>
-          </a:solidFill>
-          <a:prstDash val="solid"/>
-        </a:ln>
-        <a:ln w="38100" cap="flat" cmpd="sng" algn="ctr">
-          <a:solidFill>
-            <a:schemeClr val="phClr"/>
-          </a:solidFill>
-          <a:prstDash val="solid"/>
-        </a:ln>
-      </a:lnStyleLst>
-      <a:effectStyleLst>
-        <a:effectStyle>
-          <a:effectLst>
-            <a:outerShdw blurRad="40000" dist="20000" dir="5400000" rotWithShape="0">
-              <a:srgbClr val="000000">
-                <a:alpha val="38000"/>
-              </a:srgbClr>
-            </a:outerShdw>
-          </a:effectLst>
-        </a:effectStyle>
-        <a:effectStyle>
-          <a:effectLst>
-            <a:outerShdw blurRad="40000" dist="23000" dir="5400000" rotWithShape="0">
-              <a:srgbClr val="000000">
-                <a:alpha val="35000"/>
-              </a:srgbClr>
-            </a:outerShdw>
-          </a:effectLst>
-        </a:effectStyle>
-        <a:effectStyle>
-          <a:effectLst>
-            <a:outerShdw blurRad="40000" dist="23000" dir="5400000" rotWithShape="0">
-              <a:srgbClr val="000000">
-                <a:alpha val="35000"/>
-              </a:srgbClr>
-            </a:outerShdw>
-          </a:effectLst>
-          <a:scene3d>
-            <a:camera prst="orthographicFront">
-              <a:rot lat="0" lon="0" rev="0"/>
-            </a:camera>
-            <a:lightRig rig="threePt" dir="t">
-              <a:rot lat="0" lon="0" rev="1200000"/>
-            </a:lightRig>
-          </a:scene3d>
-          <a:sp3d>
-            <a:bevelT w="63500" h="25400"/>
-          </a:sp3d>
-        </a:effectStyle>
-      </a:effectStyleLst>
-      <a:bgFillStyleLst>
-        <a:solidFill>
-          <a:schemeClr val="phClr"/>
-        </a:solidFill>
-        <a:gradFill rotWithShape="1">
-          <a:gsLst>
-            <a:gs pos="0">
-              <a:schemeClr val="phClr">
-                <a:tint val="40000"/>
-                <a:satMod val="350000"/>
-              </a:schemeClr>
-            </a:gs>
-            <a:gs pos="40000">
-              <a:schemeClr val="phClr">
-                <a:tint val="45000"/>
-                <a:shade val="99000"/>
-                <a:satMod val="350000"/>
-              </a:schemeClr>
-            </a:gs>
-            <a:gs pos="100000">
-              <a:schemeClr val="phClr">
-                <a:shade val="20000"/>
-                <a:satMod val="255000"/>
-              </a:schemeClr>
-            </a:gs>
-          </a:gsLst>
-          <a:path path="circle">
-            <a:fillToRect l="50000" t="-80000" r="50000" b="180000"/>
-          </a:path>
-        </a:gradFill>
-        <a:gradFill rotWithShape="1">
-          <a:gsLst>
-            <a:gs pos="0">
-              <a:schemeClr val="phClr">
-                <a:tint val="80000"/>
-                <a:satMod val="300000"/>
-              </a:schemeClr>
-            </a:gs>
-            <a:gs pos="100000">
-              <a:schemeClr val="phClr">
-                <a:shade val="30000"/>
-                <a:satMod val="200000"/>
-              </a:schemeClr>
-            </a:gs>
-          </a:gsLst>
-          <a:path path="circle">
-            <a:fillToRect l="50000" t="50000" r="50000" b="50000"/>
-          </a:path>
-        </a:gradFill>
-      </a:bgFillStyleLst>
-    </a:fmtScheme>
-  </a:themeElements>
-</a:theme>
 </file>
</xml_diff>

<commit_message>
docs: deck slide 'Google Cloud AI map': each Gemini capability, its jobs and what was measured
</commit_message>
<xml_diff>
--- a/docs/submission/BreederNear-AI-deck.pptx
+++ b/docs/submission/BreederNear-AI-deck.pptx
@@ -17,6 +17,7 @@
     <p:sldId id="262" r:id="rId12"/>
     <p:sldId id="263" r:id="rId13"/>
     <p:sldId id="264" r:id="rId14"/>
+    <p:sldId id="273" r:id="rId23"/>
     <p:sldId id="265" r:id="rId15"/>
     <p:sldId id="270" r:id="rId20"/>
     <p:sldId id="266" r:id="rId16"/>
@@ -8308,7 +8309,7 @@
                           </a:solidFill>
                           <a:latin typeface="Google Sans Flex SemiBold"/>
                         </a:rPr>
-                        <a:t>335 · 17/17</a:t>
+                        <a:t>339 · 17/17</a:t>
                       </a:r>
                     </a:p>
                   </a:txBody>
@@ -11764,11 +11765,818 @@
                 </a:solidFill>
                 <a:latin typeface="Google Sans Flex"/>
               </a:rPr>
-              <a:t>every step works by tapping or by asking seven Gemini agents in English or Tamil. Live now: 66/66 agent eval runs, 335 unit tests, 0 accessibility problems.</a:t>
+              <a:t>every step works by tapping or by asking seven Gemini agents in English or Tamil. Live now: 66/66 agent eval runs, 339 unit tests, 0 accessibility problems.</a:t>
             </a:r>
           </a:p>
         </p:txBody>
       </p:sp>
+    </p:spTree>
+  </p:cSld>
+  <p:clrMapOvr>
+    <a:masterClrMapping/>
+  </p:clrMapOvr>
+</p:sld>
+</file>
+
+<file path=ppt/slides/slide18.xml><?xml version="1.0" encoding="utf-8"?>
+<p:sld xmlns:a="http://schemas.openxmlformats.org/drawingml/2006/main" xmlns:p="http://schemas.openxmlformats.org/presentationml/2006/main" xmlns:r="http://schemas.openxmlformats.org/officeDocument/2006/relationships">
+  <p:cSld>
+    <p:spTree>
+      <p:nvGrpSpPr>
+        <p:cNvPr id="1" name=""/>
+        <p:cNvGrpSpPr/>
+        <p:nvPr/>
+      </p:nvGrpSpPr>
+      <p:grpSpPr/>
+      <p:pic>
+        <p:nvPicPr>
+          <p:cNvPr id="164" name="Google Shape;164;p27" title="Frame 144.png"/>
+          <p:cNvPicPr preferRelativeResize="0"/>
+          <p:nvPr/>
+        </p:nvPicPr>
+        <p:blipFill rotWithShape="1">
+          <a:blip r:embed="rId2">
+            <a:alphaModFix/>
+          </a:blip>
+          <a:srcRect b="98001" l="0" r="0" t="0"/>
+          <a:stretch/>
+        </p:blipFill>
+        <p:spPr>
+          <a:xfrm>
+            <a:off x="0" y="5093562"/>
+            <a:ext cx="9144000" cy="54275"/>
+          </a:xfrm>
+          <a:prstGeom prst="rect">
+            <a:avLst/>
+          </a:prstGeom>
+          <a:noFill/>
+          <a:ln>
+            <a:noFill/>
+          </a:ln>
+        </p:spPr>
+      </p:pic>
+      <p:pic>
+        <p:nvPicPr>
+          <p:cNvPr id="165" name="Google Shape;165;p27" title="Group 427319979.png"/>
+          <p:cNvPicPr preferRelativeResize="0"/>
+          <p:nvPr/>
+        </p:nvPicPr>
+        <p:blipFill>
+          <a:blip r:embed="rId3">
+            <a:alphaModFix/>
+          </a:blip>
+          <a:stretch>
+            <a:fillRect/>
+          </a:stretch>
+        </p:blipFill>
+        <p:spPr>
+          <a:xfrm>
+            <a:off x="0" y="1"/>
+            <a:ext cx="9144000" cy="507359"/>
+          </a:xfrm>
+          <a:prstGeom prst="rect">
+            <a:avLst/>
+          </a:prstGeom>
+          <a:noFill/>
+          <a:ln>
+            <a:noFill/>
+          </a:ln>
+        </p:spPr>
+      </p:pic>
+      <p:sp>
+        <p:nvSpPr>
+          <p:cNvPr id="166" name="Google Shape;166;p27"/>
+          <p:cNvSpPr/>
+          <p:nvPr/>
+        </p:nvSpPr>
+        <p:spPr>
+          <a:xfrm>
+            <a:off x="-29250" y="5071875"/>
+            <a:ext cx="9173400" cy="97800"/>
+          </a:xfrm>
+          <a:prstGeom prst="rect">
+            <a:avLst/>
+          </a:prstGeom>
+          <a:solidFill>
+            <a:schemeClr val="dk1"/>
+          </a:solidFill>
+          <a:ln>
+            <a:noFill/>
+          </a:ln>
+        </p:spPr>
+        <p:txBody>
+          <a:bodyPr anchorCtr="0" anchor="ctr" bIns="91425" lIns="91425" spcFirstLastPara="1" rIns="91425" wrap="square" tIns="91425">
+            <a:noAutofit/>
+          </a:bodyPr>
+          <a:lstStyle/>
+          <a:p>
+            <a:pPr indent="0" lvl="0" marL="0" rtl="0" algn="ctr">
+              <a:spcBef>
+                <a:spcPts val="0"/>
+              </a:spcBef>
+              <a:spcAft>
+                <a:spcPts val="0"/>
+              </a:spcAft>
+              <a:buNone/>
+            </a:pPr>
+            <a:r>
+              <a:t/>
+            </a:r>
+            <a:endParaRPr/>
+          </a:p>
+        </p:txBody>
+      </p:sp>
+      <p:sp>
+        <p:nvSpPr>
+          <p:cNvPr id="135" name="Google Shape;135;p23"/>
+          <p:cNvSpPr txBox="1"/>
+          <p:nvPr/>
+        </p:nvSpPr>
+        <p:spPr>
+          <a:xfrm>
+            <a:off x="265350" y="663825"/>
+            <a:ext cx="8943000" cy="561900"/>
+          </a:xfrm>
+          <a:prstGeom prst="rect">
+            <a:avLst/>
+          </a:prstGeom>
+          <a:noFill/>
+          <a:ln>
+            <a:noFill/>
+          </a:ln>
+        </p:spPr>
+        <p:txBody>
+          <a:bodyPr anchorCtr="0" anchor="t" bIns="91425" lIns="91425" spcFirstLastPara="1" rIns="91425" wrap="square" tIns="91425">
+            <a:noAutofit/>
+          </a:bodyPr>
+          <a:lstStyle/>
+          <a:p>
+            <a:pPr indent="0" lvl="0" marL="0" rtl="0" algn="l">
+              <a:spcBef>
+                <a:spcPts val="0"/>
+              </a:spcBef>
+              <a:spcAft>
+                <a:spcPts val="0"/>
+              </a:spcAft>
+              <a:buNone/>
+            </a:pPr>
+            <a:r>
+              <a:rPr lang="en-GB" sz="1600">
+                <a:latin typeface="Google Sans Flex Medium"/>
+                <a:ea typeface="Google Sans Flex Medium"/>
+                <a:cs typeface="Google Sans Flex Medium"/>
+                <a:sym typeface="Google Sans Flex Medium"/>
+              </a:rPr>
+              <a:t>Google Cloud AI map: which AI does each job, and how well</a:t>
+            </a:r>
+            <a:endParaRPr sz="1600">
+              <a:latin typeface="Google Sans Flex Medium"/>
+              <a:ea typeface="Google Sans Flex Medium"/>
+              <a:cs typeface="Google Sans Flex Medium"/>
+              <a:sym typeface="Google Sans Flex Medium"/>
+            </a:endParaRPr>
+          </a:p>
+        </p:txBody>
+      </p:sp>
+      <p:graphicFrame>
+        <p:nvGraphicFramePr>
+          <p:cNvPr id="167" name="Table 166"/>
+          <p:cNvGraphicFramePr>
+            <a:graphicFrameLocks noGrp="1"/>
+          </p:cNvGraphicFramePr>
+          <p:nvPr/>
+        </p:nvGraphicFramePr>
+        <p:xfrm>
+          <a:off x="320040" y="1097280"/>
+          <a:ext cx="8503920" cy="3456432"/>
+        </p:xfrm>
+        <a:graphic>
+          <a:graphicData uri="http://schemas.openxmlformats.org/drawingml/2006/table">
+            <a:tbl>
+              <a:tblPr firstRow="1" bandRow="1">
+                <a:tableStyleId>{5C22544A-7EE6-4342-B048-85BDC9FD1C3A}</a:tableStyleId>
+              </a:tblPr>
+              <a:tblGrid>
+                <a:gridCol w="1600200"/>
+                <a:gridCol w="4343400"/>
+                <a:gridCol w="2560320"/>
+              </a:tblGrid>
+              <a:tr h="384048">
+                <a:tc>
+                  <a:txBody>
+                    <a:bodyPr wrap="square"/>
+                    <a:lstStyle/>
+                    <a:p>
+                      <a:r>
+                        <a:rPr sz="860">
+                          <a:solidFill>
+                            <a:srgbClr val="FFFFFF"/>
+                          </a:solidFill>
+                          <a:latin typeface="Google Sans Flex SemiBold"/>
+                        </a:rPr>
+                        <a:t>Google Cloud AI</a:t>
+                      </a:r>
+                    </a:p>
+                  </a:txBody>
+                  <a:tcPr marL="54864" marR="54864" marT="22860" marB="22860" anchor="ctr">
+                    <a:solidFill>
+                      <a:srgbClr val="1D1D1F"/>
+                    </a:solidFill>
+                  </a:tcPr>
+                </a:tc>
+                <a:tc>
+                  <a:txBody>
+                    <a:bodyPr wrap="square"/>
+                    <a:lstStyle/>
+                    <a:p>
+                      <a:r>
+                        <a:rPr sz="860">
+                          <a:solidFill>
+                            <a:srgbClr val="FFFFFF"/>
+                          </a:solidFill>
+                          <a:latin typeface="Google Sans Flex SemiBold"/>
+                        </a:rPr>
+                        <a:t>What it does in BreederNear AI</a:t>
+                      </a:r>
+                    </a:p>
+                  </a:txBody>
+                  <a:tcPr marL="54864" marR="54864" marT="22860" marB="22860" anchor="ctr">
+                    <a:solidFill>
+                      <a:srgbClr val="1D1D1F"/>
+                    </a:solidFill>
+                  </a:tcPr>
+                </a:tc>
+                <a:tc>
+                  <a:txBody>
+                    <a:bodyPr wrap="square"/>
+                    <a:lstStyle/>
+                    <a:p>
+                      <a:r>
+                        <a:rPr sz="860">
+                          <a:solidFill>
+                            <a:srgbClr val="FFFFFF"/>
+                          </a:solidFill>
+                          <a:latin typeface="Google Sans Flex SemiBold"/>
+                        </a:rPr>
+                        <a:t>Measured</a:t>
+                      </a:r>
+                    </a:p>
+                  </a:txBody>
+                  <a:tcPr marL="54864" marR="54864" marT="22860" marB="22860" anchor="ctr">
+                    <a:solidFill>
+                      <a:srgbClr val="1D1D1F"/>
+                    </a:solidFill>
+                  </a:tcPr>
+                </a:tc>
+              </a:tr>
+              <a:tr h="384048">
+                <a:tc>
+                  <a:txBody>
+                    <a:bodyPr wrap="square"/>
+                    <a:lstStyle/>
+                    <a:p>
+                      <a:r>
+                        <a:rPr sz="860">
+                          <a:solidFill>
+                            <a:srgbClr val="1D1D1F"/>
+                          </a:solidFill>
+                          <a:latin typeface="Google Sans Flex"/>
+                        </a:rPr>
+                        <a:t>Gemini vision</a:t>
+                      </a:r>
+                    </a:p>
+                  </a:txBody>
+                  <a:tcPr marL="54864" marR="54864" marT="22860" marB="22860" anchor="ctr">
+                    <a:solidFill>
+                      <a:srgbClr val="FFFFFF"/>
+                    </a:solidFill>
+                  </a:tcPr>
+                </a:tc>
+                <a:tc>
+                  <a:txBody>
+                    <a:bodyPr wrap="square"/>
+                    <a:lstStyle/>
+                    <a:p>
+                      <a:r>
+                        <a:rPr sz="860">
+                          <a:solidFill>
+                            <a:srgbClr val="1D1D1F"/>
+                          </a:solidFill>
+                          <a:latin typeface="Google Sans Flex"/>
+                        </a:rPr>
+                        <a:t>Listing photos: species, protected birds, dye, blur, watermarks, stock photos. Facility photos, dog-breeder certificates, vaccination cards, food photos</a:t>
+                      </a:r>
+                    </a:p>
+                  </a:txBody>
+                  <a:tcPr marL="54864" marR="54864" marT="22860" marB="22860" anchor="ctr">
+                    <a:solidFill>
+                      <a:srgbClr val="FFFFFF"/>
+                    </a:solidFill>
+                  </a:tcPr>
+                </a:tc>
+                <a:tc>
+                  <a:txBody>
+                    <a:bodyPr wrap="square"/>
+                    <a:lstStyle/>
+                    <a:p>
+                      <a:r>
+                        <a:rPr sz="860">
+                          <a:solidFill>
+                            <a:srgbClr val="1F6E43"/>
+                          </a:solidFill>
+                          <a:latin typeface="Google Sans Flex SemiBold"/>
+                        </a:rPr>
+                        <a:t>8/8 protected species blocked; 0/37 false alarms; 202/202 photo checks</a:t>
+                      </a:r>
+                    </a:p>
+                  </a:txBody>
+                  <a:tcPr marL="54864" marR="54864" marT="22860" marB="22860" anchor="ctr">
+                    <a:solidFill>
+                      <a:srgbClr val="FFFFFF"/>
+                    </a:solidFill>
+                  </a:tcPr>
+                </a:tc>
+              </a:tr>
+              <a:tr h="384048">
+                <a:tc>
+                  <a:txBody>
+                    <a:bodyPr wrap="square"/>
+                    <a:lstStyle/>
+                    <a:p>
+                      <a:r>
+                        <a:rPr sz="860">
+                          <a:solidFill>
+                            <a:srgbClr val="1D1D1F"/>
+                          </a:solidFill>
+                          <a:latin typeface="Google Sans Flex"/>
+                        </a:rPr>
+                        <a:t>Gemini audio</a:t>
+                      </a:r>
+                    </a:p>
+                  </a:txBody>
+                  <a:tcPr marL="54864" marR="54864" marT="22860" marB="22860" anchor="ctr">
+                    <a:solidFill>
+                      <a:srgbClr val="F3F3F0"/>
+                    </a:solidFill>
+                  </a:tcPr>
+                </a:tc>
+                <a:tc>
+                  <a:txBody>
+                    <a:bodyPr wrap="square"/>
+                    <a:lstStyle/>
+                    <a:p>
+                      <a:r>
+                        <a:rPr sz="860">
+                          <a:solidFill>
+                            <a:srgbClr val="1D1D1F"/>
+                          </a:solidFill>
+                          <a:latin typeface="Google Sans Flex"/>
+                        </a:rPr>
+                        <a:t>A breeder’s Tamil or English voice note becomes a full listing, with a transcript; no separate speech-to-text step</a:t>
+                      </a:r>
+                    </a:p>
+                  </a:txBody>
+                  <a:tcPr marL="54864" marR="54864" marT="22860" marB="22860" anchor="ctr">
+                    <a:solidFill>
+                      <a:srgbClr val="F3F3F0"/>
+                    </a:solidFill>
+                  </a:tcPr>
+                </a:tc>
+                <a:tc>
+                  <a:txBody>
+                    <a:bodyPr wrap="square"/>
+                    <a:lstStyle/>
+                    <a:p>
+                      <a:r>
+                        <a:rPr sz="860">
+                          <a:solidFill>
+                            <a:srgbClr val="1F6E43"/>
+                          </a:solidFill>
+                          <a:latin typeface="Google Sans Flex SemiBold"/>
+                        </a:rPr>
+                        <a:t>Tamil voice note → correct listing (eval E23)</a:t>
+                      </a:r>
+                    </a:p>
+                  </a:txBody>
+                  <a:tcPr marL="54864" marR="54864" marT="22860" marB="22860" anchor="ctr">
+                    <a:solidFill>
+                      <a:srgbClr val="F3F3F0"/>
+                    </a:solidFill>
+                  </a:tcPr>
+                </a:tc>
+              </a:tr>
+              <a:tr h="384048">
+                <a:tc>
+                  <a:txBody>
+                    <a:bodyPr wrap="square"/>
+                    <a:lstStyle/>
+                    <a:p>
+                      <a:r>
+                        <a:rPr sz="860">
+                          <a:solidFill>
+                            <a:srgbClr val="1D1D1F"/>
+                          </a:solidFill>
+                          <a:latin typeface="Google Sans Flex"/>
+                        </a:rPr>
+                        <a:t>Gemini, multilingual</a:t>
+                      </a:r>
+                    </a:p>
+                  </a:txBody>
+                  <a:tcPr marL="54864" marR="54864" marT="22860" marB="22860" anchor="ctr">
+                    <a:solidFill>
+                      <a:srgbClr val="FFFFFF"/>
+                    </a:solidFill>
+                  </a:tcPr>
+                </a:tc>
+                <a:tc>
+                  <a:txBody>
+                    <a:bodyPr wrap="square"/>
+                    <a:lstStyle/>
+                    <a:p>
+                      <a:r>
+                        <a:rPr sz="860">
+                          <a:solidFill>
+                            <a:srgbClr val="1D1D1F"/>
+                          </a:solidFill>
+                          <a:latin typeface="Google Sans Flex"/>
+                        </a:rPr>
+                        <a:t>Romanised Tamil and English sale messages; a buyer’s own words become a home profile</a:t>
+                      </a:r>
+                    </a:p>
+                  </a:txBody>
+                  <a:tcPr marL="54864" marR="54864" marT="22860" marB="22860" anchor="ctr">
+                    <a:solidFill>
+                      <a:srgbClr val="FFFFFF"/>
+                    </a:solidFill>
+                  </a:tcPr>
+                </a:tc>
+                <a:tc>
+                  <a:txBody>
+                    <a:bodyPr wrap="square"/>
+                    <a:lstStyle/>
+                    <a:p>
+                      <a:r>
+                        <a:rPr sz="860">
+                          <a:solidFill>
+                            <a:srgbClr val="1D1D1F"/>
+                          </a:solidFill>
+                          <a:latin typeface="Google Sans Flex"/>
+                        </a:rPr>
+                        <a:t>Tamil message → same listing (E02); profile → match % (E21)</a:t>
+                      </a:r>
+                    </a:p>
+                  </a:txBody>
+                  <a:tcPr marL="54864" marR="54864" marT="22860" marB="22860" anchor="ctr">
+                    <a:solidFill>
+                      <a:srgbClr val="FFFFFF"/>
+                    </a:solidFill>
+                  </a:tcPr>
+                </a:tc>
+              </a:tr>
+              <a:tr h="384048">
+                <a:tc>
+                  <a:txBody>
+                    <a:bodyPr wrap="square"/>
+                    <a:lstStyle/>
+                    <a:p>
+                      <a:r>
+                        <a:rPr sz="860">
+                          <a:solidFill>
+                            <a:srgbClr val="1D1D1F"/>
+                          </a:solidFill>
+                          <a:latin typeface="Google Sans Flex"/>
+                        </a:rPr>
+                        <a:t>Gemini structured output</a:t>
+                      </a:r>
+                    </a:p>
+                  </a:txBody>
+                  <a:tcPr marL="54864" marR="54864" marT="22860" marB="22860" anchor="ctr">
+                    <a:solidFill>
+                      <a:srgbClr val="F3F3F0"/>
+                    </a:solidFill>
+                  </a:tcPr>
+                </a:tc>
+                <a:tc>
+                  <a:txBody>
+                    <a:bodyPr wrap="square"/>
+                    <a:lstStyle/>
+                    <a:p>
+                      <a:r>
+                        <a:rPr sz="860">
+                          <a:solidFill>
+                            <a:srgbClr val="1D1D1F"/>
+                          </a:solidFill>
+                          <a:latin typeface="Google Sans Flex"/>
+                        </a:rPr>
+                        <a:t>12 task types, each with a JSON schema. Gemini reads and writes; code decides trust, badges, match % and urgency</a:t>
+                      </a:r>
+                    </a:p>
+                  </a:txBody>
+                  <a:tcPr marL="54864" marR="54864" marT="22860" marB="22860" anchor="ctr">
+                    <a:solidFill>
+                      <a:srgbClr val="F3F3F0"/>
+                    </a:solidFill>
+                  </a:tcPr>
+                </a:tc>
+                <a:tc>
+                  <a:txBody>
+                    <a:bodyPr wrap="square"/>
+                    <a:lstStyle/>
+                    <a:p>
+                      <a:r>
+                        <a:rPr sz="860">
+                          <a:solidFill>
+                            <a:srgbClr val="1D1D1F"/>
+                          </a:solidFill>
+                          <a:latin typeface="Google Sans Flex"/>
+                        </a:rPr>
+                        <a:t>Prompt injection still ends in CAUTION (E12)</a:t>
+                      </a:r>
+                    </a:p>
+                  </a:txBody>
+                  <a:tcPr marL="54864" marR="54864" marT="22860" marB="22860" anchor="ctr">
+                    <a:solidFill>
+                      <a:srgbClr val="F3F3F0"/>
+                    </a:solidFill>
+                  </a:tcPr>
+                </a:tc>
+              </a:tr>
+              <a:tr h="384048">
+                <a:tc>
+                  <a:txBody>
+                    <a:bodyPr wrap="square"/>
+                    <a:lstStyle/>
+                    <a:p>
+                      <a:r>
+                        <a:rPr sz="860">
+                          <a:solidFill>
+                            <a:srgbClr val="1D1D1F"/>
+                          </a:solidFill>
+                          <a:latin typeface="Google Sans Flex"/>
+                        </a:rPr>
+                        <a:t>Google ADK</a:t>
+                      </a:r>
+                    </a:p>
+                  </a:txBody>
+                  <a:tcPr marL="54864" marR="54864" marT="22860" marB="22860" anchor="ctr">
+                    <a:solidFill>
+                      <a:srgbClr val="FFFFFF"/>
+                    </a:solidFill>
+                  </a:tcPr>
+                </a:tc>
+                <a:tc>
+                  <a:txBody>
+                    <a:bodyPr wrap="square"/>
+                    <a:lstStyle/>
+                    <a:p>
+                      <a:r>
+                        <a:rPr sz="860">
+                          <a:solidFill>
+                            <a:srgbClr val="1D1D1F"/>
+                          </a:solidFill>
+                          <a:latin typeface="Google Sans Flex"/>
+                        </a:rPr>
+                        <a:t>7 agents (a concierge and 6 specialists) and 29 tools, the same tools the tap screens use; streamed replies</a:t>
+                      </a:r>
+                    </a:p>
+                  </a:txBody>
+                  <a:tcPr marL="54864" marR="54864" marT="22860" marB="22860" anchor="ctr">
+                    <a:solidFill>
+                      <a:srgbClr val="FFFFFF"/>
+                    </a:solidFill>
+                  </a:tcPr>
+                </a:tc>
+                <a:tc>
+                  <a:txBody>
+                    <a:bodyPr wrap="square"/>
+                    <a:lstStyle/>
+                    <a:p>
+                      <a:r>
+                        <a:rPr sz="860">
+                          <a:solidFill>
+                            <a:srgbClr val="1F6E43"/>
+                          </a:solidFill>
+                          <a:latin typeface="Google Sans Flex SemiBold"/>
+                        </a:rPr>
+                        <a:t>66/66 passed agent eval runs (22 cases × 3 runs)</a:t>
+                      </a:r>
+                    </a:p>
+                  </a:txBody>
+                  <a:tcPr marL="54864" marR="54864" marT="22860" marB="22860" anchor="ctr">
+                    <a:solidFill>
+                      <a:srgbClr val="FFFFFF"/>
+                    </a:solidFill>
+                  </a:tcPr>
+                </a:tc>
+              </a:tr>
+              <a:tr h="384048">
+                <a:tc>
+                  <a:txBody>
+                    <a:bodyPr wrap="square"/>
+                    <a:lstStyle/>
+                    <a:p>
+                      <a:r>
+                        <a:rPr sz="860">
+                          <a:solidFill>
+                            <a:srgbClr val="1D1D1F"/>
+                          </a:solidFill>
+                          <a:latin typeface="Google Sans Flex"/>
+                        </a:rPr>
+                        <a:t>ADK callbacks</a:t>
+                      </a:r>
+                    </a:p>
+                  </a:txBody>
+                  <a:tcPr marL="54864" marR="54864" marT="22860" marB="22860" anchor="ctr">
+                    <a:solidFill>
+                      <a:srgbClr val="F3F3F0"/>
+                    </a:solidFill>
+                  </a:tcPr>
+                </a:tc>
+                <a:tc>
+                  <a:txBody>
+                    <a:bodyPr wrap="square"/>
+                    <a:lstStyle/>
+                    <a:p>
+                      <a:r>
+                        <a:rPr sz="860">
+                          <a:solidFill>
+                            <a:srgbClr val="1D1D1F"/>
+                          </a:solidFill>
+                          <a:latin typeface="Google Sans Flex"/>
+                        </a:rPr>
+                        <a:t>Context before every model call; every reply checked for medicine names and doses, even while streaming; every tool call logged</a:t>
+                      </a:r>
+                    </a:p>
+                  </a:txBody>
+                  <a:tcPr marL="54864" marR="54864" marT="22860" marB="22860" anchor="ctr">
+                    <a:solidFill>
+                      <a:srgbClr val="F3F3F0"/>
+                    </a:solidFill>
+                  </a:tcPr>
+                </a:tc>
+                <a:tc>
+                  <a:txBody>
+                    <a:bodyPr wrap="square"/>
+                    <a:lstStyle/>
+                    <a:p>
+                      <a:r>
+                        <a:rPr sz="860">
+                          <a:solidFill>
+                            <a:srgbClr val="1D1D1F"/>
+                          </a:solidFill>
+                          <a:latin typeface="Google Sans Flex"/>
+                        </a:rPr>
+                        <a:t>No drug names or doses (E11, E19)</a:t>
+                      </a:r>
+                    </a:p>
+                  </a:txBody>
+                  <a:tcPr marL="54864" marR="54864" marT="22860" marB="22860" anchor="ctr">
+                    <a:solidFill>
+                      <a:srgbClr val="F3F3F0"/>
+                    </a:solidFill>
+                  </a:tcPr>
+                </a:tc>
+              </a:tr>
+              <a:tr h="384048">
+                <a:tc>
+                  <a:txBody>
+                    <a:bodyPr wrap="square"/>
+                    <a:lstStyle/>
+                    <a:p>
+                      <a:r>
+                        <a:rPr sz="860">
+                          <a:solidFill>
+                            <a:srgbClr val="1D1D1F"/>
+                          </a:solidFill>
+                          <a:latin typeface="Google Sans Flex"/>
+                        </a:rPr>
+                        <a:t>Vertex AI</a:t>
+                      </a:r>
+                    </a:p>
+                  </a:txBody>
+                  <a:tcPr marL="54864" marR="54864" marT="22860" marB="22860" anchor="ctr">
+                    <a:solidFill>
+                      <a:srgbClr val="FFFFFF"/>
+                    </a:solidFill>
+                  </a:tcPr>
+                </a:tc>
+                <a:tc>
+                  <a:txBody>
+                    <a:bodyPr wrap="square"/>
+                    <a:lstStyle/>
+                    <a:p>
+                      <a:r>
+                        <a:rPr sz="860">
+                          <a:solidFill>
+                            <a:srgbClr val="1D1D1F"/>
+                          </a:solidFill>
+                          <a:latin typeface="Google Sans Flex"/>
+                        </a:rPr>
+                        <a:t>Gemini 3.8 Flash on the global endpoint, retries with backoff on 408, 429 and 5xx</a:t>
+                      </a:r>
+                    </a:p>
+                  </a:txBody>
+                  <a:tcPr marL="54864" marR="54864" marT="22860" marB="22860" anchor="ctr">
+                    <a:solidFill>
+                      <a:srgbClr val="FFFFFF"/>
+                    </a:solidFill>
+                  </a:tcPr>
+                </a:tc>
+                <a:tc>
+                  <a:txBody>
+                    <a:bodyPr wrap="square"/>
+                    <a:lstStyle/>
+                    <a:p>
+                      <a:r>
+                        <a:rPr sz="860">
+                          <a:solidFill>
+                            <a:srgbClr val="1D1D1F"/>
+                          </a:solidFill>
+                          <a:latin typeface="Google Sans Flex"/>
+                        </a:rPr>
+                        <a:t>Listing in 17–27 s; post check 5–7 s</a:t>
+                      </a:r>
+                    </a:p>
+                  </a:txBody>
+                  <a:tcPr marL="54864" marR="54864" marT="22860" marB="22860" anchor="ctr">
+                    <a:solidFill>
+                      <a:srgbClr val="FFFFFF"/>
+                    </a:solidFill>
+                  </a:tcPr>
+                </a:tc>
+              </a:tr>
+              <a:tr h="384048">
+                <a:tc>
+                  <a:txBody>
+                    <a:bodyPr wrap="square"/>
+                    <a:lstStyle/>
+                    <a:p>
+                      <a:r>
+                        <a:rPr sz="860">
+                          <a:solidFill>
+                            <a:srgbClr val="1D1D1F"/>
+                          </a:solidFill>
+                          <a:latin typeface="Google Sans Flex"/>
+                        </a:rPr>
+                        <a:t>Firebase Auth, Cloud Run, Firestore, Storage</a:t>
+                      </a:r>
+                    </a:p>
+                  </a:txBody>
+                  <a:tcPr marL="54864" marR="54864" marT="22860" marB="22860" anchor="ctr">
+                    <a:solidFill>
+                      <a:srgbClr val="F3F3F0"/>
+                    </a:solidFill>
+                  </a:tcPr>
+                </a:tc>
+                <a:tc>
+                  <a:txBody>
+                    <a:bodyPr wrap="square"/>
+                    <a:lstStyle/>
+                    <a:p>
+                      <a:r>
+                        <a:rPr sz="860">
+                          <a:solidFill>
+                            <a:srgbClr val="1D1D1F"/>
+                          </a:solidFill>
+                          <a:latin typeface="Google Sans Flex"/>
+                        </a:rPr>
+                        <a:t>Google sign-in; the API and agents; all data; private uploads</a:t>
+                      </a:r>
+                    </a:p>
+                  </a:txBody>
+                  <a:tcPr marL="54864" marR="54864" marT="22860" marB="22860" anchor="ctr">
+                    <a:solidFill>
+                      <a:srgbClr val="F3F3F0"/>
+                    </a:solidFill>
+                  </a:tcPr>
+                </a:tc>
+                <a:tc>
+                  <a:txBody>
+                    <a:bodyPr wrap="square"/>
+                    <a:lstStyle/>
+                    <a:p>
+                      <a:r>
+                        <a:rPr sz="860">
+                          <a:solidFill>
+                            <a:srgbClr val="1D1D1F"/>
+                          </a:solidFill>
+                          <a:latin typeface="Google Sans Flex"/>
+                        </a:rPr>
+                        <a:t>Smoke test 17/17 on every release</a:t>
+                      </a:r>
+                    </a:p>
+                  </a:txBody>
+                  <a:tcPr marL="54864" marR="54864" marT="22860" marB="22860" anchor="ctr">
+                    <a:solidFill>
+                      <a:srgbClr val="F3F3F0"/>
+                    </a:solidFill>
+                  </a:tcPr>
+                </a:tc>
+              </a:tr>
+            </a:tbl>
+          </a:graphicData>
+        </a:graphic>
+      </p:graphicFrame>
     </p:spTree>
   </p:cSld>
   <p:clrMapOvr>
@@ -19686,7 +20494,7 @@
                           </a:solidFill>
                           <a:latin typeface="Google Sans Flex"/>
                         </a:rPr>
-                        <a:t>Seven ADK agents; listing extraction from photos + Tamil/English; photo, facility and certificate reading; care plans, daily-log feedback, symptom urgency; message drafts and scam scan. JSON schemas.</a:t>
+                        <a:t>Seven ADK agents; listings from photos, Tamil/English text and voice notes; photo, facility and certificate reading; care plans, daily-log feedback, symptom urgency; message drafts and scam scan. JSON schemas.</a:t>
                       </a:r>
                     </a:p>
                   </a:txBody>
@@ -20200,6 +21008,285 @@
 </file>
 
 <file path=ppt/theme/theme1.xml><?xml version="1.0" encoding="utf-8"?>
+<a:theme xmlns:a="http://schemas.openxmlformats.org/drawingml/2006/main" xmlns:r="http://schemas.openxmlformats.org/officeDocument/2006/relationships">
+  <a:themeElements>
+    <a:clrScheme name="Default">
+      <a:dk1>
+        <a:srgbClr val="000000"/>
+      </a:dk1>
+      <a:lt1>
+        <a:srgbClr val="FFFFFF"/>
+      </a:lt1>
+      <a:dk2>
+        <a:srgbClr val="158158"/>
+      </a:dk2>
+      <a:lt2>
+        <a:srgbClr val="F3F3F3"/>
+      </a:lt2>
+      <a:accent1>
+        <a:srgbClr val="058DC7"/>
+      </a:accent1>
+      <a:accent2>
+        <a:srgbClr val="50B432"/>
+      </a:accent2>
+      <a:accent3>
+        <a:srgbClr val="ED561B"/>
+      </a:accent3>
+      <a:accent4>
+        <a:srgbClr val="EDEF00"/>
+      </a:accent4>
+      <a:accent5>
+        <a:srgbClr val="24CBE5"/>
+      </a:accent5>
+      <a:accent6>
+        <a:srgbClr val="64E572"/>
+      </a:accent6>
+      <a:hlink>
+        <a:srgbClr val="2200CC"/>
+      </a:hlink>
+      <a:folHlink>
+        <a:srgbClr val="551A8B"/>
+      </a:folHlink>
+    </a:clrScheme>
+    <a:fontScheme name="Office">
+      <a:majorFont>
+        <a:latin typeface="Arial"/>
+        <a:ea typeface=""/>
+        <a:cs typeface=""/>
+        <a:font script="Jpan" typeface="ＭＳ Ｐゴシック"/>
+        <a:font script="Hang" typeface="맑은 고딕"/>
+        <a:font script="Hans" typeface="宋体"/>
+        <a:font script="Hant" typeface="新細明體"/>
+        <a:font script="Arab" typeface="Times New Roman"/>
+        <a:font script="Hebr" typeface="Times New Roman"/>
+        <a:font script="Thai" typeface="Angsana New"/>
+        <a:font script="Ethi" typeface="Nyala"/>
+        <a:font script="Beng" typeface="Vrinda"/>
+        <a:font script="Gujr" typeface="Shruti"/>
+        <a:font script="Khmr" typeface="MoolBoran"/>
+        <a:font script="Knda" typeface="Tunga"/>
+        <a:font script="Guru" typeface="Raavi"/>
+        <a:font script="Cans" typeface="Euphemia"/>
+        <a:font script="Cher" typeface="Plantagenet Cherokee"/>
+        <a:font script="Yiii" typeface="Microsoft Yi Baiti"/>
+        <a:font script="Tibt" typeface="Microsoft Himalaya"/>
+        <a:font script="Thaa" typeface="MV Boli"/>
+        <a:font script="Deva" typeface="Mangal"/>
+        <a:font script="Telu" typeface="Gautami"/>
+        <a:font script="Taml" typeface="Latha"/>
+        <a:font script="Syrc" typeface="Estrangelo Edessa"/>
+        <a:font script="Orya" typeface="Kalinga"/>
+        <a:font script="Mlym" typeface="Kartika"/>
+        <a:font script="Laoo" typeface="DokChampa"/>
+        <a:font script="Sinh" typeface="Iskoola Pota"/>
+        <a:font script="Mong" typeface="Mongolian Baiti"/>
+        <a:font script="Viet" typeface="Times New Roman"/>
+        <a:font script="Uigh" typeface="Microsoft Uighur"/>
+        <a:font script="Geor" typeface="Sylfaen"/>
+      </a:majorFont>
+      <a:minorFont>
+        <a:latin typeface="Arial"/>
+        <a:ea typeface=""/>
+        <a:cs typeface=""/>
+        <a:font script="Jpan" typeface="ＭＳ Ｐゴシック"/>
+        <a:font script="Hang" typeface="맑은 고딕"/>
+        <a:font script="Hans" typeface="宋体"/>
+        <a:font script="Hant" typeface="新細明體"/>
+        <a:font script="Arab" typeface="Arial"/>
+        <a:font script="Hebr" typeface="Arial"/>
+        <a:font script="Thai" typeface="Cordia New"/>
+        <a:font script="Ethi" typeface="Nyala"/>
+        <a:font script="Beng" typeface="Vrinda"/>
+        <a:font script="Gujr" typeface="Shruti"/>
+        <a:font script="Khmr" typeface="DaunPenh"/>
+        <a:font script="Knda" typeface="Tunga"/>
+        <a:font script="Guru" typeface="Raavi"/>
+        <a:font script="Cans" typeface="Euphemia"/>
+        <a:font script="Cher" typeface="Plantagenet Cherokee"/>
+        <a:font script="Yiii" typeface="Microsoft Yi Baiti"/>
+        <a:font script="Tibt" typeface="Microsoft Himalaya"/>
+        <a:font script="Thaa" typeface="MV Boli"/>
+        <a:font script="Deva" typeface="Mangal"/>
+        <a:font script="Telu" typeface="Gautami"/>
+        <a:font script="Taml" typeface="Latha"/>
+        <a:font script="Syrc" typeface="Estrangelo Edessa"/>
+        <a:font script="Orya" typeface="Kalinga"/>
+        <a:font script="Mlym" typeface="Kartika"/>
+        <a:font script="Laoo" typeface="DokChampa"/>
+        <a:font script="Sinh" typeface="Iskoola Pota"/>
+        <a:font script="Mong" typeface="Mongolian Baiti"/>
+        <a:font script="Viet" typeface="Arial"/>
+        <a:font script="Uigh" typeface="Microsoft Uighur"/>
+        <a:font script="Geor" typeface="Sylfaen"/>
+      </a:minorFont>
+    </a:fontScheme>
+    <a:fmtScheme name="Office">
+      <a:fillStyleLst>
+        <a:solidFill>
+          <a:schemeClr val="phClr"/>
+        </a:solidFill>
+        <a:gradFill rotWithShape="1">
+          <a:gsLst>
+            <a:gs pos="0">
+              <a:schemeClr val="phClr">
+                <a:tint val="50000"/>
+                <a:satMod val="300000"/>
+              </a:schemeClr>
+            </a:gs>
+            <a:gs pos="35000">
+              <a:schemeClr val="phClr">
+                <a:tint val="37000"/>
+                <a:satMod val="300000"/>
+              </a:schemeClr>
+            </a:gs>
+            <a:gs pos="100000">
+              <a:schemeClr val="phClr">
+                <a:tint val="15000"/>
+                <a:satMod val="350000"/>
+              </a:schemeClr>
+            </a:gs>
+          </a:gsLst>
+          <a:lin ang="16200000" scaled="1"/>
+        </a:gradFill>
+        <a:gradFill rotWithShape="1">
+          <a:gsLst>
+            <a:gs pos="0">
+              <a:schemeClr val="phClr">
+                <a:tint val="100000"/>
+                <a:shade val="100000"/>
+                <a:satMod val="130000"/>
+              </a:schemeClr>
+            </a:gs>
+            <a:gs pos="100000">
+              <a:schemeClr val="phClr">
+                <a:tint val="50000"/>
+                <a:shade val="100000"/>
+                <a:satMod val="350000"/>
+              </a:schemeClr>
+            </a:gs>
+          </a:gsLst>
+          <a:lin ang="16200000" scaled="0"/>
+        </a:gradFill>
+      </a:fillStyleLst>
+      <a:lnStyleLst>
+        <a:ln w="9525" cap="flat" cmpd="sng" algn="ctr">
+          <a:solidFill>
+            <a:schemeClr val="phClr">
+              <a:shade val="95000"/>
+              <a:satMod val="105000"/>
+            </a:schemeClr>
+          </a:solidFill>
+          <a:prstDash val="solid"/>
+        </a:ln>
+        <a:ln w="25400" cap="flat" cmpd="sng" algn="ctr">
+          <a:solidFill>
+            <a:schemeClr val="phClr"/>
+          </a:solidFill>
+          <a:prstDash val="solid"/>
+        </a:ln>
+        <a:ln w="38100" cap="flat" cmpd="sng" algn="ctr">
+          <a:solidFill>
+            <a:schemeClr val="phClr"/>
+          </a:solidFill>
+          <a:prstDash val="solid"/>
+        </a:ln>
+      </a:lnStyleLst>
+      <a:effectStyleLst>
+        <a:effectStyle>
+          <a:effectLst>
+            <a:outerShdw blurRad="40000" dist="20000" dir="5400000" rotWithShape="0">
+              <a:srgbClr val="000000">
+                <a:alpha val="38000"/>
+              </a:srgbClr>
+            </a:outerShdw>
+          </a:effectLst>
+        </a:effectStyle>
+        <a:effectStyle>
+          <a:effectLst>
+            <a:outerShdw blurRad="40000" dist="23000" dir="5400000" rotWithShape="0">
+              <a:srgbClr val="000000">
+                <a:alpha val="35000"/>
+              </a:srgbClr>
+            </a:outerShdw>
+          </a:effectLst>
+        </a:effectStyle>
+        <a:effectStyle>
+          <a:effectLst>
+            <a:outerShdw blurRad="40000" dist="23000" dir="5400000" rotWithShape="0">
+              <a:srgbClr val="000000">
+                <a:alpha val="35000"/>
+              </a:srgbClr>
+            </a:outerShdw>
+          </a:effectLst>
+          <a:scene3d>
+            <a:camera prst="orthographicFront">
+              <a:rot lat="0" lon="0" rev="0"/>
+            </a:camera>
+            <a:lightRig rig="threePt" dir="t">
+              <a:rot lat="0" lon="0" rev="1200000"/>
+            </a:lightRig>
+          </a:scene3d>
+          <a:sp3d>
+            <a:bevelT w="63500" h="25400"/>
+          </a:sp3d>
+        </a:effectStyle>
+      </a:effectStyleLst>
+      <a:bgFillStyleLst>
+        <a:solidFill>
+          <a:schemeClr val="phClr"/>
+        </a:solidFill>
+        <a:gradFill rotWithShape="1">
+          <a:gsLst>
+            <a:gs pos="0">
+              <a:schemeClr val="phClr">
+                <a:tint val="40000"/>
+                <a:satMod val="350000"/>
+              </a:schemeClr>
+            </a:gs>
+            <a:gs pos="40000">
+              <a:schemeClr val="phClr">
+                <a:tint val="45000"/>
+                <a:shade val="99000"/>
+                <a:satMod val="350000"/>
+              </a:schemeClr>
+            </a:gs>
+            <a:gs pos="100000">
+              <a:schemeClr val="phClr">
+                <a:shade val="20000"/>
+                <a:satMod val="255000"/>
+              </a:schemeClr>
+            </a:gs>
+          </a:gsLst>
+          <a:path path="circle">
+            <a:fillToRect l="50000" t="-80000" r="50000" b="180000"/>
+          </a:path>
+        </a:gradFill>
+        <a:gradFill rotWithShape="1">
+          <a:gsLst>
+            <a:gs pos="0">
+              <a:schemeClr val="phClr">
+                <a:tint val="80000"/>
+                <a:satMod val="300000"/>
+              </a:schemeClr>
+            </a:gs>
+            <a:gs pos="100000">
+              <a:schemeClr val="phClr">
+                <a:shade val="30000"/>
+                <a:satMod val="200000"/>
+              </a:schemeClr>
+            </a:gs>
+          </a:gsLst>
+          <a:path path="circle">
+            <a:fillToRect l="50000" t="50000" r="50000" b="50000"/>
+          </a:path>
+        </a:gradFill>
+      </a:bgFillStyleLst>
+    </a:fmtScheme>
+  </a:themeElements>
+</a:theme>
+</file>
+
+<file path=ppt/theme/theme2.xml><?xml version="1.0" encoding="utf-8"?>
 <a:theme xmlns:a="http://schemas.openxmlformats.org/drawingml/2006/main" xmlns:r="http://schemas.openxmlformats.org/officeDocument/2006/relationships" name="Simple Light">
   <a:themeElements>
     <a:clrScheme name="Simple Light">
@@ -20476,283 +21563,4 @@
     </a:fmtScheme>
   </a:themeElements>
 </a:theme>
-</file>
-
-<file path=ppt/theme/theme2.xml><?xml version="1.0" encoding="utf-8"?>
-<a:theme xmlns:a="http://schemas.openxmlformats.org/drawingml/2006/main" xmlns:r="http://schemas.openxmlformats.org/officeDocument/2006/relationships">
-  <a:themeElements>
-    <a:clrScheme name="Default">
-      <a:dk1>
-        <a:srgbClr val="000000"/>
-      </a:dk1>
-      <a:lt1>
-        <a:srgbClr val="FFFFFF"/>
-      </a:lt1>
-      <a:dk2>
-        <a:srgbClr val="158158"/>
-      </a:dk2>
-      <a:lt2>
-        <a:srgbClr val="F3F3F3"/>
-      </a:lt2>
-      <a:accent1>
-        <a:srgbClr val="058DC7"/>
-      </a:accent1>
-      <a:accent2>
-        <a:srgbClr val="50B432"/>
-      </a:accent2>
-      <a:accent3>
-        <a:srgbClr val="ED561B"/>
-      </a:accent3>
-      <a:accent4>
-        <a:srgbClr val="EDEF00"/>
-      </a:accent4>
-      <a:accent5>
-        <a:srgbClr val="24CBE5"/>
-      </a:accent5>
-      <a:accent6>
-        <a:srgbClr val="64E572"/>
-      </a:accent6>
-      <a:hlink>
-        <a:srgbClr val="2200CC"/>
-      </a:hlink>
-      <a:folHlink>
-        <a:srgbClr val="551A8B"/>
-      </a:folHlink>
-    </a:clrScheme>
-    <a:fontScheme name="Office">
-      <a:majorFont>
-        <a:latin typeface="Arial"/>
-        <a:ea typeface=""/>
-        <a:cs typeface=""/>
-        <a:font script="Jpan" typeface="ＭＳ Ｐゴシック"/>
-        <a:font script="Hang" typeface="맑은 고딕"/>
-        <a:font script="Hans" typeface="宋体"/>
-        <a:font script="Hant" typeface="新細明體"/>
-        <a:font script="Arab" typeface="Times New Roman"/>
-        <a:font script="Hebr" typeface="Times New Roman"/>
-        <a:font script="Thai" typeface="Angsana New"/>
-        <a:font script="Ethi" typeface="Nyala"/>
-        <a:font script="Beng" typeface="Vrinda"/>
-        <a:font script="Gujr" typeface="Shruti"/>
-        <a:font script="Khmr" typeface="MoolBoran"/>
-        <a:font script="Knda" typeface="Tunga"/>
-        <a:font script="Guru" typeface="Raavi"/>
-        <a:font script="Cans" typeface="Euphemia"/>
-        <a:font script="Cher" typeface="Plantagenet Cherokee"/>
-        <a:font script="Yiii" typeface="Microsoft Yi Baiti"/>
-        <a:font script="Tibt" typeface="Microsoft Himalaya"/>
-        <a:font script="Thaa" typeface="MV Boli"/>
-        <a:font script="Deva" typeface="Mangal"/>
-        <a:font script="Telu" typeface="Gautami"/>
-        <a:font script="Taml" typeface="Latha"/>
-        <a:font script="Syrc" typeface="Estrangelo Edessa"/>
-        <a:font script="Orya" typeface="Kalinga"/>
-        <a:font script="Mlym" typeface="Kartika"/>
-        <a:font script="Laoo" typeface="DokChampa"/>
-        <a:font script="Sinh" typeface="Iskoola Pota"/>
-        <a:font script="Mong" typeface="Mongolian Baiti"/>
-        <a:font script="Viet" typeface="Times New Roman"/>
-        <a:font script="Uigh" typeface="Microsoft Uighur"/>
-        <a:font script="Geor" typeface="Sylfaen"/>
-      </a:majorFont>
-      <a:minorFont>
-        <a:latin typeface="Arial"/>
-        <a:ea typeface=""/>
-        <a:cs typeface=""/>
-        <a:font script="Jpan" typeface="ＭＳ Ｐゴシック"/>
-        <a:font script="Hang" typeface="맑은 고딕"/>
-        <a:font script="Hans" typeface="宋体"/>
-        <a:font script="Hant" typeface="新細明體"/>
-        <a:font script="Arab" typeface="Arial"/>
-        <a:font script="Hebr" typeface="Arial"/>
-        <a:font script="Thai" typeface="Cordia New"/>
-        <a:font script="Ethi" typeface="Nyala"/>
-        <a:font script="Beng" typeface="Vrinda"/>
-        <a:font script="Gujr" typeface="Shruti"/>
-        <a:font script="Khmr" typeface="DaunPenh"/>
-        <a:font script="Knda" typeface="Tunga"/>
-        <a:font script="Guru" typeface="Raavi"/>
-        <a:font script="Cans" typeface="Euphemia"/>
-        <a:font script="Cher" typeface="Plantagenet Cherokee"/>
-        <a:font script="Yiii" typeface="Microsoft Yi Baiti"/>
-        <a:font script="Tibt" typeface="Microsoft Himalaya"/>
-        <a:font script="Thaa" typeface="MV Boli"/>
-        <a:font script="Deva" typeface="Mangal"/>
-        <a:font script="Telu" typeface="Gautami"/>
-        <a:font script="Taml" typeface="Latha"/>
-        <a:font script="Syrc" typeface="Estrangelo Edessa"/>
-        <a:font script="Orya" typeface="Kalinga"/>
-        <a:font script="Mlym" typeface="Kartika"/>
-        <a:font script="Laoo" typeface="DokChampa"/>
-        <a:font script="Sinh" typeface="Iskoola Pota"/>
-        <a:font script="Mong" typeface="Mongolian Baiti"/>
-        <a:font script="Viet" typeface="Arial"/>
-        <a:font script="Uigh" typeface="Microsoft Uighur"/>
-        <a:font script="Geor" typeface="Sylfaen"/>
-      </a:minorFont>
-    </a:fontScheme>
-    <a:fmtScheme name="Office">
-      <a:fillStyleLst>
-        <a:solidFill>
-          <a:schemeClr val="phClr"/>
-        </a:solidFill>
-        <a:gradFill rotWithShape="1">
-          <a:gsLst>
-            <a:gs pos="0">
-              <a:schemeClr val="phClr">
-                <a:tint val="50000"/>
-                <a:satMod val="300000"/>
-              </a:schemeClr>
-            </a:gs>
-            <a:gs pos="35000">
-              <a:schemeClr val="phClr">
-                <a:tint val="37000"/>
-                <a:satMod val="300000"/>
-              </a:schemeClr>
-            </a:gs>
-            <a:gs pos="100000">
-              <a:schemeClr val="phClr">
-                <a:tint val="15000"/>
-                <a:satMod val="350000"/>
-              </a:schemeClr>
-            </a:gs>
-          </a:gsLst>
-          <a:lin ang="16200000" scaled="1"/>
-        </a:gradFill>
-        <a:gradFill rotWithShape="1">
-          <a:gsLst>
-            <a:gs pos="0">
-              <a:schemeClr val="phClr">
-                <a:tint val="100000"/>
-                <a:shade val="100000"/>
-                <a:satMod val="130000"/>
-              </a:schemeClr>
-            </a:gs>
-            <a:gs pos="100000">
-              <a:schemeClr val="phClr">
-                <a:tint val="50000"/>
-                <a:shade val="100000"/>
-                <a:satMod val="350000"/>
-              </a:schemeClr>
-            </a:gs>
-          </a:gsLst>
-          <a:lin ang="16200000" scaled="0"/>
-        </a:gradFill>
-      </a:fillStyleLst>
-      <a:lnStyleLst>
-        <a:ln w="9525" cap="flat" cmpd="sng" algn="ctr">
-          <a:solidFill>
-            <a:schemeClr val="phClr">
-              <a:shade val="95000"/>
-              <a:satMod val="105000"/>
-            </a:schemeClr>
-          </a:solidFill>
-          <a:prstDash val="solid"/>
-        </a:ln>
-        <a:ln w="25400" cap="flat" cmpd="sng" algn="ctr">
-          <a:solidFill>
-            <a:schemeClr val="phClr"/>
-          </a:solidFill>
-          <a:prstDash val="solid"/>
-        </a:ln>
-        <a:ln w="38100" cap="flat" cmpd="sng" algn="ctr">
-          <a:solidFill>
-            <a:schemeClr val="phClr"/>
-          </a:solidFill>
-          <a:prstDash val="solid"/>
-        </a:ln>
-      </a:lnStyleLst>
-      <a:effectStyleLst>
-        <a:effectStyle>
-          <a:effectLst>
-            <a:outerShdw blurRad="40000" dist="20000" dir="5400000" rotWithShape="0">
-              <a:srgbClr val="000000">
-                <a:alpha val="38000"/>
-              </a:srgbClr>
-            </a:outerShdw>
-          </a:effectLst>
-        </a:effectStyle>
-        <a:effectStyle>
-          <a:effectLst>
-            <a:outerShdw blurRad="40000" dist="23000" dir="5400000" rotWithShape="0">
-              <a:srgbClr val="000000">
-                <a:alpha val="35000"/>
-              </a:srgbClr>
-            </a:outerShdw>
-          </a:effectLst>
-        </a:effectStyle>
-        <a:effectStyle>
-          <a:effectLst>
-            <a:outerShdw blurRad="40000" dist="23000" dir="5400000" rotWithShape="0">
-              <a:srgbClr val="000000">
-                <a:alpha val="35000"/>
-              </a:srgbClr>
-            </a:outerShdw>
-          </a:effectLst>
-          <a:scene3d>
-            <a:camera prst="orthographicFront">
-              <a:rot lat="0" lon="0" rev="0"/>
-            </a:camera>
-            <a:lightRig rig="threePt" dir="t">
-              <a:rot lat="0" lon="0" rev="1200000"/>
-            </a:lightRig>
-          </a:scene3d>
-          <a:sp3d>
-            <a:bevelT w="63500" h="25400"/>
-          </a:sp3d>
-        </a:effectStyle>
-      </a:effectStyleLst>
-      <a:bgFillStyleLst>
-        <a:solidFill>
-          <a:schemeClr val="phClr"/>
-        </a:solidFill>
-        <a:gradFill rotWithShape="1">
-          <a:gsLst>
-            <a:gs pos="0">
-              <a:schemeClr val="phClr">
-                <a:tint val="40000"/>
-                <a:satMod val="350000"/>
-              </a:schemeClr>
-            </a:gs>
-            <a:gs pos="40000">
-              <a:schemeClr val="phClr">
-                <a:tint val="45000"/>
-                <a:shade val="99000"/>
-                <a:satMod val="350000"/>
-              </a:schemeClr>
-            </a:gs>
-            <a:gs pos="100000">
-              <a:schemeClr val="phClr">
-                <a:shade val="20000"/>
-                <a:satMod val="255000"/>
-              </a:schemeClr>
-            </a:gs>
-          </a:gsLst>
-          <a:path path="circle">
-            <a:fillToRect l="50000" t="-80000" r="50000" b="180000"/>
-          </a:path>
-        </a:gradFill>
-        <a:gradFill rotWithShape="1">
-          <a:gsLst>
-            <a:gs pos="0">
-              <a:schemeClr val="phClr">
-                <a:tint val="80000"/>
-                <a:satMod val="300000"/>
-              </a:schemeClr>
-            </a:gs>
-            <a:gs pos="100000">
-              <a:schemeClr val="phClr">
-                <a:shade val="30000"/>
-                <a:satMod val="200000"/>
-              </a:schemeClr>
-            </a:gs>
-          </a:gsLst>
-          <a:path path="circle">
-            <a:fillToRect l="50000" t="50000" r="50000" b="50000"/>
-          </a:path>
-        </a:gradFill>
-      </a:bgFillStyleLst>
-    </a:fmtScheme>
-  </a:themeElements>
-</a:theme>
 </file>
</xml_diff>

<commit_message>
docs: deck title slide lists team member Shreya Azad
</commit_message>
<xml_diff>
--- a/docs/submission/BreederNear-AI-deck.pptx
+++ b/docs/submission/BreederNear-AI-deck.pptx
@@ -6995,6 +6995,43 @@
                 <a:sym typeface="Google Sans Flex"/>
               </a:rPr>
               <a:t>Sudarsan N</a:t>
+            </a:r>
+          </a:p>
+          <a:p>
+            <a:pPr indent="-342900" lvl="1" marL="914400" rtl="0" algn="l">
+              <a:spcBef>
+                <a:spcPts val="0"/>
+              </a:spcBef>
+              <a:spcAft>
+                <a:spcPts val="0"/>
+              </a:spcAft>
+              <a:buSzPts val="1800"/>
+              <a:buFont typeface="Google Sans Flex"/>
+              <a:buAutoNum type="alphaLcPeriod"/>
+            </a:pPr>
+            <a:r>
+              <a:rPr lang="en-GB" sz="1800">
+                <a:latin typeface="Google Sans Flex"/>
+                <a:ea typeface="Google Sans Flex"/>
+                <a:cs typeface="Google Sans Flex"/>
+                <a:sym typeface="Google Sans Flex"/>
+              </a:rPr>
+              <a:t>Team member: </a:t>
+            </a:r>
+            <a:endParaRPr sz="1800">
+              <a:latin typeface="Google Sans Flex"/>
+              <a:ea typeface="Google Sans Flex"/>
+              <a:cs typeface="Google Sans Flex"/>
+              <a:sym typeface="Google Sans Flex"/>
+            </a:endParaRPr>
+            <a:r>
+              <a:rPr lang="en-GB" sz="1800">
+                <a:latin typeface="Google Sans Flex Medium"/>
+                <a:ea typeface="Google Sans Flex"/>
+                <a:cs typeface="Google Sans Flex"/>
+                <a:sym typeface="Google Sans Flex"/>
+              </a:rPr>
+              <a:t>Shreya Azad</a:t>
             </a:r>
           </a:p>
           <a:p>
@@ -12358,7 +12395,7 @@
                           </a:solidFill>
                           <a:latin typeface="Google Sans Flex SemiBold"/>
                         </a:rPr>
-                        <a:t>66/66 passed agent eval runs (22 cases × 3 runs)</a:t>
+                        <a:t>66/66 agent eval runs passed (22 cases × 3 runs)</a:t>
                       </a:r>
                     </a:p>
                   </a:txBody>
@@ -21008,6 +21045,285 @@
 </file>
 
 <file path=ppt/theme/theme1.xml><?xml version="1.0" encoding="utf-8"?>
+<a:theme xmlns:a="http://schemas.openxmlformats.org/drawingml/2006/main" xmlns:r="http://schemas.openxmlformats.org/officeDocument/2006/relationships" name="Simple Light">
+  <a:themeElements>
+    <a:clrScheme name="Simple Light">
+      <a:dk1>
+        <a:srgbClr val="000000"/>
+      </a:dk1>
+      <a:lt1>
+        <a:srgbClr val="FFFFFF"/>
+      </a:lt1>
+      <a:dk2>
+        <a:srgbClr val="595959"/>
+      </a:dk2>
+      <a:lt2>
+        <a:srgbClr val="EEEEEE"/>
+      </a:lt2>
+      <a:accent1>
+        <a:srgbClr val="4285F4"/>
+      </a:accent1>
+      <a:accent2>
+        <a:srgbClr val="212121"/>
+      </a:accent2>
+      <a:accent3>
+        <a:srgbClr val="78909C"/>
+      </a:accent3>
+      <a:accent4>
+        <a:srgbClr val="FFAB40"/>
+      </a:accent4>
+      <a:accent5>
+        <a:srgbClr val="0097A7"/>
+      </a:accent5>
+      <a:accent6>
+        <a:srgbClr val="EEFF41"/>
+      </a:accent6>
+      <a:hlink>
+        <a:srgbClr val="0097A7"/>
+      </a:hlink>
+      <a:folHlink>
+        <a:srgbClr val="0097A7"/>
+      </a:folHlink>
+    </a:clrScheme>
+    <a:fontScheme name="Office">
+      <a:majorFont>
+        <a:latin typeface="Arial"/>
+        <a:ea typeface=""/>
+        <a:cs typeface=""/>
+        <a:font script="Jpan" typeface="ＭＳ Ｐゴシック"/>
+        <a:font script="Hang" typeface="맑은 고딕"/>
+        <a:font script="Hans" typeface="宋体"/>
+        <a:font script="Hant" typeface="新細明體"/>
+        <a:font script="Arab" typeface="Times New Roman"/>
+        <a:font script="Hebr" typeface="Times New Roman"/>
+        <a:font script="Thai" typeface="Angsana New"/>
+        <a:font script="Ethi" typeface="Nyala"/>
+        <a:font script="Beng" typeface="Vrinda"/>
+        <a:font script="Gujr" typeface="Shruti"/>
+        <a:font script="Khmr" typeface="MoolBoran"/>
+        <a:font script="Knda" typeface="Tunga"/>
+        <a:font script="Guru" typeface="Raavi"/>
+        <a:font script="Cans" typeface="Euphemia"/>
+        <a:font script="Cher" typeface="Plantagenet Cherokee"/>
+        <a:font script="Yiii" typeface="Microsoft Yi Baiti"/>
+        <a:font script="Tibt" typeface="Microsoft Himalaya"/>
+        <a:font script="Thaa" typeface="MV Boli"/>
+        <a:font script="Deva" typeface="Mangal"/>
+        <a:font script="Telu" typeface="Gautami"/>
+        <a:font script="Taml" typeface="Latha"/>
+        <a:font script="Syrc" typeface="Estrangelo Edessa"/>
+        <a:font script="Orya" typeface="Kalinga"/>
+        <a:font script="Mlym" typeface="Kartika"/>
+        <a:font script="Laoo" typeface="DokChampa"/>
+        <a:font script="Sinh" typeface="Iskoola Pota"/>
+        <a:font script="Mong" typeface="Mongolian Baiti"/>
+        <a:font script="Viet" typeface="Times New Roman"/>
+        <a:font script="Uigh" typeface="Microsoft Uighur"/>
+        <a:font script="Geor" typeface="Sylfaen"/>
+      </a:majorFont>
+      <a:minorFont>
+        <a:latin typeface="Arial"/>
+        <a:ea typeface=""/>
+        <a:cs typeface=""/>
+        <a:font script="Jpan" typeface="ＭＳ Ｐゴシック"/>
+        <a:font script="Hang" typeface="맑은 고딕"/>
+        <a:font script="Hans" typeface="宋体"/>
+        <a:font script="Hant" typeface="新細明體"/>
+        <a:font script="Arab" typeface="Arial"/>
+        <a:font script="Hebr" typeface="Arial"/>
+        <a:font script="Thai" typeface="Cordia New"/>
+        <a:font script="Ethi" typeface="Nyala"/>
+        <a:font script="Beng" typeface="Vrinda"/>
+        <a:font script="Gujr" typeface="Shruti"/>
+        <a:font script="Khmr" typeface="DaunPenh"/>
+        <a:font script="Knda" typeface="Tunga"/>
+        <a:font script="Guru" typeface="Raavi"/>
+        <a:font script="Cans" typeface="Euphemia"/>
+        <a:font script="Cher" typeface="Plantagenet Cherokee"/>
+        <a:font script="Yiii" typeface="Microsoft Yi Baiti"/>
+        <a:font script="Tibt" typeface="Microsoft Himalaya"/>
+        <a:font script="Thaa" typeface="MV Boli"/>
+        <a:font script="Deva" typeface="Mangal"/>
+        <a:font script="Telu" typeface="Gautami"/>
+        <a:font script="Taml" typeface="Latha"/>
+        <a:font script="Syrc" typeface="Estrangelo Edessa"/>
+        <a:font script="Orya" typeface="Kalinga"/>
+        <a:font script="Mlym" typeface="Kartika"/>
+        <a:font script="Laoo" typeface="DokChampa"/>
+        <a:font script="Sinh" typeface="Iskoola Pota"/>
+        <a:font script="Mong" typeface="Mongolian Baiti"/>
+        <a:font script="Viet" typeface="Arial"/>
+        <a:font script="Uigh" typeface="Microsoft Uighur"/>
+        <a:font script="Geor" typeface="Sylfaen"/>
+      </a:minorFont>
+    </a:fontScheme>
+    <a:fmtScheme name="Office">
+      <a:fillStyleLst>
+        <a:solidFill>
+          <a:schemeClr val="phClr"/>
+        </a:solidFill>
+        <a:gradFill rotWithShape="1">
+          <a:gsLst>
+            <a:gs pos="0">
+              <a:schemeClr val="phClr">
+                <a:tint val="50000"/>
+                <a:satMod val="300000"/>
+              </a:schemeClr>
+            </a:gs>
+            <a:gs pos="35000">
+              <a:schemeClr val="phClr">
+                <a:tint val="37000"/>
+                <a:satMod val="300000"/>
+              </a:schemeClr>
+            </a:gs>
+            <a:gs pos="100000">
+              <a:schemeClr val="phClr">
+                <a:tint val="15000"/>
+                <a:satMod val="350000"/>
+              </a:schemeClr>
+            </a:gs>
+          </a:gsLst>
+          <a:lin ang="16200000" scaled="1"/>
+        </a:gradFill>
+        <a:gradFill rotWithShape="1">
+          <a:gsLst>
+            <a:gs pos="0">
+              <a:schemeClr val="phClr">
+                <a:tint val="100000"/>
+                <a:shade val="100000"/>
+                <a:satMod val="130000"/>
+              </a:schemeClr>
+            </a:gs>
+            <a:gs pos="100000">
+              <a:schemeClr val="phClr">
+                <a:tint val="50000"/>
+                <a:shade val="100000"/>
+                <a:satMod val="350000"/>
+              </a:schemeClr>
+            </a:gs>
+          </a:gsLst>
+          <a:lin ang="16200000" scaled="0"/>
+        </a:gradFill>
+      </a:fillStyleLst>
+      <a:lnStyleLst>
+        <a:ln w="9525" cap="flat" cmpd="sng" algn="ctr">
+          <a:solidFill>
+            <a:schemeClr val="phClr">
+              <a:shade val="95000"/>
+              <a:satMod val="105000"/>
+            </a:schemeClr>
+          </a:solidFill>
+          <a:prstDash val="solid"/>
+        </a:ln>
+        <a:ln w="25400" cap="flat" cmpd="sng" algn="ctr">
+          <a:solidFill>
+            <a:schemeClr val="phClr"/>
+          </a:solidFill>
+          <a:prstDash val="solid"/>
+        </a:ln>
+        <a:ln w="38100" cap="flat" cmpd="sng" algn="ctr">
+          <a:solidFill>
+            <a:schemeClr val="phClr"/>
+          </a:solidFill>
+          <a:prstDash val="solid"/>
+        </a:ln>
+      </a:lnStyleLst>
+      <a:effectStyleLst>
+        <a:effectStyle>
+          <a:effectLst>
+            <a:outerShdw blurRad="40000" dist="20000" dir="5400000" rotWithShape="0">
+              <a:srgbClr val="000000">
+                <a:alpha val="38000"/>
+              </a:srgbClr>
+            </a:outerShdw>
+          </a:effectLst>
+        </a:effectStyle>
+        <a:effectStyle>
+          <a:effectLst>
+            <a:outerShdw blurRad="40000" dist="23000" dir="5400000" rotWithShape="0">
+              <a:srgbClr val="000000">
+                <a:alpha val="35000"/>
+              </a:srgbClr>
+            </a:outerShdw>
+          </a:effectLst>
+        </a:effectStyle>
+        <a:effectStyle>
+          <a:effectLst>
+            <a:outerShdw blurRad="40000" dist="23000" dir="5400000" rotWithShape="0">
+              <a:srgbClr val="000000">
+                <a:alpha val="35000"/>
+              </a:srgbClr>
+            </a:outerShdw>
+          </a:effectLst>
+          <a:scene3d>
+            <a:camera prst="orthographicFront">
+              <a:rot lat="0" lon="0" rev="0"/>
+            </a:camera>
+            <a:lightRig rig="threePt" dir="t">
+              <a:rot lat="0" lon="0" rev="1200000"/>
+            </a:lightRig>
+          </a:scene3d>
+          <a:sp3d>
+            <a:bevelT w="63500" h="25400"/>
+          </a:sp3d>
+        </a:effectStyle>
+      </a:effectStyleLst>
+      <a:bgFillStyleLst>
+        <a:solidFill>
+          <a:schemeClr val="phClr"/>
+        </a:solidFill>
+        <a:gradFill rotWithShape="1">
+          <a:gsLst>
+            <a:gs pos="0">
+              <a:schemeClr val="phClr">
+                <a:tint val="40000"/>
+                <a:satMod val="350000"/>
+              </a:schemeClr>
+            </a:gs>
+            <a:gs pos="40000">
+              <a:schemeClr val="phClr">
+                <a:tint val="45000"/>
+                <a:shade val="99000"/>
+                <a:satMod val="350000"/>
+              </a:schemeClr>
+            </a:gs>
+            <a:gs pos="100000">
+              <a:schemeClr val="phClr">
+                <a:shade val="20000"/>
+                <a:satMod val="255000"/>
+              </a:schemeClr>
+            </a:gs>
+          </a:gsLst>
+          <a:path path="circle">
+            <a:fillToRect l="50000" t="-80000" r="50000" b="180000"/>
+          </a:path>
+        </a:gradFill>
+        <a:gradFill rotWithShape="1">
+          <a:gsLst>
+            <a:gs pos="0">
+              <a:schemeClr val="phClr">
+                <a:tint val="80000"/>
+                <a:satMod val="300000"/>
+              </a:schemeClr>
+            </a:gs>
+            <a:gs pos="100000">
+              <a:schemeClr val="phClr">
+                <a:shade val="30000"/>
+                <a:satMod val="200000"/>
+              </a:schemeClr>
+            </a:gs>
+          </a:gsLst>
+          <a:path path="circle">
+            <a:fillToRect l="50000" t="50000" r="50000" b="50000"/>
+          </a:path>
+        </a:gradFill>
+      </a:bgFillStyleLst>
+    </a:fmtScheme>
+  </a:themeElements>
+</a:theme>
+</file>
+
+<file path=ppt/theme/theme2.xml><?xml version="1.0" encoding="utf-8"?>
 <a:theme xmlns:a="http://schemas.openxmlformats.org/drawingml/2006/main" xmlns:r="http://schemas.openxmlformats.org/officeDocument/2006/relationships">
   <a:themeElements>
     <a:clrScheme name="Default">
@@ -21284,283 +21600,4 @@
     </a:fmtScheme>
   </a:themeElements>
 </a:theme>
-</file>
-
-<file path=ppt/theme/theme2.xml><?xml version="1.0" encoding="utf-8"?>
-<a:theme xmlns:a="http://schemas.openxmlformats.org/drawingml/2006/main" xmlns:r="http://schemas.openxmlformats.org/officeDocument/2006/relationships" name="Simple Light">
-  <a:themeElements>
-    <a:clrScheme name="Simple Light">
-      <a:dk1>
-        <a:srgbClr val="000000"/>
-      </a:dk1>
-      <a:lt1>
-        <a:srgbClr val="FFFFFF"/>
-      </a:lt1>
-      <a:dk2>
-        <a:srgbClr val="595959"/>
-      </a:dk2>
-      <a:lt2>
-        <a:srgbClr val="EEEEEE"/>
-      </a:lt2>
-      <a:accent1>
-        <a:srgbClr val="4285F4"/>
-      </a:accent1>
-      <a:accent2>
-        <a:srgbClr val="212121"/>
-      </a:accent2>
-      <a:accent3>
-        <a:srgbClr val="78909C"/>
-      </a:accent3>
-      <a:accent4>
-        <a:srgbClr val="FFAB40"/>
-      </a:accent4>
-      <a:accent5>
-        <a:srgbClr val="0097A7"/>
-      </a:accent5>
-      <a:accent6>
-        <a:srgbClr val="EEFF41"/>
-      </a:accent6>
-      <a:hlink>
-        <a:srgbClr val="0097A7"/>
-      </a:hlink>
-      <a:folHlink>
-        <a:srgbClr val="0097A7"/>
-      </a:folHlink>
-    </a:clrScheme>
-    <a:fontScheme name="Office">
-      <a:majorFont>
-        <a:latin typeface="Arial"/>
-        <a:ea typeface=""/>
-        <a:cs typeface=""/>
-        <a:font script="Jpan" typeface="ＭＳ Ｐゴシック"/>
-        <a:font script="Hang" typeface="맑은 고딕"/>
-        <a:font script="Hans" typeface="宋体"/>
-        <a:font script="Hant" typeface="新細明體"/>
-        <a:font script="Arab" typeface="Times New Roman"/>
-        <a:font script="Hebr" typeface="Times New Roman"/>
-        <a:font script="Thai" typeface="Angsana New"/>
-        <a:font script="Ethi" typeface="Nyala"/>
-        <a:font script="Beng" typeface="Vrinda"/>
-        <a:font script="Gujr" typeface="Shruti"/>
-        <a:font script="Khmr" typeface="MoolBoran"/>
-        <a:font script="Knda" typeface="Tunga"/>
-        <a:font script="Guru" typeface="Raavi"/>
-        <a:font script="Cans" typeface="Euphemia"/>
-        <a:font script="Cher" typeface="Plantagenet Cherokee"/>
-        <a:font script="Yiii" typeface="Microsoft Yi Baiti"/>
-        <a:font script="Tibt" typeface="Microsoft Himalaya"/>
-        <a:font script="Thaa" typeface="MV Boli"/>
-        <a:font script="Deva" typeface="Mangal"/>
-        <a:font script="Telu" typeface="Gautami"/>
-        <a:font script="Taml" typeface="Latha"/>
-        <a:font script="Syrc" typeface="Estrangelo Edessa"/>
-        <a:font script="Orya" typeface="Kalinga"/>
-        <a:font script="Mlym" typeface="Kartika"/>
-        <a:font script="Laoo" typeface="DokChampa"/>
-        <a:font script="Sinh" typeface="Iskoola Pota"/>
-        <a:font script="Mong" typeface="Mongolian Baiti"/>
-        <a:font script="Viet" typeface="Times New Roman"/>
-        <a:font script="Uigh" typeface="Microsoft Uighur"/>
-        <a:font script="Geor" typeface="Sylfaen"/>
-      </a:majorFont>
-      <a:minorFont>
-        <a:latin typeface="Arial"/>
-        <a:ea typeface=""/>
-        <a:cs typeface=""/>
-        <a:font script="Jpan" typeface="ＭＳ Ｐゴシック"/>
-        <a:font script="Hang" typeface="맑은 고딕"/>
-        <a:font script="Hans" typeface="宋体"/>
-        <a:font script="Hant" typeface="新細明體"/>
-        <a:font script="Arab" typeface="Arial"/>
-        <a:font script="Hebr" typeface="Arial"/>
-        <a:font script="Thai" typeface="Cordia New"/>
-        <a:font script="Ethi" typeface="Nyala"/>
-        <a:font script="Beng" typeface="Vrinda"/>
-        <a:font script="Gujr" typeface="Shruti"/>
-        <a:font script="Khmr" typeface="DaunPenh"/>
-        <a:font script="Knda" typeface="Tunga"/>
-        <a:font script="Guru" typeface="Raavi"/>
-        <a:font script="Cans" typeface="Euphemia"/>
-        <a:font script="Cher" typeface="Plantagenet Cherokee"/>
-        <a:font script="Yiii" typeface="Microsoft Yi Baiti"/>
-        <a:font script="Tibt" typeface="Microsoft Himalaya"/>
-        <a:font script="Thaa" typeface="MV Boli"/>
-        <a:font script="Deva" typeface="Mangal"/>
-        <a:font script="Telu" typeface="Gautami"/>
-        <a:font script="Taml" typeface="Latha"/>
-        <a:font script="Syrc" typeface="Estrangelo Edessa"/>
-        <a:font script="Orya" typeface="Kalinga"/>
-        <a:font script="Mlym" typeface="Kartika"/>
-        <a:font script="Laoo" typeface="DokChampa"/>
-        <a:font script="Sinh" typeface="Iskoola Pota"/>
-        <a:font script="Mong" typeface="Mongolian Baiti"/>
-        <a:font script="Viet" typeface="Arial"/>
-        <a:font script="Uigh" typeface="Microsoft Uighur"/>
-        <a:font script="Geor" typeface="Sylfaen"/>
-      </a:minorFont>
-    </a:fontScheme>
-    <a:fmtScheme name="Office">
-      <a:fillStyleLst>
-        <a:solidFill>
-          <a:schemeClr val="phClr"/>
-        </a:solidFill>
-        <a:gradFill rotWithShape="1">
-          <a:gsLst>
-            <a:gs pos="0">
-              <a:schemeClr val="phClr">
-                <a:tint val="50000"/>
-                <a:satMod val="300000"/>
-              </a:schemeClr>
-            </a:gs>
-            <a:gs pos="35000">
-              <a:schemeClr val="phClr">
-                <a:tint val="37000"/>
-                <a:satMod val="300000"/>
-              </a:schemeClr>
-            </a:gs>
-            <a:gs pos="100000">
-              <a:schemeClr val="phClr">
-                <a:tint val="15000"/>
-                <a:satMod val="350000"/>
-              </a:schemeClr>
-            </a:gs>
-          </a:gsLst>
-          <a:lin ang="16200000" scaled="1"/>
-        </a:gradFill>
-        <a:gradFill rotWithShape="1">
-          <a:gsLst>
-            <a:gs pos="0">
-              <a:schemeClr val="phClr">
-                <a:tint val="100000"/>
-                <a:shade val="100000"/>
-                <a:satMod val="130000"/>
-              </a:schemeClr>
-            </a:gs>
-            <a:gs pos="100000">
-              <a:schemeClr val="phClr">
-                <a:tint val="50000"/>
-                <a:shade val="100000"/>
-                <a:satMod val="350000"/>
-              </a:schemeClr>
-            </a:gs>
-          </a:gsLst>
-          <a:lin ang="16200000" scaled="0"/>
-        </a:gradFill>
-      </a:fillStyleLst>
-      <a:lnStyleLst>
-        <a:ln w="9525" cap="flat" cmpd="sng" algn="ctr">
-          <a:solidFill>
-            <a:schemeClr val="phClr">
-              <a:shade val="95000"/>
-              <a:satMod val="105000"/>
-            </a:schemeClr>
-          </a:solidFill>
-          <a:prstDash val="solid"/>
-        </a:ln>
-        <a:ln w="25400" cap="flat" cmpd="sng" algn="ctr">
-          <a:solidFill>
-            <a:schemeClr val="phClr"/>
-          </a:solidFill>
-          <a:prstDash val="solid"/>
-        </a:ln>
-        <a:ln w="38100" cap="flat" cmpd="sng" algn="ctr">
-          <a:solidFill>
-            <a:schemeClr val="phClr"/>
-          </a:solidFill>
-          <a:prstDash val="solid"/>
-        </a:ln>
-      </a:lnStyleLst>
-      <a:effectStyleLst>
-        <a:effectStyle>
-          <a:effectLst>
-            <a:outerShdw blurRad="40000" dist="20000" dir="5400000" rotWithShape="0">
-              <a:srgbClr val="000000">
-                <a:alpha val="38000"/>
-              </a:srgbClr>
-            </a:outerShdw>
-          </a:effectLst>
-        </a:effectStyle>
-        <a:effectStyle>
-          <a:effectLst>
-            <a:outerShdw blurRad="40000" dist="23000" dir="5400000" rotWithShape="0">
-              <a:srgbClr val="000000">
-                <a:alpha val="35000"/>
-              </a:srgbClr>
-            </a:outerShdw>
-          </a:effectLst>
-        </a:effectStyle>
-        <a:effectStyle>
-          <a:effectLst>
-            <a:outerShdw blurRad="40000" dist="23000" dir="5400000" rotWithShape="0">
-              <a:srgbClr val="000000">
-                <a:alpha val="35000"/>
-              </a:srgbClr>
-            </a:outerShdw>
-          </a:effectLst>
-          <a:scene3d>
-            <a:camera prst="orthographicFront">
-              <a:rot lat="0" lon="0" rev="0"/>
-            </a:camera>
-            <a:lightRig rig="threePt" dir="t">
-              <a:rot lat="0" lon="0" rev="1200000"/>
-            </a:lightRig>
-          </a:scene3d>
-          <a:sp3d>
-            <a:bevelT w="63500" h="25400"/>
-          </a:sp3d>
-        </a:effectStyle>
-      </a:effectStyleLst>
-      <a:bgFillStyleLst>
-        <a:solidFill>
-          <a:schemeClr val="phClr"/>
-        </a:solidFill>
-        <a:gradFill rotWithShape="1">
-          <a:gsLst>
-            <a:gs pos="0">
-              <a:schemeClr val="phClr">
-                <a:tint val="40000"/>
-                <a:satMod val="350000"/>
-              </a:schemeClr>
-            </a:gs>
-            <a:gs pos="40000">
-              <a:schemeClr val="phClr">
-                <a:tint val="45000"/>
-                <a:shade val="99000"/>
-                <a:satMod val="350000"/>
-              </a:schemeClr>
-            </a:gs>
-            <a:gs pos="100000">
-              <a:schemeClr val="phClr">
-                <a:shade val="20000"/>
-                <a:satMod val="255000"/>
-              </a:schemeClr>
-            </a:gs>
-          </a:gsLst>
-          <a:path path="circle">
-            <a:fillToRect l="50000" t="-80000" r="50000" b="180000"/>
-          </a:path>
-        </a:gradFill>
-        <a:gradFill rotWithShape="1">
-          <a:gsLst>
-            <a:gs pos="0">
-              <a:schemeClr val="phClr">
-                <a:tint val="80000"/>
-                <a:satMod val="300000"/>
-              </a:schemeClr>
-            </a:gs>
-            <a:gs pos="100000">
-              <a:schemeClr val="phClr">
-                <a:shade val="30000"/>
-                <a:satMod val="200000"/>
-              </a:schemeClr>
-            </a:gs>
-          </a:gsLst>
-          <a:path path="circle">
-            <a:fillToRect l="50000" t="50000" r="50000" b="50000"/>
-          </a:path>
-        </a:gradFill>
-      </a:bgFillStyleLst>
-    </a:fmtScheme>
-  </a:themeElements>
-</a:theme>
 </file>
</xml_diff>

<commit_message>
docs: final eval run 69/69 (23 cases × 3, current test code); brief description with seven agents, voice notes and Firebase Authentication; deck rebuilt
</commit_message>
<xml_diff>
--- a/docs/submission/BreederNear-AI-deck.pptx
+++ b/docs/submission/BreederNear-AI-deck.pptx
@@ -8048,7 +8048,7 @@
                           </a:solidFill>
                           <a:latin typeface="Google Sans Flex SemiBold"/>
                         </a:rPr>
-                        <a:t>Quality (real Gemini, 10–11 Oct 2026)</a:t>
+                        <a:t>Quality (real Gemini, 10–12 Oct 2026)</a:t>
                       </a:r>
                     </a:p>
                   </a:txBody>
@@ -8094,7 +8094,7 @@
                           </a:solidFill>
                           <a:latin typeface="Google Sans Flex"/>
                         </a:rPr>
-                        <a:t>Agent evals: 22 cases × 3 runs (listing, Tamil, blocking, scams, reused photos, prompt injection, no medicine advice, roles, verification, visits, care companion)</a:t>
+                        <a:t>Agent evals: 23 cases × 3 runs (listing, Tamil, blocking, scams, reused photos, prompt injection, no medicine advice, roles, verification, visits, care companion)</a:t>
                       </a:r>
                     </a:p>
                   </a:txBody>
@@ -8116,7 +8116,7 @@
                           </a:solidFill>
                           <a:latin typeface="Google Sans Flex SemiBold"/>
                         </a:rPr>
-                        <a:t>66/66 passed</a:t>
+                        <a:t>69/69 passed</a:t>
                       </a:r>
                     </a:p>
                   </a:txBody>
@@ -8602,7 +8602,7 @@
                           </a:solidFill>
                           <a:latin typeface="Google Sans Flex"/>
                         </a:rPr>
-                        <a:t>≈ 4.5 s · ≈ 2 s</a:t>
+                        <a:t>8–9 s · 2–3 s</a:t>
                       </a:r>
                     </a:p>
                   </a:txBody>
@@ -8648,7 +8648,7 @@
                           </a:solidFill>
                           <a:latin typeface="Google Sans Flex"/>
                         </a:rPr>
-                        <a:t>≈ 8 s</a:t>
+                        <a:t>7–8 s · 4–10 s</a:t>
                       </a:r>
                     </a:p>
                   </a:txBody>
@@ -11114,7 +11114,7 @@
                           </a:solidFill>
                           <a:latin typeface="Google Sans Flex"/>
                         </a:rPr>
-                        <a:t>Match % calculated in code; 16 breeders, 36 pets</a:t>
+                        <a:t>Match % calculated in code; 16 sample breeders, 36 sample pets</a:t>
                       </a:r>
                     </a:p>
                   </a:txBody>
@@ -11182,7 +11182,7 @@
                           </a:solidFill>
                           <a:latin typeface="Google Sans Flex"/>
                         </a:rPr>
-                        <a:t>Photos + a Tamil or English message become a full listing</a:t>
+                        <a:t>Photos + a Tamil or English message, typed or as a voice note, become a full listing</a:t>
                       </a:r>
                     </a:p>
                   </a:txBody>
@@ -11802,7 +11802,7 @@
                 </a:solidFill>
                 <a:latin typeface="Google Sans Flex"/>
               </a:rPr>
-              <a:t>every step works by tapping or by asking seven Gemini agents in English or Tamil. Live now: 66/66 agent eval runs, 339 unit tests, 0 accessibility problems.</a:t>
+              <a:t>every step works by tapping or by asking seven Gemini agents in English or Tamil. Live now: 69/69 agent eval runs, 339 unit tests, 0 accessibility problems.</a:t>
             </a:r>
           </a:p>
         </p:txBody>
@@ -12191,7 +12191,7 @@
                           </a:solidFill>
                           <a:latin typeface="Google Sans Flex SemiBold"/>
                         </a:rPr>
-                        <a:t>Tamil voice note → correct listing (eval E23)</a:t>
+                        <a:t>Tamil voice note → correct listing (3/3 eval runs, E23)</a:t>
                       </a:r>
                     </a:p>
                   </a:txBody>
@@ -12395,7 +12395,7 @@
                           </a:solidFill>
                           <a:latin typeface="Google Sans Flex SemiBold"/>
                         </a:rPr>
-                        <a:t>66/66 agent eval runs passed (22 cases × 3 runs)</a:t>
+                        <a:t>69/69 agent eval runs passed (23 cases × 3 runs)</a:t>
                       </a:r>
                     </a:p>
                   </a:txBody>
@@ -14604,7 +14604,7 @@
                 </a:solidFill>
                 <a:latin typeface="Google Sans Flex"/>
               </a:rPr>
-              <a:t>“Is this post safe?”, starter kit, Local Breeders directory</a:t>
+              <a:t>“Is this post safe?” with share and report; starter kit; Local Breeders</a:t>
             </a:r>
           </a:p>
         </p:txBody>
@@ -14704,7 +14704,7 @@
                 </a:solidFill>
                 <a:latin typeface="Google Sans Flex"/>
               </a:rPr>
-              <a:t>“Fill with AI”: photos + a Tamil/English message become a listing</a:t>
+              <a:t>“Fill with AI”: photos + a Tamil/English message or voice note become a listing</a:t>
             </a:r>
           </a:p>
           <a:p>
@@ -20980,7 +20980,7 @@
                 </a:solidFill>
                 <a:latin typeface="Google Sans Flex"/>
               </a:rPr>
-              <a:t>imagehash: reused-photo detection</a:t>
+              <a:t>Pillow: our own perceptual hash (dHash) for reused photos</a:t>
             </a:r>
           </a:p>
           <a:p>
@@ -21045,6 +21045,285 @@
 </file>
 
 <file path=ppt/theme/theme1.xml><?xml version="1.0" encoding="utf-8"?>
+<a:theme xmlns:a="http://schemas.openxmlformats.org/drawingml/2006/main" xmlns:r="http://schemas.openxmlformats.org/officeDocument/2006/relationships">
+  <a:themeElements>
+    <a:clrScheme name="Default">
+      <a:dk1>
+        <a:srgbClr val="000000"/>
+      </a:dk1>
+      <a:lt1>
+        <a:srgbClr val="FFFFFF"/>
+      </a:lt1>
+      <a:dk2>
+        <a:srgbClr val="158158"/>
+      </a:dk2>
+      <a:lt2>
+        <a:srgbClr val="F3F3F3"/>
+      </a:lt2>
+      <a:accent1>
+        <a:srgbClr val="058DC7"/>
+      </a:accent1>
+      <a:accent2>
+        <a:srgbClr val="50B432"/>
+      </a:accent2>
+      <a:accent3>
+        <a:srgbClr val="ED561B"/>
+      </a:accent3>
+      <a:accent4>
+        <a:srgbClr val="EDEF00"/>
+      </a:accent4>
+      <a:accent5>
+        <a:srgbClr val="24CBE5"/>
+      </a:accent5>
+      <a:accent6>
+        <a:srgbClr val="64E572"/>
+      </a:accent6>
+      <a:hlink>
+        <a:srgbClr val="2200CC"/>
+      </a:hlink>
+      <a:folHlink>
+        <a:srgbClr val="551A8B"/>
+      </a:folHlink>
+    </a:clrScheme>
+    <a:fontScheme name="Office">
+      <a:majorFont>
+        <a:latin typeface="Arial"/>
+        <a:ea typeface=""/>
+        <a:cs typeface=""/>
+        <a:font script="Jpan" typeface="ＭＳ Ｐゴシック"/>
+        <a:font script="Hang" typeface="맑은 고딕"/>
+        <a:font script="Hans" typeface="宋体"/>
+        <a:font script="Hant" typeface="新細明體"/>
+        <a:font script="Arab" typeface="Times New Roman"/>
+        <a:font script="Hebr" typeface="Times New Roman"/>
+        <a:font script="Thai" typeface="Angsana New"/>
+        <a:font script="Ethi" typeface="Nyala"/>
+        <a:font script="Beng" typeface="Vrinda"/>
+        <a:font script="Gujr" typeface="Shruti"/>
+        <a:font script="Khmr" typeface="MoolBoran"/>
+        <a:font script="Knda" typeface="Tunga"/>
+        <a:font script="Guru" typeface="Raavi"/>
+        <a:font script="Cans" typeface="Euphemia"/>
+        <a:font script="Cher" typeface="Plantagenet Cherokee"/>
+        <a:font script="Yiii" typeface="Microsoft Yi Baiti"/>
+        <a:font script="Tibt" typeface="Microsoft Himalaya"/>
+        <a:font script="Thaa" typeface="MV Boli"/>
+        <a:font script="Deva" typeface="Mangal"/>
+        <a:font script="Telu" typeface="Gautami"/>
+        <a:font script="Taml" typeface="Latha"/>
+        <a:font script="Syrc" typeface="Estrangelo Edessa"/>
+        <a:font script="Orya" typeface="Kalinga"/>
+        <a:font script="Mlym" typeface="Kartika"/>
+        <a:font script="Laoo" typeface="DokChampa"/>
+        <a:font script="Sinh" typeface="Iskoola Pota"/>
+        <a:font script="Mong" typeface="Mongolian Baiti"/>
+        <a:font script="Viet" typeface="Times New Roman"/>
+        <a:font script="Uigh" typeface="Microsoft Uighur"/>
+        <a:font script="Geor" typeface="Sylfaen"/>
+      </a:majorFont>
+      <a:minorFont>
+        <a:latin typeface="Arial"/>
+        <a:ea typeface=""/>
+        <a:cs typeface=""/>
+        <a:font script="Jpan" typeface="ＭＳ Ｐゴシック"/>
+        <a:font script="Hang" typeface="맑은 고딕"/>
+        <a:font script="Hans" typeface="宋体"/>
+        <a:font script="Hant" typeface="新細明體"/>
+        <a:font script="Arab" typeface="Arial"/>
+        <a:font script="Hebr" typeface="Arial"/>
+        <a:font script="Thai" typeface="Cordia New"/>
+        <a:font script="Ethi" typeface="Nyala"/>
+        <a:font script="Beng" typeface="Vrinda"/>
+        <a:font script="Gujr" typeface="Shruti"/>
+        <a:font script="Khmr" typeface="DaunPenh"/>
+        <a:font script="Knda" typeface="Tunga"/>
+        <a:font script="Guru" typeface="Raavi"/>
+        <a:font script="Cans" typeface="Euphemia"/>
+        <a:font script="Cher" typeface="Plantagenet Cherokee"/>
+        <a:font script="Yiii" typeface="Microsoft Yi Baiti"/>
+        <a:font script="Tibt" typeface="Microsoft Himalaya"/>
+        <a:font script="Thaa" typeface="MV Boli"/>
+        <a:font script="Deva" typeface="Mangal"/>
+        <a:font script="Telu" typeface="Gautami"/>
+        <a:font script="Taml" typeface="Latha"/>
+        <a:font script="Syrc" typeface="Estrangelo Edessa"/>
+        <a:font script="Orya" typeface="Kalinga"/>
+        <a:font script="Mlym" typeface="Kartika"/>
+        <a:font script="Laoo" typeface="DokChampa"/>
+        <a:font script="Sinh" typeface="Iskoola Pota"/>
+        <a:font script="Mong" typeface="Mongolian Baiti"/>
+        <a:font script="Viet" typeface="Arial"/>
+        <a:font script="Uigh" typeface="Microsoft Uighur"/>
+        <a:font script="Geor" typeface="Sylfaen"/>
+      </a:minorFont>
+    </a:fontScheme>
+    <a:fmtScheme name="Office">
+      <a:fillStyleLst>
+        <a:solidFill>
+          <a:schemeClr val="phClr"/>
+        </a:solidFill>
+        <a:gradFill rotWithShape="1">
+          <a:gsLst>
+            <a:gs pos="0">
+              <a:schemeClr val="phClr">
+                <a:tint val="50000"/>
+                <a:satMod val="300000"/>
+              </a:schemeClr>
+            </a:gs>
+            <a:gs pos="35000">
+              <a:schemeClr val="phClr">
+                <a:tint val="37000"/>
+                <a:satMod val="300000"/>
+              </a:schemeClr>
+            </a:gs>
+            <a:gs pos="100000">
+              <a:schemeClr val="phClr">
+                <a:tint val="15000"/>
+                <a:satMod val="350000"/>
+              </a:schemeClr>
+            </a:gs>
+          </a:gsLst>
+          <a:lin ang="16200000" scaled="1"/>
+        </a:gradFill>
+        <a:gradFill rotWithShape="1">
+          <a:gsLst>
+            <a:gs pos="0">
+              <a:schemeClr val="phClr">
+                <a:tint val="100000"/>
+                <a:shade val="100000"/>
+                <a:satMod val="130000"/>
+              </a:schemeClr>
+            </a:gs>
+            <a:gs pos="100000">
+              <a:schemeClr val="phClr">
+                <a:tint val="50000"/>
+                <a:shade val="100000"/>
+                <a:satMod val="350000"/>
+              </a:schemeClr>
+            </a:gs>
+          </a:gsLst>
+          <a:lin ang="16200000" scaled="0"/>
+        </a:gradFill>
+      </a:fillStyleLst>
+      <a:lnStyleLst>
+        <a:ln w="9525" cap="flat" cmpd="sng" algn="ctr">
+          <a:solidFill>
+            <a:schemeClr val="phClr">
+              <a:shade val="95000"/>
+              <a:satMod val="105000"/>
+            </a:schemeClr>
+          </a:solidFill>
+          <a:prstDash val="solid"/>
+        </a:ln>
+        <a:ln w="25400" cap="flat" cmpd="sng" algn="ctr">
+          <a:solidFill>
+            <a:schemeClr val="phClr"/>
+          </a:solidFill>
+          <a:prstDash val="solid"/>
+        </a:ln>
+        <a:ln w="38100" cap="flat" cmpd="sng" algn="ctr">
+          <a:solidFill>
+            <a:schemeClr val="phClr"/>
+          </a:solidFill>
+          <a:prstDash val="solid"/>
+        </a:ln>
+      </a:lnStyleLst>
+      <a:effectStyleLst>
+        <a:effectStyle>
+          <a:effectLst>
+            <a:outerShdw blurRad="40000" dist="20000" dir="5400000" rotWithShape="0">
+              <a:srgbClr val="000000">
+                <a:alpha val="38000"/>
+              </a:srgbClr>
+            </a:outerShdw>
+          </a:effectLst>
+        </a:effectStyle>
+        <a:effectStyle>
+          <a:effectLst>
+            <a:outerShdw blurRad="40000" dist="23000" dir="5400000" rotWithShape="0">
+              <a:srgbClr val="000000">
+                <a:alpha val="35000"/>
+              </a:srgbClr>
+            </a:outerShdw>
+          </a:effectLst>
+        </a:effectStyle>
+        <a:effectStyle>
+          <a:effectLst>
+            <a:outerShdw blurRad="40000" dist="23000" dir="5400000" rotWithShape="0">
+              <a:srgbClr val="000000">
+                <a:alpha val="35000"/>
+              </a:srgbClr>
+            </a:outerShdw>
+          </a:effectLst>
+          <a:scene3d>
+            <a:camera prst="orthographicFront">
+              <a:rot lat="0" lon="0" rev="0"/>
+            </a:camera>
+            <a:lightRig rig="threePt" dir="t">
+              <a:rot lat="0" lon="0" rev="1200000"/>
+            </a:lightRig>
+          </a:scene3d>
+          <a:sp3d>
+            <a:bevelT w="63500" h="25400"/>
+          </a:sp3d>
+        </a:effectStyle>
+      </a:effectStyleLst>
+      <a:bgFillStyleLst>
+        <a:solidFill>
+          <a:schemeClr val="phClr"/>
+        </a:solidFill>
+        <a:gradFill rotWithShape="1">
+          <a:gsLst>
+            <a:gs pos="0">
+              <a:schemeClr val="phClr">
+                <a:tint val="40000"/>
+                <a:satMod val="350000"/>
+              </a:schemeClr>
+            </a:gs>
+            <a:gs pos="40000">
+              <a:schemeClr val="phClr">
+                <a:tint val="45000"/>
+                <a:shade val="99000"/>
+                <a:satMod val="350000"/>
+              </a:schemeClr>
+            </a:gs>
+            <a:gs pos="100000">
+              <a:schemeClr val="phClr">
+                <a:shade val="20000"/>
+                <a:satMod val="255000"/>
+              </a:schemeClr>
+            </a:gs>
+          </a:gsLst>
+          <a:path path="circle">
+            <a:fillToRect l="50000" t="-80000" r="50000" b="180000"/>
+          </a:path>
+        </a:gradFill>
+        <a:gradFill rotWithShape="1">
+          <a:gsLst>
+            <a:gs pos="0">
+              <a:schemeClr val="phClr">
+                <a:tint val="80000"/>
+                <a:satMod val="300000"/>
+              </a:schemeClr>
+            </a:gs>
+            <a:gs pos="100000">
+              <a:schemeClr val="phClr">
+                <a:shade val="30000"/>
+                <a:satMod val="200000"/>
+              </a:schemeClr>
+            </a:gs>
+          </a:gsLst>
+          <a:path path="circle">
+            <a:fillToRect l="50000" t="50000" r="50000" b="50000"/>
+          </a:path>
+        </a:gradFill>
+      </a:bgFillStyleLst>
+    </a:fmtScheme>
+  </a:themeElements>
+</a:theme>
+</file>
+
+<file path=ppt/theme/theme2.xml><?xml version="1.0" encoding="utf-8"?>
 <a:theme xmlns:a="http://schemas.openxmlformats.org/drawingml/2006/main" xmlns:r="http://schemas.openxmlformats.org/officeDocument/2006/relationships" name="Simple Light">
   <a:themeElements>
     <a:clrScheme name="Simple Light">
@@ -21321,283 +21600,4 @@
     </a:fmtScheme>
   </a:themeElements>
 </a:theme>
-</file>
-
-<file path=ppt/theme/theme2.xml><?xml version="1.0" encoding="utf-8"?>
-<a:theme xmlns:a="http://schemas.openxmlformats.org/drawingml/2006/main" xmlns:r="http://schemas.openxmlformats.org/officeDocument/2006/relationships">
-  <a:themeElements>
-    <a:clrScheme name="Default">
-      <a:dk1>
-        <a:srgbClr val="000000"/>
-      </a:dk1>
-      <a:lt1>
-        <a:srgbClr val="FFFFFF"/>
-      </a:lt1>
-      <a:dk2>
-        <a:srgbClr val="158158"/>
-      </a:dk2>
-      <a:lt2>
-        <a:srgbClr val="F3F3F3"/>
-      </a:lt2>
-      <a:accent1>
-        <a:srgbClr val="058DC7"/>
-      </a:accent1>
-      <a:accent2>
-        <a:srgbClr val="50B432"/>
-      </a:accent2>
-      <a:accent3>
-        <a:srgbClr val="ED561B"/>
-      </a:accent3>
-      <a:accent4>
-        <a:srgbClr val="EDEF00"/>
-      </a:accent4>
-      <a:accent5>
-        <a:srgbClr val="24CBE5"/>
-      </a:accent5>
-      <a:accent6>
-        <a:srgbClr val="64E572"/>
-      </a:accent6>
-      <a:hlink>
-        <a:srgbClr val="2200CC"/>
-      </a:hlink>
-      <a:folHlink>
-        <a:srgbClr val="551A8B"/>
-      </a:folHlink>
-    </a:clrScheme>
-    <a:fontScheme name="Office">
-      <a:majorFont>
-        <a:latin typeface="Arial"/>
-        <a:ea typeface=""/>
-        <a:cs typeface=""/>
-        <a:font script="Jpan" typeface="ＭＳ Ｐゴシック"/>
-        <a:font script="Hang" typeface="맑은 고딕"/>
-        <a:font script="Hans" typeface="宋体"/>
-        <a:font script="Hant" typeface="新細明體"/>
-        <a:font script="Arab" typeface="Times New Roman"/>
-        <a:font script="Hebr" typeface="Times New Roman"/>
-        <a:font script="Thai" typeface="Angsana New"/>
-        <a:font script="Ethi" typeface="Nyala"/>
-        <a:font script="Beng" typeface="Vrinda"/>
-        <a:font script="Gujr" typeface="Shruti"/>
-        <a:font script="Khmr" typeface="MoolBoran"/>
-        <a:font script="Knda" typeface="Tunga"/>
-        <a:font script="Guru" typeface="Raavi"/>
-        <a:font script="Cans" typeface="Euphemia"/>
-        <a:font script="Cher" typeface="Plantagenet Cherokee"/>
-        <a:font script="Yiii" typeface="Microsoft Yi Baiti"/>
-        <a:font script="Tibt" typeface="Microsoft Himalaya"/>
-        <a:font script="Thaa" typeface="MV Boli"/>
-        <a:font script="Deva" typeface="Mangal"/>
-        <a:font script="Telu" typeface="Gautami"/>
-        <a:font script="Taml" typeface="Latha"/>
-        <a:font script="Syrc" typeface="Estrangelo Edessa"/>
-        <a:font script="Orya" typeface="Kalinga"/>
-        <a:font script="Mlym" typeface="Kartika"/>
-        <a:font script="Laoo" typeface="DokChampa"/>
-        <a:font script="Sinh" typeface="Iskoola Pota"/>
-        <a:font script="Mong" typeface="Mongolian Baiti"/>
-        <a:font script="Viet" typeface="Times New Roman"/>
-        <a:font script="Uigh" typeface="Microsoft Uighur"/>
-        <a:font script="Geor" typeface="Sylfaen"/>
-      </a:majorFont>
-      <a:minorFont>
-        <a:latin typeface="Arial"/>
-        <a:ea typeface=""/>
-        <a:cs typeface=""/>
-        <a:font script="Jpan" typeface="ＭＳ Ｐゴシック"/>
-        <a:font script="Hang" typeface="맑은 고딕"/>
-        <a:font script="Hans" typeface="宋体"/>
-        <a:font script="Hant" typeface="新細明體"/>
-        <a:font script="Arab" typeface="Arial"/>
-        <a:font script="Hebr" typeface="Arial"/>
-        <a:font script="Thai" typeface="Cordia New"/>
-        <a:font script="Ethi" typeface="Nyala"/>
-        <a:font script="Beng" typeface="Vrinda"/>
-        <a:font script="Gujr" typeface="Shruti"/>
-        <a:font script="Khmr" typeface="DaunPenh"/>
-        <a:font script="Knda" typeface="Tunga"/>
-        <a:font script="Guru" typeface="Raavi"/>
-        <a:font script="Cans" typeface="Euphemia"/>
-        <a:font script="Cher" typeface="Plantagenet Cherokee"/>
-        <a:font script="Yiii" typeface="Microsoft Yi Baiti"/>
-        <a:font script="Tibt" typeface="Microsoft Himalaya"/>
-        <a:font script="Thaa" typeface="MV Boli"/>
-        <a:font script="Deva" typeface="Mangal"/>
-        <a:font script="Telu" typeface="Gautami"/>
-        <a:font script="Taml" typeface="Latha"/>
-        <a:font script="Syrc" typeface="Estrangelo Edessa"/>
-        <a:font script="Orya" typeface="Kalinga"/>
-        <a:font script="Mlym" typeface="Kartika"/>
-        <a:font script="Laoo" typeface="DokChampa"/>
-        <a:font script="Sinh" typeface="Iskoola Pota"/>
-        <a:font script="Mong" typeface="Mongolian Baiti"/>
-        <a:font script="Viet" typeface="Arial"/>
-        <a:font script="Uigh" typeface="Microsoft Uighur"/>
-        <a:font script="Geor" typeface="Sylfaen"/>
-      </a:minorFont>
-    </a:fontScheme>
-    <a:fmtScheme name="Office">
-      <a:fillStyleLst>
-        <a:solidFill>
-          <a:schemeClr val="phClr"/>
-        </a:solidFill>
-        <a:gradFill rotWithShape="1">
-          <a:gsLst>
-            <a:gs pos="0">
-              <a:schemeClr val="phClr">
-                <a:tint val="50000"/>
-                <a:satMod val="300000"/>
-              </a:schemeClr>
-            </a:gs>
-            <a:gs pos="35000">
-              <a:schemeClr val="phClr">
-                <a:tint val="37000"/>
-                <a:satMod val="300000"/>
-              </a:schemeClr>
-            </a:gs>
-            <a:gs pos="100000">
-              <a:schemeClr val="phClr">
-                <a:tint val="15000"/>
-                <a:satMod val="350000"/>
-              </a:schemeClr>
-            </a:gs>
-          </a:gsLst>
-          <a:lin ang="16200000" scaled="1"/>
-        </a:gradFill>
-        <a:gradFill rotWithShape="1">
-          <a:gsLst>
-            <a:gs pos="0">
-              <a:schemeClr val="phClr">
-                <a:tint val="100000"/>
-                <a:shade val="100000"/>
-                <a:satMod val="130000"/>
-              </a:schemeClr>
-            </a:gs>
-            <a:gs pos="100000">
-              <a:schemeClr val="phClr">
-                <a:tint val="50000"/>
-                <a:shade val="100000"/>
-                <a:satMod val="350000"/>
-              </a:schemeClr>
-            </a:gs>
-          </a:gsLst>
-          <a:lin ang="16200000" scaled="0"/>
-        </a:gradFill>
-      </a:fillStyleLst>
-      <a:lnStyleLst>
-        <a:ln w="9525" cap="flat" cmpd="sng" algn="ctr">
-          <a:solidFill>
-            <a:schemeClr val="phClr">
-              <a:shade val="95000"/>
-              <a:satMod val="105000"/>
-            </a:schemeClr>
-          </a:solidFill>
-          <a:prstDash val="solid"/>
-        </a:ln>
-        <a:ln w="25400" cap="flat" cmpd="sng" algn="ctr">
-          <a:solidFill>
-            <a:schemeClr val="phClr"/>
-          </a:solidFill>
-          <a:prstDash val="solid"/>
-        </a:ln>
-        <a:ln w="38100" cap="flat" cmpd="sng" algn="ctr">
-          <a:solidFill>
-            <a:schemeClr val="phClr"/>
-          </a:solidFill>
-          <a:prstDash val="solid"/>
-        </a:ln>
-      </a:lnStyleLst>
-      <a:effectStyleLst>
-        <a:effectStyle>
-          <a:effectLst>
-            <a:outerShdw blurRad="40000" dist="20000" dir="5400000" rotWithShape="0">
-              <a:srgbClr val="000000">
-                <a:alpha val="38000"/>
-              </a:srgbClr>
-            </a:outerShdw>
-          </a:effectLst>
-        </a:effectStyle>
-        <a:effectStyle>
-          <a:effectLst>
-            <a:outerShdw blurRad="40000" dist="23000" dir="5400000" rotWithShape="0">
-              <a:srgbClr val="000000">
-                <a:alpha val="35000"/>
-              </a:srgbClr>
-            </a:outerShdw>
-          </a:effectLst>
-        </a:effectStyle>
-        <a:effectStyle>
-          <a:effectLst>
-            <a:outerShdw blurRad="40000" dist="23000" dir="5400000" rotWithShape="0">
-              <a:srgbClr val="000000">
-                <a:alpha val="35000"/>
-              </a:srgbClr>
-            </a:outerShdw>
-          </a:effectLst>
-          <a:scene3d>
-            <a:camera prst="orthographicFront">
-              <a:rot lat="0" lon="0" rev="0"/>
-            </a:camera>
-            <a:lightRig rig="threePt" dir="t">
-              <a:rot lat="0" lon="0" rev="1200000"/>
-            </a:lightRig>
-          </a:scene3d>
-          <a:sp3d>
-            <a:bevelT w="63500" h="25400"/>
-          </a:sp3d>
-        </a:effectStyle>
-      </a:effectStyleLst>
-      <a:bgFillStyleLst>
-        <a:solidFill>
-          <a:schemeClr val="phClr"/>
-        </a:solidFill>
-        <a:gradFill rotWithShape="1">
-          <a:gsLst>
-            <a:gs pos="0">
-              <a:schemeClr val="phClr">
-                <a:tint val="40000"/>
-                <a:satMod val="350000"/>
-              </a:schemeClr>
-            </a:gs>
-            <a:gs pos="40000">
-              <a:schemeClr val="phClr">
-                <a:tint val="45000"/>
-                <a:shade val="99000"/>
-                <a:satMod val="350000"/>
-              </a:schemeClr>
-            </a:gs>
-            <a:gs pos="100000">
-              <a:schemeClr val="phClr">
-                <a:shade val="20000"/>
-                <a:satMod val="255000"/>
-              </a:schemeClr>
-            </a:gs>
-          </a:gsLst>
-          <a:path path="circle">
-            <a:fillToRect l="50000" t="-80000" r="50000" b="180000"/>
-          </a:path>
-        </a:gradFill>
-        <a:gradFill rotWithShape="1">
-          <a:gsLst>
-            <a:gs pos="0">
-              <a:schemeClr val="phClr">
-                <a:tint val="80000"/>
-                <a:satMod val="300000"/>
-              </a:schemeClr>
-            </a:gs>
-            <a:gs pos="100000">
-              <a:schemeClr val="phClr">
-                <a:shade val="30000"/>
-                <a:satMod val="200000"/>
-              </a:schemeClr>
-            </a:gs>
-          </a:gsLst>
-          <a:path path="circle">
-            <a:fillToRect l="50000" t="50000" r="50000" b="50000"/>
-          </a:path>
-        </a:gradFill>
-      </a:bgFillStyleLst>
-    </a:fmtScheme>
-  </a:themeElements>
-</a:theme>
 </file>
</xml_diff>

<commit_message>
docs: demo video link (Google Drive, public view) in the deck and README
</commit_message>
<xml_diff>
--- a/docs/submission/BreederNear-AI-deck.pptx
+++ b/docs/submission/BreederNear-AI-deck.pptx
@@ -9572,7 +9572,7 @@
                 <a:cs typeface="Google Sans Flex Medium"/>
                 <a:sym typeface="Google Sans Flex Medium"/>
               </a:rPr>
-              <a:t>: [add the YouTube link on 17 Oct]</a:t>
+              <a:t>: https://drive.google.com/file/d/1R4uJceUVbF6Lt0R7gGpk-nVUlvT33xrd/view?usp=sharing</a:t>
             </a:r>
           </a:p>
           <a:p>
@@ -21045,6 +21045,285 @@
 </file>
 
 <file path=ppt/theme/theme1.xml><?xml version="1.0" encoding="utf-8"?>
+<a:theme xmlns:a="http://schemas.openxmlformats.org/drawingml/2006/main" xmlns:r="http://schemas.openxmlformats.org/officeDocument/2006/relationships" name="Simple Light">
+  <a:themeElements>
+    <a:clrScheme name="Simple Light">
+      <a:dk1>
+        <a:srgbClr val="000000"/>
+      </a:dk1>
+      <a:lt1>
+        <a:srgbClr val="FFFFFF"/>
+      </a:lt1>
+      <a:dk2>
+        <a:srgbClr val="595959"/>
+      </a:dk2>
+      <a:lt2>
+        <a:srgbClr val="EEEEEE"/>
+      </a:lt2>
+      <a:accent1>
+        <a:srgbClr val="4285F4"/>
+      </a:accent1>
+      <a:accent2>
+        <a:srgbClr val="212121"/>
+      </a:accent2>
+      <a:accent3>
+        <a:srgbClr val="78909C"/>
+      </a:accent3>
+      <a:accent4>
+        <a:srgbClr val="FFAB40"/>
+      </a:accent4>
+      <a:accent5>
+        <a:srgbClr val="0097A7"/>
+      </a:accent5>
+      <a:accent6>
+        <a:srgbClr val="EEFF41"/>
+      </a:accent6>
+      <a:hlink>
+        <a:srgbClr val="0097A7"/>
+      </a:hlink>
+      <a:folHlink>
+        <a:srgbClr val="0097A7"/>
+      </a:folHlink>
+    </a:clrScheme>
+    <a:fontScheme name="Office">
+      <a:majorFont>
+        <a:latin typeface="Arial"/>
+        <a:ea typeface=""/>
+        <a:cs typeface=""/>
+        <a:font script="Jpan" typeface="ＭＳ Ｐゴシック"/>
+        <a:font script="Hang" typeface="맑은 고딕"/>
+        <a:font script="Hans" typeface="宋体"/>
+        <a:font script="Hant" typeface="新細明體"/>
+        <a:font script="Arab" typeface="Times New Roman"/>
+        <a:font script="Hebr" typeface="Times New Roman"/>
+        <a:font script="Thai" typeface="Angsana New"/>
+        <a:font script="Ethi" typeface="Nyala"/>
+        <a:font script="Beng" typeface="Vrinda"/>
+        <a:font script="Gujr" typeface="Shruti"/>
+        <a:font script="Khmr" typeface="MoolBoran"/>
+        <a:font script="Knda" typeface="Tunga"/>
+        <a:font script="Guru" typeface="Raavi"/>
+        <a:font script="Cans" typeface="Euphemia"/>
+        <a:font script="Cher" typeface="Plantagenet Cherokee"/>
+        <a:font script="Yiii" typeface="Microsoft Yi Baiti"/>
+        <a:font script="Tibt" typeface="Microsoft Himalaya"/>
+        <a:font script="Thaa" typeface="MV Boli"/>
+        <a:font script="Deva" typeface="Mangal"/>
+        <a:font script="Telu" typeface="Gautami"/>
+        <a:font script="Taml" typeface="Latha"/>
+        <a:font script="Syrc" typeface="Estrangelo Edessa"/>
+        <a:font script="Orya" typeface="Kalinga"/>
+        <a:font script="Mlym" typeface="Kartika"/>
+        <a:font script="Laoo" typeface="DokChampa"/>
+        <a:font script="Sinh" typeface="Iskoola Pota"/>
+        <a:font script="Mong" typeface="Mongolian Baiti"/>
+        <a:font script="Viet" typeface="Times New Roman"/>
+        <a:font script="Uigh" typeface="Microsoft Uighur"/>
+        <a:font script="Geor" typeface="Sylfaen"/>
+      </a:majorFont>
+      <a:minorFont>
+        <a:latin typeface="Arial"/>
+        <a:ea typeface=""/>
+        <a:cs typeface=""/>
+        <a:font script="Jpan" typeface="ＭＳ Ｐゴシック"/>
+        <a:font script="Hang" typeface="맑은 고딕"/>
+        <a:font script="Hans" typeface="宋体"/>
+        <a:font script="Hant" typeface="新細明體"/>
+        <a:font script="Arab" typeface="Arial"/>
+        <a:font script="Hebr" typeface="Arial"/>
+        <a:font script="Thai" typeface="Cordia New"/>
+        <a:font script="Ethi" typeface="Nyala"/>
+        <a:font script="Beng" typeface="Vrinda"/>
+        <a:font script="Gujr" typeface="Shruti"/>
+        <a:font script="Khmr" typeface="DaunPenh"/>
+        <a:font script="Knda" typeface="Tunga"/>
+        <a:font script="Guru" typeface="Raavi"/>
+        <a:font script="Cans" typeface="Euphemia"/>
+        <a:font script="Cher" typeface="Plantagenet Cherokee"/>
+        <a:font script="Yiii" typeface="Microsoft Yi Baiti"/>
+        <a:font script="Tibt" typeface="Microsoft Himalaya"/>
+        <a:font script="Thaa" typeface="MV Boli"/>
+        <a:font script="Deva" typeface="Mangal"/>
+        <a:font script="Telu" typeface="Gautami"/>
+        <a:font script="Taml" typeface="Latha"/>
+        <a:font script="Syrc" typeface="Estrangelo Edessa"/>
+        <a:font script="Orya" typeface="Kalinga"/>
+        <a:font script="Mlym" typeface="Kartika"/>
+        <a:font script="Laoo" typeface="DokChampa"/>
+        <a:font script="Sinh" typeface="Iskoola Pota"/>
+        <a:font script="Mong" typeface="Mongolian Baiti"/>
+        <a:font script="Viet" typeface="Arial"/>
+        <a:font script="Uigh" typeface="Microsoft Uighur"/>
+        <a:font script="Geor" typeface="Sylfaen"/>
+      </a:minorFont>
+    </a:fontScheme>
+    <a:fmtScheme name="Office">
+      <a:fillStyleLst>
+        <a:solidFill>
+          <a:schemeClr val="phClr"/>
+        </a:solidFill>
+        <a:gradFill rotWithShape="1">
+          <a:gsLst>
+            <a:gs pos="0">
+              <a:schemeClr val="phClr">
+                <a:tint val="50000"/>
+                <a:satMod val="300000"/>
+              </a:schemeClr>
+            </a:gs>
+            <a:gs pos="35000">
+              <a:schemeClr val="phClr">
+                <a:tint val="37000"/>
+                <a:satMod val="300000"/>
+              </a:schemeClr>
+            </a:gs>
+            <a:gs pos="100000">
+              <a:schemeClr val="phClr">
+                <a:tint val="15000"/>
+                <a:satMod val="350000"/>
+              </a:schemeClr>
+            </a:gs>
+          </a:gsLst>
+          <a:lin ang="16200000" scaled="1"/>
+        </a:gradFill>
+        <a:gradFill rotWithShape="1">
+          <a:gsLst>
+            <a:gs pos="0">
+              <a:schemeClr val="phClr">
+                <a:tint val="100000"/>
+                <a:shade val="100000"/>
+                <a:satMod val="130000"/>
+              </a:schemeClr>
+            </a:gs>
+            <a:gs pos="100000">
+              <a:schemeClr val="phClr">
+                <a:tint val="50000"/>
+                <a:shade val="100000"/>
+                <a:satMod val="350000"/>
+              </a:schemeClr>
+            </a:gs>
+          </a:gsLst>
+          <a:lin ang="16200000" scaled="0"/>
+        </a:gradFill>
+      </a:fillStyleLst>
+      <a:lnStyleLst>
+        <a:ln w="9525" cap="flat" cmpd="sng" algn="ctr">
+          <a:solidFill>
+            <a:schemeClr val="phClr">
+              <a:shade val="95000"/>
+              <a:satMod val="105000"/>
+            </a:schemeClr>
+          </a:solidFill>
+          <a:prstDash val="solid"/>
+        </a:ln>
+        <a:ln w="25400" cap="flat" cmpd="sng" algn="ctr">
+          <a:solidFill>
+            <a:schemeClr val="phClr"/>
+          </a:solidFill>
+          <a:prstDash val="solid"/>
+        </a:ln>
+        <a:ln w="38100" cap="flat" cmpd="sng" algn="ctr">
+          <a:solidFill>
+            <a:schemeClr val="phClr"/>
+          </a:solidFill>
+          <a:prstDash val="solid"/>
+        </a:ln>
+      </a:lnStyleLst>
+      <a:effectStyleLst>
+        <a:effectStyle>
+          <a:effectLst>
+            <a:outerShdw blurRad="40000" dist="20000" dir="5400000" rotWithShape="0">
+              <a:srgbClr val="000000">
+                <a:alpha val="38000"/>
+              </a:srgbClr>
+            </a:outerShdw>
+          </a:effectLst>
+        </a:effectStyle>
+        <a:effectStyle>
+          <a:effectLst>
+            <a:outerShdw blurRad="40000" dist="23000" dir="5400000" rotWithShape="0">
+              <a:srgbClr val="000000">
+                <a:alpha val="35000"/>
+              </a:srgbClr>
+            </a:outerShdw>
+          </a:effectLst>
+        </a:effectStyle>
+        <a:effectStyle>
+          <a:effectLst>
+            <a:outerShdw blurRad="40000" dist="23000" dir="5400000" rotWithShape="0">
+              <a:srgbClr val="000000">
+                <a:alpha val="35000"/>
+              </a:srgbClr>
+            </a:outerShdw>
+          </a:effectLst>
+          <a:scene3d>
+            <a:camera prst="orthographicFront">
+              <a:rot lat="0" lon="0" rev="0"/>
+            </a:camera>
+            <a:lightRig rig="threePt" dir="t">
+              <a:rot lat="0" lon="0" rev="1200000"/>
+            </a:lightRig>
+          </a:scene3d>
+          <a:sp3d>
+            <a:bevelT w="63500" h="25400"/>
+          </a:sp3d>
+        </a:effectStyle>
+      </a:effectStyleLst>
+      <a:bgFillStyleLst>
+        <a:solidFill>
+          <a:schemeClr val="phClr"/>
+        </a:solidFill>
+        <a:gradFill rotWithShape="1">
+          <a:gsLst>
+            <a:gs pos="0">
+              <a:schemeClr val="phClr">
+                <a:tint val="40000"/>
+                <a:satMod val="350000"/>
+              </a:schemeClr>
+            </a:gs>
+            <a:gs pos="40000">
+              <a:schemeClr val="phClr">
+                <a:tint val="45000"/>
+                <a:shade val="99000"/>
+                <a:satMod val="350000"/>
+              </a:schemeClr>
+            </a:gs>
+            <a:gs pos="100000">
+              <a:schemeClr val="phClr">
+                <a:shade val="20000"/>
+                <a:satMod val="255000"/>
+              </a:schemeClr>
+            </a:gs>
+          </a:gsLst>
+          <a:path path="circle">
+            <a:fillToRect l="50000" t="-80000" r="50000" b="180000"/>
+          </a:path>
+        </a:gradFill>
+        <a:gradFill rotWithShape="1">
+          <a:gsLst>
+            <a:gs pos="0">
+              <a:schemeClr val="phClr">
+                <a:tint val="80000"/>
+                <a:satMod val="300000"/>
+              </a:schemeClr>
+            </a:gs>
+            <a:gs pos="100000">
+              <a:schemeClr val="phClr">
+                <a:shade val="30000"/>
+                <a:satMod val="200000"/>
+              </a:schemeClr>
+            </a:gs>
+          </a:gsLst>
+          <a:path path="circle">
+            <a:fillToRect l="50000" t="50000" r="50000" b="50000"/>
+          </a:path>
+        </a:gradFill>
+      </a:bgFillStyleLst>
+    </a:fmtScheme>
+  </a:themeElements>
+</a:theme>
+</file>
+
+<file path=ppt/theme/theme2.xml><?xml version="1.0" encoding="utf-8"?>
 <a:theme xmlns:a="http://schemas.openxmlformats.org/drawingml/2006/main" xmlns:r="http://schemas.openxmlformats.org/officeDocument/2006/relationships">
   <a:themeElements>
     <a:clrScheme name="Default">
@@ -21321,283 +21600,4 @@
     </a:fmtScheme>
   </a:themeElements>
 </a:theme>
-</file>
-
-<file path=ppt/theme/theme2.xml><?xml version="1.0" encoding="utf-8"?>
-<a:theme xmlns:a="http://schemas.openxmlformats.org/drawingml/2006/main" xmlns:r="http://schemas.openxmlformats.org/officeDocument/2006/relationships" name="Simple Light">
-  <a:themeElements>
-    <a:clrScheme name="Simple Light">
-      <a:dk1>
-        <a:srgbClr val="000000"/>
-      </a:dk1>
-      <a:lt1>
-        <a:srgbClr val="FFFFFF"/>
-      </a:lt1>
-      <a:dk2>
-        <a:srgbClr val="595959"/>
-      </a:dk2>
-      <a:lt2>
-        <a:srgbClr val="EEEEEE"/>
-      </a:lt2>
-      <a:accent1>
-        <a:srgbClr val="4285F4"/>
-      </a:accent1>
-      <a:accent2>
-        <a:srgbClr val="212121"/>
-      </a:accent2>
-      <a:accent3>
-        <a:srgbClr val="78909C"/>
-      </a:accent3>
-      <a:accent4>
-        <a:srgbClr val="FFAB40"/>
-      </a:accent4>
-      <a:accent5>
-        <a:srgbClr val="0097A7"/>
-      </a:accent5>
-      <a:accent6>
-        <a:srgbClr val="EEFF41"/>
-      </a:accent6>
-      <a:hlink>
-        <a:srgbClr val="0097A7"/>
-      </a:hlink>
-      <a:folHlink>
-        <a:srgbClr val="0097A7"/>
-      </a:folHlink>
-    </a:clrScheme>
-    <a:fontScheme name="Office">
-      <a:majorFont>
-        <a:latin typeface="Arial"/>
-        <a:ea typeface=""/>
-        <a:cs typeface=""/>
-        <a:font script="Jpan" typeface="ＭＳ Ｐゴシック"/>
-        <a:font script="Hang" typeface="맑은 고딕"/>
-        <a:font script="Hans" typeface="宋体"/>
-        <a:font script="Hant" typeface="新細明體"/>
-        <a:font script="Arab" typeface="Times New Roman"/>
-        <a:font script="Hebr" typeface="Times New Roman"/>
-        <a:font script="Thai" typeface="Angsana New"/>
-        <a:font script="Ethi" typeface="Nyala"/>
-        <a:font script="Beng" typeface="Vrinda"/>
-        <a:font script="Gujr" typeface="Shruti"/>
-        <a:font script="Khmr" typeface="MoolBoran"/>
-        <a:font script="Knda" typeface="Tunga"/>
-        <a:font script="Guru" typeface="Raavi"/>
-        <a:font script="Cans" typeface="Euphemia"/>
-        <a:font script="Cher" typeface="Plantagenet Cherokee"/>
-        <a:font script="Yiii" typeface="Microsoft Yi Baiti"/>
-        <a:font script="Tibt" typeface="Microsoft Himalaya"/>
-        <a:font script="Thaa" typeface="MV Boli"/>
-        <a:font script="Deva" typeface="Mangal"/>
-        <a:font script="Telu" typeface="Gautami"/>
-        <a:font script="Taml" typeface="Latha"/>
-        <a:font script="Syrc" typeface="Estrangelo Edessa"/>
-        <a:font script="Orya" typeface="Kalinga"/>
-        <a:font script="Mlym" typeface="Kartika"/>
-        <a:font script="Laoo" typeface="DokChampa"/>
-        <a:font script="Sinh" typeface="Iskoola Pota"/>
-        <a:font script="Mong" typeface="Mongolian Baiti"/>
-        <a:font script="Viet" typeface="Times New Roman"/>
-        <a:font script="Uigh" typeface="Microsoft Uighur"/>
-        <a:font script="Geor" typeface="Sylfaen"/>
-      </a:majorFont>
-      <a:minorFont>
-        <a:latin typeface="Arial"/>
-        <a:ea typeface=""/>
-        <a:cs typeface=""/>
-        <a:font script="Jpan" typeface="ＭＳ Ｐゴシック"/>
-        <a:font script="Hang" typeface="맑은 고딕"/>
-        <a:font script="Hans" typeface="宋体"/>
-        <a:font script="Hant" typeface="新細明體"/>
-        <a:font script="Arab" typeface="Arial"/>
-        <a:font script="Hebr" typeface="Arial"/>
-        <a:font script="Thai" typeface="Cordia New"/>
-        <a:font script="Ethi" typeface="Nyala"/>
-        <a:font script="Beng" typeface="Vrinda"/>
-        <a:font script="Gujr" typeface="Shruti"/>
-        <a:font script="Khmr" typeface="DaunPenh"/>
-        <a:font script="Knda" typeface="Tunga"/>
-        <a:font script="Guru" typeface="Raavi"/>
-        <a:font script="Cans" typeface="Euphemia"/>
-        <a:font script="Cher" typeface="Plantagenet Cherokee"/>
-        <a:font script="Yiii" typeface="Microsoft Yi Baiti"/>
-        <a:font script="Tibt" typeface="Microsoft Himalaya"/>
-        <a:font script="Thaa" typeface="MV Boli"/>
-        <a:font script="Deva" typeface="Mangal"/>
-        <a:font script="Telu" typeface="Gautami"/>
-        <a:font script="Taml" typeface="Latha"/>
-        <a:font script="Syrc" typeface="Estrangelo Edessa"/>
-        <a:font script="Orya" typeface="Kalinga"/>
-        <a:font script="Mlym" typeface="Kartika"/>
-        <a:font script="Laoo" typeface="DokChampa"/>
-        <a:font script="Sinh" typeface="Iskoola Pota"/>
-        <a:font script="Mong" typeface="Mongolian Baiti"/>
-        <a:font script="Viet" typeface="Arial"/>
-        <a:font script="Uigh" typeface="Microsoft Uighur"/>
-        <a:font script="Geor" typeface="Sylfaen"/>
-      </a:minorFont>
-    </a:fontScheme>
-    <a:fmtScheme name="Office">
-      <a:fillStyleLst>
-        <a:solidFill>
-          <a:schemeClr val="phClr"/>
-        </a:solidFill>
-        <a:gradFill rotWithShape="1">
-          <a:gsLst>
-            <a:gs pos="0">
-              <a:schemeClr val="phClr">
-                <a:tint val="50000"/>
-                <a:satMod val="300000"/>
-              </a:schemeClr>
-            </a:gs>
-            <a:gs pos="35000">
-              <a:schemeClr val="phClr">
-                <a:tint val="37000"/>
-                <a:satMod val="300000"/>
-              </a:schemeClr>
-            </a:gs>
-            <a:gs pos="100000">
-              <a:schemeClr val="phClr">
-                <a:tint val="15000"/>
-                <a:satMod val="350000"/>
-              </a:schemeClr>
-            </a:gs>
-          </a:gsLst>
-          <a:lin ang="16200000" scaled="1"/>
-        </a:gradFill>
-        <a:gradFill rotWithShape="1">
-          <a:gsLst>
-            <a:gs pos="0">
-              <a:schemeClr val="phClr">
-                <a:tint val="100000"/>
-                <a:shade val="100000"/>
-                <a:satMod val="130000"/>
-              </a:schemeClr>
-            </a:gs>
-            <a:gs pos="100000">
-              <a:schemeClr val="phClr">
-                <a:tint val="50000"/>
-                <a:shade val="100000"/>
-                <a:satMod val="350000"/>
-              </a:schemeClr>
-            </a:gs>
-          </a:gsLst>
-          <a:lin ang="16200000" scaled="0"/>
-        </a:gradFill>
-      </a:fillStyleLst>
-      <a:lnStyleLst>
-        <a:ln w="9525" cap="flat" cmpd="sng" algn="ctr">
-          <a:solidFill>
-            <a:schemeClr val="phClr">
-              <a:shade val="95000"/>
-              <a:satMod val="105000"/>
-            </a:schemeClr>
-          </a:solidFill>
-          <a:prstDash val="solid"/>
-        </a:ln>
-        <a:ln w="25400" cap="flat" cmpd="sng" algn="ctr">
-          <a:solidFill>
-            <a:schemeClr val="phClr"/>
-          </a:solidFill>
-          <a:prstDash val="solid"/>
-        </a:ln>
-        <a:ln w="38100" cap="flat" cmpd="sng" algn="ctr">
-          <a:solidFill>
-            <a:schemeClr val="phClr"/>
-          </a:solidFill>
-          <a:prstDash val="solid"/>
-        </a:ln>
-      </a:lnStyleLst>
-      <a:effectStyleLst>
-        <a:effectStyle>
-          <a:effectLst>
-            <a:outerShdw blurRad="40000" dist="20000" dir="5400000" rotWithShape="0">
-              <a:srgbClr val="000000">
-                <a:alpha val="38000"/>
-              </a:srgbClr>
-            </a:outerShdw>
-          </a:effectLst>
-        </a:effectStyle>
-        <a:effectStyle>
-          <a:effectLst>
-            <a:outerShdw blurRad="40000" dist="23000" dir="5400000" rotWithShape="0">
-              <a:srgbClr val="000000">
-                <a:alpha val="35000"/>
-              </a:srgbClr>
-            </a:outerShdw>
-          </a:effectLst>
-        </a:effectStyle>
-        <a:effectStyle>
-          <a:effectLst>
-            <a:outerShdw blurRad="40000" dist="23000" dir="5400000" rotWithShape="0">
-              <a:srgbClr val="000000">
-                <a:alpha val="35000"/>
-              </a:srgbClr>
-            </a:outerShdw>
-          </a:effectLst>
-          <a:scene3d>
-            <a:camera prst="orthographicFront">
-              <a:rot lat="0" lon="0" rev="0"/>
-            </a:camera>
-            <a:lightRig rig="threePt" dir="t">
-              <a:rot lat="0" lon="0" rev="1200000"/>
-            </a:lightRig>
-          </a:scene3d>
-          <a:sp3d>
-            <a:bevelT w="63500" h="25400"/>
-          </a:sp3d>
-        </a:effectStyle>
-      </a:effectStyleLst>
-      <a:bgFillStyleLst>
-        <a:solidFill>
-          <a:schemeClr val="phClr"/>
-        </a:solidFill>
-        <a:gradFill rotWithShape="1">
-          <a:gsLst>
-            <a:gs pos="0">
-              <a:schemeClr val="phClr">
-                <a:tint val="40000"/>
-                <a:satMod val="350000"/>
-              </a:schemeClr>
-            </a:gs>
-            <a:gs pos="40000">
-              <a:schemeClr val="phClr">
-                <a:tint val="45000"/>
-                <a:shade val="99000"/>
-                <a:satMod val="350000"/>
-              </a:schemeClr>
-            </a:gs>
-            <a:gs pos="100000">
-              <a:schemeClr val="phClr">
-                <a:shade val="20000"/>
-                <a:satMod val="255000"/>
-              </a:schemeClr>
-            </a:gs>
-          </a:gsLst>
-          <a:path path="circle">
-            <a:fillToRect l="50000" t="-80000" r="50000" b="180000"/>
-          </a:path>
-        </a:gradFill>
-        <a:gradFill rotWithShape="1">
-          <a:gsLst>
-            <a:gs pos="0">
-              <a:schemeClr val="phClr">
-                <a:tint val="80000"/>
-                <a:satMod val="300000"/>
-              </a:schemeClr>
-            </a:gs>
-            <a:gs pos="100000">
-              <a:schemeClr val="phClr">
-                <a:shade val="30000"/>
-                <a:satMod val="200000"/>
-              </a:schemeClr>
-            </a:gs>
-          </a:gsLst>
-          <a:path path="circle">
-            <a:fillToRect l="50000" t="50000" r="50000" b="50000"/>
-          </a:path>
-        </a:gradFill>
-      </a:bgFillStyleLst>
-    </a:fmtScheme>
-  </a:themeElements>
-</a:theme>
 </file>
</xml_diff>

<commit_message>
docs: deck links are clickable in the PDF
</commit_message>
<xml_diff>
--- a/docs/submission/BreederNear-AI-deck.pptx
+++ b/docs/submission/BreederNear-AI-deck.pptx
@@ -9531,6 +9531,7 @@
                 <a:ea typeface="Google Sans Flex Medium"/>
                 <a:cs typeface="Google Sans Flex Medium"/>
                 <a:sym typeface="Google Sans Flex Medium"/>
+                <a:hlinkClick r:id="rId5"/>
               </a:rPr>
               <a:t>: https://github.com/sudarsan-22/breedernear-ai</a:t>
             </a:r>
@@ -9571,6 +9572,7 @@
                 <a:ea typeface="Google Sans Flex Medium"/>
                 <a:cs typeface="Google Sans Flex Medium"/>
                 <a:sym typeface="Google Sans Flex Medium"/>
+                <a:hlinkClick r:id="rId6"/>
               </a:rPr>
               <a:t>: https://drive.google.com/file/d/1R4uJceUVbF6Lt0R7gGpk-nVUlvT33xrd/view?usp=sharing</a:t>
             </a:r>
@@ -9611,6 +9613,7 @@
                 <a:ea typeface="Google Sans Flex Medium"/>
                 <a:cs typeface="Google Sans Flex Medium"/>
                 <a:sym typeface="Google Sans Flex Medium"/>
+                <a:hlinkClick r:id="rId7"/>
               </a:rPr>
               <a:t>: https://breedernear-ai-2026.web.app  (API: https://breedernear-655711985039.asia-south1.run.app)</a:t>
             </a:r>
@@ -21045,6 +21048,285 @@
 </file>
 
 <file path=ppt/theme/theme1.xml><?xml version="1.0" encoding="utf-8"?>
+<a:theme xmlns:a="http://schemas.openxmlformats.org/drawingml/2006/main" xmlns:r="http://schemas.openxmlformats.org/officeDocument/2006/relationships">
+  <a:themeElements>
+    <a:clrScheme name="Default">
+      <a:dk1>
+        <a:srgbClr val="000000"/>
+      </a:dk1>
+      <a:lt1>
+        <a:srgbClr val="FFFFFF"/>
+      </a:lt1>
+      <a:dk2>
+        <a:srgbClr val="158158"/>
+      </a:dk2>
+      <a:lt2>
+        <a:srgbClr val="F3F3F3"/>
+      </a:lt2>
+      <a:accent1>
+        <a:srgbClr val="058DC7"/>
+      </a:accent1>
+      <a:accent2>
+        <a:srgbClr val="50B432"/>
+      </a:accent2>
+      <a:accent3>
+        <a:srgbClr val="ED561B"/>
+      </a:accent3>
+      <a:accent4>
+        <a:srgbClr val="EDEF00"/>
+      </a:accent4>
+      <a:accent5>
+        <a:srgbClr val="24CBE5"/>
+      </a:accent5>
+      <a:accent6>
+        <a:srgbClr val="64E572"/>
+      </a:accent6>
+      <a:hlink>
+        <a:srgbClr val="2200CC"/>
+      </a:hlink>
+      <a:folHlink>
+        <a:srgbClr val="551A8B"/>
+      </a:folHlink>
+    </a:clrScheme>
+    <a:fontScheme name="Office">
+      <a:majorFont>
+        <a:latin typeface="Arial"/>
+        <a:ea typeface=""/>
+        <a:cs typeface=""/>
+        <a:font script="Jpan" typeface="ＭＳ Ｐゴシック"/>
+        <a:font script="Hang" typeface="맑은 고딕"/>
+        <a:font script="Hans" typeface="宋体"/>
+        <a:font script="Hant" typeface="新細明體"/>
+        <a:font script="Arab" typeface="Times New Roman"/>
+        <a:font script="Hebr" typeface="Times New Roman"/>
+        <a:font script="Thai" typeface="Angsana New"/>
+        <a:font script="Ethi" typeface="Nyala"/>
+        <a:font script="Beng" typeface="Vrinda"/>
+        <a:font script="Gujr" typeface="Shruti"/>
+        <a:font script="Khmr" typeface="MoolBoran"/>
+        <a:font script="Knda" typeface="Tunga"/>
+        <a:font script="Guru" typeface="Raavi"/>
+        <a:font script="Cans" typeface="Euphemia"/>
+        <a:font script="Cher" typeface="Plantagenet Cherokee"/>
+        <a:font script="Yiii" typeface="Microsoft Yi Baiti"/>
+        <a:font script="Tibt" typeface="Microsoft Himalaya"/>
+        <a:font script="Thaa" typeface="MV Boli"/>
+        <a:font script="Deva" typeface="Mangal"/>
+        <a:font script="Telu" typeface="Gautami"/>
+        <a:font script="Taml" typeface="Latha"/>
+        <a:font script="Syrc" typeface="Estrangelo Edessa"/>
+        <a:font script="Orya" typeface="Kalinga"/>
+        <a:font script="Mlym" typeface="Kartika"/>
+        <a:font script="Laoo" typeface="DokChampa"/>
+        <a:font script="Sinh" typeface="Iskoola Pota"/>
+        <a:font script="Mong" typeface="Mongolian Baiti"/>
+        <a:font script="Viet" typeface="Times New Roman"/>
+        <a:font script="Uigh" typeface="Microsoft Uighur"/>
+        <a:font script="Geor" typeface="Sylfaen"/>
+      </a:majorFont>
+      <a:minorFont>
+        <a:latin typeface="Arial"/>
+        <a:ea typeface=""/>
+        <a:cs typeface=""/>
+        <a:font script="Jpan" typeface="ＭＳ Ｐゴシック"/>
+        <a:font script="Hang" typeface="맑은 고딕"/>
+        <a:font script="Hans" typeface="宋体"/>
+        <a:font script="Hant" typeface="新細明體"/>
+        <a:font script="Arab" typeface="Arial"/>
+        <a:font script="Hebr" typeface="Arial"/>
+        <a:font script="Thai" typeface="Cordia New"/>
+        <a:font script="Ethi" typeface="Nyala"/>
+        <a:font script="Beng" typeface="Vrinda"/>
+        <a:font script="Gujr" typeface="Shruti"/>
+        <a:font script="Khmr" typeface="DaunPenh"/>
+        <a:font script="Knda" typeface="Tunga"/>
+        <a:font script="Guru" typeface="Raavi"/>
+        <a:font script="Cans" typeface="Euphemia"/>
+        <a:font script="Cher" typeface="Plantagenet Cherokee"/>
+        <a:font script="Yiii" typeface="Microsoft Yi Baiti"/>
+        <a:font script="Tibt" typeface="Microsoft Himalaya"/>
+        <a:font script="Thaa" typeface="MV Boli"/>
+        <a:font script="Deva" typeface="Mangal"/>
+        <a:font script="Telu" typeface="Gautami"/>
+        <a:font script="Taml" typeface="Latha"/>
+        <a:font script="Syrc" typeface="Estrangelo Edessa"/>
+        <a:font script="Orya" typeface="Kalinga"/>
+        <a:font script="Mlym" typeface="Kartika"/>
+        <a:font script="Laoo" typeface="DokChampa"/>
+        <a:font script="Sinh" typeface="Iskoola Pota"/>
+        <a:font script="Mong" typeface="Mongolian Baiti"/>
+        <a:font script="Viet" typeface="Arial"/>
+        <a:font script="Uigh" typeface="Microsoft Uighur"/>
+        <a:font script="Geor" typeface="Sylfaen"/>
+      </a:minorFont>
+    </a:fontScheme>
+    <a:fmtScheme name="Office">
+      <a:fillStyleLst>
+        <a:solidFill>
+          <a:schemeClr val="phClr"/>
+        </a:solidFill>
+        <a:gradFill rotWithShape="1">
+          <a:gsLst>
+            <a:gs pos="0">
+              <a:schemeClr val="phClr">
+                <a:tint val="50000"/>
+                <a:satMod val="300000"/>
+              </a:schemeClr>
+            </a:gs>
+            <a:gs pos="35000">
+              <a:schemeClr val="phClr">
+                <a:tint val="37000"/>
+                <a:satMod val="300000"/>
+              </a:schemeClr>
+            </a:gs>
+            <a:gs pos="100000">
+              <a:schemeClr val="phClr">
+                <a:tint val="15000"/>
+                <a:satMod val="350000"/>
+              </a:schemeClr>
+            </a:gs>
+          </a:gsLst>
+          <a:lin ang="16200000" scaled="1"/>
+        </a:gradFill>
+        <a:gradFill rotWithShape="1">
+          <a:gsLst>
+            <a:gs pos="0">
+              <a:schemeClr val="phClr">
+                <a:tint val="100000"/>
+                <a:shade val="100000"/>
+                <a:satMod val="130000"/>
+              </a:schemeClr>
+            </a:gs>
+            <a:gs pos="100000">
+              <a:schemeClr val="phClr">
+                <a:tint val="50000"/>
+                <a:shade val="100000"/>
+                <a:satMod val="350000"/>
+              </a:schemeClr>
+            </a:gs>
+          </a:gsLst>
+          <a:lin ang="16200000" scaled="0"/>
+        </a:gradFill>
+      </a:fillStyleLst>
+      <a:lnStyleLst>
+        <a:ln w="9525" cap="flat" cmpd="sng" algn="ctr">
+          <a:solidFill>
+            <a:schemeClr val="phClr">
+              <a:shade val="95000"/>
+              <a:satMod val="105000"/>
+            </a:schemeClr>
+          </a:solidFill>
+          <a:prstDash val="solid"/>
+        </a:ln>
+        <a:ln w="25400" cap="flat" cmpd="sng" algn="ctr">
+          <a:solidFill>
+            <a:schemeClr val="phClr"/>
+          </a:solidFill>
+          <a:prstDash val="solid"/>
+        </a:ln>
+        <a:ln w="38100" cap="flat" cmpd="sng" algn="ctr">
+          <a:solidFill>
+            <a:schemeClr val="phClr"/>
+          </a:solidFill>
+          <a:prstDash val="solid"/>
+        </a:ln>
+      </a:lnStyleLst>
+      <a:effectStyleLst>
+        <a:effectStyle>
+          <a:effectLst>
+            <a:outerShdw blurRad="40000" dist="20000" dir="5400000" rotWithShape="0">
+              <a:srgbClr val="000000">
+                <a:alpha val="38000"/>
+              </a:srgbClr>
+            </a:outerShdw>
+          </a:effectLst>
+        </a:effectStyle>
+        <a:effectStyle>
+          <a:effectLst>
+            <a:outerShdw blurRad="40000" dist="23000" dir="5400000" rotWithShape="0">
+              <a:srgbClr val="000000">
+                <a:alpha val="35000"/>
+              </a:srgbClr>
+            </a:outerShdw>
+          </a:effectLst>
+        </a:effectStyle>
+        <a:effectStyle>
+          <a:effectLst>
+            <a:outerShdw blurRad="40000" dist="23000" dir="5400000" rotWithShape="0">
+              <a:srgbClr val="000000">
+                <a:alpha val="35000"/>
+              </a:srgbClr>
+            </a:outerShdw>
+          </a:effectLst>
+          <a:scene3d>
+            <a:camera prst="orthographicFront">
+              <a:rot lat="0" lon="0" rev="0"/>
+            </a:camera>
+            <a:lightRig rig="threePt" dir="t">
+              <a:rot lat="0" lon="0" rev="1200000"/>
+            </a:lightRig>
+          </a:scene3d>
+          <a:sp3d>
+            <a:bevelT w="63500" h="25400"/>
+          </a:sp3d>
+        </a:effectStyle>
+      </a:effectStyleLst>
+      <a:bgFillStyleLst>
+        <a:solidFill>
+          <a:schemeClr val="phClr"/>
+        </a:solidFill>
+        <a:gradFill rotWithShape="1">
+          <a:gsLst>
+            <a:gs pos="0">
+              <a:schemeClr val="phClr">
+                <a:tint val="40000"/>
+                <a:satMod val="350000"/>
+              </a:schemeClr>
+            </a:gs>
+            <a:gs pos="40000">
+              <a:schemeClr val="phClr">
+                <a:tint val="45000"/>
+                <a:shade val="99000"/>
+                <a:satMod val="350000"/>
+              </a:schemeClr>
+            </a:gs>
+            <a:gs pos="100000">
+              <a:schemeClr val="phClr">
+                <a:shade val="20000"/>
+                <a:satMod val="255000"/>
+              </a:schemeClr>
+            </a:gs>
+          </a:gsLst>
+          <a:path path="circle">
+            <a:fillToRect l="50000" t="-80000" r="50000" b="180000"/>
+          </a:path>
+        </a:gradFill>
+        <a:gradFill rotWithShape="1">
+          <a:gsLst>
+            <a:gs pos="0">
+              <a:schemeClr val="phClr">
+                <a:tint val="80000"/>
+                <a:satMod val="300000"/>
+              </a:schemeClr>
+            </a:gs>
+            <a:gs pos="100000">
+              <a:schemeClr val="phClr">
+                <a:shade val="30000"/>
+                <a:satMod val="200000"/>
+              </a:schemeClr>
+            </a:gs>
+          </a:gsLst>
+          <a:path path="circle">
+            <a:fillToRect l="50000" t="50000" r="50000" b="50000"/>
+          </a:path>
+        </a:gradFill>
+      </a:bgFillStyleLst>
+    </a:fmtScheme>
+  </a:themeElements>
+</a:theme>
+</file>
+
+<file path=ppt/theme/theme2.xml><?xml version="1.0" encoding="utf-8"?>
 <a:theme xmlns:a="http://schemas.openxmlformats.org/drawingml/2006/main" xmlns:r="http://schemas.openxmlformats.org/officeDocument/2006/relationships" name="Simple Light">
   <a:themeElements>
     <a:clrScheme name="Simple Light">
@@ -21321,283 +21603,4 @@
     </a:fmtScheme>
   </a:themeElements>
 </a:theme>
-</file>
-
-<file path=ppt/theme/theme2.xml><?xml version="1.0" encoding="utf-8"?>
-<a:theme xmlns:a="http://schemas.openxmlformats.org/drawingml/2006/main" xmlns:r="http://schemas.openxmlformats.org/officeDocument/2006/relationships">
-  <a:themeElements>
-    <a:clrScheme name="Default">
-      <a:dk1>
-        <a:srgbClr val="000000"/>
-      </a:dk1>
-      <a:lt1>
-        <a:srgbClr val="FFFFFF"/>
-      </a:lt1>
-      <a:dk2>
-        <a:srgbClr val="158158"/>
-      </a:dk2>
-      <a:lt2>
-        <a:srgbClr val="F3F3F3"/>
-      </a:lt2>
-      <a:accent1>
-        <a:srgbClr val="058DC7"/>
-      </a:accent1>
-      <a:accent2>
-        <a:srgbClr val="50B432"/>
-      </a:accent2>
-      <a:accent3>
-        <a:srgbClr val="ED561B"/>
-      </a:accent3>
-      <a:accent4>
-        <a:srgbClr val="EDEF00"/>
-      </a:accent4>
-      <a:accent5>
-        <a:srgbClr val="24CBE5"/>
-      </a:accent5>
-      <a:accent6>
-        <a:srgbClr val="64E572"/>
-      </a:accent6>
-      <a:hlink>
-        <a:srgbClr val="2200CC"/>
-      </a:hlink>
-      <a:folHlink>
-        <a:srgbClr val="551A8B"/>
-      </a:folHlink>
-    </a:clrScheme>
-    <a:fontScheme name="Office">
-      <a:majorFont>
-        <a:latin typeface="Arial"/>
-        <a:ea typeface=""/>
-        <a:cs typeface=""/>
-        <a:font script="Jpan" typeface="ＭＳ Ｐゴシック"/>
-        <a:font script="Hang" typeface="맑은 고딕"/>
-        <a:font script="Hans" typeface="宋体"/>
-        <a:font script="Hant" typeface="新細明體"/>
-        <a:font script="Arab" typeface="Times New Roman"/>
-        <a:font script="Hebr" typeface="Times New Roman"/>
-        <a:font script="Thai" typeface="Angsana New"/>
-        <a:font script="Ethi" typeface="Nyala"/>
-        <a:font script="Beng" typeface="Vrinda"/>
-        <a:font script="Gujr" typeface="Shruti"/>
-        <a:font script="Khmr" typeface="MoolBoran"/>
-        <a:font script="Knda" typeface="Tunga"/>
-        <a:font script="Guru" typeface="Raavi"/>
-        <a:font script="Cans" typeface="Euphemia"/>
-        <a:font script="Cher" typeface="Plantagenet Cherokee"/>
-        <a:font script="Yiii" typeface="Microsoft Yi Baiti"/>
-        <a:font script="Tibt" typeface="Microsoft Himalaya"/>
-        <a:font script="Thaa" typeface="MV Boli"/>
-        <a:font script="Deva" typeface="Mangal"/>
-        <a:font script="Telu" typeface="Gautami"/>
-        <a:font script="Taml" typeface="Latha"/>
-        <a:font script="Syrc" typeface="Estrangelo Edessa"/>
-        <a:font script="Orya" typeface="Kalinga"/>
-        <a:font script="Mlym" typeface="Kartika"/>
-        <a:font script="Laoo" typeface="DokChampa"/>
-        <a:font script="Sinh" typeface="Iskoola Pota"/>
-        <a:font script="Mong" typeface="Mongolian Baiti"/>
-        <a:font script="Viet" typeface="Times New Roman"/>
-        <a:font script="Uigh" typeface="Microsoft Uighur"/>
-        <a:font script="Geor" typeface="Sylfaen"/>
-      </a:majorFont>
-      <a:minorFont>
-        <a:latin typeface="Arial"/>
-        <a:ea typeface=""/>
-        <a:cs typeface=""/>
-        <a:font script="Jpan" typeface="ＭＳ Ｐゴシック"/>
-        <a:font script="Hang" typeface="맑은 고딕"/>
-        <a:font script="Hans" typeface="宋体"/>
-        <a:font script="Hant" typeface="新細明體"/>
-        <a:font script="Arab" typeface="Arial"/>
-        <a:font script="Hebr" typeface="Arial"/>
-        <a:font script="Thai" typeface="Cordia New"/>
-        <a:font script="Ethi" typeface="Nyala"/>
-        <a:font script="Beng" typeface="Vrinda"/>
-        <a:font script="Gujr" typeface="Shruti"/>
-        <a:font script="Khmr" typeface="DaunPenh"/>
-        <a:font script="Knda" typeface="Tunga"/>
-        <a:font script="Guru" typeface="Raavi"/>
-        <a:font script="Cans" typeface="Euphemia"/>
-        <a:font script="Cher" typeface="Plantagenet Cherokee"/>
-        <a:font script="Yiii" typeface="Microsoft Yi Baiti"/>
-        <a:font script="Tibt" typeface="Microsoft Himalaya"/>
-        <a:font script="Thaa" typeface="MV Boli"/>
-        <a:font script="Deva" typeface="Mangal"/>
-        <a:font script="Telu" typeface="Gautami"/>
-        <a:font script="Taml" typeface="Latha"/>
-        <a:font script="Syrc" typeface="Estrangelo Edessa"/>
-        <a:font script="Orya" typeface="Kalinga"/>
-        <a:font script="Mlym" typeface="Kartika"/>
-        <a:font script="Laoo" typeface="DokChampa"/>
-        <a:font script="Sinh" typeface="Iskoola Pota"/>
-        <a:font script="Mong" typeface="Mongolian Baiti"/>
-        <a:font script="Viet" typeface="Arial"/>
-        <a:font script="Uigh" typeface="Microsoft Uighur"/>
-        <a:font script="Geor" typeface="Sylfaen"/>
-      </a:minorFont>
-    </a:fontScheme>
-    <a:fmtScheme name="Office">
-      <a:fillStyleLst>
-        <a:solidFill>
-          <a:schemeClr val="phClr"/>
-        </a:solidFill>
-        <a:gradFill rotWithShape="1">
-          <a:gsLst>
-            <a:gs pos="0">
-              <a:schemeClr val="phClr">
-                <a:tint val="50000"/>
-                <a:satMod val="300000"/>
-              </a:schemeClr>
-            </a:gs>
-            <a:gs pos="35000">
-              <a:schemeClr val="phClr">
-                <a:tint val="37000"/>
-                <a:satMod val="300000"/>
-              </a:schemeClr>
-            </a:gs>
-            <a:gs pos="100000">
-              <a:schemeClr val="phClr">
-                <a:tint val="15000"/>
-                <a:satMod val="350000"/>
-              </a:schemeClr>
-            </a:gs>
-          </a:gsLst>
-          <a:lin ang="16200000" scaled="1"/>
-        </a:gradFill>
-        <a:gradFill rotWithShape="1">
-          <a:gsLst>
-            <a:gs pos="0">
-              <a:schemeClr val="phClr">
-                <a:tint val="100000"/>
-                <a:shade val="100000"/>
-                <a:satMod val="130000"/>
-              </a:schemeClr>
-            </a:gs>
-            <a:gs pos="100000">
-              <a:schemeClr val="phClr">
-                <a:tint val="50000"/>
-                <a:shade val="100000"/>
-                <a:satMod val="350000"/>
-              </a:schemeClr>
-            </a:gs>
-          </a:gsLst>
-          <a:lin ang="16200000" scaled="0"/>
-        </a:gradFill>
-      </a:fillStyleLst>
-      <a:lnStyleLst>
-        <a:ln w="9525" cap="flat" cmpd="sng" algn="ctr">
-          <a:solidFill>
-            <a:schemeClr val="phClr">
-              <a:shade val="95000"/>
-              <a:satMod val="105000"/>
-            </a:schemeClr>
-          </a:solidFill>
-          <a:prstDash val="solid"/>
-        </a:ln>
-        <a:ln w="25400" cap="flat" cmpd="sng" algn="ctr">
-          <a:solidFill>
-            <a:schemeClr val="phClr"/>
-          </a:solidFill>
-          <a:prstDash val="solid"/>
-        </a:ln>
-        <a:ln w="38100" cap="flat" cmpd="sng" algn="ctr">
-          <a:solidFill>
-            <a:schemeClr val="phClr"/>
-          </a:solidFill>
-          <a:prstDash val="solid"/>
-        </a:ln>
-      </a:lnStyleLst>
-      <a:effectStyleLst>
-        <a:effectStyle>
-          <a:effectLst>
-            <a:outerShdw blurRad="40000" dist="20000" dir="5400000" rotWithShape="0">
-              <a:srgbClr val="000000">
-                <a:alpha val="38000"/>
-              </a:srgbClr>
-            </a:outerShdw>
-          </a:effectLst>
-        </a:effectStyle>
-        <a:effectStyle>
-          <a:effectLst>
-            <a:outerShdw blurRad="40000" dist="23000" dir="5400000" rotWithShape="0">
-              <a:srgbClr val="000000">
-                <a:alpha val="35000"/>
-              </a:srgbClr>
-            </a:outerShdw>
-          </a:effectLst>
-        </a:effectStyle>
-        <a:effectStyle>
-          <a:effectLst>
-            <a:outerShdw blurRad="40000" dist="23000" dir="5400000" rotWithShape="0">
-              <a:srgbClr val="000000">
-                <a:alpha val="35000"/>
-              </a:srgbClr>
-            </a:outerShdw>
-          </a:effectLst>
-          <a:scene3d>
-            <a:camera prst="orthographicFront">
-              <a:rot lat="0" lon="0" rev="0"/>
-            </a:camera>
-            <a:lightRig rig="threePt" dir="t">
-              <a:rot lat="0" lon="0" rev="1200000"/>
-            </a:lightRig>
-          </a:scene3d>
-          <a:sp3d>
-            <a:bevelT w="63500" h="25400"/>
-          </a:sp3d>
-        </a:effectStyle>
-      </a:effectStyleLst>
-      <a:bgFillStyleLst>
-        <a:solidFill>
-          <a:schemeClr val="phClr"/>
-        </a:solidFill>
-        <a:gradFill rotWithShape="1">
-          <a:gsLst>
-            <a:gs pos="0">
-              <a:schemeClr val="phClr">
-                <a:tint val="40000"/>
-                <a:satMod val="350000"/>
-              </a:schemeClr>
-            </a:gs>
-            <a:gs pos="40000">
-              <a:schemeClr val="phClr">
-                <a:tint val="45000"/>
-                <a:shade val="99000"/>
-                <a:satMod val="350000"/>
-              </a:schemeClr>
-            </a:gs>
-            <a:gs pos="100000">
-              <a:schemeClr val="phClr">
-                <a:shade val="20000"/>
-                <a:satMod val="255000"/>
-              </a:schemeClr>
-            </a:gs>
-          </a:gsLst>
-          <a:path path="circle">
-            <a:fillToRect l="50000" t="-80000" r="50000" b="180000"/>
-          </a:path>
-        </a:gradFill>
-        <a:gradFill rotWithShape="1">
-          <a:gsLst>
-            <a:gs pos="0">
-              <a:schemeClr val="phClr">
-                <a:tint val="80000"/>
-                <a:satMod val="300000"/>
-              </a:schemeClr>
-            </a:gs>
-            <a:gs pos="100000">
-              <a:schemeClr val="phClr">
-                <a:shade val="30000"/>
-                <a:satMod val="200000"/>
-              </a:schemeClr>
-            </a:gs>
-          </a:gsLst>
-          <a:path path="circle">
-            <a:fillToRect l="50000" t="50000" r="50000" b="50000"/>
-          </a:path>
-        </a:gradFill>
-      </a:bgFillStyleLst>
-    </a:fmtScheme>
-  </a:themeElements>
-</a:theme>
 </file>
</xml_diff>